<commit_message>
Refine consolidated deck: drop region note on Slide 6, rewrite deeper-reading tiles as audience topics
Co-authored-by: Copilot <223556219+Copilot@users.noreply.github.com>
</commit_message>
<xml_diff>
--- a/workshop-assets/kaiser-consolidated-customer-deck.pptx
+++ b/workshop-assets/kaiser-consolidated-customer-deck.pptx
@@ -12008,7 +12008,7 @@
                 <a:ea typeface="Aptos" pitchFamily="34" charset="-122"/>
                 <a:cs typeface="Aptos" pitchFamily="34" charset="-120"/>
               </a:rPr>
-              <a:t>securing-mcp-servers.md; capability-host-reuse-and-cost.md; existing-vs-foundry-search.md; sharepoint-o365-rag-ingest.md; rag-guidance-gpt-rag.md.</a:t>
+              <a:t>Securing MCP tool servers; reusing capability-host Search and its cost; existing vs. Foundry search; SharePoint / O365 RAG ingest; RAG design guidance.</a:t>
             </a:r>
             <a:endParaRPr lang="en-US" sz="920" dirty="0"/>
           </a:p>
@@ -12149,7 +12149,7 @@
                 <a:ea typeface="Aptos" pitchFamily="34" charset="-122"/>
                 <a:cs typeface="Aptos" pitchFamily="34" charset="-120"/>
               </a:rPr>
-              <a:t>healthcare-content-safety.md; agent-type-decision.md; governance-security-observability.md; policy/ guardrails and test matrix.</a:t>
+              <a:t>Healthcare content safety; choosing the right agent type; governance, security and observability; guardrail policy and its test matrix.</a:t>
             </a:r>
             <a:endParaRPr lang="en-US" sz="920" dirty="0"/>
           </a:p>
@@ -12290,7 +12290,7 @@
                 <a:ea typeface="Aptos" pitchFamily="34" charset="-122"/>
                 <a:cs typeface="Aptos" pitchFamily="34" charset="-120"/>
               </a:rPr>
-              <a:t>observability-dedicated-cluster-cmk-ampls.md; observability-correlation-trace.md; hitl-durable-task-scheduler.md.</a:t>
+              <a:t>Dedicated cluster with CMK and AMPLS; end-to-end trace correlation; human-in-the-loop with the Durable Task Scheduler.</a:t>
             </a:r>
             <a:endParaRPr lang="en-US" sz="920" dirty="0"/>
           </a:p>
@@ -12431,7 +12431,7 @@
                 <a:ea typeface="Aptos" pitchFamily="34" charset="-122"/>
                 <a:cs typeface="Aptos" pitchFamily="34" charset="-120"/>
               </a:rPr>
-              <a:t>workshop-assets/agenda-2-day.md; run-of-show.md; facilitator-cheatsheet.md (who wants what -&gt; which brief).</a:t>
+              <a:t>Two-day agenda, run-of-show, and a facilitator cheat-sheet that maps each stakeholder question to the right brief.</a:t>
             </a:r>
             <a:endParaRPr lang="en-US" sz="920" dirty="0"/>
           </a:p>
@@ -12470,7 +12470,7 @@
                 <a:ea typeface="Aptos" pitchFamily="34" charset="-122"/>
                 <a:cs typeface="Aptos" pitchFamily="34" charset="-120"/>
               </a:rPr>
-              <a:t>Every brief cites current Microsoft Learn and maps to a slide in this deck.</a:t>
+              <a:t>Detailed, source-grounded briefs are provided as a leave-behind pack; every brief cites current Microsoft Learn.</a:t>
             </a:r>
             <a:endParaRPr lang="en-US" sz="1000" dirty="0"/>
           </a:p>
@@ -15682,24 +15682,6 @@
             <a:normAutofit/>
           </a:bodyPr>
           <a:lstStyle/>
-          <a:p>
-            <a:pPr marL="152400" indent="-152400">
-              <a:buSzPct val="100000"/>
-              <a:buChar char="•"/>
-            </a:pPr>
-            <a:r>
-              <a:rPr lang="en-US" sz="1150" dirty="0">
-                <a:solidFill>
-                  <a:srgbClr val="334155"/>
-                </a:solidFill>
-                <a:latin typeface="Aptos" pitchFamily="34" charset="0"/>
-                <a:ea typeface="Aptos" pitchFamily="34" charset="-122"/>
-                <a:cs typeface="Aptos" pitchFamily="34" charset="-120"/>
-              </a:rPr>
-              <a:t>Workload in Sweden Central; Azure AI Search in Norway East (regional SKU capacity).</a:t>
-            </a:r>
-            <a:endParaRPr lang="en-US" sz="1150" dirty="0"/>
-          </a:p>
           <a:p>
             <a:pPr marL="152400" indent="-152400">
               <a:buSzPct val="100000"/>

</xml_diff>

<commit_message>
Add verified Work IQ content: brief, deck slide, Module 02 rewrite, facilitator talk track
Work IQ is a shipping Microsoft service (MCP/A2A/REST over M365) with delegated-identity-only
governance, OPA policy, and usage-based Copilot Credits billing. Adds docs/work-iq-overview.md
(Microsoft Learn citations), a dedicated deck slide (now 23 slides), updates Module 02, and adds a
Slide 9 talk track with renumbered slide references in the facilitator delivery plan.

Co-authored-by: Copilot <223556219+Copilot@users.noreply.github.com>
</commit_message>
<xml_diff>
--- a/workshop-assets/kaiser-consolidated-customer-deck.pptx
+++ b/workshop-assets/kaiser-consolidated-customer-deck.pptx
@@ -27,9 +27,10 @@
     <p:sldId id="275" r:id="rId21"/>
     <p:sldId id="276" r:id="rId22"/>
     <p:sldId id="277" r:id="rId23"/>
+    <p:sldId id="278" r:id="rId24"/>
   </p:sldIdLst>
   <p:notesMasterIdLst>
-    <p:notesMasterId r:id="rId24"/>
+    <p:notesMasterId r:id="rId25"/>
   </p:notesMasterIdLst>
   <p:sldSz cx="12192000" cy="6858000"/>
   <p:notesSz cx="6858000" cy="12192000"/>
@@ -611,7 +612,7 @@
           <a:p>
             <a:r>
               <a:rPr lang="en-US" dirty="0"/>
-              <a:t>The RAG core. Emphasize evidence-packet-before-answer and measure-retrieval-first; both are the differentiators from a naive RAG demo.</a:t>
+              <a:t>Natural follow to MCP. The message: govern once, reuse everywhere. This is also where credential rotation and policy live.</a:t>
             </a:r>
             <a:endParaRPr lang="en-US" dirty="0"/>
           </a:p>
@@ -699,7 +700,7 @@
           <a:p>
             <a:r>
               <a:rPr lang="en-US" dirty="0"/>
-              <a:t>This was the most-raised, critical question. Lead with the two instances, the reuse-for-cost answer, and the immutability caveat.</a:t>
+              <a:t>The RAG core. Emphasize evidence-packet-before-answer and measure-retrieval-first; both are the differentiators from a naive RAG demo.</a:t>
             </a:r>
             <a:endParaRPr lang="en-US" dirty="0"/>
           </a:p>
@@ -787,7 +788,7 @@
           <a:p>
             <a:r>
               <a:rPr lang="en-US" dirty="0"/>
-              <a:t>Matt's ask about SharePoint PDFs/PPT/Word/Excel. Give both patterns and stress the ACL caveat on the indexed path.</a:t>
+              <a:t>This was the most-raised, critical question. Lead with the two instances, the reuse-for-cost answer, and the immutability caveat.</a:t>
             </a:r>
             <a:endParaRPr lang="en-US" dirty="0"/>
           </a:p>
@@ -875,7 +876,7 @@
           <a:p>
             <a:r>
               <a:rPr lang="en-US" dirty="0"/>
-              <a:t>Sarita's content-safety concern. Emphasize layered tuning and the ticket path. Demo a benign clinical prompt passing and 'safe to discharge' still blocked.</a:t>
+              <a:t>Matt's ask about SharePoint PDFs/PPT/Word/Excel. Give both patterns and stress the ACL caveat on the indexed path.</a:t>
             </a:r>
             <a:endParaRPr lang="en-US" dirty="0"/>
           </a:p>
@@ -963,7 +964,7 @@
           <a:p>
             <a:r>
               <a:rPr lang="en-US" dirty="0"/>
-              <a:t>Matt wanted decision criteria. Give the spectrum, the tipping factors, and why our use case is hosted.</a:t>
+              <a:t>Sarita's content-safety concern. Emphasize layered tuning and the ticket path. Demo a benign clinical prompt passing and 'safe to discharge' still blocked.</a:t>
             </a:r>
             <a:endParaRPr lang="en-US" dirty="0"/>
           </a:p>
@@ -1051,7 +1052,7 @@
           <a:p>
             <a:r>
               <a:rPr lang="en-US" dirty="0"/>
-              <a:t>Two-in-one: the correlation-trace story plus the PHI-protection posture. The driver is request/response content in Foundry logs.</a:t>
+              <a:t>Matt wanted decision criteria. Give the spectrum, the tipping factors, and why our use case is hosted.</a:t>
             </a:r>
             <a:endParaRPr lang="en-US" dirty="0"/>
           </a:p>
@@ -1139,7 +1140,7 @@
           <a:p>
             <a:r>
               <a:rPr lang="en-US" dirty="0"/>
-              <a:t>The human-control capstone. This is built and running today; demo approve, a blocked illegal transition, and SLA auto-escalation.</a:t>
+              <a:t>Two-in-one: the correlation-trace story plus the PHI-protection posture. The driver is request/response content in Foundry logs.</a:t>
             </a:r>
             <a:endParaRPr lang="en-US" dirty="0"/>
           </a:p>
@@ -1227,7 +1228,7 @@
           <a:p>
             <a:r>
               <a:rPr lang="en-US" dirty="0"/>
-              <a:t/>
+              <a:t>The human-control capstone. This is built and running today; demo approve, a blocked illegal transition, and SLA auto-escalation.</a:t>
             </a:r>
             <a:endParaRPr lang="en-US" dirty="0"/>
           </a:p>
@@ -1315,7 +1316,7 @@
           <a:p>
             <a:r>
               <a:rPr lang="en-US" dirty="0"/>
-              <a:t>The integrated demo. Run one case start to finish; let the trace and the human gate tell the story.</a:t>
+              <a:t/>
             </a:r>
             <a:endParaRPr lang="en-US" dirty="0"/>
           </a:p>
@@ -1403,7 +1404,7 @@
           <a:p>
             <a:r>
               <a:rPr lang="en-US" dirty="0"/>
-              <a:t>Show that safety is testable and enforced in CI. The score-override adversarial case is the one to highlight.</a:t>
+              <a:t>The integrated demo. Run one case start to finish; let the trace and the human gate tell the story.</a:t>
             </a:r>
             <a:endParaRPr lang="en-US" dirty="0"/>
           </a:p>
@@ -1579,7 +1580,7 @@
           <a:p>
             <a:r>
               <a:rPr lang="en-US" dirty="0"/>
-              <a:t>Close with a concrete, cost-aware plan. Tie each phase back to the priorities and the two-quarter window Kaiser cares about.</a:t>
+              <a:t>Show that safety is testable and enforced in CI. The score-override adversarial case is the one to highlight.</a:t>
             </a:r>
             <a:endParaRPr lang="en-US" dirty="0"/>
           </a:p>
@@ -1667,7 +1668,7 @@
           <a:p>
             <a:r>
               <a:rPr lang="en-US" dirty="0"/>
-              <a:t>Leave-behind slide. Point each persona to their briefs; the facilitator cheat-sheet has the full question -&gt; doc lookup.</a:t>
+              <a:t>Close with a concrete, cost-aware plan. Tie each phase back to the priorities and the two-quarter window Kaiser cares about.</a:t>
             </a:r>
             <a:endParaRPr lang="en-US" dirty="0"/>
           </a:p>
@@ -1755,7 +1756,7 @@
           <a:p>
             <a:r>
               <a:rPr lang="en-US" dirty="0"/>
-              <a:t>Close on the through-line: we do not choose between capability and governance - we build them together, sequenced around what Kaiser asked for.</a:t>
+              <a:t>Leave-behind slide. Point each persona to their briefs; the facilitator cheat-sheet has the full question -&gt; doc lookup.</a:t>
             </a:r>
             <a:endParaRPr lang="en-US" dirty="0"/>
           </a:p>
@@ -1779,6 +1780,94 @@
             <a:fld id="{F7021451-1387-4CA6-816F-3879F97B5CBC}" type="slidenum">
               <a:rPr lang="en-US"/>
               <a:t>22</a:t>
+            </a:fld>
+            <a:endParaRPr lang="en-US"/>
+          </a:p>
+        </p:txBody>
+      </p:sp>
+    </p:spTree>
+    <p:extLst>
+      <p:ext uri="{BB962C8B-B14F-4D97-AF65-F5344CB8AC3E}">
+        <p14:creationId xmlns:p14="http://schemas.microsoft.com/office/powerpoint/2010/main" val="1024086991"/>
+      </p:ext>
+    </p:extLst>
+  </p:cSld>
+  <p:clrMapOvr>
+    <a:masterClrMapping/>
+  </p:clrMapOvr>
+</p:notes>
+</file>
+
+<file path=ppt/notesSlides/notesSlide23.xml><?xml version="1.0" encoding="utf-8"?>
+<p:notes xmlns:a="http://schemas.openxmlformats.org/drawingml/2006/main" xmlns:r="http://schemas.openxmlformats.org/officeDocument/2006/relationships" xmlns:p="http://schemas.openxmlformats.org/presentationml/2006/main">
+  <p:cSld>
+    <p:spTree>
+      <p:nvGrpSpPr>
+        <p:cNvPr id="1" name=""/>
+        <p:cNvGrpSpPr/>
+        <p:nvPr/>
+      </p:nvGrpSpPr>
+      <p:grpSpPr>
+        <a:xfrm>
+          <a:off x="0" y="0"/>
+          <a:ext cx="0" cy="0"/>
+          <a:chOff x="0" y="0"/>
+          <a:chExt cx="0" cy="0"/>
+        </a:xfrm>
+      </p:grpSpPr>
+      <p:sp>
+        <p:nvSpPr>
+          <p:cNvPr id="2" name="Slide Image Placeholder 1"/>
+          <p:cNvSpPr>
+            <a:spLocks noGrp="1" noRot="1" noChangeAspect="1"/>
+          </p:cNvSpPr>
+          <p:nvPr>
+            <p:ph type="sldImg"/>
+          </p:nvPr>
+        </p:nvSpPr>
+        <p:spPr/>
+      </p:sp>
+      <p:sp>
+        <p:nvSpPr>
+          <p:cNvPr id="3" name="Notes Placeholder 2"/>
+          <p:cNvSpPr>
+            <a:spLocks noGrp="1"/>
+          </p:cNvSpPr>
+          <p:nvPr>
+            <p:ph type="body" idx="1"/>
+          </p:nvPr>
+        </p:nvSpPr>
+        <p:spPr/>
+        <p:txBody>
+          <a:bodyPr/>
+          <a:lstStyle/>
+          <a:p>
+            <a:r>
+              <a:rPr lang="en-US" dirty="0"/>
+              <a:t>Close on the through-line: we do not choose between capability and governance - we build them together, sequenced around what Kaiser asked for.</a:t>
+            </a:r>
+            <a:endParaRPr lang="en-US" dirty="0"/>
+          </a:p>
+        </p:txBody>
+      </p:sp>
+      <p:sp>
+        <p:nvSpPr>
+          <p:cNvPr id="4" name="Slide Number Placeholder 3"/>
+          <p:cNvSpPr>
+            <a:spLocks noGrp="1"/>
+          </p:cNvSpPr>
+          <p:nvPr>
+            <p:ph type="sldNum" sz="quarter" idx="10"/>
+          </p:nvPr>
+        </p:nvSpPr>
+        <p:spPr/>
+        <p:txBody>
+          <a:bodyPr/>
+          <a:lstStyle/>
+          <a:p>
+            <a:fld id="{F7021451-1387-4CA6-816F-3879F97B5CBC}" type="slidenum">
+              <a:rPr lang="en-US"/>
+              <a:t>23</a:t>
             </a:fld>
             <a:endParaRPr lang="en-US"/>
           </a:p>
@@ -2371,7 +2460,7 @@
           <a:p>
             <a:r>
               <a:rPr lang="en-US" dirty="0"/>
-              <a:t>Natural follow to MCP. The message: govern once, reuse everywhere. This is also where credential rotation and policy live.</a:t>
+              <a:t>Reframe from earlier: Work IQ is a shipping, consumable service (MCP/A2A/REST), not just a pattern. Emphasize delegated-identity-only + OPA + audit as the governance story, and the clean split - our MCP for clinical tools, Work IQ for M365 context. Cost is usage-based Copilot Credits.</a:t>
             </a:r>
             <a:endParaRPr lang="en-US" dirty="0"/>
           </a:p>
@@ -3441,7 +3530,7 @@
                 <a:ea typeface="Aptos" pitchFamily="34" charset="-122"/>
                 <a:cs typeface="Aptos" pitchFamily="34" charset="-120"/>
               </a:rPr>
-              <a:t>PRIORITY - RAG BEST PRACTICES</a:t>
+              <a:t>PRIORITY - PAIRS WITH MCP</a:t>
             </a:r>
             <a:endParaRPr lang="en-US" sz="800" dirty="0"/>
           </a:p>
@@ -3482,7 +3571,7 @@
                 <a:ea typeface="Aptos Display" pitchFamily="34" charset="-122"/>
                 <a:cs typeface="Aptos Display" pitchFamily="34" charset="-120"/>
               </a:rPr>
-              <a:t>Foundry IQ and RAG done right</a:t>
+              <a:t>Toolboxes: one governed endpoint</a:t>
             </a:r>
             <a:endParaRPr lang="en-US" sz="2300" dirty="0"/>
           </a:p>
@@ -3520,11 +3609,11 @@
         <p:spPr>
           <a:xfrm>
             <a:off x="640080" y="1463040"/>
-            <a:ext cx="3520440" cy="1828800"/>
+            <a:ext cx="3520440" cy="1783080"/>
           </a:xfrm>
           <a:prstGeom prst="roundRect">
             <a:avLst>
-              <a:gd name="adj" fmla="val 4000"/>
+              <a:gd name="adj" fmla="val 4103"/>
             </a:avLst>
           </a:prstGeom>
           <a:solidFill>
@@ -3554,17 +3643,17 @@
         <p:spPr>
           <a:xfrm>
             <a:off x="640080" y="1463040"/>
-            <a:ext cx="64008" cy="1828800"/>
+            <a:ext cx="64008" cy="1783080"/>
           </a:xfrm>
           <a:prstGeom prst="rect">
             <a:avLst/>
           </a:prstGeom>
           <a:solidFill>
-            <a:srgbClr val="0F766E"/>
+            <a:srgbClr val="F59E0B"/>
           </a:solidFill>
           <a:ln w="12700">
             <a:solidFill>
-              <a:srgbClr val="0F766E"/>
+              <a:srgbClr val="F59E0B"/>
             </a:solidFill>
             <a:prstDash val="solid"/>
           </a:ln>
@@ -3605,7 +3694,7 @@
                 <a:ea typeface="Aptos" pitchFamily="34" charset="-122"/>
                 <a:cs typeface="Aptos" pitchFamily="34" charset="-120"/>
               </a:rPr>
-              <a:t>One retrieval endpoint</a:t>
+              <a:t>The problem</a:t>
             </a:r>
             <a:endParaRPr lang="en-US" sz="1200" dirty="0"/>
           </a:p>
@@ -3620,7 +3709,7 @@
         <p:spPr>
           <a:xfrm>
             <a:off x="841248" y="1920240"/>
-            <a:ext cx="3200400" cy="1280160"/>
+            <a:ext cx="3200400" cy="1234440"/>
           </a:xfrm>
           <a:prstGeom prst="rect">
             <a:avLst/>
@@ -3646,7 +3735,7 @@
                 <a:ea typeface="Aptos" pitchFamily="34" charset="-122"/>
                 <a:cs typeface="Aptos" pitchFamily="34" charset="-120"/>
               </a:rPr>
-              <a:t>Foundry IQ fans out to Blob, AI Search index, Work IQ, SharePoint, Fabric, and MCP - with permission trimming built in.</a:t>
+              <a:t>Configuring tools + credentials on every agent creates sprawl and drift - hard to govern, version, or rotate.</a:t>
             </a:r>
             <a:endParaRPr lang="en-US" sz="920" dirty="0"/>
           </a:p>
@@ -3661,11 +3750,11 @@
         <p:spPr>
           <a:xfrm>
             <a:off x="4343400" y="1463040"/>
-            <a:ext cx="3520440" cy="1828800"/>
+            <a:ext cx="3520440" cy="1783080"/>
           </a:xfrm>
           <a:prstGeom prst="roundRect">
             <a:avLst>
-              <a:gd name="adj" fmla="val 4000"/>
+              <a:gd name="adj" fmla="val 4103"/>
             </a:avLst>
           </a:prstGeom>
           <a:solidFill>
@@ -3695,17 +3784,17 @@
         <p:spPr>
           <a:xfrm>
             <a:off x="4343400" y="1463040"/>
-            <a:ext cx="64008" cy="1828800"/>
+            <a:ext cx="64008" cy="1783080"/>
           </a:xfrm>
           <a:prstGeom prst="rect">
             <a:avLst/>
           </a:prstGeom>
           <a:solidFill>
-            <a:srgbClr val="7C3AED"/>
+            <a:srgbClr val="0F766E"/>
           </a:solidFill>
           <a:ln w="12700">
             <a:solidFill>
-              <a:srgbClr val="7C3AED"/>
+              <a:srgbClr val="0F766E"/>
             </a:solidFill>
             <a:prstDash val="solid"/>
           </a:ln>
@@ -3746,7 +3835,7 @@
                 <a:ea typeface="Aptos" pitchFamily="34" charset="-122"/>
                 <a:cs typeface="Aptos" pitchFamily="34" charset="-120"/>
               </a:rPr>
-              <a:t>Evidence before answer</a:t>
+              <a:t>The pattern</a:t>
             </a:r>
             <a:endParaRPr lang="en-US" sz="1200" dirty="0"/>
           </a:p>
@@ -3761,7 +3850,7 @@
         <p:spPr>
           <a:xfrm>
             <a:off x="4544568" y="1920240"/>
-            <a:ext cx="3200400" cy="1280160"/>
+            <a:ext cx="3200400" cy="1234440"/>
           </a:xfrm>
           <a:prstGeom prst="rect">
             <a:avLst/>
@@ -3787,7 +3876,7 @@
                 <a:ea typeface="Aptos" pitchFamily="34" charset="-122"/>
                 <a:cs typeface="Aptos" pitchFamily="34" charset="-120"/>
               </a:rPr>
-              <a:t>Retrieve first, build an evidence packet with claim-level citations, then generate. Missing / conflicting evidence -&gt; escalate, never guess.</a:t>
+              <a:t>Bundle tools (MCP servers, AI Search, OpenAPI, code interpreter, A2A) into one MCP-compatible Toolbox endpoint with central credentials, versioning, and policy.</a:t>
             </a:r>
             <a:endParaRPr lang="en-US" sz="920" dirty="0"/>
           </a:p>
@@ -3802,11 +3891,11 @@
         <p:spPr>
           <a:xfrm>
             <a:off x="8046720" y="1463040"/>
-            <a:ext cx="3520440" cy="1828800"/>
+            <a:ext cx="3520440" cy="1783080"/>
           </a:xfrm>
           <a:prstGeom prst="roundRect">
             <a:avLst>
-              <a:gd name="adj" fmla="val 4000"/>
+              <a:gd name="adj" fmla="val 4103"/>
             </a:avLst>
           </a:prstGeom>
           <a:solidFill>
@@ -3836,17 +3925,17 @@
         <p:spPr>
           <a:xfrm>
             <a:off x="8046720" y="1463040"/>
-            <a:ext cx="64008" cy="1828800"/>
+            <a:ext cx="64008" cy="1783080"/>
           </a:xfrm>
           <a:prstGeom prst="rect">
             <a:avLst/>
           </a:prstGeom>
           <a:solidFill>
-            <a:srgbClr val="2563EB"/>
+            <a:srgbClr val="16A34A"/>
           </a:solidFill>
           <a:ln w="12700">
             <a:solidFill>
-              <a:srgbClr val="2563EB"/>
+              <a:srgbClr val="16A34A"/>
             </a:solidFill>
             <a:prstDash val="solid"/>
           </a:ln>
@@ -3887,7 +3976,7 @@
                 <a:ea typeface="Aptos" pitchFamily="34" charset="-122"/>
                 <a:cs typeface="Aptos" pitchFamily="34" charset="-120"/>
               </a:rPr>
-              <a:t>Measure retrieval first</a:t>
+              <a:t>The payoff</a:t>
             </a:r>
             <a:endParaRPr lang="en-US" sz="1200" dirty="0"/>
           </a:p>
@@ -3902,7 +3991,7 @@
         <p:spPr>
           <a:xfrm>
             <a:off x="8247888" y="1920240"/>
-            <a:ext cx="3200400" cy="1280160"/>
+            <a:ext cx="3200400" cy="1234440"/>
           </a:xfrm>
           <a:prstGeom prst="rect">
             <a:avLst/>
@@ -3928,7 +4017,7 @@
                 <a:ea typeface="Aptos" pitchFamily="34" charset="-122"/>
                 <a:cs typeface="Aptos" pitchFamily="34" charset="-120"/>
               </a:rPr>
-              <a:t>Use labeled relevance judgments (qrels) to measure precision / recall before tuning prompts or models. Governance and provenance are part of the design.</a:t>
+              <a:t>Point agents at the Toolbox; add / remove / reconfigure tools without changing agent code. Any MCP-capable runtime can consume it.</a:t>
             </a:r>
             <a:endParaRPr lang="en-US" sz="920" dirty="0"/>
           </a:p>
@@ -3942,7 +4031,7 @@
         </p:nvSpPr>
         <p:spPr>
           <a:xfrm>
-            <a:off x="640080" y="3520440"/>
+            <a:off x="640080" y="3474720"/>
             <a:ext cx="10972800" cy="2011680"/>
           </a:xfrm>
           <a:prstGeom prst="rect">
@@ -3970,7 +4059,7 @@
                 <a:ea typeface="Aptos" pitchFamily="34" charset="-122"/>
                 <a:cs typeface="Aptos" pitchFamily="34" charset="-120"/>
               </a:rPr>
-              <a:t>Permission-trim with delegated identity (OBO); never rely on a service-identity test for user isolation.</a:t>
+              <a:t>Centralized authentication, governance, and versioning is the recommended way to run MCP at scale.</a:t>
             </a:r>
             <a:endParaRPr lang="en-US" sz="1150" dirty="0"/>
           </a:p>
@@ -3988,7 +4077,7 @@
                 <a:ea typeface="Aptos" pitchFamily="34" charset="-122"/>
                 <a:cs typeface="Aptos" pitchFamily="34" charset="-120"/>
               </a:rPr>
-              <a:t>A working local retrieval-eval harness ships in agent-service/eval/.</a:t>
+              <a:t>One endpoint to secure and audit instead of per-agent credential management.</a:t>
             </a:r>
             <a:endParaRPr lang="en-US" sz="1150" dirty="0"/>
           </a:p>
@@ -4006,7 +4095,7 @@
                 <a:ea typeface="Aptos" pitchFamily="34" charset="-122"/>
                 <a:cs typeface="Aptos" pitchFamily="34" charset="-120"/>
               </a:rPr>
-              <a:t>Briefs: docs/rag-guidance-gpt-rag.md, docs/rag-development-patterns.md.</a:t>
+              <a:t>Reference: Foundry Toolboxes (see securing-mcp-servers.md).</a:t>
             </a:r>
             <a:endParaRPr lang="en-US" sz="1150" dirty="0"/>
           </a:p>
@@ -4045,7 +4134,7 @@
                 <a:ea typeface="Aptos" pitchFamily="34" charset="-122"/>
                 <a:cs typeface="Aptos" pitchFamily="34" charset="-120"/>
               </a:rPr>
-              <a:t>RAG as a production engineering pattern - grounded, measured, and governed, not a demo trick.</a:t>
+              <a:t>Toolboxes turn 'many tools on many agents' into one governed surface.</a:t>
             </a:r>
             <a:endParaRPr lang="en-US" sz="1000" dirty="0"/>
           </a:p>
@@ -4164,7 +4253,7 @@
                 <a:ea typeface="Aptos" pitchFamily="34" charset="-122"/>
                 <a:cs typeface="Aptos" pitchFamily="34" charset="-120"/>
               </a:rPr>
-              <a:t>PRIORITY - JOSHUA / MATT: THE CRITICAL COST QUESTION</a:t>
+              <a:t>PRIORITY - RAG BEST PRACTICES</a:t>
             </a:r>
             <a:endParaRPr lang="en-US" sz="800" dirty="0"/>
           </a:p>
@@ -4205,7 +4294,7 @@
                 <a:ea typeface="Aptos Display" pitchFamily="34" charset="-122"/>
                 <a:cs typeface="Aptos Display" pitchFamily="34" charset="-120"/>
               </a:rPr>
-              <a:t>Existing vs Foundry Search + capability-host reuse</a:t>
+              <a:t>Foundry IQ and RAG done right</a:t>
             </a:r>
             <a:endParaRPr lang="en-US" sz="2300" dirty="0"/>
           </a:p>
@@ -4283,11 +4372,11 @@
             <a:avLst/>
           </a:prstGeom>
           <a:solidFill>
-            <a:srgbClr val="2563EB"/>
+            <a:srgbClr val="0F766E"/>
           </a:solidFill>
           <a:ln w="12700">
             <a:solidFill>
-              <a:srgbClr val="2563EB"/>
+              <a:srgbClr val="0F766E"/>
             </a:solidFill>
             <a:prstDash val="solid"/>
           </a:ln>
@@ -4328,7 +4417,7 @@
                 <a:ea typeface="Aptos" pitchFamily="34" charset="-122"/>
                 <a:cs typeface="Aptos" pitchFamily="34" charset="-120"/>
               </a:rPr>
-              <a:t>Two Search instances</a:t>
+              <a:t>One retrieval endpoint</a:t>
             </a:r>
             <a:endParaRPr lang="en-US" sz="1200" dirty="0"/>
           </a:p>
@@ -4369,7 +4458,7 @@
                 <a:ea typeface="Aptos" pitchFamily="34" charset="-122"/>
                 <a:cs typeface="Aptos" pitchFamily="34" charset="-120"/>
               </a:rPr>
-              <a:t>A: the Search Foundry provisions per project for agent vector stores. B: your existing Search with your RAG indexes. Independent unless you connect them.</a:t>
+              <a:t>Foundry IQ fans out to Blob, AI Search index, Work IQ, SharePoint, Fabric, and MCP - with permission trimming built in.</a:t>
             </a:r>
             <a:endParaRPr lang="en-US" sz="920" dirty="0"/>
           </a:p>
@@ -4424,11 +4513,11 @@
             <a:avLst/>
           </a:prstGeom>
           <a:solidFill>
-            <a:srgbClr val="16A34A"/>
+            <a:srgbClr val="7C3AED"/>
           </a:solidFill>
           <a:ln w="12700">
             <a:solidFill>
-              <a:srgbClr val="16A34A"/>
+              <a:srgbClr val="7C3AED"/>
             </a:solidFill>
             <a:prstDash val="solid"/>
           </a:ln>
@@ -4469,7 +4558,7 @@
                 <a:ea typeface="Aptos" pitchFamily="34" charset="-122"/>
                 <a:cs typeface="Aptos" pitchFamily="34" charset="-120"/>
               </a:rPr>
-              <a:t>Reuse to save cost</a:t>
+              <a:t>Evidence before answer</a:t>
             </a:r>
             <a:endParaRPr lang="en-US" sz="1200" dirty="0"/>
           </a:p>
@@ -4510,7 +4599,7 @@
                 <a:ea typeface="Aptos" pitchFamily="34" charset="-122"/>
                 <a:cs typeface="Aptos" pitchFamily="34" charset="-120"/>
               </a:rPr>
-              <a:t>Standard setup is bring-your-own: reuse existing or let Foundry provision. The cost win is one always-on Search for both agent and app indexes.</a:t>
+              <a:t>Retrieve first, build an evidence packet with claim-level citations, then generate. Missing / conflicting evidence -&gt; escalate, never guess.</a:t>
             </a:r>
             <a:endParaRPr lang="en-US" sz="920" dirty="0"/>
           </a:p>
@@ -4565,11 +4654,11 @@
             <a:avLst/>
           </a:prstGeom>
           <a:solidFill>
-            <a:srgbClr val="DC2626"/>
+            <a:srgbClr val="2563EB"/>
           </a:solidFill>
           <a:ln w="12700">
             <a:solidFill>
-              <a:srgbClr val="DC2626"/>
+              <a:srgbClr val="2563EB"/>
             </a:solidFill>
             <a:prstDash val="solid"/>
           </a:ln>
@@ -4610,7 +4699,7 @@
                 <a:ea typeface="Aptos" pitchFamily="34" charset="-122"/>
                 <a:cs typeface="Aptos" pitchFamily="34" charset="-120"/>
               </a:rPr>
-              <a:t>The caveat</a:t>
+              <a:t>Measure retrieval first</a:t>
             </a:r>
             <a:endParaRPr lang="en-US" sz="1200" dirty="0"/>
           </a:p>
@@ -4651,7 +4740,7 @@
                 <a:ea typeface="Aptos" pitchFamily="34" charset="-122"/>
                 <a:cs typeface="Aptos" pitchFamily="34" charset="-120"/>
               </a:rPr>
-              <a:t>Capability connections are immutable; build on separate indexes / DBs / containers, never the agent's own. Cosmos / Storage are consumption - little saving.</a:t>
+              <a:t>Use labeled relevance judgments (qrels) to measure precision / recall before tuning prompts or models. Governance and provenance are part of the design.</a:t>
             </a:r>
             <a:endParaRPr lang="en-US" sz="920" dirty="0"/>
           </a:p>
@@ -4693,7 +4782,7 @@
                 <a:ea typeface="Aptos" pitchFamily="34" charset="-122"/>
                 <a:cs typeface="Aptos" pitchFamily="34" charset="-120"/>
               </a:rPr>
-              <a:t>Reuse only with capacity headroom + isolation + RBAC + accepted lifecycle coupling; else go dedicated.</a:t>
+              <a:t>Permission-trim with delegated identity (OBO); never rely on a service-identity test for user isolation.</a:t>
             </a:r>
             <a:endParaRPr lang="en-US" sz="1150" dirty="0"/>
           </a:p>
@@ -4711,7 +4800,7 @@
                 <a:ea typeface="Aptos" pitchFamily="34" charset="-122"/>
                 <a:cs typeface="Aptos" pitchFamily="34" charset="-120"/>
               </a:rPr>
-              <a:t>Usually you do NOT need a second Search - reuse one, isolate, RBAC.</a:t>
+              <a:t>A working local retrieval-eval harness ships in agent-service/eval/.</a:t>
             </a:r>
             <a:endParaRPr lang="en-US" sz="1150" dirty="0"/>
           </a:p>
@@ -4729,7 +4818,7 @@
                 <a:ea typeface="Aptos" pitchFamily="34" charset="-122"/>
                 <a:cs typeface="Aptos" pitchFamily="34" charset="-120"/>
               </a:rPr>
-              <a:t>Briefs: docs/capability-host-reuse-and-cost.md, docs/existing-vs-foundry-search.md.</a:t>
+              <a:t>Briefs: docs/rag-guidance-gpt-rag.md, docs/rag-development-patterns.md.</a:t>
             </a:r>
             <a:endParaRPr lang="en-US" sz="1150" dirty="0"/>
           </a:p>
@@ -4768,7 +4857,7 @@
                 <a:ea typeface="Aptos" pitchFamily="34" charset="-122"/>
                 <a:cs typeface="Aptos" pitchFamily="34" charset="-120"/>
               </a:rPr>
-              <a:t>The 'do we pay for another Search?' answer: usually no - reuse one, safely.</a:t>
+              <a:t>RAG as a production engineering pattern - grounded, measured, and governed, not a demo trick.</a:t>
             </a:r>
             <a:endParaRPr lang="en-US" sz="1000" dirty="0"/>
           </a:p>
@@ -4887,7 +4976,7 @@
                 <a:ea typeface="Aptos" pitchFamily="34" charset="-122"/>
                 <a:cs typeface="Aptos" pitchFamily="34" charset="-120"/>
               </a:rPr>
-              <a:t>PRIORITY - MATT</a:t>
+              <a:t>PRIORITY - JOSHUA / MATT: THE CRITICAL COST QUESTION</a:t>
             </a:r>
             <a:endParaRPr lang="en-US" sz="800" dirty="0"/>
           </a:p>
@@ -4928,7 +5017,7 @@
                 <a:ea typeface="Aptos Display" pitchFamily="34" charset="-122"/>
                 <a:cs typeface="Aptos Display" pitchFamily="34" charset="-120"/>
               </a:rPr>
-              <a:t>SharePoint / O365 docs as a RAG source</a:t>
+              <a:t>Existing vs Foundry Search + capability-host reuse</a:t>
             </a:r>
             <a:endParaRPr lang="en-US" sz="2300" dirty="0"/>
           </a:p>
@@ -5006,11 +5095,11 @@
             <a:avLst/>
           </a:prstGeom>
           <a:solidFill>
-            <a:srgbClr val="0F766E"/>
+            <a:srgbClr val="2563EB"/>
           </a:solidFill>
           <a:ln w="12700">
             <a:solidFill>
-              <a:srgbClr val="0F766E"/>
+              <a:srgbClr val="2563EB"/>
             </a:solidFill>
             <a:prstDash val="solid"/>
           </a:ln>
@@ -5051,7 +5140,7 @@
                 <a:ea typeface="Aptos" pitchFamily="34" charset="-122"/>
                 <a:cs typeface="Aptos" pitchFamily="34" charset="-120"/>
               </a:rPr>
-              <a:t>Pattern A - live tool</a:t>
+              <a:t>Two Search instances</a:t>
             </a:r>
             <a:endParaRPr lang="en-US" sz="1200" dirty="0"/>
           </a:p>
@@ -5092,7 +5181,7 @@
                 <a:ea typeface="Aptos" pitchFamily="34" charset="-122"/>
                 <a:cs typeface="Aptos" pitchFamily="34" charset="-120"/>
               </a:rPr>
-              <a:t>Foundry SharePoint tool via the Copilot Retrieval API: per-user OBO honors SharePoint permissions automatically, no pipeline to build.</a:t>
+              <a:t>A: the Search Foundry provisions per project for agent vector stores. B: your existing Search with your RAG indexes. Independent unless you connect them.</a:t>
             </a:r>
             <a:endParaRPr lang="en-US" sz="920" dirty="0"/>
           </a:p>
@@ -5147,11 +5236,11 @@
             <a:avLst/>
           </a:prstGeom>
           <a:solidFill>
-            <a:srgbClr val="7C3AED"/>
+            <a:srgbClr val="16A34A"/>
           </a:solidFill>
           <a:ln w="12700">
             <a:solidFill>
-              <a:srgbClr val="7C3AED"/>
+              <a:srgbClr val="16A34A"/>
             </a:solidFill>
             <a:prstDash val="solid"/>
           </a:ln>
@@ -5192,7 +5281,7 @@
                 <a:ea typeface="Aptos" pitchFamily="34" charset="-122"/>
                 <a:cs typeface="Aptos" pitchFamily="34" charset="-120"/>
               </a:rPr>
-              <a:t>Pattern B - indexed</a:t>
+              <a:t>Reuse to save cost</a:t>
             </a:r>
             <a:endParaRPr lang="en-US" sz="1200" dirty="0"/>
           </a:p>
@@ -5233,7 +5322,7 @@
                 <a:ea typeface="Aptos" pitchFamily="34" charset="-122"/>
                 <a:cs typeface="Aptos" pitchFamily="34" charset="-120"/>
               </a:rPr>
-              <a:t>You tokenize / vectorize: crack Office &amp; PDF (Document Intelligence) -&gt; chunk -&gt; embed -&gt; index in AI Search -&gt; ground via Foundry IQ. Full control.</a:t>
+              <a:t>Standard setup is bring-your-own: reuse existing or let Foundry provision. The cost win is one always-on Search for both agent and app indexes.</a:t>
             </a:r>
             <a:endParaRPr lang="en-US" sz="920" dirty="0"/>
           </a:p>
@@ -5333,7 +5422,7 @@
                 <a:ea typeface="Aptos" pitchFamily="34" charset="-122"/>
                 <a:cs typeface="Aptos" pitchFamily="34" charset="-120"/>
               </a:rPr>
-              <a:t>The ACL caveat</a:t>
+              <a:t>The caveat</a:t>
             </a:r>
             <a:endParaRPr lang="en-US" sz="1200" dirty="0"/>
           </a:p>
@@ -5374,7 +5463,7 @@
                 <a:ea typeface="Aptos" pitchFamily="34" charset="-122"/>
                 <a:cs typeface="Aptos" pitchFamily="34" charset="-120"/>
               </a:rPr>
-              <a:t>The indexed path does NOT auto-honor SharePoint permissions. Restrict the corpus or carry ACLs and security-trim - or use Pattern A.</a:t>
+              <a:t>Capability connections are immutable; build on separate indexes / DBs / containers, never the agent's own. Cosmos / Storage are consumption - little saving.</a:t>
             </a:r>
             <a:endParaRPr lang="en-US" sz="920" dirty="0"/>
           </a:p>
@@ -5416,7 +5505,7 @@
                 <a:ea typeface="Aptos" pitchFamily="34" charset="-122"/>
                 <a:cs typeface="Aptos" pitchFamily="34" charset="-120"/>
               </a:rPr>
-              <a:t>Choose A for per-user ACLs honored automatically (needs M365 Copilot / PAYG licensing).</a:t>
+              <a:t>Reuse only with capacity headroom + isolation + RBAC + accepted lifecycle coupling; else go dedicated.</a:t>
             </a:r>
             <a:endParaRPr lang="en-US" sz="1150" dirty="0"/>
           </a:p>
@@ -5434,7 +5523,7 @@
                 <a:ea typeface="Aptos" pitchFamily="34" charset="-122"/>
                 <a:cs typeface="Aptos" pitchFamily="34" charset="-120"/>
               </a:rPr>
-              <a:t>Choose B for custom chunking / metadata or a broadly-readable corpus (e.g. approved protocols).</a:t>
+              <a:t>Usually you do NOT need a second Search - reuse one, isolate, RBAC.</a:t>
             </a:r>
             <a:endParaRPr lang="en-US" sz="1150" dirty="0"/>
           </a:p>
@@ -5452,7 +5541,7 @@
                 <a:ea typeface="Aptos" pitchFamily="34" charset="-122"/>
                 <a:cs typeface="Aptos" pitchFamily="34" charset="-120"/>
               </a:rPr>
-              <a:t>Brief: docs/sharepoint-o365-rag-ingest.md.</a:t>
+              <a:t>Briefs: docs/capability-host-reuse-and-cost.md, docs/existing-vs-foundry-search.md.</a:t>
             </a:r>
             <a:endParaRPr lang="en-US" sz="1150" dirty="0"/>
           </a:p>
@@ -5491,7 +5580,7 @@
                 <a:ea typeface="Aptos" pitchFamily="34" charset="-122"/>
                 <a:cs typeface="Aptos" pitchFamily="34" charset="-120"/>
               </a:rPr>
-              <a:t>Two KP teams want this - A honors permissions for free, B gives control over tokenization.</a:t>
+              <a:t>The 'do we pay for another Search?' answer: usually no - reuse one, safely.</a:t>
             </a:r>
             <a:endParaRPr lang="en-US" sz="1000" dirty="0"/>
           </a:p>
@@ -5610,7 +5699,7 @@
                 <a:ea typeface="Aptos" pitchFamily="34" charset="-122"/>
                 <a:cs typeface="Aptos" pitchFamily="34" charset="-120"/>
               </a:rPr>
-              <a:t>PRIORITY - SARITA</a:t>
+              <a:t>PRIORITY - MATT</a:t>
             </a:r>
             <a:endParaRPr lang="en-US" sz="800" dirty="0"/>
           </a:p>
@@ -5651,7 +5740,7 @@
                 <a:ea typeface="Aptos Display" pitchFamily="34" charset="-122"/>
                 <a:cs typeface="Aptos Display" pitchFamily="34" charset="-120"/>
               </a:rPr>
-              <a:t>Compliance, guardrails, and healthcare content safety</a:t>
+              <a:t>SharePoint / O365 docs as a RAG source</a:t>
             </a:r>
             <a:endParaRPr lang="en-US" sz="2300" dirty="0"/>
           </a:p>
@@ -5774,7 +5863,7 @@
                 <a:ea typeface="Aptos" pitchFamily="34" charset="-122"/>
                 <a:cs typeface="Aptos" pitchFamily="34" charset="-120"/>
               </a:rPr>
-              <a:t>Layered guardrails</a:t>
+              <a:t>Pattern A - live tool</a:t>
             </a:r>
             <a:endParaRPr lang="en-US" sz="1200" dirty="0"/>
           </a:p>
@@ -5815,7 +5904,7 @@
                 <a:ea typeface="Aptos" pitchFamily="34" charset="-122"/>
                 <a:cs typeface="Aptos" pitchFamily="34" charset="-120"/>
               </a:rPr>
-              <a:t>Input, retrieval, tool, generation, output, and approval - each a separate control. Prompts alone are not enough.</a:t>
+              <a:t>Foundry SharePoint tool via the Copilot Retrieval API: per-user OBO honors SharePoint permissions automatically, no pipeline to build.</a:t>
             </a:r>
             <a:endParaRPr lang="en-US" sz="920" dirty="0"/>
           </a:p>
@@ -5870,11 +5959,11 @@
             <a:avLst/>
           </a:prstGeom>
           <a:solidFill>
-            <a:srgbClr val="F59E0B"/>
+            <a:srgbClr val="7C3AED"/>
           </a:solidFill>
           <a:ln w="12700">
             <a:solidFill>
-              <a:srgbClr val="F59E0B"/>
+              <a:srgbClr val="7C3AED"/>
             </a:solidFill>
             <a:prstDash val="solid"/>
           </a:ln>
@@ -5915,7 +6004,7 @@
                 <a:ea typeface="Aptos" pitchFamily="34" charset="-122"/>
                 <a:cs typeface="Aptos" pitchFamily="34" charset="-120"/>
               </a:rPr>
-              <a:t>Medical false positives</a:t>
+              <a:t>Pattern B - indexed</a:t>
             </a:r>
             <a:endParaRPr lang="en-US" sz="1200" dirty="0"/>
           </a:p>
@@ -5956,7 +6045,7 @@
                 <a:ea typeface="Aptos" pitchFamily="34" charset="-122"/>
                 <a:cs typeface="Aptos" pitchFamily="34" charset="-120"/>
               </a:rPr>
-              <a:t>General content filters flag benign clinical language (e.g. a Tylenol question). Fix at the right layer - do not weaken safety globally.</a:t>
+              <a:t>You tokenize / vectorize: crack Office &amp; PDF (Document Intelligence) -&gt; chunk -&gt; embed -&gt; index in AI Search -&gt; ground via Foundry IQ. Full control.</a:t>
             </a:r>
             <a:endParaRPr lang="en-US" sz="920" dirty="0"/>
           </a:p>
@@ -6056,7 +6145,7 @@
                 <a:ea typeface="Aptos" pitchFamily="34" charset="-122"/>
                 <a:cs typeface="Aptos" pitchFamily="34" charset="-120"/>
               </a:rPr>
-              <a:t>The fix + the path</a:t>
+              <a:t>The ACL caveat</a:t>
             </a:r>
             <a:endParaRPr lang="en-US" sz="1200" dirty="0"/>
           </a:p>
@@ -6097,7 +6186,7 @@
                 <a:ea typeface="Aptos" pitchFamily="34" charset="-122"/>
                 <a:cs typeface="Aptos" pitchFamily="34" charset="-120"/>
               </a:rPr>
-              <a:t>App-side allowlist for clinical terms + a custom content filter on the deployment + a false-positive test suite; ticket the product team for genuine filter errors.</a:t>
+              <a:t>The indexed path does NOT auto-honor SharePoint permissions. Restrict the corpus or carry ACLs and security-trim - or use Pattern A.</a:t>
             </a:r>
             <a:endParaRPr lang="en-US" sz="920" dirty="0"/>
           </a:p>
@@ -6139,7 +6228,7 @@
                 <a:ea typeface="Aptos" pitchFamily="34" charset="-122"/>
                 <a:cs typeface="Aptos" pitchFamily="34" charset="-120"/>
               </a:rPr>
-              <a:t>Request, response, and app-side filters are independent knobs - tune the right one.</a:t>
+              <a:t>Choose A for per-user ACLs honored automatically (needs M365 Copilot / PAYG licensing).</a:t>
             </a:r>
             <a:endParaRPr lang="en-US" sz="1150" dirty="0"/>
           </a:p>
@@ -6157,7 +6246,7 @@
                 <a:ea typeface="Aptos" pitchFamily="34" charset="-122"/>
                 <a:cs typeface="Aptos" pitchFamily="34" charset="-120"/>
               </a:rPr>
-              <a:t>Keep a healthcare false-positive suite next to the adversarial suite; both gate release.</a:t>
+              <a:t>Choose B for custom chunking / metadata or a broadly-readable corpus (e.g. approved protocols).</a:t>
             </a:r>
             <a:endParaRPr lang="en-US" sz="1150" dirty="0"/>
           </a:p>
@@ -6175,7 +6264,7 @@
                 <a:ea typeface="Aptos" pitchFamily="34" charset="-122"/>
                 <a:cs typeface="Aptos" pitchFamily="34" charset="-120"/>
               </a:rPr>
-              <a:t>Brief: docs/healthcare-content-safety.md.</a:t>
+              <a:t>Brief: docs/sharepoint-o365-rag-ingest.md.</a:t>
             </a:r>
             <a:endParaRPr lang="en-US" sz="1150" dirty="0"/>
           </a:p>
@@ -6214,7 +6303,7 @@
                 <a:ea typeface="Aptos" pitchFamily="34" charset="-122"/>
                 <a:cs typeface="Aptos" pitchFamily="34" charset="-120"/>
               </a:rPr>
-              <a:t>Never fix a clinical false positive by lowering the global safety bar - tune the layer, encode approved terms.</a:t>
+              <a:t>Two KP teams want this - A honors permissions for free, B gives control over tokenization.</a:t>
             </a:r>
             <a:endParaRPr lang="en-US" sz="1000" dirty="0"/>
           </a:p>
@@ -6333,7 +6422,7 @@
                 <a:ea typeface="Aptos" pitchFamily="34" charset="-122"/>
                 <a:cs typeface="Aptos" pitchFamily="34" charset="-120"/>
               </a:rPr>
-              <a:t>PRIORITY - MATT: THE TIPPING FACTOR</a:t>
+              <a:t>PRIORITY - SARITA</a:t>
             </a:r>
             <a:endParaRPr lang="en-US" sz="800" dirty="0"/>
           </a:p>
@@ -6374,7 +6463,7 @@
                 <a:ea typeface="Aptos Display" pitchFamily="34" charset="-122"/>
                 <a:cs typeface="Aptos Display" pitchFamily="34" charset="-120"/>
               </a:rPr>
-              <a:t>Hosted vs prompt vs custom agent</a:t>
+              <a:t>Compliance, guardrails, and healthcare content safety</a:t>
             </a:r>
             <a:endParaRPr lang="en-US" sz="2300" dirty="0"/>
           </a:p>
@@ -6412,11 +6501,11 @@
         <p:spPr>
           <a:xfrm>
             <a:off x="640080" y="1463040"/>
-            <a:ext cx="3520440" cy="1783080"/>
+            <a:ext cx="3520440" cy="1828800"/>
           </a:xfrm>
           <a:prstGeom prst="roundRect">
             <a:avLst>
-              <a:gd name="adj" fmla="val 4103"/>
+              <a:gd name="adj" fmla="val 4000"/>
             </a:avLst>
           </a:prstGeom>
           <a:solidFill>
@@ -6446,7 +6535,7 @@
         <p:spPr>
           <a:xfrm>
             <a:off x="640080" y="1463040"/>
-            <a:ext cx="64008" cy="1783080"/>
+            <a:ext cx="64008" cy="1828800"/>
           </a:xfrm>
           <a:prstGeom prst="rect">
             <a:avLst/>
@@ -6497,7 +6586,7 @@
                 <a:ea typeface="Aptos" pitchFamily="34" charset="-122"/>
                 <a:cs typeface="Aptos" pitchFamily="34" charset="-120"/>
               </a:rPr>
-              <a:t>Prompt agent</a:t>
+              <a:t>Layered guardrails</a:t>
             </a:r>
             <a:endParaRPr lang="en-US" sz="1200" dirty="0"/>
           </a:p>
@@ -6512,7 +6601,7 @@
         <p:spPr>
           <a:xfrm>
             <a:off x="841248" y="1920240"/>
-            <a:ext cx="3200400" cy="1234440"/>
+            <a:ext cx="3200400" cy="1280160"/>
           </a:xfrm>
           <a:prstGeom prst="rect">
             <a:avLst/>
@@ -6538,7 +6627,7 @@
                 <a:ea typeface="Aptos" pitchFamily="34" charset="-122"/>
                 <a:cs typeface="Aptos" pitchFamily="34" charset="-120"/>
               </a:rPr>
-              <a:t>Instructions + model + tools; Foundry runs it, no code or infra. The fastest path; best without custom orchestration.</a:t>
+              <a:t>Input, retrieval, tool, generation, output, and approval - each a separate control. Prompts alone are not enough.</a:t>
             </a:r>
             <a:endParaRPr lang="en-US" sz="920" dirty="0"/>
           </a:p>
@@ -6553,11 +6642,11 @@
         <p:spPr>
           <a:xfrm>
             <a:off x="4343400" y="1463040"/>
-            <a:ext cx="3520440" cy="1783080"/>
+            <a:ext cx="3520440" cy="1828800"/>
           </a:xfrm>
           <a:prstGeom prst="roundRect">
             <a:avLst>
-              <a:gd name="adj" fmla="val 4103"/>
+              <a:gd name="adj" fmla="val 4000"/>
             </a:avLst>
           </a:prstGeom>
           <a:solidFill>
@@ -6587,17 +6676,17 @@
         <p:spPr>
           <a:xfrm>
             <a:off x="4343400" y="1463040"/>
-            <a:ext cx="64008" cy="1783080"/>
+            <a:ext cx="64008" cy="1828800"/>
           </a:xfrm>
           <a:prstGeom prst="rect">
             <a:avLst/>
           </a:prstGeom>
           <a:solidFill>
-            <a:srgbClr val="7C3AED"/>
+            <a:srgbClr val="F59E0B"/>
           </a:solidFill>
           <a:ln w="12700">
             <a:solidFill>
-              <a:srgbClr val="7C3AED"/>
+              <a:srgbClr val="F59E0B"/>
             </a:solidFill>
             <a:prstDash val="solid"/>
           </a:ln>
@@ -6638,7 +6727,7 @@
                 <a:ea typeface="Aptos" pitchFamily="34" charset="-122"/>
                 <a:cs typeface="Aptos" pitchFamily="34" charset="-120"/>
               </a:rPr>
-              <a:t>Hosted agent</a:t>
+              <a:t>Medical false positives</a:t>
             </a:r>
             <a:endParaRPr lang="en-US" sz="1200" dirty="0"/>
           </a:p>
@@ -6653,7 +6742,7 @@
         <p:spPr>
           <a:xfrm>
             <a:off x="4544568" y="1920240"/>
-            <a:ext cx="3200400" cy="1234440"/>
+            <a:ext cx="3200400" cy="1280160"/>
           </a:xfrm>
           <a:prstGeom prst="rect">
             <a:avLst/>
@@ -6679,7 +6768,7 @@
                 <a:ea typeface="Aptos" pitchFamily="34" charset="-122"/>
                 <a:cs typeface="Aptos" pitchFamily="34" charset="-120"/>
               </a:rPr>
-              <a:t>Your code + framework as a container; Foundry gives a managed endpoint, scaling, identity, and tracing. You own the logic.</a:t>
+              <a:t>General content filters flag benign clinical language (e.g. a Tylenol question). Fix at the right layer - do not weaken safety globally.</a:t>
             </a:r>
             <a:endParaRPr lang="en-US" sz="920" dirty="0"/>
           </a:p>
@@ -6694,11 +6783,11 @@
         <p:spPr>
           <a:xfrm>
             <a:off x="8046720" y="1463040"/>
-            <a:ext cx="3520440" cy="1783080"/>
+            <a:ext cx="3520440" cy="1828800"/>
           </a:xfrm>
           <a:prstGeom prst="roundRect">
             <a:avLst>
-              <a:gd name="adj" fmla="val 4103"/>
+              <a:gd name="adj" fmla="val 4000"/>
             </a:avLst>
           </a:prstGeom>
           <a:solidFill>
@@ -6728,17 +6817,17 @@
         <p:spPr>
           <a:xfrm>
             <a:off x="8046720" y="1463040"/>
-            <a:ext cx="64008" cy="1783080"/>
+            <a:ext cx="64008" cy="1828800"/>
           </a:xfrm>
           <a:prstGeom prst="rect">
             <a:avLst/>
           </a:prstGeom>
           <a:solidFill>
-            <a:srgbClr val="F59E0B"/>
+            <a:srgbClr val="DC2626"/>
           </a:solidFill>
           <a:ln w="12700">
             <a:solidFill>
-              <a:srgbClr val="F59E0B"/>
+              <a:srgbClr val="DC2626"/>
             </a:solidFill>
             <a:prstDash val="solid"/>
           </a:ln>
@@ -6779,7 +6868,7 @@
                 <a:ea typeface="Aptos" pitchFamily="34" charset="-122"/>
                 <a:cs typeface="Aptos" pitchFamily="34" charset="-120"/>
               </a:rPr>
-              <a:t>Self-hosted</a:t>
+              <a:t>The fix + the path</a:t>
             </a:r>
             <a:endParaRPr lang="en-US" sz="1200" dirty="0"/>
           </a:p>
@@ -6794,7 +6883,7 @@
         <p:spPr>
           <a:xfrm>
             <a:off x="8247888" y="1920240"/>
-            <a:ext cx="3200400" cy="1234440"/>
+            <a:ext cx="3200400" cy="1280160"/>
           </a:xfrm>
           <a:prstGeom prst="rect">
             <a:avLst/>
@@ -6820,7 +6909,7 @@
                 <a:ea typeface="Aptos" pitchFamily="34" charset="-122"/>
                 <a:cs typeface="Aptos" pitchFamily="34" charset="-120"/>
               </a:rPr>
-              <a:t>Run the agent elsewhere and call the Responses API for Foundry models + tools. Only when you must own the runtime.</a:t>
+              <a:t>App-side allowlist for clinical terms + a custom content filter on the deployment + a false-positive test suite; ticket the product team for genuine filter errors.</a:t>
             </a:r>
             <a:endParaRPr lang="en-US" sz="920" dirty="0"/>
           </a:p>
@@ -6834,7 +6923,7 @@
         </p:nvSpPr>
         <p:spPr>
           <a:xfrm>
-            <a:off x="640080" y="3429000"/>
+            <a:off x="640080" y="3520440"/>
             <a:ext cx="10972800" cy="2011680"/>
           </a:xfrm>
           <a:prstGeom prst="rect">
@@ -6862,7 +6951,7 @@
                 <a:ea typeface="Aptos" pitchFamily="34" charset="-122"/>
                 <a:cs typeface="Aptos" pitchFamily="34" charset="-120"/>
               </a:rPr>
-              <a:t>Tipping factors -&gt; hosted: custom orchestration, multi-agent handoffs, an existing framework, or your own code.</a:t>
+              <a:t>Request, response, and app-side filters are independent knobs - tune the right one.</a:t>
             </a:r>
             <a:endParaRPr lang="en-US" sz="1150" dirty="0"/>
           </a:p>
@@ -6880,7 +6969,7 @@
                 <a:ea typeface="Aptos" pitchFamily="34" charset="-122"/>
                 <a:cs typeface="Aptos" pitchFamily="34" charset="-120"/>
               </a:rPr>
-              <a:t>Default to a prompt agent; let a real requirement pull you up. Model choice is swappable in all types.</a:t>
+              <a:t>Keep a healthcare false-positive suite next to the adversarial suite; both gate release.</a:t>
             </a:r>
             <a:endParaRPr lang="en-US" sz="1150" dirty="0"/>
           </a:p>
@@ -6898,7 +6987,7 @@
                 <a:ea typeface="Aptos" pitchFamily="34" charset="-122"/>
                 <a:cs typeface="Aptos" pitchFamily="34" charset="-120"/>
               </a:rPr>
-              <a:t>Our multi-agent discharge workflow is exactly the hosted-agent tipping point. Brief: docs/agent-type-decision.md.</a:t>
+              <a:t>Brief: docs/healthcare-content-safety.md.</a:t>
             </a:r>
             <a:endParaRPr lang="en-US" sz="1150" dirty="0"/>
           </a:p>
@@ -6937,7 +7026,7 @@
                 <a:ea typeface="Aptos" pitchFamily="34" charset="-122"/>
                 <a:cs typeface="Aptos" pitchFamily="34" charset="-120"/>
               </a:rPr>
-              <a:t>Start with prompt; graduate to hosted the moment you need orchestration or your own code.</a:t>
+              <a:t>Never fix a clinical false positive by lowering the global safety bar - tune the layer, encode approved terms.</a:t>
             </a:r>
             <a:endParaRPr lang="en-US" sz="1000" dirty="0"/>
           </a:p>
@@ -7056,7 +7145,7 @@
                 <a:ea typeface="Aptos" pitchFamily="34" charset="-122"/>
                 <a:cs typeface="Aptos" pitchFamily="34" charset="-120"/>
               </a:rPr>
-              <a:t>PRIORITY - LEE / DAY 2</a:t>
+              <a:t>PRIORITY - MATT: THE TIPPING FACTOR</a:t>
             </a:r>
             <a:endParaRPr lang="en-US" sz="800" dirty="0"/>
           </a:p>
@@ -7097,7 +7186,7 @@
                 <a:ea typeface="Aptos Display" pitchFamily="34" charset="-122"/>
                 <a:cs typeface="Aptos Display" pitchFamily="34" charset="-120"/>
               </a:rPr>
-              <a:t>Observability, and protecting PHI in logs</a:t>
+              <a:t>Hosted vs prompt vs custom agent</a:t>
             </a:r>
             <a:endParaRPr lang="en-US" sz="2300" dirty="0"/>
           </a:p>
@@ -7135,11 +7224,11 @@
         <p:spPr>
           <a:xfrm>
             <a:off x="640080" y="1463040"/>
-            <a:ext cx="3520440" cy="1828800"/>
+            <a:ext cx="3520440" cy="1783080"/>
           </a:xfrm>
           <a:prstGeom prst="roundRect">
             <a:avLst>
-              <a:gd name="adj" fmla="val 4000"/>
+              <a:gd name="adj" fmla="val 4103"/>
             </a:avLst>
           </a:prstGeom>
           <a:solidFill>
@@ -7169,17 +7258,17 @@
         <p:spPr>
           <a:xfrm>
             <a:off x="640080" y="1463040"/>
-            <a:ext cx="64008" cy="1828800"/>
+            <a:ext cx="64008" cy="1783080"/>
           </a:xfrm>
           <a:prstGeom prst="rect">
             <a:avLst/>
           </a:prstGeom>
           <a:solidFill>
-            <a:srgbClr val="06B6D4"/>
+            <a:srgbClr val="0F766E"/>
           </a:solidFill>
           <a:ln w="12700">
             <a:solidFill>
-              <a:srgbClr val="06B6D4"/>
+              <a:srgbClr val="0F766E"/>
             </a:solidFill>
             <a:prstDash val="solid"/>
           </a:ln>
@@ -7220,7 +7309,7 @@
                 <a:ea typeface="Aptos" pitchFamily="34" charset="-122"/>
                 <a:cs typeface="Aptos" pitchFamily="34" charset="-120"/>
               </a:rPr>
-              <a:t>See every decision</a:t>
+              <a:t>Prompt agent</a:t>
             </a:r>
             <a:endParaRPr lang="en-US" sz="1200" dirty="0"/>
           </a:p>
@@ -7235,7 +7324,7 @@
         <p:spPr>
           <a:xfrm>
             <a:off x="841248" y="1920240"/>
-            <a:ext cx="3200400" cy="1280160"/>
+            <a:ext cx="3200400" cy="1234440"/>
           </a:xfrm>
           <a:prstGeom prst="rect">
             <a:avLst/>
@@ -7261,7 +7350,7 @@
                 <a:ea typeface="Aptos" pitchFamily="34" charset="-122"/>
                 <a:cs typeface="Aptos" pitchFamily="34" charset="-120"/>
               </a:rPr>
-              <a:t>One correlation ID joins agents, tools, policy, retrieval, and the human gate. A stable event taxonomy maps to App Insights custom events.</a:t>
+              <a:t>Instructions + model + tools; Foundry runs it, no code or infra. The fastest path; best without custom orchestration.</a:t>
             </a:r>
             <a:endParaRPr lang="en-US" sz="920" dirty="0"/>
           </a:p>
@@ -7276,11 +7365,11 @@
         <p:spPr>
           <a:xfrm>
             <a:off x="4343400" y="1463040"/>
-            <a:ext cx="3520440" cy="1828800"/>
+            <a:ext cx="3520440" cy="1783080"/>
           </a:xfrm>
           <a:prstGeom prst="roundRect">
             <a:avLst>
-              <a:gd name="adj" fmla="val 4000"/>
+              <a:gd name="adj" fmla="val 4103"/>
             </a:avLst>
           </a:prstGeom>
           <a:solidFill>
@@ -7310,17 +7399,17 @@
         <p:spPr>
           <a:xfrm>
             <a:off x="4343400" y="1463040"/>
-            <a:ext cx="64008" cy="1828800"/>
+            <a:ext cx="64008" cy="1783080"/>
           </a:xfrm>
           <a:prstGeom prst="rect">
             <a:avLst/>
           </a:prstGeom>
           <a:solidFill>
-            <a:srgbClr val="F59E0B"/>
+            <a:srgbClr val="7C3AED"/>
           </a:solidFill>
           <a:ln w="12700">
             <a:solidFill>
-              <a:srgbClr val="F59E0B"/>
+              <a:srgbClr val="7C3AED"/>
             </a:solidFill>
             <a:prstDash val="solid"/>
           </a:ln>
@@ -7361,7 +7450,7 @@
                 <a:ea typeface="Aptos" pitchFamily="34" charset="-122"/>
                 <a:cs typeface="Aptos" pitchFamily="34" charset="-120"/>
               </a:rPr>
-              <a:t>Foundry changes the posture</a:t>
+              <a:t>Hosted agent</a:t>
             </a:r>
             <a:endParaRPr lang="en-US" sz="1200" dirty="0"/>
           </a:p>
@@ -7376,7 +7465,7 @@
         <p:spPr>
           <a:xfrm>
             <a:off x="4544568" y="1920240"/>
-            <a:ext cx="3200400" cy="1280160"/>
+            <a:ext cx="3200400" cy="1234440"/>
           </a:xfrm>
           <a:prstGeom prst="rect">
             <a:avLst/>
@@ -7402,7 +7491,7 @@
                 <a:ea typeface="Aptos" pitchFamily="34" charset="-122"/>
                 <a:cs typeface="Aptos" pitchFamily="34" charset="-120"/>
               </a:rPr>
-              <a:t>Logs can now hold request / response content - possibly PHI. That reclassifies the store from telemetry to regulated data at rest.</a:t>
+              <a:t>Your code + framework as a container; Foundry gives a managed endpoint, scaling, identity, and tracing. You own the logic.</a:t>
             </a:r>
             <a:endParaRPr lang="en-US" sz="920" dirty="0"/>
           </a:p>
@@ -7417,11 +7506,11 @@
         <p:spPr>
           <a:xfrm>
             <a:off x="8046720" y="1463040"/>
-            <a:ext cx="3520440" cy="1828800"/>
+            <a:ext cx="3520440" cy="1783080"/>
           </a:xfrm>
           <a:prstGeom prst="roundRect">
             <a:avLst>
-              <a:gd name="adj" fmla="val 4000"/>
+              <a:gd name="adj" fmla="val 4103"/>
             </a:avLst>
           </a:prstGeom>
           <a:solidFill>
@@ -7451,17 +7540,17 @@
         <p:spPr>
           <a:xfrm>
             <a:off x="8046720" y="1463040"/>
-            <a:ext cx="64008" cy="1828800"/>
+            <a:ext cx="64008" cy="1783080"/>
           </a:xfrm>
           <a:prstGeom prst="rect">
             <a:avLst/>
           </a:prstGeom>
           <a:solidFill>
-            <a:srgbClr val="2563EB"/>
+            <a:srgbClr val="F59E0B"/>
           </a:solidFill>
           <a:ln w="12700">
             <a:solidFill>
-              <a:srgbClr val="2563EB"/>
+              <a:srgbClr val="F59E0B"/>
             </a:solidFill>
             <a:prstDash val="solid"/>
           </a:ln>
@@ -7502,7 +7591,7 @@
                 <a:ea typeface="Aptos" pitchFamily="34" charset="-122"/>
                 <a:cs typeface="Aptos" pitchFamily="34" charset="-120"/>
               </a:rPr>
-              <a:t>Dedicated + CMK + AMPLS</a:t>
+              <a:t>Self-hosted</a:t>
             </a:r>
             <a:endParaRPr lang="en-US" sz="1200" dirty="0"/>
           </a:p>
@@ -7517,7 +7606,7 @@
         <p:spPr>
           <a:xfrm>
             <a:off x="8247888" y="1920240"/>
-            <a:ext cx="3200400" cy="1280160"/>
+            <a:ext cx="3200400" cy="1234440"/>
           </a:xfrm>
           <a:prstGeom prst="rect">
             <a:avLst/>
@@ -7543,7 +7632,7 @@
                 <a:ea typeface="Aptos" pitchFamily="34" charset="-122"/>
                 <a:cs typeface="Aptos" pitchFamily="34" charset="-120"/>
               </a:rPr>
-              <a:t>CMK needs a dedicated LAW cluster (double encryption); AMPLS puts ingestion + query on a private endpoint. Plus minimize what you log.</a:t>
+              <a:t>Run the agent elsewhere and call the Responses API for Foundry models + tools. Only when you must own the runtime.</a:t>
             </a:r>
             <a:endParaRPr lang="en-US" sz="920" dirty="0"/>
           </a:p>
@@ -7557,7 +7646,7 @@
         </p:nvSpPr>
         <p:spPr>
           <a:xfrm>
-            <a:off x="640080" y="3520440"/>
+            <a:off x="640080" y="3429000"/>
             <a:ext cx="10972800" cy="2011680"/>
           </a:xfrm>
           <a:prstGeom prst="rect">
@@ -7585,7 +7674,7 @@
                 <a:ea typeface="Aptos" pitchFamily="34" charset="-122"/>
                 <a:cs typeface="Aptos" pitchFamily="34" charset="-120"/>
               </a:rPr>
-              <a:t>Sensitive content off by default; pseudonymize actors; never capture secrets.</a:t>
+              <a:t>Tipping factors -&gt; hosted: custom orchestration, multi-agent handoffs, an existing framework, or your own code.</a:t>
             </a:r>
             <a:endParaRPr lang="en-US" sz="1150" dirty="0"/>
           </a:p>
@@ -7603,7 +7692,7 @@
                 <a:ea typeface="Aptos" pitchFamily="34" charset="-122"/>
                 <a:cs typeface="Aptos" pitchFamily="34" charset="-120"/>
               </a:rPr>
-              <a:t>Start with the Foundry workspace on the dedicated cluster; KP volume makes it cost-favorable.</a:t>
+              <a:t>Default to a prompt agent; let a real requirement pull you up. Model choice is swappable in all types.</a:t>
             </a:r>
             <a:endParaRPr lang="en-US" sz="1150" dirty="0"/>
           </a:p>
@@ -7621,7 +7710,7 @@
                 <a:ea typeface="Aptos" pitchFamily="34" charset="-122"/>
                 <a:cs typeface="Aptos" pitchFamily="34" charset="-120"/>
               </a:rPr>
-              <a:t>Brief: docs/observability-dedicated-cluster-cmk-ampls.md (Lee leads Day 2).</a:t>
+              <a:t>Our multi-agent discharge workflow is exactly the hosted-agent tipping point. Brief: docs/agent-type-decision.md.</a:t>
             </a:r>
             <a:endParaRPr lang="en-US" sz="1150" dirty="0"/>
           </a:p>
@@ -7660,7 +7749,7 @@
                 <a:ea typeface="Aptos" pitchFamily="34" charset="-122"/>
                 <a:cs typeface="Aptos" pitchFamily="34" charset="-120"/>
               </a:rPr>
-              <a:t>Minimize at the source, CMK-encrypt what remains, keep it on the private network.</a:t>
+              <a:t>Start with prompt; graduate to hosted the moment you need orchestration or your own code.</a:t>
             </a:r>
             <a:endParaRPr lang="en-US" sz="1000" dirty="0"/>
           </a:p>
@@ -7779,7 +7868,7 @@
                 <a:ea typeface="Aptos" pitchFamily="34" charset="-122"/>
                 <a:cs typeface="Aptos" pitchFamily="34" charset="-120"/>
               </a:rPr>
-              <a:t>PRIORITY - DAY 2</a:t>
+              <a:t>PRIORITY - LEE / DAY 2</a:t>
             </a:r>
             <a:endParaRPr lang="en-US" sz="800" dirty="0"/>
           </a:p>
@@ -7820,7 +7909,7 @@
                 <a:ea typeface="Aptos Display" pitchFamily="34" charset="-122"/>
                 <a:cs typeface="Aptos Display" pitchFamily="34" charset="-120"/>
               </a:rPr>
-              <a:t>Human in the loop: the durable approval gate</a:t>
+              <a:t>Observability, and protecting PHI in logs</a:t>
             </a:r>
             <a:endParaRPr lang="en-US" sz="2300" dirty="0"/>
           </a:p>
@@ -7898,11 +7987,11 @@
             <a:avLst/>
           </a:prstGeom>
           <a:solidFill>
-            <a:srgbClr val="F59E0B"/>
+            <a:srgbClr val="06B6D4"/>
           </a:solidFill>
           <a:ln w="12700">
             <a:solidFill>
-              <a:srgbClr val="F59E0B"/>
+              <a:srgbClr val="06B6D4"/>
             </a:solidFill>
             <a:prstDash val="solid"/>
           </a:ln>
@@ -7943,7 +8032,7 @@
                 <a:ea typeface="Aptos" pitchFamily="34" charset="-122"/>
                 <a:cs typeface="Aptos" pitchFamily="34" charset="-120"/>
               </a:rPr>
-              <a:t>The gate</a:t>
+              <a:t>See every decision</a:t>
             </a:r>
             <a:endParaRPr lang="en-US" sz="1200" dirty="0"/>
           </a:p>
@@ -7984,7 +8073,7 @@
                 <a:ea typeface="Aptos" pitchFamily="34" charset="-122"/>
                 <a:cs typeface="Aptos" pitchFamily="34" charset="-120"/>
               </a:rPr>
-              <a:t>Every run drafts an exception packet, then STOPS at a care-manager approval gate. The agent drafts and reworks only; a human owns approve / reject.</a:t>
+              <a:t>One correlation ID joins agents, tools, policy, retrieval, and the human gate. A stable event taxonomy maps to App Insights custom events.</a:t>
             </a:r>
             <a:endParaRPr lang="en-US" sz="920" dirty="0"/>
           </a:p>
@@ -8039,11 +8128,11 @@
             <a:avLst/>
           </a:prstGeom>
           <a:solidFill>
-            <a:srgbClr val="0F766E"/>
+            <a:srgbClr val="F59E0B"/>
           </a:solidFill>
           <a:ln w="12700">
             <a:solidFill>
-              <a:srgbClr val="0F766E"/>
+              <a:srgbClr val="F59E0B"/>
             </a:solidFill>
             <a:prstDash val="solid"/>
           </a:ln>
@@ -8084,7 +8173,7 @@
                 <a:ea typeface="Aptos" pitchFamily="34" charset="-122"/>
                 <a:cs typeface="Aptos" pitchFamily="34" charset="-120"/>
               </a:rPr>
-              <a:t>Durable + auditable</a:t>
+              <a:t>Foundry changes the posture</a:t>
             </a:r>
             <a:endParaRPr lang="en-US" sz="1200" dirty="0"/>
           </a:p>
@@ -8125,7 +8214,7 @@
                 <a:ea typeface="Aptos" pitchFamily="34" charset="-122"/>
                 <a:cs typeface="Aptos" pitchFamily="34" charset="-120"/>
               </a:rPr>
-              <a:t>PendingReview -&gt; Approved / NeedsRework / Rejected; SLA timeout or policy -&gt; Escalated. Every transition writes an append-only audit record.</a:t>
+              <a:t>Logs can now hold request / response content - possibly PHI. That reclassifies the store from telemetry to regulated data at rest.</a:t>
             </a:r>
             <a:endParaRPr lang="en-US" sz="920" dirty="0"/>
           </a:p>
@@ -8180,11 +8269,11 @@
             <a:avLst/>
           </a:prstGeom>
           <a:solidFill>
-            <a:srgbClr val="7C3AED"/>
+            <a:srgbClr val="2563EB"/>
           </a:solidFill>
           <a:ln w="12700">
             <a:solidFill>
-              <a:srgbClr val="7C3AED"/>
+              <a:srgbClr val="2563EB"/>
             </a:solidFill>
             <a:prstDash val="solid"/>
           </a:ln>
@@ -8225,7 +8314,7 @@
                 <a:ea typeface="Aptos" pitchFamily="34" charset="-122"/>
                 <a:cs typeface="Aptos" pitchFamily="34" charset="-120"/>
               </a:rPr>
-              <a:t>Scales to zero waiting</a:t>
+              <a:t>Dedicated + CMK + AMPLS</a:t>
             </a:r>
             <a:endParaRPr lang="en-US" sz="1200" dirty="0"/>
           </a:p>
@@ -8266,7 +8355,7 @@
                 <a:ea typeface="Aptos" pitchFamily="34" charset="-122"/>
                 <a:cs typeface="Aptos" pitchFamily="34" charset="-120"/>
               </a:rPr>
-              <a:t>On the Durable Task Scheduler the run pauses on an external event + durable timer - a review can safely take hours or days, consuming no compute.</a:t>
+              <a:t>CMK needs a dedicated LAW cluster (double encryption); AMPLS puts ingestion + query on a private endpoint. Plus minimize what you log.</a:t>
             </a:r>
             <a:endParaRPr lang="en-US" sz="920" dirty="0"/>
           </a:p>
@@ -8308,7 +8397,7 @@
                 <a:ea typeface="Aptos" pitchFamily="34" charset="-122"/>
                 <a:cs typeface="Aptos" pitchFamily="34" charset="-120"/>
               </a:rPr>
-              <a:t>Guardrails in code: illegal transition -&gt; 409; an agent trying to approve -&gt; 403.</a:t>
+              <a:t>Sensitive content off by default; pseudonymize actors; never capture secrets.</a:t>
             </a:r>
             <a:endParaRPr lang="en-US" sz="1150" dirty="0"/>
           </a:p>
@@ -8326,7 +8415,7 @@
                 <a:ea typeface="Aptos" pitchFamily="34" charset="-122"/>
                 <a:cs typeface="Aptos" pitchFamily="34" charset="-120"/>
               </a:rPr>
-              <a:t>Live and verified end to end in the deployed app against the real Durable Task Scheduler.</a:t>
+              <a:t>Start with the Foundry workspace on the dedicated cluster; KP volume makes it cost-favorable.</a:t>
             </a:r>
             <a:endParaRPr lang="en-US" sz="1150" dirty="0"/>
           </a:p>
@@ -8344,7 +8433,7 @@
                 <a:ea typeface="Aptos" pitchFamily="34" charset="-122"/>
                 <a:cs typeface="Aptos" pitchFamily="34" charset="-120"/>
               </a:rPr>
-              <a:t>Brief / doc: docs/hitl-durable-task-scheduler.md.</a:t>
+              <a:t>Brief: docs/observability-dedicated-cluster-cmk-ampls.md (Lee leads Day 2).</a:t>
             </a:r>
             <a:endParaRPr lang="en-US" sz="1150" dirty="0"/>
           </a:p>
@@ -8383,7 +8472,7 @@
                 <a:ea typeface="Aptos" pitchFamily="34" charset="-122"/>
                 <a:cs typeface="Aptos" pitchFamily="34" charset="-120"/>
               </a:rPr>
-              <a:t>A governed workflow must pause for a human - durably, with an audit trail.</a:t>
+              <a:t>Minimize at the source, CMK-encrypt what remains, keep it on the private network.</a:t>
             </a:r>
             <a:endParaRPr lang="en-US" sz="1000" dirty="0"/>
           </a:p>
@@ -8448,6 +8537,729 @@
 <file path=ppt/slides/slide17.xml><?xml version="1.0" encoding="utf-8"?>
 <p:sld xmlns:a="http://schemas.openxmlformats.org/drawingml/2006/main" xmlns:r="http://schemas.openxmlformats.org/officeDocument/2006/relationships" xmlns:p="http://schemas.openxmlformats.org/presentationml/2006/main">
   <p:cSld name="Slide 17">
+    <p:bg>
+      <p:bgPr>
+        <a:solidFill>
+          <a:srgbClr val="F8FAFC"/>
+        </a:solidFill>
+      </p:bgPr>
+    </p:bg>
+    <p:spTree>
+      <p:nvGrpSpPr>
+        <p:cNvPr id="1" name=""/>
+        <p:cNvGrpSpPr/>
+        <p:nvPr/>
+      </p:nvGrpSpPr>
+      <p:grpSpPr>
+        <a:xfrm>
+          <a:off x="0" y="0"/>
+          <a:ext cx="0" cy="0"/>
+          <a:chOff x="0" y="0"/>
+          <a:chExt cx="0" cy="0"/>
+        </a:xfrm>
+      </p:grpSpPr>
+      <p:sp>
+        <p:nvSpPr>
+          <p:cNvPr id="2" name="Text 0"/>
+          <p:cNvSpPr/>
+          <p:nvPr/>
+        </p:nvSpPr>
+        <p:spPr>
+          <a:xfrm>
+            <a:off x="566928" y="384048"/>
+            <a:ext cx="10789920" cy="201168"/>
+          </a:xfrm>
+          <a:prstGeom prst="rect">
+            <a:avLst/>
+          </a:prstGeom>
+          <a:noFill/>
+          <a:ln/>
+        </p:spPr>
+        <p:txBody>
+          <a:bodyPr wrap="square" lIns="0" tIns="0" rIns="0" bIns="0" rtlCol="0" anchor="ctr"/>
+          <a:lstStyle/>
+          <a:p>
+            <a:pPr indent="0" marL="0">
+              <a:buNone/>
+            </a:pPr>
+            <a:r>
+              <a:rPr lang="en-US" sz="800" b="1" dirty="0">
+                <a:solidFill>
+                  <a:srgbClr val="0F766E"/>
+                </a:solidFill>
+                <a:latin typeface="Aptos" pitchFamily="34" charset="0"/>
+                <a:ea typeface="Aptos" pitchFamily="34" charset="-122"/>
+                <a:cs typeface="Aptos" pitchFamily="34" charset="-120"/>
+              </a:rPr>
+              <a:t>PRIORITY - DAY 2</a:t>
+            </a:r>
+            <a:endParaRPr lang="en-US" sz="800" dirty="0"/>
+          </a:p>
+        </p:txBody>
+      </p:sp>
+      <p:sp>
+        <p:nvSpPr>
+          <p:cNvPr id="3" name="Text 1"/>
+          <p:cNvSpPr/>
+          <p:nvPr/>
+        </p:nvSpPr>
+        <p:spPr>
+          <a:xfrm>
+            <a:off x="548640" y="658368"/>
+            <a:ext cx="11064240" cy="502920"/>
+          </a:xfrm>
+          <a:prstGeom prst="rect">
+            <a:avLst/>
+          </a:prstGeom>
+          <a:noFill/>
+          <a:ln/>
+        </p:spPr>
+        <p:txBody>
+          <a:bodyPr wrap="square" lIns="0" tIns="0" rIns="0" bIns="0" rtlCol="0" anchor="ctr">
+            <a:normAutofit/>
+          </a:bodyPr>
+          <a:lstStyle/>
+          <a:p>
+            <a:pPr indent="0" marL="0">
+              <a:buNone/>
+            </a:pPr>
+            <a:r>
+              <a:rPr lang="en-US" sz="2300" b="1" dirty="0">
+                <a:solidFill>
+                  <a:srgbClr val="0B1220"/>
+                </a:solidFill>
+                <a:latin typeface="Aptos Display" pitchFamily="34" charset="0"/>
+                <a:ea typeface="Aptos Display" pitchFamily="34" charset="-122"/>
+                <a:cs typeface="Aptos Display" pitchFamily="34" charset="-120"/>
+              </a:rPr>
+              <a:t>Human in the loop: the durable approval gate</a:t>
+            </a:r>
+            <a:endParaRPr lang="en-US" sz="2300" dirty="0"/>
+          </a:p>
+        </p:txBody>
+      </p:sp>
+      <p:sp>
+        <p:nvSpPr>
+          <p:cNvPr id="4" name="Shape 2"/>
+          <p:cNvSpPr/>
+          <p:nvPr/>
+        </p:nvSpPr>
+        <p:spPr>
+          <a:xfrm>
+            <a:off x="548640" y="1243584"/>
+            <a:ext cx="11064240" cy="0"/>
+          </a:xfrm>
+          <a:prstGeom prst="line">
+            <a:avLst/>
+          </a:prstGeom>
+          <a:noFill/>
+          <a:ln w="12700">
+            <a:solidFill>
+              <a:srgbClr val="CBD5E1"/>
+            </a:solidFill>
+            <a:prstDash val="solid"/>
+          </a:ln>
+        </p:spPr>
+      </p:sp>
+      <p:sp>
+        <p:nvSpPr>
+          <p:cNvPr id="5" name="Shape 3"/>
+          <p:cNvSpPr/>
+          <p:nvPr/>
+        </p:nvSpPr>
+        <p:spPr>
+          <a:xfrm>
+            <a:off x="640080" y="1463040"/>
+            <a:ext cx="3520440" cy="1828800"/>
+          </a:xfrm>
+          <a:prstGeom prst="roundRect">
+            <a:avLst>
+              <a:gd name="adj" fmla="val 4000"/>
+            </a:avLst>
+          </a:prstGeom>
+          <a:solidFill>
+            <a:srgbClr val="FFFFFF"/>
+          </a:solidFill>
+          <a:ln w="12700">
+            <a:solidFill>
+              <a:srgbClr val="E2E8F0"/>
+            </a:solidFill>
+            <a:prstDash val="solid"/>
+          </a:ln>
+          <a:effectLst>
+            <a:outerShdw sx="100000" sy="100000" kx="0" ky="0" algn="bl" rotWithShape="0" blurRad="25400" dist="50800" dir="2700000">
+              <a:srgbClr val="94A3B8">
+                <a:alpha val="12000"/>
+              </a:srgbClr>
+            </a:outerShdw>
+          </a:effectLst>
+        </p:spPr>
+      </p:sp>
+      <p:sp>
+        <p:nvSpPr>
+          <p:cNvPr id="6" name="Shape 4"/>
+          <p:cNvSpPr/>
+          <p:nvPr/>
+        </p:nvSpPr>
+        <p:spPr>
+          <a:xfrm>
+            <a:off x="640080" y="1463040"/>
+            <a:ext cx="64008" cy="1828800"/>
+          </a:xfrm>
+          <a:prstGeom prst="rect">
+            <a:avLst/>
+          </a:prstGeom>
+          <a:solidFill>
+            <a:srgbClr val="F59E0B"/>
+          </a:solidFill>
+          <a:ln w="12700">
+            <a:solidFill>
+              <a:srgbClr val="F59E0B"/>
+            </a:solidFill>
+            <a:prstDash val="solid"/>
+          </a:ln>
+        </p:spPr>
+      </p:sp>
+      <p:sp>
+        <p:nvSpPr>
+          <p:cNvPr id="7" name="Text 5"/>
+          <p:cNvSpPr/>
+          <p:nvPr/>
+        </p:nvSpPr>
+        <p:spPr>
+          <a:xfrm>
+            <a:off x="841248" y="1609344"/>
+            <a:ext cx="3200400" cy="219456"/>
+          </a:xfrm>
+          <a:prstGeom prst="rect">
+            <a:avLst/>
+          </a:prstGeom>
+          <a:noFill/>
+          <a:ln/>
+        </p:spPr>
+        <p:txBody>
+          <a:bodyPr wrap="square" lIns="0" tIns="0" rIns="0" bIns="0" rtlCol="0" anchor="ctr">
+            <a:normAutofit/>
+          </a:bodyPr>
+          <a:lstStyle/>
+          <a:p>
+            <a:pPr indent="0" marL="0">
+              <a:buNone/>
+            </a:pPr>
+            <a:r>
+              <a:rPr lang="en-US" sz="1200" b="1" dirty="0">
+                <a:solidFill>
+                  <a:srgbClr val="0B1220"/>
+                </a:solidFill>
+                <a:latin typeface="Aptos" pitchFamily="34" charset="0"/>
+                <a:ea typeface="Aptos" pitchFamily="34" charset="-122"/>
+                <a:cs typeface="Aptos" pitchFamily="34" charset="-120"/>
+              </a:rPr>
+              <a:t>The gate</a:t>
+            </a:r>
+            <a:endParaRPr lang="en-US" sz="1200" dirty="0"/>
+          </a:p>
+        </p:txBody>
+      </p:sp>
+      <p:sp>
+        <p:nvSpPr>
+          <p:cNvPr id="8" name="Text 6"/>
+          <p:cNvSpPr/>
+          <p:nvPr/>
+        </p:nvSpPr>
+        <p:spPr>
+          <a:xfrm>
+            <a:off x="841248" y="1920240"/>
+            <a:ext cx="3200400" cy="1280160"/>
+          </a:xfrm>
+          <a:prstGeom prst="rect">
+            <a:avLst/>
+          </a:prstGeom>
+          <a:noFill/>
+          <a:ln/>
+        </p:spPr>
+        <p:txBody>
+          <a:bodyPr wrap="square" lIns="254" tIns="254" rIns="254" bIns="254" rtlCol="0" anchor="t">
+            <a:normAutofit/>
+          </a:bodyPr>
+          <a:lstStyle/>
+          <a:p>
+            <a:pPr indent="0" marL="0">
+              <a:buNone/>
+            </a:pPr>
+            <a:r>
+              <a:rPr lang="en-US" sz="920" dirty="0">
+                <a:solidFill>
+                  <a:srgbClr val="334155"/>
+                </a:solidFill>
+                <a:latin typeface="Aptos" pitchFamily="34" charset="0"/>
+                <a:ea typeface="Aptos" pitchFamily="34" charset="-122"/>
+                <a:cs typeface="Aptos" pitchFamily="34" charset="-120"/>
+              </a:rPr>
+              <a:t>Every run drafts an exception packet, then STOPS at a care-manager approval gate. The agent drafts and reworks only; a human owns approve / reject.</a:t>
+            </a:r>
+            <a:endParaRPr lang="en-US" sz="920" dirty="0"/>
+          </a:p>
+        </p:txBody>
+      </p:sp>
+      <p:sp>
+        <p:nvSpPr>
+          <p:cNvPr id="9" name="Shape 7"/>
+          <p:cNvSpPr/>
+          <p:nvPr/>
+        </p:nvSpPr>
+        <p:spPr>
+          <a:xfrm>
+            <a:off x="4343400" y="1463040"/>
+            <a:ext cx="3520440" cy="1828800"/>
+          </a:xfrm>
+          <a:prstGeom prst="roundRect">
+            <a:avLst>
+              <a:gd name="adj" fmla="val 4000"/>
+            </a:avLst>
+          </a:prstGeom>
+          <a:solidFill>
+            <a:srgbClr val="FFFFFF"/>
+          </a:solidFill>
+          <a:ln w="12700">
+            <a:solidFill>
+              <a:srgbClr val="E2E8F0"/>
+            </a:solidFill>
+            <a:prstDash val="solid"/>
+          </a:ln>
+          <a:effectLst>
+            <a:outerShdw sx="100000" sy="100000" kx="0" ky="0" algn="bl" rotWithShape="0" blurRad="25400" dist="50800" dir="2700000">
+              <a:srgbClr val="94A3B8">
+                <a:alpha val="12000"/>
+              </a:srgbClr>
+            </a:outerShdw>
+          </a:effectLst>
+        </p:spPr>
+      </p:sp>
+      <p:sp>
+        <p:nvSpPr>
+          <p:cNvPr id="10" name="Shape 8"/>
+          <p:cNvSpPr/>
+          <p:nvPr/>
+        </p:nvSpPr>
+        <p:spPr>
+          <a:xfrm>
+            <a:off x="4343400" y="1463040"/>
+            <a:ext cx="64008" cy="1828800"/>
+          </a:xfrm>
+          <a:prstGeom prst="rect">
+            <a:avLst/>
+          </a:prstGeom>
+          <a:solidFill>
+            <a:srgbClr val="0F766E"/>
+          </a:solidFill>
+          <a:ln w="12700">
+            <a:solidFill>
+              <a:srgbClr val="0F766E"/>
+            </a:solidFill>
+            <a:prstDash val="solid"/>
+          </a:ln>
+        </p:spPr>
+      </p:sp>
+      <p:sp>
+        <p:nvSpPr>
+          <p:cNvPr id="11" name="Text 9"/>
+          <p:cNvSpPr/>
+          <p:nvPr/>
+        </p:nvSpPr>
+        <p:spPr>
+          <a:xfrm>
+            <a:off x="4544568" y="1609344"/>
+            <a:ext cx="3200400" cy="219456"/>
+          </a:xfrm>
+          <a:prstGeom prst="rect">
+            <a:avLst/>
+          </a:prstGeom>
+          <a:noFill/>
+          <a:ln/>
+        </p:spPr>
+        <p:txBody>
+          <a:bodyPr wrap="square" lIns="0" tIns="0" rIns="0" bIns="0" rtlCol="0" anchor="ctr">
+            <a:normAutofit/>
+          </a:bodyPr>
+          <a:lstStyle/>
+          <a:p>
+            <a:pPr indent="0" marL="0">
+              <a:buNone/>
+            </a:pPr>
+            <a:r>
+              <a:rPr lang="en-US" sz="1200" b="1" dirty="0">
+                <a:solidFill>
+                  <a:srgbClr val="0B1220"/>
+                </a:solidFill>
+                <a:latin typeface="Aptos" pitchFamily="34" charset="0"/>
+                <a:ea typeface="Aptos" pitchFamily="34" charset="-122"/>
+                <a:cs typeface="Aptos" pitchFamily="34" charset="-120"/>
+              </a:rPr>
+              <a:t>Durable + auditable</a:t>
+            </a:r>
+            <a:endParaRPr lang="en-US" sz="1200" dirty="0"/>
+          </a:p>
+        </p:txBody>
+      </p:sp>
+      <p:sp>
+        <p:nvSpPr>
+          <p:cNvPr id="12" name="Text 10"/>
+          <p:cNvSpPr/>
+          <p:nvPr/>
+        </p:nvSpPr>
+        <p:spPr>
+          <a:xfrm>
+            <a:off x="4544568" y="1920240"/>
+            <a:ext cx="3200400" cy="1280160"/>
+          </a:xfrm>
+          <a:prstGeom prst="rect">
+            <a:avLst/>
+          </a:prstGeom>
+          <a:noFill/>
+          <a:ln/>
+        </p:spPr>
+        <p:txBody>
+          <a:bodyPr wrap="square" lIns="254" tIns="254" rIns="254" bIns="254" rtlCol="0" anchor="t">
+            <a:normAutofit/>
+          </a:bodyPr>
+          <a:lstStyle/>
+          <a:p>
+            <a:pPr indent="0" marL="0">
+              <a:buNone/>
+            </a:pPr>
+            <a:r>
+              <a:rPr lang="en-US" sz="920" dirty="0">
+                <a:solidFill>
+                  <a:srgbClr val="334155"/>
+                </a:solidFill>
+                <a:latin typeface="Aptos" pitchFamily="34" charset="0"/>
+                <a:ea typeface="Aptos" pitchFamily="34" charset="-122"/>
+                <a:cs typeface="Aptos" pitchFamily="34" charset="-120"/>
+              </a:rPr>
+              <a:t>PendingReview -&gt; Approved / NeedsRework / Rejected; SLA timeout or policy -&gt; Escalated. Every transition writes an append-only audit record.</a:t>
+            </a:r>
+            <a:endParaRPr lang="en-US" sz="920" dirty="0"/>
+          </a:p>
+        </p:txBody>
+      </p:sp>
+      <p:sp>
+        <p:nvSpPr>
+          <p:cNvPr id="13" name="Shape 11"/>
+          <p:cNvSpPr/>
+          <p:nvPr/>
+        </p:nvSpPr>
+        <p:spPr>
+          <a:xfrm>
+            <a:off x="8046720" y="1463040"/>
+            <a:ext cx="3520440" cy="1828800"/>
+          </a:xfrm>
+          <a:prstGeom prst="roundRect">
+            <a:avLst>
+              <a:gd name="adj" fmla="val 4000"/>
+            </a:avLst>
+          </a:prstGeom>
+          <a:solidFill>
+            <a:srgbClr val="FFFFFF"/>
+          </a:solidFill>
+          <a:ln w="12700">
+            <a:solidFill>
+              <a:srgbClr val="E2E8F0"/>
+            </a:solidFill>
+            <a:prstDash val="solid"/>
+          </a:ln>
+          <a:effectLst>
+            <a:outerShdw sx="100000" sy="100000" kx="0" ky="0" algn="bl" rotWithShape="0" blurRad="25400" dist="50800" dir="2700000">
+              <a:srgbClr val="94A3B8">
+                <a:alpha val="12000"/>
+              </a:srgbClr>
+            </a:outerShdw>
+          </a:effectLst>
+        </p:spPr>
+      </p:sp>
+      <p:sp>
+        <p:nvSpPr>
+          <p:cNvPr id="14" name="Shape 12"/>
+          <p:cNvSpPr/>
+          <p:nvPr/>
+        </p:nvSpPr>
+        <p:spPr>
+          <a:xfrm>
+            <a:off x="8046720" y="1463040"/>
+            <a:ext cx="64008" cy="1828800"/>
+          </a:xfrm>
+          <a:prstGeom prst="rect">
+            <a:avLst/>
+          </a:prstGeom>
+          <a:solidFill>
+            <a:srgbClr val="7C3AED"/>
+          </a:solidFill>
+          <a:ln w="12700">
+            <a:solidFill>
+              <a:srgbClr val="7C3AED"/>
+            </a:solidFill>
+            <a:prstDash val="solid"/>
+          </a:ln>
+        </p:spPr>
+      </p:sp>
+      <p:sp>
+        <p:nvSpPr>
+          <p:cNvPr id="15" name="Text 13"/>
+          <p:cNvSpPr/>
+          <p:nvPr/>
+        </p:nvSpPr>
+        <p:spPr>
+          <a:xfrm>
+            <a:off x="8247888" y="1609344"/>
+            <a:ext cx="3200400" cy="219456"/>
+          </a:xfrm>
+          <a:prstGeom prst="rect">
+            <a:avLst/>
+          </a:prstGeom>
+          <a:noFill/>
+          <a:ln/>
+        </p:spPr>
+        <p:txBody>
+          <a:bodyPr wrap="square" lIns="0" tIns="0" rIns="0" bIns="0" rtlCol="0" anchor="ctr">
+            <a:normAutofit/>
+          </a:bodyPr>
+          <a:lstStyle/>
+          <a:p>
+            <a:pPr indent="0" marL="0">
+              <a:buNone/>
+            </a:pPr>
+            <a:r>
+              <a:rPr lang="en-US" sz="1200" b="1" dirty="0">
+                <a:solidFill>
+                  <a:srgbClr val="0B1220"/>
+                </a:solidFill>
+                <a:latin typeface="Aptos" pitchFamily="34" charset="0"/>
+                <a:ea typeface="Aptos" pitchFamily="34" charset="-122"/>
+                <a:cs typeface="Aptos" pitchFamily="34" charset="-120"/>
+              </a:rPr>
+              <a:t>Scales to zero waiting</a:t>
+            </a:r>
+            <a:endParaRPr lang="en-US" sz="1200" dirty="0"/>
+          </a:p>
+        </p:txBody>
+      </p:sp>
+      <p:sp>
+        <p:nvSpPr>
+          <p:cNvPr id="16" name="Text 14"/>
+          <p:cNvSpPr/>
+          <p:nvPr/>
+        </p:nvSpPr>
+        <p:spPr>
+          <a:xfrm>
+            <a:off x="8247888" y="1920240"/>
+            <a:ext cx="3200400" cy="1280160"/>
+          </a:xfrm>
+          <a:prstGeom prst="rect">
+            <a:avLst/>
+          </a:prstGeom>
+          <a:noFill/>
+          <a:ln/>
+        </p:spPr>
+        <p:txBody>
+          <a:bodyPr wrap="square" lIns="254" tIns="254" rIns="254" bIns="254" rtlCol="0" anchor="t">
+            <a:normAutofit/>
+          </a:bodyPr>
+          <a:lstStyle/>
+          <a:p>
+            <a:pPr indent="0" marL="0">
+              <a:buNone/>
+            </a:pPr>
+            <a:r>
+              <a:rPr lang="en-US" sz="920" dirty="0">
+                <a:solidFill>
+                  <a:srgbClr val="334155"/>
+                </a:solidFill>
+                <a:latin typeface="Aptos" pitchFamily="34" charset="0"/>
+                <a:ea typeface="Aptos" pitchFamily="34" charset="-122"/>
+                <a:cs typeface="Aptos" pitchFamily="34" charset="-120"/>
+              </a:rPr>
+              <a:t>On the Durable Task Scheduler the run pauses on an external event + durable timer - a review can safely take hours or days, consuming no compute.</a:t>
+            </a:r>
+            <a:endParaRPr lang="en-US" sz="920" dirty="0"/>
+          </a:p>
+        </p:txBody>
+      </p:sp>
+      <p:sp>
+        <p:nvSpPr>
+          <p:cNvPr id="17" name="Text 15"/>
+          <p:cNvSpPr/>
+          <p:nvPr/>
+        </p:nvSpPr>
+        <p:spPr>
+          <a:xfrm>
+            <a:off x="640080" y="3520440"/>
+            <a:ext cx="10972800" cy="2011680"/>
+          </a:xfrm>
+          <a:prstGeom prst="rect">
+            <a:avLst/>
+          </a:prstGeom>
+          <a:noFill/>
+          <a:ln/>
+        </p:spPr>
+        <p:txBody>
+          <a:bodyPr wrap="square" lIns="381" tIns="381" rIns="381" bIns="381" rtlCol="0" anchor="ctr">
+            <a:normAutofit/>
+          </a:bodyPr>
+          <a:lstStyle/>
+          <a:p>
+            <a:pPr marL="152400" indent="-152400">
+              <a:buSzPct val="100000"/>
+              <a:buChar char="•"/>
+            </a:pPr>
+            <a:r>
+              <a:rPr lang="en-US" sz="1150" dirty="0">
+                <a:solidFill>
+                  <a:srgbClr val="334155"/>
+                </a:solidFill>
+                <a:latin typeface="Aptos" pitchFamily="34" charset="0"/>
+                <a:ea typeface="Aptos" pitchFamily="34" charset="-122"/>
+                <a:cs typeface="Aptos" pitchFamily="34" charset="-120"/>
+              </a:rPr>
+              <a:t>Guardrails in code: illegal transition -&gt; 409; an agent trying to approve -&gt; 403.</a:t>
+            </a:r>
+            <a:endParaRPr lang="en-US" sz="1150" dirty="0"/>
+          </a:p>
+          <a:p>
+            <a:pPr marL="152400" indent="-152400">
+              <a:buSzPct val="100000"/>
+              <a:buChar char="•"/>
+            </a:pPr>
+            <a:r>
+              <a:rPr lang="en-US" sz="1150" dirty="0">
+                <a:solidFill>
+                  <a:srgbClr val="334155"/>
+                </a:solidFill>
+                <a:latin typeface="Aptos" pitchFamily="34" charset="0"/>
+                <a:ea typeface="Aptos" pitchFamily="34" charset="-122"/>
+                <a:cs typeface="Aptos" pitchFamily="34" charset="-120"/>
+              </a:rPr>
+              <a:t>Live and verified end to end in the deployed app against the real Durable Task Scheduler.</a:t>
+            </a:r>
+            <a:endParaRPr lang="en-US" sz="1150" dirty="0"/>
+          </a:p>
+          <a:p>
+            <a:pPr marL="152400" indent="-152400">
+              <a:buSzPct val="100000"/>
+              <a:buChar char="•"/>
+            </a:pPr>
+            <a:r>
+              <a:rPr lang="en-US" sz="1150" dirty="0">
+                <a:solidFill>
+                  <a:srgbClr val="334155"/>
+                </a:solidFill>
+                <a:latin typeface="Aptos" pitchFamily="34" charset="0"/>
+                <a:ea typeface="Aptos" pitchFamily="34" charset="-122"/>
+                <a:cs typeface="Aptos" pitchFamily="34" charset="-120"/>
+              </a:rPr>
+              <a:t>Brief / doc: docs/hitl-durable-task-scheduler.md.</a:t>
+            </a:r>
+            <a:endParaRPr lang="en-US" sz="1150" dirty="0"/>
+          </a:p>
+        </p:txBody>
+      </p:sp>
+      <p:sp>
+        <p:nvSpPr>
+          <p:cNvPr id="18" name="Text 16"/>
+          <p:cNvSpPr/>
+          <p:nvPr/>
+        </p:nvSpPr>
+        <p:spPr>
+          <a:xfrm>
+            <a:off x="640080" y="5806440"/>
+            <a:ext cx="10972800" cy="457200"/>
+          </a:xfrm>
+          <a:prstGeom prst="rect">
+            <a:avLst/>
+          </a:prstGeom>
+          <a:noFill/>
+          <a:ln/>
+        </p:spPr>
+        <p:txBody>
+          <a:bodyPr wrap="square" lIns="0" tIns="0" rIns="0" bIns="0" rtlCol="0" anchor="ctr"/>
+          <a:lstStyle/>
+          <a:p>
+            <a:pPr indent="0" marL="0">
+              <a:buNone/>
+            </a:pPr>
+            <a:r>
+              <a:rPr lang="en-US" sz="1000" i="1" dirty="0">
+                <a:solidFill>
+                  <a:srgbClr val="64748B"/>
+                </a:solidFill>
+                <a:latin typeface="Aptos" pitchFamily="34" charset="0"/>
+                <a:ea typeface="Aptos" pitchFamily="34" charset="-122"/>
+                <a:cs typeface="Aptos" pitchFamily="34" charset="-120"/>
+              </a:rPr>
+              <a:t>A governed workflow must pause for a human - durably, with an audit trail.</a:t>
+            </a:r>
+            <a:endParaRPr lang="en-US" sz="1000" dirty="0"/>
+          </a:p>
+        </p:txBody>
+      </p:sp>
+      <p:sp>
+        <p:nvSpPr>
+          <p:cNvPr id="25" name="Slide Number Placeholder 0"/>
+          <p:cNvSpPr>
+            <a:spLocks noGrp="1"/>
+          </p:cNvSpPr>
+          <p:nvPr>
+            <p:ph type="sldNum" sz="quarter" idx="4294967295"/>
+          </p:nvPr>
+        </p:nvSpPr>
+        <p:spPr>
+          <a:xfrm>
+            <a:off x="11475720" y="6565392"/>
+            <a:ext cx="800000" cy="300000"/>
+          </a:xfrm>
+          <a:prstGeom prst="rect">
+            <a:avLst/>
+          </a:prstGeom>
+          <a:extLst>
+            <a:ext uri="{C572A759-6A51-4108-AA02-DFA0A04FC94B}">
+              <ma14:wrappingTextBoxFlag xmlns:ma14="http://schemas.microsoft.com/office/mac/drawingml/2011/main" val="0"/>
+            </a:ext>
+          </a:extLst>
+        </p:spPr>
+        <p:txBody>
+          <a:bodyPr/>
+          <a:lstStyle>
+            <a:lvl1pPr>
+              <a:defRPr sz="700">
+                <a:solidFill>
+                  <a:srgbClr val="64748B"/>
+                </a:solidFill>
+                <a:latin typeface="Aptos"/>
+                <a:ea typeface="Aptos"/>
+                <a:cs typeface="Aptos"/>
+              </a:defRPr>
+            </a:lvl1pPr>
+          </a:lstStyle>
+          <a:p>
+            <a:pPr algn="l"/>
+            <a:fld id="{F7021451-1387-4CA6-816F-3879F97B5CBC}" type="slidenum">
+              <a:rPr b="0" lang="en-US"/>
+              <a:t>17</a:t>
+            </a:fld>
+            <a:endParaRPr lang="en-US"/>
+          </a:p>
+        </p:txBody>
+      </p:sp>
+    </p:spTree>
+  </p:cSld>
+  <p:clrMapOvr>
+    <a:masterClrMapping/>
+  </p:clrMapOvr>
+</p:sld>
+</file>
+
+<file path=ppt/slides/slide18.xml><?xml version="1.0" encoding="utf-8"?>
+<p:sld xmlns:a="http://schemas.openxmlformats.org/drawingml/2006/main" xmlns:r="http://schemas.openxmlformats.org/officeDocument/2006/relationships" xmlns:p="http://schemas.openxmlformats.org/presentationml/2006/main">
+  <p:cSld name="Slide 18">
     <p:bg>
       <p:bgPr>
         <a:solidFill>
@@ -8843,729 +9655,6 @@
               <a:t>30/60/90 roadmap</a:t>
             </a:r>
             <a:endParaRPr lang="en-US" sz="720" dirty="0"/>
-          </a:p>
-        </p:txBody>
-      </p:sp>
-    </p:spTree>
-  </p:cSld>
-  <p:clrMapOvr>
-    <a:masterClrMapping/>
-  </p:clrMapOvr>
-</p:sld>
-</file>
-
-<file path=ppt/slides/slide18.xml><?xml version="1.0" encoding="utf-8"?>
-<p:sld xmlns:a="http://schemas.openxmlformats.org/drawingml/2006/main" xmlns:r="http://schemas.openxmlformats.org/officeDocument/2006/relationships" xmlns:p="http://schemas.openxmlformats.org/presentationml/2006/main">
-  <p:cSld name="Slide 18">
-    <p:bg>
-      <p:bgPr>
-        <a:solidFill>
-          <a:srgbClr val="F8FAFC"/>
-        </a:solidFill>
-      </p:bgPr>
-    </p:bg>
-    <p:spTree>
-      <p:nvGrpSpPr>
-        <p:cNvPr id="1" name=""/>
-        <p:cNvGrpSpPr/>
-        <p:nvPr/>
-      </p:nvGrpSpPr>
-      <p:grpSpPr>
-        <a:xfrm>
-          <a:off x="0" y="0"/>
-          <a:ext cx="0" cy="0"/>
-          <a:chOff x="0" y="0"/>
-          <a:chExt cx="0" cy="0"/>
-        </a:xfrm>
-      </p:grpSpPr>
-      <p:sp>
-        <p:nvSpPr>
-          <p:cNvPr id="2" name="Text 0"/>
-          <p:cNvSpPr/>
-          <p:nvPr/>
-        </p:nvSpPr>
-        <p:spPr>
-          <a:xfrm>
-            <a:off x="566928" y="384048"/>
-            <a:ext cx="10789920" cy="201168"/>
-          </a:xfrm>
-          <a:prstGeom prst="rect">
-            <a:avLst/>
-          </a:prstGeom>
-          <a:noFill/>
-          <a:ln/>
-        </p:spPr>
-        <p:txBody>
-          <a:bodyPr wrap="square" lIns="0" tIns="0" rIns="0" bIns="0" rtlCol="0" anchor="ctr"/>
-          <a:lstStyle/>
-          <a:p>
-            <a:pPr indent="0" marL="0">
-              <a:buNone/>
-            </a:pPr>
-            <a:r>
-              <a:rPr lang="en-US" sz="800" b="1" dirty="0">
-                <a:solidFill>
-                  <a:srgbClr val="0F766E"/>
-                </a:solidFill>
-                <a:latin typeface="Aptos" pitchFamily="34" charset="0"/>
-                <a:ea typeface="Aptos" pitchFamily="34" charset="-122"/>
-                <a:cs typeface="Aptos" pitchFamily="34" charset="-120"/>
-              </a:rPr>
-              <a:t>PLAYBACK</a:t>
-            </a:r>
-            <a:endParaRPr lang="en-US" sz="800" dirty="0"/>
-          </a:p>
-        </p:txBody>
-      </p:sp>
-      <p:sp>
-        <p:nvSpPr>
-          <p:cNvPr id="3" name="Text 1"/>
-          <p:cNvSpPr/>
-          <p:nvPr/>
-        </p:nvSpPr>
-        <p:spPr>
-          <a:xfrm>
-            <a:off x="548640" y="658368"/>
-            <a:ext cx="11064240" cy="502920"/>
-          </a:xfrm>
-          <a:prstGeom prst="rect">
-            <a:avLst/>
-          </a:prstGeom>
-          <a:noFill/>
-          <a:ln/>
-        </p:spPr>
-        <p:txBody>
-          <a:bodyPr wrap="square" lIns="0" tIns="0" rIns="0" bIns="0" rtlCol="0" anchor="ctr">
-            <a:normAutofit/>
-          </a:bodyPr>
-          <a:lstStyle/>
-          <a:p>
-            <a:pPr indent="0" marL="0">
-              <a:buNone/>
-            </a:pPr>
-            <a:r>
-              <a:rPr lang="en-US" sz="2300" b="1" dirty="0">
-                <a:solidFill>
-                  <a:srgbClr val="0B1220"/>
-                </a:solidFill>
-                <a:latin typeface="Aptos Display" pitchFamily="34" charset="0"/>
-                <a:ea typeface="Aptos Display" pitchFamily="34" charset="-122"/>
-                <a:cs typeface="Aptos Display" pitchFamily="34" charset="-120"/>
-              </a:rPr>
-              <a:t>The whole thing, working end to end</a:t>
-            </a:r>
-            <a:endParaRPr lang="en-US" sz="2300" dirty="0"/>
-          </a:p>
-        </p:txBody>
-      </p:sp>
-      <p:sp>
-        <p:nvSpPr>
-          <p:cNvPr id="4" name="Shape 2"/>
-          <p:cNvSpPr/>
-          <p:nvPr/>
-        </p:nvSpPr>
-        <p:spPr>
-          <a:xfrm>
-            <a:off x="548640" y="1243584"/>
-            <a:ext cx="11064240" cy="0"/>
-          </a:xfrm>
-          <a:prstGeom prst="line">
-            <a:avLst/>
-          </a:prstGeom>
-          <a:noFill/>
-          <a:ln w="12700">
-            <a:solidFill>
-              <a:srgbClr val="CBD5E1"/>
-            </a:solidFill>
-            <a:prstDash val="solid"/>
-          </a:ln>
-        </p:spPr>
-      </p:sp>
-      <p:sp>
-        <p:nvSpPr>
-          <p:cNvPr id="5" name="Shape 3"/>
-          <p:cNvSpPr/>
-          <p:nvPr/>
-        </p:nvSpPr>
-        <p:spPr>
-          <a:xfrm>
-            <a:off x="640080" y="1463040"/>
-            <a:ext cx="3520440" cy="1828800"/>
-          </a:xfrm>
-          <a:prstGeom prst="roundRect">
-            <a:avLst>
-              <a:gd name="adj" fmla="val 4000"/>
-            </a:avLst>
-          </a:prstGeom>
-          <a:solidFill>
-            <a:srgbClr val="FFFFFF"/>
-          </a:solidFill>
-          <a:ln w="12700">
-            <a:solidFill>
-              <a:srgbClr val="E2E8F0"/>
-            </a:solidFill>
-            <a:prstDash val="solid"/>
-          </a:ln>
-          <a:effectLst>
-            <a:outerShdw sx="100000" sy="100000" kx="0" ky="0" algn="bl" rotWithShape="0" blurRad="25400" dist="50800" dir="2700000">
-              <a:srgbClr val="94A3B8">
-                <a:alpha val="12000"/>
-              </a:srgbClr>
-            </a:outerShdw>
-          </a:effectLst>
-        </p:spPr>
-      </p:sp>
-      <p:sp>
-        <p:nvSpPr>
-          <p:cNvPr id="6" name="Shape 4"/>
-          <p:cNvSpPr/>
-          <p:nvPr/>
-        </p:nvSpPr>
-        <p:spPr>
-          <a:xfrm>
-            <a:off x="640080" y="1463040"/>
-            <a:ext cx="64008" cy="1828800"/>
-          </a:xfrm>
-          <a:prstGeom prst="rect">
-            <a:avLst/>
-          </a:prstGeom>
-          <a:solidFill>
-            <a:srgbClr val="0F766E"/>
-          </a:solidFill>
-          <a:ln w="12700">
-            <a:solidFill>
-              <a:srgbClr val="0F766E"/>
-            </a:solidFill>
-            <a:prstDash val="solid"/>
-          </a:ln>
-        </p:spPr>
-      </p:sp>
-      <p:sp>
-        <p:nvSpPr>
-          <p:cNvPr id="7" name="Text 5"/>
-          <p:cNvSpPr/>
-          <p:nvPr/>
-        </p:nvSpPr>
-        <p:spPr>
-          <a:xfrm>
-            <a:off x="841248" y="1609344"/>
-            <a:ext cx="3200400" cy="219456"/>
-          </a:xfrm>
-          <a:prstGeom prst="rect">
-            <a:avLst/>
-          </a:prstGeom>
-          <a:noFill/>
-          <a:ln/>
-        </p:spPr>
-        <p:txBody>
-          <a:bodyPr wrap="square" lIns="0" tIns="0" rIns="0" bIns="0" rtlCol="0" anchor="ctr">
-            <a:normAutofit/>
-          </a:bodyPr>
-          <a:lstStyle/>
-          <a:p>
-            <a:pPr indent="0" marL="0">
-              <a:buNone/>
-            </a:pPr>
-            <a:r>
-              <a:rPr lang="en-US" sz="1200" b="1" dirty="0">
-                <a:solidFill>
-                  <a:srgbClr val="0B1220"/>
-                </a:solidFill>
-                <a:latin typeface="Aptos" pitchFamily="34" charset="0"/>
-                <a:ea typeface="Aptos" pitchFamily="34" charset="-122"/>
-                <a:cs typeface="Aptos" pitchFamily="34" charset="-120"/>
-              </a:rPr>
-              <a:t>One case, all layers</a:t>
-            </a:r>
-            <a:endParaRPr lang="en-US" sz="1200" dirty="0"/>
-          </a:p>
-        </p:txBody>
-      </p:sp>
-      <p:sp>
-        <p:nvSpPr>
-          <p:cNvPr id="8" name="Text 6"/>
-          <p:cNvSpPr/>
-          <p:nvPr/>
-        </p:nvSpPr>
-        <p:spPr>
-          <a:xfrm>
-            <a:off x="841248" y="1920240"/>
-            <a:ext cx="3200400" cy="1280160"/>
-          </a:xfrm>
-          <a:prstGeom prst="rect">
-            <a:avLst/>
-          </a:prstGeom>
-          <a:noFill/>
-          <a:ln/>
-        </p:spPr>
-        <p:txBody>
-          <a:bodyPr wrap="square" lIns="254" tIns="254" rIns="254" bIns="254" rtlCol="0" anchor="t">
-            <a:normAutofit/>
-          </a:bodyPr>
-          <a:lstStyle/>
-          <a:p>
-            <a:pPr indent="0" marL="0">
-              <a:buNone/>
-            </a:pPr>
-            <a:r>
-              <a:rPr lang="en-US" sz="920" dirty="0">
-                <a:solidFill>
-                  <a:srgbClr val="334155"/>
-                </a:solidFill>
-                <a:latin typeface="Aptos" pitchFamily="34" charset="0"/>
-                <a:ea typeface="Aptos" pitchFamily="34" charset="-122"/>
-                <a:cs typeface="Aptos" pitchFamily="34" charset="-120"/>
-              </a:rPr>
-              <a:t>Invoke a discharge case: eight agents hand off, tools are scoped and redacted, RAG cites protocol, guardrails hold, and it stops at the human gate.</a:t>
-            </a:r>
-            <a:endParaRPr lang="en-US" sz="920" dirty="0"/>
-          </a:p>
-        </p:txBody>
-      </p:sp>
-      <p:sp>
-        <p:nvSpPr>
-          <p:cNvPr id="9" name="Shape 7"/>
-          <p:cNvSpPr/>
-          <p:nvPr/>
-        </p:nvSpPr>
-        <p:spPr>
-          <a:xfrm>
-            <a:off x="4343400" y="1463040"/>
-            <a:ext cx="3520440" cy="1828800"/>
-          </a:xfrm>
-          <a:prstGeom prst="roundRect">
-            <a:avLst>
-              <a:gd name="adj" fmla="val 4000"/>
-            </a:avLst>
-          </a:prstGeom>
-          <a:solidFill>
-            <a:srgbClr val="FFFFFF"/>
-          </a:solidFill>
-          <a:ln w="12700">
-            <a:solidFill>
-              <a:srgbClr val="E2E8F0"/>
-            </a:solidFill>
-            <a:prstDash val="solid"/>
-          </a:ln>
-          <a:effectLst>
-            <a:outerShdw sx="100000" sy="100000" kx="0" ky="0" algn="bl" rotWithShape="0" blurRad="25400" dist="50800" dir="2700000">
-              <a:srgbClr val="94A3B8">
-                <a:alpha val="12000"/>
-              </a:srgbClr>
-            </a:outerShdw>
-          </a:effectLst>
-        </p:spPr>
-      </p:sp>
-      <p:sp>
-        <p:nvSpPr>
-          <p:cNvPr id="10" name="Shape 8"/>
-          <p:cNvSpPr/>
-          <p:nvPr/>
-        </p:nvSpPr>
-        <p:spPr>
-          <a:xfrm>
-            <a:off x="4343400" y="1463040"/>
-            <a:ext cx="64008" cy="1828800"/>
-          </a:xfrm>
-          <a:prstGeom prst="rect">
-            <a:avLst/>
-          </a:prstGeom>
-          <a:solidFill>
-            <a:srgbClr val="06B6D4"/>
-          </a:solidFill>
-          <a:ln w="12700">
-            <a:solidFill>
-              <a:srgbClr val="06B6D4"/>
-            </a:solidFill>
-            <a:prstDash val="solid"/>
-          </a:ln>
-        </p:spPr>
-      </p:sp>
-      <p:sp>
-        <p:nvSpPr>
-          <p:cNvPr id="11" name="Text 9"/>
-          <p:cNvSpPr/>
-          <p:nvPr/>
-        </p:nvSpPr>
-        <p:spPr>
-          <a:xfrm>
-            <a:off x="4544568" y="1609344"/>
-            <a:ext cx="3200400" cy="219456"/>
-          </a:xfrm>
-          <a:prstGeom prst="rect">
-            <a:avLst/>
-          </a:prstGeom>
-          <a:noFill/>
-          <a:ln/>
-        </p:spPr>
-        <p:txBody>
-          <a:bodyPr wrap="square" lIns="0" tIns="0" rIns="0" bIns="0" rtlCol="0" anchor="ctr">
-            <a:normAutofit/>
-          </a:bodyPr>
-          <a:lstStyle/>
-          <a:p>
-            <a:pPr indent="0" marL="0">
-              <a:buNone/>
-            </a:pPr>
-            <a:r>
-              <a:rPr lang="en-US" sz="1200" b="1" dirty="0">
-                <a:solidFill>
-                  <a:srgbClr val="0B1220"/>
-                </a:solidFill>
-                <a:latin typeface="Aptos" pitchFamily="34" charset="0"/>
-                <a:ea typeface="Aptos" pitchFamily="34" charset="-122"/>
-                <a:cs typeface="Aptos" pitchFamily="34" charset="-120"/>
-              </a:rPr>
-              <a:t>One trace</a:t>
-            </a:r>
-            <a:endParaRPr lang="en-US" sz="1200" dirty="0"/>
-          </a:p>
-        </p:txBody>
-      </p:sp>
-      <p:sp>
-        <p:nvSpPr>
-          <p:cNvPr id="12" name="Text 10"/>
-          <p:cNvSpPr/>
-          <p:nvPr/>
-        </p:nvSpPr>
-        <p:spPr>
-          <a:xfrm>
-            <a:off x="4544568" y="1920240"/>
-            <a:ext cx="3200400" cy="1280160"/>
-          </a:xfrm>
-          <a:prstGeom prst="rect">
-            <a:avLst/>
-          </a:prstGeom>
-          <a:noFill/>
-          <a:ln/>
-        </p:spPr>
-        <p:txBody>
-          <a:bodyPr wrap="square" lIns="254" tIns="254" rIns="254" bIns="254" rtlCol="0" anchor="t">
-            <a:normAutofit/>
-          </a:bodyPr>
-          <a:lstStyle/>
-          <a:p>
-            <a:pPr indent="0" marL="0">
-              <a:buNone/>
-            </a:pPr>
-            <a:r>
-              <a:rPr lang="en-US" sz="920" dirty="0">
-                <a:solidFill>
-                  <a:srgbClr val="334155"/>
-                </a:solidFill>
-                <a:latin typeface="Aptos" pitchFamily="34" charset="0"/>
-                <a:ea typeface="Aptos" pitchFamily="34" charset="-122"/>
-                <a:cs typeface="Aptos" pitchFamily="34" charset="-120"/>
-              </a:rPr>
-              <a:t>Copy the correlation ID and walk the ordered events - tool decisions, agent handoffs, policy calls, the review transition - one join key across the run.</a:t>
-            </a:r>
-            <a:endParaRPr lang="en-US" sz="920" dirty="0"/>
-          </a:p>
-        </p:txBody>
-      </p:sp>
-      <p:sp>
-        <p:nvSpPr>
-          <p:cNvPr id="13" name="Shape 11"/>
-          <p:cNvSpPr/>
-          <p:nvPr/>
-        </p:nvSpPr>
-        <p:spPr>
-          <a:xfrm>
-            <a:off x="8046720" y="1463040"/>
-            <a:ext cx="3520440" cy="1828800"/>
-          </a:xfrm>
-          <a:prstGeom prst="roundRect">
-            <a:avLst>
-              <a:gd name="adj" fmla="val 4000"/>
-            </a:avLst>
-          </a:prstGeom>
-          <a:solidFill>
-            <a:srgbClr val="FFFFFF"/>
-          </a:solidFill>
-          <a:ln w="12700">
-            <a:solidFill>
-              <a:srgbClr val="E2E8F0"/>
-            </a:solidFill>
-            <a:prstDash val="solid"/>
-          </a:ln>
-          <a:effectLst>
-            <a:outerShdw sx="100000" sy="100000" kx="0" ky="0" algn="bl" rotWithShape="0" blurRad="25400" dist="50800" dir="2700000">
-              <a:srgbClr val="94A3B8">
-                <a:alpha val="12000"/>
-              </a:srgbClr>
-            </a:outerShdw>
-          </a:effectLst>
-        </p:spPr>
-      </p:sp>
-      <p:sp>
-        <p:nvSpPr>
-          <p:cNvPr id="14" name="Shape 12"/>
-          <p:cNvSpPr/>
-          <p:nvPr/>
-        </p:nvSpPr>
-        <p:spPr>
-          <a:xfrm>
-            <a:off x="8046720" y="1463040"/>
-            <a:ext cx="64008" cy="1828800"/>
-          </a:xfrm>
-          <a:prstGeom prst="rect">
-            <a:avLst/>
-          </a:prstGeom>
-          <a:solidFill>
-            <a:srgbClr val="F59E0B"/>
-          </a:solidFill>
-          <a:ln w="12700">
-            <a:solidFill>
-              <a:srgbClr val="F59E0B"/>
-            </a:solidFill>
-            <a:prstDash val="solid"/>
-          </a:ln>
-        </p:spPr>
-      </p:sp>
-      <p:sp>
-        <p:nvSpPr>
-          <p:cNvPr id="15" name="Text 13"/>
-          <p:cNvSpPr/>
-          <p:nvPr/>
-        </p:nvSpPr>
-        <p:spPr>
-          <a:xfrm>
-            <a:off x="8247888" y="1609344"/>
-            <a:ext cx="3200400" cy="219456"/>
-          </a:xfrm>
-          <a:prstGeom prst="rect">
-            <a:avLst/>
-          </a:prstGeom>
-          <a:noFill/>
-          <a:ln/>
-        </p:spPr>
-        <p:txBody>
-          <a:bodyPr wrap="square" lIns="0" tIns="0" rIns="0" bIns="0" rtlCol="0" anchor="ctr">
-            <a:normAutofit/>
-          </a:bodyPr>
-          <a:lstStyle/>
-          <a:p>
-            <a:pPr indent="0" marL="0">
-              <a:buNone/>
-            </a:pPr>
-            <a:r>
-              <a:rPr lang="en-US" sz="1200" b="1" dirty="0">
-                <a:solidFill>
-                  <a:srgbClr val="0B1220"/>
-                </a:solidFill>
-                <a:latin typeface="Aptos" pitchFamily="34" charset="0"/>
-                <a:ea typeface="Aptos" pitchFamily="34" charset="-122"/>
-                <a:cs typeface="Aptos" pitchFamily="34" charset="-120"/>
-              </a:rPr>
-              <a:t>One decision</a:t>
-            </a:r>
-            <a:endParaRPr lang="en-US" sz="1200" dirty="0"/>
-          </a:p>
-        </p:txBody>
-      </p:sp>
-      <p:sp>
-        <p:nvSpPr>
-          <p:cNvPr id="16" name="Text 14"/>
-          <p:cNvSpPr/>
-          <p:nvPr/>
-        </p:nvSpPr>
-        <p:spPr>
-          <a:xfrm>
-            <a:off x="8247888" y="1920240"/>
-            <a:ext cx="3200400" cy="1280160"/>
-          </a:xfrm>
-          <a:prstGeom prst="rect">
-            <a:avLst/>
-          </a:prstGeom>
-          <a:noFill/>
-          <a:ln/>
-        </p:spPr>
-        <p:txBody>
-          <a:bodyPr wrap="square" lIns="254" tIns="254" rIns="254" bIns="254" rtlCol="0" anchor="t">
-            <a:normAutofit/>
-          </a:bodyPr>
-          <a:lstStyle/>
-          <a:p>
-            <a:pPr indent="0" marL="0">
-              <a:buNone/>
-            </a:pPr>
-            <a:r>
-              <a:rPr lang="en-US" sz="920" dirty="0">
-                <a:solidFill>
-                  <a:srgbClr val="334155"/>
-                </a:solidFill>
-                <a:latin typeface="Aptos" pitchFamily="34" charset="0"/>
-                <a:ea typeface="Aptos" pitchFamily="34" charset="-122"/>
-                <a:cs typeface="Aptos" pitchFamily="34" charset="-120"/>
-              </a:rPr>
-              <a:t>A care manager approves in the UI; the durable task reaches Approved with a full audit trail. An agent-actor approve is denied.</a:t>
-            </a:r>
-            <a:endParaRPr lang="en-US" sz="920" dirty="0"/>
-          </a:p>
-        </p:txBody>
-      </p:sp>
-      <p:sp>
-        <p:nvSpPr>
-          <p:cNvPr id="17" name="Text 15"/>
-          <p:cNvSpPr/>
-          <p:nvPr/>
-        </p:nvSpPr>
-        <p:spPr>
-          <a:xfrm>
-            <a:off x="640080" y="3520440"/>
-            <a:ext cx="10972800" cy="2011680"/>
-          </a:xfrm>
-          <a:prstGeom prst="rect">
-            <a:avLst/>
-          </a:prstGeom>
-          <a:noFill/>
-          <a:ln/>
-        </p:spPr>
-        <p:txBody>
-          <a:bodyPr wrap="square" lIns="381" tIns="381" rIns="381" bIns="381" rtlCol="0" anchor="ctr">
-            <a:normAutofit/>
-          </a:bodyPr>
-          <a:lstStyle/>
-          <a:p>
-            <a:pPr marL="152400" indent="-152400">
-              <a:buSzPct val="100000"/>
-              <a:buChar char="•"/>
-            </a:pPr>
-            <a:r>
-              <a:rPr lang="en-US" sz="1150" dirty="0">
-                <a:solidFill>
-                  <a:srgbClr val="334155"/>
-                </a:solidFill>
-                <a:latin typeface="Aptos" pitchFamily="34" charset="0"/>
-                <a:ea typeface="Aptos" pitchFamily="34" charset="-122"/>
-                <a:cs typeface="Aptos" pitchFamily="34" charset="-120"/>
-              </a:rPr>
-              <a:t>This is the deployed system, not a mockup - live on Azure Container Apps + Foundry.</a:t>
-            </a:r>
-            <a:endParaRPr lang="en-US" sz="1150" dirty="0"/>
-          </a:p>
-          <a:p>
-            <a:pPr marL="152400" indent="-152400">
-              <a:buSzPct val="100000"/>
-              <a:buChar char="•"/>
-            </a:pPr>
-            <a:r>
-              <a:rPr lang="en-US" sz="1150" dirty="0">
-                <a:solidFill>
-                  <a:srgbClr val="334155"/>
-                </a:solidFill>
-                <a:latin typeface="Aptos" pitchFamily="34" charset="0"/>
-                <a:ea typeface="Aptos" pitchFamily="34" charset="-122"/>
-                <a:cs typeface="Aptos" pitchFamily="34" charset="-120"/>
-              </a:rPr>
-              <a:t>The same contract runs in foundry mode (hosted agents) and a local mode for offline demos.</a:t>
-            </a:r>
-            <a:endParaRPr lang="en-US" sz="1150" dirty="0"/>
-          </a:p>
-          <a:p>
-            <a:pPr marL="152400" indent="-152400">
-              <a:buSzPct val="100000"/>
-              <a:buChar char="•"/>
-            </a:pPr>
-            <a:r>
-              <a:rPr lang="en-US" sz="1150" dirty="0">
-                <a:solidFill>
-                  <a:srgbClr val="334155"/>
-                </a:solidFill>
-                <a:latin typeface="Aptos" pitchFamily="34" charset="0"/>
-                <a:ea typeface="Aptos" pitchFamily="34" charset="-122"/>
-                <a:cs typeface="Aptos" pitchFamily="34" charset="-120"/>
-              </a:rPr>
-              <a:t>Reference: docs/observability-correlation-trace.md, docs/hitl-durable-task-scheduler.md.</a:t>
-            </a:r>
-            <a:endParaRPr lang="en-US" sz="1150" dirty="0"/>
-          </a:p>
-        </p:txBody>
-      </p:sp>
-      <p:sp>
-        <p:nvSpPr>
-          <p:cNvPr id="18" name="Text 16"/>
-          <p:cNvSpPr/>
-          <p:nvPr/>
-        </p:nvSpPr>
-        <p:spPr>
-          <a:xfrm>
-            <a:off x="640080" y="5806440"/>
-            <a:ext cx="10972800" cy="457200"/>
-          </a:xfrm>
-          <a:prstGeom prst="rect">
-            <a:avLst/>
-          </a:prstGeom>
-          <a:noFill/>
-          <a:ln/>
-        </p:spPr>
-        <p:txBody>
-          <a:bodyPr wrap="square" lIns="0" tIns="0" rIns="0" bIns="0" rtlCol="0" anchor="ctr"/>
-          <a:lstStyle/>
-          <a:p>
-            <a:pPr indent="0" marL="0">
-              <a:buNone/>
-            </a:pPr>
-            <a:r>
-              <a:rPr lang="en-US" sz="1000" i="1" dirty="0">
-                <a:solidFill>
-                  <a:srgbClr val="64748B"/>
-                </a:solidFill>
-                <a:latin typeface="Aptos" pitchFamily="34" charset="0"/>
-                <a:ea typeface="Aptos" pitchFamily="34" charset="-122"/>
-                <a:cs typeface="Aptos" pitchFamily="34" charset="-120"/>
-              </a:rPr>
-              <a:t>Capability and governance in one run - the point of the whole two days.</a:t>
-            </a:r>
-            <a:endParaRPr lang="en-US" sz="1000" dirty="0"/>
-          </a:p>
-        </p:txBody>
-      </p:sp>
-      <p:sp>
-        <p:nvSpPr>
-          <p:cNvPr id="25" name="Slide Number Placeholder 0"/>
-          <p:cNvSpPr>
-            <a:spLocks noGrp="1"/>
-          </p:cNvSpPr>
-          <p:nvPr>
-            <p:ph type="sldNum" sz="quarter" idx="4294967295"/>
-          </p:nvPr>
-        </p:nvSpPr>
-        <p:spPr>
-          <a:xfrm>
-            <a:off x="11475720" y="6565392"/>
-            <a:ext cx="800000" cy="300000"/>
-          </a:xfrm>
-          <a:prstGeom prst="rect">
-            <a:avLst/>
-          </a:prstGeom>
-          <a:extLst>
-            <a:ext uri="{C572A759-6A51-4108-AA02-DFA0A04FC94B}">
-              <ma14:wrappingTextBoxFlag xmlns:ma14="http://schemas.microsoft.com/office/mac/drawingml/2011/main" val="0"/>
-            </a:ext>
-          </a:extLst>
-        </p:spPr>
-        <p:txBody>
-          <a:bodyPr/>
-          <a:lstStyle>
-            <a:lvl1pPr>
-              <a:defRPr sz="700">
-                <a:solidFill>
-                  <a:srgbClr val="64748B"/>
-                </a:solidFill>
-                <a:latin typeface="Aptos"/>
-                <a:ea typeface="Aptos"/>
-                <a:cs typeface="Aptos"/>
-              </a:defRPr>
-            </a:lvl1pPr>
-          </a:lstStyle>
-          <a:p>
-            <a:pPr algn="l"/>
-            <a:fld id="{F7021451-1387-4CA6-816F-3879F97B5CBC}" type="slidenum">
-              <a:rPr b="0" lang="en-US"/>
-              <a:t>18</a:t>
-            </a:fld>
-            <a:endParaRPr lang="en-US"/>
           </a:p>
         </p:txBody>
       </p:sp>
@@ -9634,7 +9723,7 @@
                 <a:ea typeface="Aptos" pitchFamily="34" charset="-122"/>
                 <a:cs typeface="Aptos" pitchFamily="34" charset="-120"/>
               </a:rPr>
-              <a:t>PROVE IT IS SAFE</a:t>
+              <a:t>PLAYBACK</a:t>
             </a:r>
             <a:endParaRPr lang="en-US" sz="800" dirty="0"/>
           </a:p>
@@ -9675,7 +9764,7 @@
                 <a:ea typeface="Aptos Display" pitchFamily="34" charset="-122"/>
                 <a:cs typeface="Aptos Display" pitchFamily="34" charset="-120"/>
               </a:rPr>
-              <a:t>Evaluation as a release gate</a:t>
+              <a:t>The whole thing, working end to end</a:t>
             </a:r>
             <a:endParaRPr lang="en-US" sz="2300" dirty="0"/>
           </a:p>
@@ -9713,11 +9802,11 @@
         <p:spPr>
           <a:xfrm>
             <a:off x="640080" y="1463040"/>
-            <a:ext cx="3520440" cy="1737360"/>
+            <a:ext cx="3520440" cy="1828800"/>
           </a:xfrm>
           <a:prstGeom prst="roundRect">
             <a:avLst>
-              <a:gd name="adj" fmla="val 4211"/>
+              <a:gd name="adj" fmla="val 4000"/>
             </a:avLst>
           </a:prstGeom>
           <a:solidFill>
@@ -9747,17 +9836,17 @@
         <p:spPr>
           <a:xfrm>
             <a:off x="640080" y="1463040"/>
-            <a:ext cx="64008" cy="1737360"/>
+            <a:ext cx="64008" cy="1828800"/>
           </a:xfrm>
           <a:prstGeom prst="rect">
             <a:avLst/>
           </a:prstGeom>
           <a:solidFill>
-            <a:srgbClr val="16A34A"/>
+            <a:srgbClr val="0F766E"/>
           </a:solidFill>
           <a:ln w="12700">
             <a:solidFill>
-              <a:srgbClr val="16A34A"/>
+              <a:srgbClr val="0F766E"/>
             </a:solidFill>
             <a:prstDash val="solid"/>
           </a:ln>
@@ -9798,7 +9887,7 @@
                 <a:ea typeface="Aptos" pitchFamily="34" charset="-122"/>
                 <a:cs typeface="Aptos" pitchFamily="34" charset="-120"/>
               </a:rPr>
-              <a:t>Golden cases</a:t>
+              <a:t>One case, all layers</a:t>
             </a:r>
             <a:endParaRPr lang="en-US" sz="1200" dirty="0"/>
           </a:p>
@@ -9813,7 +9902,7 @@
         <p:spPr>
           <a:xfrm>
             <a:off x="841248" y="1920240"/>
-            <a:ext cx="3200400" cy="1188720"/>
+            <a:ext cx="3200400" cy="1280160"/>
           </a:xfrm>
           <a:prstGeom prst="rect">
             <a:avLst/>
@@ -9839,7 +9928,7 @@
                 <a:ea typeface="Aptos" pitchFamily="34" charset="-122"/>
                 <a:cs typeface="Aptos" pitchFamily="34" charset="-120"/>
               </a:rPr>
-              <a:t>What it must do well: cite grounded evidence, disclose missing info, consume the approved score, route to human review.</a:t>
+              <a:t>Invoke a discharge case: eight agents hand off, tools are scoped and redacted, RAG cites protocol, guardrails hold, and it stops at the human gate.</a:t>
             </a:r>
             <a:endParaRPr lang="en-US" sz="920" dirty="0"/>
           </a:p>
@@ -9854,11 +9943,11 @@
         <p:spPr>
           <a:xfrm>
             <a:off x="4343400" y="1463040"/>
-            <a:ext cx="3520440" cy="1737360"/>
+            <a:ext cx="3520440" cy="1828800"/>
           </a:xfrm>
           <a:prstGeom prst="roundRect">
             <a:avLst>
-              <a:gd name="adj" fmla="val 4211"/>
+              <a:gd name="adj" fmla="val 4000"/>
             </a:avLst>
           </a:prstGeom>
           <a:solidFill>
@@ -9888,17 +9977,17 @@
         <p:spPr>
           <a:xfrm>
             <a:off x="4343400" y="1463040"/>
-            <a:ext cx="64008" cy="1737360"/>
+            <a:ext cx="64008" cy="1828800"/>
           </a:xfrm>
           <a:prstGeom prst="rect">
             <a:avLst/>
           </a:prstGeom>
           <a:solidFill>
-            <a:srgbClr val="DC2626"/>
+            <a:srgbClr val="06B6D4"/>
           </a:solidFill>
           <a:ln w="12700">
             <a:solidFill>
-              <a:srgbClr val="DC2626"/>
+              <a:srgbClr val="06B6D4"/>
             </a:solidFill>
             <a:prstDash val="solid"/>
           </a:ln>
@@ -9939,7 +10028,7 @@
                 <a:ea typeface="Aptos" pitchFamily="34" charset="-122"/>
                 <a:cs typeface="Aptos" pitchFamily="34" charset="-120"/>
               </a:rPr>
-              <a:t>Adversarial cases</a:t>
+              <a:t>One trace</a:t>
             </a:r>
             <a:endParaRPr lang="en-US" sz="1200" dirty="0"/>
           </a:p>
@@ -9954,7 +10043,7 @@
         <p:spPr>
           <a:xfrm>
             <a:off x="4544568" y="1920240"/>
-            <a:ext cx="3200400" cy="1188720"/>
+            <a:ext cx="3200400" cy="1280160"/>
           </a:xfrm>
           <a:prstGeom prst="rect">
             <a:avLst/>
@@ -9980,7 +10069,7 @@
                 <a:ea typeface="Aptos" pitchFamily="34" charset="-122"/>
                 <a:cs typeface="Aptos" pitchFamily="34" charset="-120"/>
               </a:rPr>
-              <a:t>What it must refuse: say 'safe to discharge', expand PHI, or recalculate / lower the risk score. Score-override is CRITICAL and must fail-closed.</a:t>
+              <a:t>Copy the correlation ID and walk the ordered events - tool decisions, agent handoffs, policy calls, the review transition - one join key across the run.</a:t>
             </a:r>
             <a:endParaRPr lang="en-US" sz="920" dirty="0"/>
           </a:p>
@@ -9995,11 +10084,11 @@
         <p:spPr>
           <a:xfrm>
             <a:off x="8046720" y="1463040"/>
-            <a:ext cx="3520440" cy="1737360"/>
+            <a:ext cx="3520440" cy="1828800"/>
           </a:xfrm>
           <a:prstGeom prst="roundRect">
             <a:avLst>
-              <a:gd name="adj" fmla="val 4211"/>
+              <a:gd name="adj" fmla="val 4000"/>
             </a:avLst>
           </a:prstGeom>
           <a:solidFill>
@@ -10029,17 +10118,17 @@
         <p:spPr>
           <a:xfrm>
             <a:off x="8046720" y="1463040"/>
-            <a:ext cx="64008" cy="1737360"/>
+            <a:ext cx="64008" cy="1828800"/>
           </a:xfrm>
           <a:prstGeom prst="rect">
             <a:avLst/>
           </a:prstGeom>
           <a:solidFill>
-            <a:srgbClr val="0F766E"/>
+            <a:srgbClr val="F59E0B"/>
           </a:solidFill>
           <a:ln w="12700">
             <a:solidFill>
-              <a:srgbClr val="0F766E"/>
+              <a:srgbClr val="F59E0B"/>
             </a:solidFill>
             <a:prstDash val="solid"/>
           </a:ln>
@@ -10080,7 +10169,7 @@
                 <a:ea typeface="Aptos" pitchFamily="34" charset="-122"/>
                 <a:cs typeface="Aptos" pitchFamily="34" charset="-120"/>
               </a:rPr>
-              <a:t>A real gate</a:t>
+              <a:t>One decision</a:t>
             </a:r>
             <a:endParaRPr lang="en-US" sz="1200" dirty="0"/>
           </a:p>
@@ -10095,7 +10184,7 @@
         <p:spPr>
           <a:xfrm>
             <a:off x="8247888" y="1920240"/>
-            <a:ext cx="3200400" cy="1188720"/>
+            <a:ext cx="3200400" cy="1280160"/>
           </a:xfrm>
           <a:prstGeom prst="rect">
             <a:avLst/>
@@ -10121,7 +10210,7 @@
                 <a:ea typeface="Aptos" pitchFamily="34" charset="-122"/>
                 <a:cs typeface="Aptos" pitchFamily="34" charset="-120"/>
               </a:rPr>
-              <a:t>Deterministic, offline checks over synthetic cases; a failure returns non-zero and blocks the release. Not a vibe check.</a:t>
+              <a:t>A care manager approves in the UI; the durable task reaches Approved with a full audit trail. An agent-actor approve is denied.</a:t>
             </a:r>
             <a:endParaRPr lang="en-US" sz="920" dirty="0"/>
           </a:p>
@@ -10135,7 +10224,7 @@
         </p:nvSpPr>
         <p:spPr>
           <a:xfrm>
-            <a:off x="640080" y="3429000"/>
+            <a:off x="640080" y="3520440"/>
             <a:ext cx="10972800" cy="2011680"/>
           </a:xfrm>
           <a:prstGeom prst="rect">
@@ -10163,7 +10252,7 @@
                 <a:ea typeface="Aptos" pitchFamily="34" charset="-122"/>
                 <a:cs typeface="Aptos" pitchFamily="34" charset="-120"/>
               </a:rPr>
-              <a:t>Measure retrieval with qrels; assert safety gates on the structured result before any pilot.</a:t>
+              <a:t>This is the deployed system, not a mockup - live on Azure Container Apps + Foundry.</a:t>
             </a:r>
             <a:endParaRPr lang="en-US" sz="1150" dirty="0"/>
           </a:p>
@@ -10181,7 +10270,7 @@
                 <a:ea typeface="Aptos" pitchFamily="34" charset="-122"/>
                 <a:cs typeface="Aptos" pitchFamily="34" charset="-120"/>
               </a:rPr>
-              <a:t>Datasets: evaluation/golden-cases.jsonl and evaluation/adversarial-cases.jsonl.</a:t>
+              <a:t>The same contract runs in foundry mode (hosted agents) and a local mode for offline demos.</a:t>
             </a:r>
             <a:endParaRPr lang="en-US" sz="1150" dirty="0"/>
           </a:p>
@@ -10199,7 +10288,7 @@
                 <a:ea typeface="Aptos" pitchFamily="34" charset="-122"/>
                 <a:cs typeface="Aptos" pitchFamily="34" charset="-120"/>
               </a:rPr>
-              <a:t>Demo: green -&gt; inject a break -&gt; red / gate-blocked -&gt; revert -&gt; green (no code editing).</a:t>
+              <a:t>Reference: docs/observability-correlation-trace.md, docs/hitl-durable-task-scheduler.md.</a:t>
             </a:r>
             <a:endParaRPr lang="en-US" sz="1150" dirty="0"/>
           </a:p>
@@ -10238,7 +10327,7 @@
                 <a:ea typeface="Aptos" pitchFamily="34" charset="-122"/>
                 <a:cs typeface="Aptos" pitchFamily="34" charset="-120"/>
               </a:rPr>
-              <a:t>You do not pilot a healthcare agent on trust - you pilot it on a passing gate.</a:t>
+              <a:t>Capability and governance in one run - the point of the whole two days.</a:t>
             </a:r>
             <a:endParaRPr lang="en-US" sz="1000" dirty="0"/>
           </a:p>
@@ -11080,7 +11169,7 @@
                 <a:ea typeface="Aptos" pitchFamily="34" charset="-122"/>
                 <a:cs typeface="Aptos" pitchFamily="34" charset="-120"/>
               </a:rPr>
-              <a:t>WHAT KAISER DOES NEXT</a:t>
+              <a:t>PROVE IT IS SAFE</a:t>
             </a:r>
             <a:endParaRPr lang="en-US" sz="800" dirty="0"/>
           </a:p>
@@ -11121,7 +11210,7 @@
                 <a:ea typeface="Aptos Display" pitchFamily="34" charset="-122"/>
                 <a:cs typeface="Aptos Display" pitchFamily="34" charset="-120"/>
               </a:rPr>
-              <a:t>30 / 60 / 90-day pilot roadmap</a:t>
+              <a:t>Evaluation as a release gate</a:t>
             </a:r>
             <a:endParaRPr lang="en-US" sz="2300" dirty="0"/>
           </a:p>
@@ -11159,11 +11248,11 @@
         <p:spPr>
           <a:xfrm>
             <a:off x="640080" y="1463040"/>
-            <a:ext cx="3520440" cy="1828800"/>
+            <a:ext cx="3520440" cy="1737360"/>
           </a:xfrm>
           <a:prstGeom prst="roundRect">
             <a:avLst>
-              <a:gd name="adj" fmla="val 4000"/>
+              <a:gd name="adj" fmla="val 4211"/>
             </a:avLst>
           </a:prstGeom>
           <a:solidFill>
@@ -11193,17 +11282,17 @@
         <p:spPr>
           <a:xfrm>
             <a:off x="640080" y="1463040"/>
-            <a:ext cx="64008" cy="1828800"/>
+            <a:ext cx="64008" cy="1737360"/>
           </a:xfrm>
           <a:prstGeom prst="rect">
             <a:avLst/>
           </a:prstGeom>
           <a:solidFill>
-            <a:srgbClr val="0F766E"/>
+            <a:srgbClr val="16A34A"/>
           </a:solidFill>
           <a:ln w="12700">
             <a:solidFill>
-              <a:srgbClr val="0F766E"/>
+              <a:srgbClr val="16A34A"/>
             </a:solidFill>
             <a:prstDash val="solid"/>
           </a:ln>
@@ -11244,7 +11333,7 @@
                 <a:ea typeface="Aptos" pitchFamily="34" charset="-122"/>
                 <a:cs typeface="Aptos" pitchFamily="34" charset="-120"/>
               </a:rPr>
-              <a:t>0 - 30 days</a:t>
+              <a:t>Golden cases</a:t>
             </a:r>
             <a:endParaRPr lang="en-US" sz="1200" dirty="0"/>
           </a:p>
@@ -11259,7 +11348,7 @@
         <p:spPr>
           <a:xfrm>
             <a:off x="841248" y="1920240"/>
-            <a:ext cx="3200400" cy="1280160"/>
+            <a:ext cx="3200400" cy="1188720"/>
           </a:xfrm>
           <a:prstGeom prst="rect">
             <a:avLst/>
@@ -11285,7 +11374,7 @@
                 <a:ea typeface="Aptos" pitchFamily="34" charset="-122"/>
                 <a:cs typeface="Aptos" pitchFamily="34" charset="-120"/>
               </a:rPr>
-              <a:t>Stand up the governed pattern on a synthetic corpus; wire Foundry IQ to approved protocols; agree the safety gate and telemetry taxonomy.</a:t>
+              <a:t>What it must do well: cite grounded evidence, disclose missing info, consume the approved score, route to human review.</a:t>
             </a:r>
             <a:endParaRPr lang="en-US" sz="920" dirty="0"/>
           </a:p>
@@ -11300,11 +11389,11 @@
         <p:spPr>
           <a:xfrm>
             <a:off x="4343400" y="1463040"/>
-            <a:ext cx="3520440" cy="1828800"/>
+            <a:ext cx="3520440" cy="1737360"/>
           </a:xfrm>
           <a:prstGeom prst="roundRect">
             <a:avLst>
-              <a:gd name="adj" fmla="val 4000"/>
+              <a:gd name="adj" fmla="val 4211"/>
             </a:avLst>
           </a:prstGeom>
           <a:solidFill>
@@ -11334,17 +11423,17 @@
         <p:spPr>
           <a:xfrm>
             <a:off x="4343400" y="1463040"/>
-            <a:ext cx="64008" cy="1828800"/>
+            <a:ext cx="64008" cy="1737360"/>
           </a:xfrm>
           <a:prstGeom prst="rect">
             <a:avLst/>
           </a:prstGeom>
           <a:solidFill>
-            <a:srgbClr val="2563EB"/>
+            <a:srgbClr val="DC2626"/>
           </a:solidFill>
           <a:ln w="12700">
             <a:solidFill>
-              <a:srgbClr val="2563EB"/>
+              <a:srgbClr val="DC2626"/>
             </a:solidFill>
             <a:prstDash val="solid"/>
           </a:ln>
@@ -11385,7 +11474,7 @@
                 <a:ea typeface="Aptos" pitchFamily="34" charset="-122"/>
                 <a:cs typeface="Aptos" pitchFamily="34" charset="-120"/>
               </a:rPr>
-              <a:t>30 - 60 days</a:t>
+              <a:t>Adversarial cases</a:t>
             </a:r>
             <a:endParaRPr lang="en-US" sz="1200" dirty="0"/>
           </a:p>
@@ -11400,7 +11489,7 @@
         <p:spPr>
           <a:xfrm>
             <a:off x="4544568" y="1920240"/>
-            <a:ext cx="3200400" cy="1280160"/>
+            <a:ext cx="3200400" cy="1188720"/>
           </a:xfrm>
           <a:prstGeom prst="rect">
             <a:avLst/>
@@ -11426,7 +11515,7 @@
                 <a:ea typeface="Aptos" pitchFamily="34" charset="-122"/>
                 <a:cs typeface="Aptos" pitchFamily="34" charset="-120"/>
               </a:rPr>
-              <a:t>Secure MCP + Toolbox for the first real tools; dedicated LAW cluster + CMK + AMPLS; capability-host reuse decisions per app team.</a:t>
+              <a:t>What it must refuse: say 'safe to discharge', expand PHI, or recalculate / lower the risk score. Score-override is CRITICAL and must fail-closed.</a:t>
             </a:r>
             <a:endParaRPr lang="en-US" sz="920" dirty="0"/>
           </a:p>
@@ -11441,11 +11530,11 @@
         <p:spPr>
           <a:xfrm>
             <a:off x="8046720" y="1463040"/>
-            <a:ext cx="3520440" cy="1828800"/>
+            <a:ext cx="3520440" cy="1737360"/>
           </a:xfrm>
           <a:prstGeom prst="roundRect">
             <a:avLst>
-              <a:gd name="adj" fmla="val 4000"/>
+              <a:gd name="adj" fmla="val 4211"/>
             </a:avLst>
           </a:prstGeom>
           <a:solidFill>
@@ -11475,17 +11564,17 @@
         <p:spPr>
           <a:xfrm>
             <a:off x="8046720" y="1463040"/>
-            <a:ext cx="64008" cy="1828800"/>
+            <a:ext cx="64008" cy="1737360"/>
           </a:xfrm>
           <a:prstGeom prst="rect">
             <a:avLst/>
           </a:prstGeom>
           <a:solidFill>
-            <a:srgbClr val="7C3AED"/>
+            <a:srgbClr val="0F766E"/>
           </a:solidFill>
           <a:ln w="12700">
             <a:solidFill>
-              <a:srgbClr val="7C3AED"/>
+              <a:srgbClr val="0F766E"/>
             </a:solidFill>
             <a:prstDash val="solid"/>
           </a:ln>
@@ -11526,7 +11615,7 @@
                 <a:ea typeface="Aptos" pitchFamily="34" charset="-122"/>
                 <a:cs typeface="Aptos" pitchFamily="34" charset="-120"/>
               </a:rPr>
-              <a:t>60 - 90 days</a:t>
+              <a:t>A real gate</a:t>
             </a:r>
             <a:endParaRPr lang="en-US" sz="1200" dirty="0"/>
           </a:p>
@@ -11541,7 +11630,7 @@
         <p:spPr>
           <a:xfrm>
             <a:off x="8247888" y="1920240"/>
-            <a:ext cx="3200400" cy="1280160"/>
+            <a:ext cx="3200400" cy="1188720"/>
           </a:xfrm>
           <a:prstGeom prst="rect">
             <a:avLst/>
@@ -11567,7 +11656,7 @@
                 <a:ea typeface="Aptos" pitchFamily="34" charset="-122"/>
                 <a:cs typeface="Aptos" pitchFamily="34" charset="-120"/>
               </a:rPr>
-              <a:t>Limited pilot behind the human gate with a real (governed) source; continuous evaluation; expand toolboxes and observability dashboards.</a:t>
+              <a:t>Deterministic, offline checks over synthetic cases; a failure returns non-zero and blocks the release. Not a vibe check.</a:t>
             </a:r>
             <a:endParaRPr lang="en-US" sz="920" dirty="0"/>
           </a:p>
@@ -11581,7 +11670,7 @@
         </p:nvSpPr>
         <p:spPr>
           <a:xfrm>
-            <a:off x="640080" y="3520440"/>
+            <a:off x="640080" y="3429000"/>
             <a:ext cx="10972800" cy="2011680"/>
           </a:xfrm>
           <a:prstGeom prst="rect">
@@ -11609,7 +11698,7 @@
                 <a:ea typeface="Aptos" pitchFamily="34" charset="-122"/>
                 <a:cs typeface="Aptos" pitchFamily="34" charset="-120"/>
               </a:rPr>
-              <a:t>Cost discipline throughout: reuse platform resources; commitment-tier logging; no duplicated Search.</a:t>
+              <a:t>Measure retrieval with qrels; assert safety gates on the structured result before any pilot.</a:t>
             </a:r>
             <a:endParaRPr lang="en-US" sz="1150" dirty="0"/>
           </a:p>
@@ -11627,7 +11716,7 @@
                 <a:ea typeface="Aptos" pitchFamily="34" charset="-122"/>
                 <a:cs typeface="Aptos" pitchFamily="34" charset="-120"/>
               </a:rPr>
-              <a:t>Governance owners named per control (guardrails, RBAC, content safety, HITL).</a:t>
+              <a:t>Datasets: evaluation/golden-cases.jsonl and evaluation/adversarial-cases.jsonl.</a:t>
             </a:r>
             <a:endParaRPr lang="en-US" sz="1150" dirty="0"/>
           </a:p>
@@ -11645,7 +11734,7 @@
                 <a:ea typeface="Aptos" pitchFamily="34" charset="-122"/>
                 <a:cs typeface="Aptos" pitchFamily="34" charset="-120"/>
               </a:rPr>
-              <a:t>Futures to scope: BYO Registry, BYO AKS for hosted agents, SRE agent - as separate tracks.</a:t>
+              <a:t>Demo: green -&gt; inject a break -&gt; red / gate-blocked -&gt; revert -&gt; green (no code editing).</a:t>
             </a:r>
             <a:endParaRPr lang="en-US" sz="1150" dirty="0"/>
           </a:p>
@@ -11684,7 +11773,7 @@
                 <a:ea typeface="Aptos" pitchFamily="34" charset="-122"/>
                 <a:cs typeface="Aptos" pitchFamily="34" charset="-120"/>
               </a:rPr>
-              <a:t>A staged path: prove the pattern, harden the platform, then pilot behind the human gate.</a:t>
+              <a:t>You do not pilot a healthcare agent on trust - you pilot it on a passing gate.</a:t>
             </a:r>
             <a:endParaRPr lang="en-US" sz="1000" dirty="0"/>
           </a:p>
@@ -11803,7 +11892,7 @@
                 <a:ea typeface="Aptos" pitchFamily="34" charset="-122"/>
                 <a:cs typeface="Aptos" pitchFamily="34" charset="-120"/>
               </a:rPr>
-              <a:t>SOURCE-GROUNDED BRIEFS</a:t>
+              <a:t>WHAT KAISER DOES NEXT</a:t>
             </a:r>
             <a:endParaRPr lang="en-US" sz="800" dirty="0"/>
           </a:p>
@@ -11844,7 +11933,7 @@
                 <a:ea typeface="Aptos Display" pitchFamily="34" charset="-122"/>
                 <a:cs typeface="Aptos Display" pitchFamily="34" charset="-120"/>
               </a:rPr>
-              <a:t>Where to go deeper</a:t>
+              <a:t>30 / 60 / 90-day pilot roadmap</a:t>
             </a:r>
             <a:endParaRPr lang="en-US" sz="2300" dirty="0"/>
           </a:p>
@@ -11882,11 +11971,11 @@
         <p:spPr>
           <a:xfrm>
             <a:off x="640080" y="1463040"/>
-            <a:ext cx="5394960" cy="1737360"/>
+            <a:ext cx="3520440" cy="1828800"/>
           </a:xfrm>
           <a:prstGeom prst="roundRect">
             <a:avLst>
-              <a:gd name="adj" fmla="val 4211"/>
+              <a:gd name="adj" fmla="val 4000"/>
             </a:avLst>
           </a:prstGeom>
           <a:solidFill>
@@ -11916,7 +12005,7 @@
         <p:spPr>
           <a:xfrm>
             <a:off x="640080" y="1463040"/>
-            <a:ext cx="64008" cy="1737360"/>
+            <a:ext cx="64008" cy="1828800"/>
           </a:xfrm>
           <a:prstGeom prst="rect">
             <a:avLst/>
@@ -11941,7 +12030,7 @@
         <p:spPr>
           <a:xfrm>
             <a:off x="841248" y="1609344"/>
-            <a:ext cx="5074920" cy="219456"/>
+            <a:ext cx="3200400" cy="219456"/>
           </a:xfrm>
           <a:prstGeom prst="rect">
             <a:avLst/>
@@ -11967,7 +12056,7 @@
                 <a:ea typeface="Aptos" pitchFamily="34" charset="-122"/>
                 <a:cs typeface="Aptos" pitchFamily="34" charset="-120"/>
               </a:rPr>
-              <a:t>Tools + grounding</a:t>
+              <a:t>0 - 30 days</a:t>
             </a:r>
             <a:endParaRPr lang="en-US" sz="1200" dirty="0"/>
           </a:p>
@@ -11982,7 +12071,7 @@
         <p:spPr>
           <a:xfrm>
             <a:off x="841248" y="1920240"/>
-            <a:ext cx="5074920" cy="1188720"/>
+            <a:ext cx="3200400" cy="1280160"/>
           </a:xfrm>
           <a:prstGeom prst="rect">
             <a:avLst/>
@@ -12008,7 +12097,7 @@
                 <a:ea typeface="Aptos" pitchFamily="34" charset="-122"/>
                 <a:cs typeface="Aptos" pitchFamily="34" charset="-120"/>
               </a:rPr>
-              <a:t>Securing MCP tool servers; reusing capability-host Search and its cost; existing vs. Foundry search; SharePoint / O365 RAG ingest; RAG design guidance.</a:t>
+              <a:t>Stand up the governed pattern on a synthetic corpus; wire Foundry IQ to approved protocols; agree the safety gate and telemetry taxonomy.</a:t>
             </a:r>
             <a:endParaRPr lang="en-US" sz="920" dirty="0"/>
           </a:p>
@@ -12022,12 +12111,12 @@
         </p:nvSpPr>
         <p:spPr>
           <a:xfrm>
-            <a:off x="6217920" y="1463040"/>
-            <a:ext cx="5394960" cy="1737360"/>
+            <a:off x="4343400" y="1463040"/>
+            <a:ext cx="3520440" cy="1828800"/>
           </a:xfrm>
           <a:prstGeom prst="roundRect">
             <a:avLst>
-              <a:gd name="adj" fmla="val 4211"/>
+              <a:gd name="adj" fmla="val 4000"/>
             </a:avLst>
           </a:prstGeom>
           <a:solidFill>
@@ -12056,18 +12145,18 @@
         </p:nvSpPr>
         <p:spPr>
           <a:xfrm>
-            <a:off x="6217920" y="1463040"/>
-            <a:ext cx="64008" cy="1737360"/>
+            <a:off x="4343400" y="1463040"/>
+            <a:ext cx="64008" cy="1828800"/>
           </a:xfrm>
           <a:prstGeom prst="rect">
             <a:avLst/>
           </a:prstGeom>
           <a:solidFill>
-            <a:srgbClr val="7C3AED"/>
+            <a:srgbClr val="2563EB"/>
           </a:solidFill>
           <a:ln w="12700">
             <a:solidFill>
-              <a:srgbClr val="7C3AED"/>
+              <a:srgbClr val="2563EB"/>
             </a:solidFill>
             <a:prstDash val="solid"/>
           </a:ln>
@@ -12081,8 +12170,8 @@
         </p:nvSpPr>
         <p:spPr>
           <a:xfrm>
-            <a:off x="6419088" y="1609344"/>
-            <a:ext cx="5074920" cy="219456"/>
+            <a:off x="4544568" y="1609344"/>
+            <a:ext cx="3200400" cy="219456"/>
           </a:xfrm>
           <a:prstGeom prst="rect">
             <a:avLst/>
@@ -12108,7 +12197,7 @@
                 <a:ea typeface="Aptos" pitchFamily="34" charset="-122"/>
                 <a:cs typeface="Aptos" pitchFamily="34" charset="-120"/>
               </a:rPr>
-              <a:t>Safety + agents</a:t>
+              <a:t>30 - 60 days</a:t>
             </a:r>
             <a:endParaRPr lang="en-US" sz="1200" dirty="0"/>
           </a:p>
@@ -12122,8 +12211,8 @@
         </p:nvSpPr>
         <p:spPr>
           <a:xfrm>
-            <a:off x="6419088" y="1920240"/>
-            <a:ext cx="5074920" cy="1188720"/>
+            <a:off x="4544568" y="1920240"/>
+            <a:ext cx="3200400" cy="1280160"/>
           </a:xfrm>
           <a:prstGeom prst="rect">
             <a:avLst/>
@@ -12149,7 +12238,7 @@
                 <a:ea typeface="Aptos" pitchFamily="34" charset="-122"/>
                 <a:cs typeface="Aptos" pitchFamily="34" charset="-120"/>
               </a:rPr>
-              <a:t>Healthcare content safety; choosing the right agent type; governance, security and observability; guardrail policy and its test matrix.</a:t>
+              <a:t>Secure MCP + Toolbox for the first real tools; dedicated LAW cluster + CMK + AMPLS; capability-host reuse decisions per app team.</a:t>
             </a:r>
             <a:endParaRPr lang="en-US" sz="920" dirty="0"/>
           </a:p>
@@ -12163,12 +12252,12 @@
         </p:nvSpPr>
         <p:spPr>
           <a:xfrm>
-            <a:off x="640080" y="3337560"/>
-            <a:ext cx="5394960" cy="1554480"/>
+            <a:off x="8046720" y="1463040"/>
+            <a:ext cx="3520440" cy="1828800"/>
           </a:xfrm>
           <a:prstGeom prst="roundRect">
             <a:avLst>
-              <a:gd name="adj" fmla="val 4706"/>
+              <a:gd name="adj" fmla="val 4000"/>
             </a:avLst>
           </a:prstGeom>
           <a:solidFill>
@@ -12197,18 +12286,18 @@
         </p:nvSpPr>
         <p:spPr>
           <a:xfrm>
-            <a:off x="640080" y="3337560"/>
-            <a:ext cx="64008" cy="1554480"/>
+            <a:off x="8046720" y="1463040"/>
+            <a:ext cx="64008" cy="1828800"/>
           </a:xfrm>
           <a:prstGeom prst="rect">
             <a:avLst/>
           </a:prstGeom>
           <a:solidFill>
-            <a:srgbClr val="2563EB"/>
+            <a:srgbClr val="7C3AED"/>
           </a:solidFill>
           <a:ln w="12700">
             <a:solidFill>
-              <a:srgbClr val="2563EB"/>
+              <a:srgbClr val="7C3AED"/>
             </a:solidFill>
             <a:prstDash val="solid"/>
           </a:ln>
@@ -12222,8 +12311,8 @@
         </p:nvSpPr>
         <p:spPr>
           <a:xfrm>
-            <a:off x="841248" y="3483864"/>
-            <a:ext cx="5074920" cy="219456"/>
+            <a:off x="8247888" y="1609344"/>
+            <a:ext cx="3200400" cy="219456"/>
           </a:xfrm>
           <a:prstGeom prst="rect">
             <a:avLst/>
@@ -12249,7 +12338,7 @@
                 <a:ea typeface="Aptos" pitchFamily="34" charset="-122"/>
                 <a:cs typeface="Aptos" pitchFamily="34" charset="-120"/>
               </a:rPr>
-              <a:t>Operate</a:t>
+              <a:t>60 - 90 days</a:t>
             </a:r>
             <a:endParaRPr lang="en-US" sz="1200" dirty="0"/>
           </a:p>
@@ -12263,8 +12352,8 @@
         </p:nvSpPr>
         <p:spPr>
           <a:xfrm>
-            <a:off x="841248" y="3794760"/>
-            <a:ext cx="5074920" cy="1005840"/>
+            <a:off x="8247888" y="1920240"/>
+            <a:ext cx="3200400" cy="1280160"/>
           </a:xfrm>
           <a:prstGeom prst="rect">
             <a:avLst/>
@@ -12290,7 +12379,7 @@
                 <a:ea typeface="Aptos" pitchFamily="34" charset="-122"/>
                 <a:cs typeface="Aptos" pitchFamily="34" charset="-120"/>
               </a:rPr>
-              <a:t>Dedicated cluster with CMK and AMPLS; end-to-end trace correlation; human-in-the-loop with the Durable Task Scheduler.</a:t>
+              <a:t>Limited pilot behind the human gate with a real (governed) source; continuous evaluation; expand toolboxes and observability dashboards.</a:t>
             </a:r>
             <a:endParaRPr lang="en-US" sz="920" dirty="0"/>
           </a:p>
@@ -12298,18 +12387,318 @@
       </p:sp>
       <p:sp>
         <p:nvSpPr>
-          <p:cNvPr id="17" name="Shape 15"/>
-          <p:cNvSpPr/>
-          <p:nvPr/>
-        </p:nvSpPr>
-        <p:spPr>
-          <a:xfrm>
-            <a:off x="6217920" y="3337560"/>
-            <a:ext cx="5394960" cy="1554480"/>
+          <p:cNvPr id="17" name="Text 15"/>
+          <p:cNvSpPr/>
+          <p:nvPr/>
+        </p:nvSpPr>
+        <p:spPr>
+          <a:xfrm>
+            <a:off x="640080" y="3520440"/>
+            <a:ext cx="10972800" cy="2011680"/>
+          </a:xfrm>
+          <a:prstGeom prst="rect">
+            <a:avLst/>
+          </a:prstGeom>
+          <a:noFill/>
+          <a:ln/>
+        </p:spPr>
+        <p:txBody>
+          <a:bodyPr wrap="square" lIns="381" tIns="381" rIns="381" bIns="381" rtlCol="0" anchor="ctr">
+            <a:normAutofit/>
+          </a:bodyPr>
+          <a:lstStyle/>
+          <a:p>
+            <a:pPr marL="152400" indent="-152400">
+              <a:buSzPct val="100000"/>
+              <a:buChar char="•"/>
+            </a:pPr>
+            <a:r>
+              <a:rPr lang="en-US" sz="1150" dirty="0">
+                <a:solidFill>
+                  <a:srgbClr val="334155"/>
+                </a:solidFill>
+                <a:latin typeface="Aptos" pitchFamily="34" charset="0"/>
+                <a:ea typeface="Aptos" pitchFamily="34" charset="-122"/>
+                <a:cs typeface="Aptos" pitchFamily="34" charset="-120"/>
+              </a:rPr>
+              <a:t>Cost discipline throughout: reuse platform resources; commitment-tier logging; no duplicated Search.</a:t>
+            </a:r>
+            <a:endParaRPr lang="en-US" sz="1150" dirty="0"/>
+          </a:p>
+          <a:p>
+            <a:pPr marL="152400" indent="-152400">
+              <a:buSzPct val="100000"/>
+              <a:buChar char="•"/>
+            </a:pPr>
+            <a:r>
+              <a:rPr lang="en-US" sz="1150" dirty="0">
+                <a:solidFill>
+                  <a:srgbClr val="334155"/>
+                </a:solidFill>
+                <a:latin typeface="Aptos" pitchFamily="34" charset="0"/>
+                <a:ea typeface="Aptos" pitchFamily="34" charset="-122"/>
+                <a:cs typeface="Aptos" pitchFamily="34" charset="-120"/>
+              </a:rPr>
+              <a:t>Governance owners named per control (guardrails, RBAC, content safety, HITL).</a:t>
+            </a:r>
+            <a:endParaRPr lang="en-US" sz="1150" dirty="0"/>
+          </a:p>
+          <a:p>
+            <a:pPr marL="152400" indent="-152400">
+              <a:buSzPct val="100000"/>
+              <a:buChar char="•"/>
+            </a:pPr>
+            <a:r>
+              <a:rPr lang="en-US" sz="1150" dirty="0">
+                <a:solidFill>
+                  <a:srgbClr val="334155"/>
+                </a:solidFill>
+                <a:latin typeface="Aptos" pitchFamily="34" charset="0"/>
+                <a:ea typeface="Aptos" pitchFamily="34" charset="-122"/>
+                <a:cs typeface="Aptos" pitchFamily="34" charset="-120"/>
+              </a:rPr>
+              <a:t>Futures to scope: BYO Registry, BYO AKS for hosted agents, SRE agent - as separate tracks.</a:t>
+            </a:r>
+            <a:endParaRPr lang="en-US" sz="1150" dirty="0"/>
+          </a:p>
+        </p:txBody>
+      </p:sp>
+      <p:sp>
+        <p:nvSpPr>
+          <p:cNvPr id="18" name="Text 16"/>
+          <p:cNvSpPr/>
+          <p:nvPr/>
+        </p:nvSpPr>
+        <p:spPr>
+          <a:xfrm>
+            <a:off x="640080" y="5806440"/>
+            <a:ext cx="10972800" cy="457200"/>
+          </a:xfrm>
+          <a:prstGeom prst="rect">
+            <a:avLst/>
+          </a:prstGeom>
+          <a:noFill/>
+          <a:ln/>
+        </p:spPr>
+        <p:txBody>
+          <a:bodyPr wrap="square" lIns="0" tIns="0" rIns="0" bIns="0" rtlCol="0" anchor="ctr"/>
+          <a:lstStyle/>
+          <a:p>
+            <a:pPr indent="0" marL="0">
+              <a:buNone/>
+            </a:pPr>
+            <a:r>
+              <a:rPr lang="en-US" sz="1000" i="1" dirty="0">
+                <a:solidFill>
+                  <a:srgbClr val="64748B"/>
+                </a:solidFill>
+                <a:latin typeface="Aptos" pitchFamily="34" charset="0"/>
+                <a:ea typeface="Aptos" pitchFamily="34" charset="-122"/>
+                <a:cs typeface="Aptos" pitchFamily="34" charset="-120"/>
+              </a:rPr>
+              <a:t>A staged path: prove the pattern, harden the platform, then pilot behind the human gate.</a:t>
+            </a:r>
+            <a:endParaRPr lang="en-US" sz="1000" dirty="0"/>
+          </a:p>
+        </p:txBody>
+      </p:sp>
+      <p:sp>
+        <p:nvSpPr>
+          <p:cNvPr id="25" name="Slide Number Placeholder 0"/>
+          <p:cNvSpPr>
+            <a:spLocks noGrp="1"/>
+          </p:cNvSpPr>
+          <p:nvPr>
+            <p:ph type="sldNum" sz="quarter" idx="4294967295"/>
+          </p:nvPr>
+        </p:nvSpPr>
+        <p:spPr>
+          <a:xfrm>
+            <a:off x="11475720" y="6565392"/>
+            <a:ext cx="800000" cy="300000"/>
+          </a:xfrm>
+          <a:prstGeom prst="rect">
+            <a:avLst/>
+          </a:prstGeom>
+          <a:extLst>
+            <a:ext uri="{C572A759-6A51-4108-AA02-DFA0A04FC94B}">
+              <ma14:wrappingTextBoxFlag xmlns:ma14="http://schemas.microsoft.com/office/mac/drawingml/2011/main" val="0"/>
+            </a:ext>
+          </a:extLst>
+        </p:spPr>
+        <p:txBody>
+          <a:bodyPr/>
+          <a:lstStyle>
+            <a:lvl1pPr>
+              <a:defRPr sz="700">
+                <a:solidFill>
+                  <a:srgbClr val="64748B"/>
+                </a:solidFill>
+                <a:latin typeface="Aptos"/>
+                <a:ea typeface="Aptos"/>
+                <a:cs typeface="Aptos"/>
+              </a:defRPr>
+            </a:lvl1pPr>
+          </a:lstStyle>
+          <a:p>
+            <a:pPr algn="l"/>
+            <a:fld id="{F7021451-1387-4CA6-816F-3879F97B5CBC}" type="slidenum">
+              <a:rPr b="0" lang="en-US"/>
+              <a:t>21</a:t>
+            </a:fld>
+            <a:endParaRPr lang="en-US"/>
+          </a:p>
+        </p:txBody>
+      </p:sp>
+    </p:spTree>
+  </p:cSld>
+  <p:clrMapOvr>
+    <a:masterClrMapping/>
+  </p:clrMapOvr>
+</p:sld>
+</file>
+
+<file path=ppt/slides/slide22.xml><?xml version="1.0" encoding="utf-8"?>
+<p:sld xmlns:a="http://schemas.openxmlformats.org/drawingml/2006/main" xmlns:r="http://schemas.openxmlformats.org/officeDocument/2006/relationships" xmlns:p="http://schemas.openxmlformats.org/presentationml/2006/main">
+  <p:cSld name="Slide 22">
+    <p:bg>
+      <p:bgPr>
+        <a:solidFill>
+          <a:srgbClr val="F8FAFC"/>
+        </a:solidFill>
+      </p:bgPr>
+    </p:bg>
+    <p:spTree>
+      <p:nvGrpSpPr>
+        <p:cNvPr id="1" name=""/>
+        <p:cNvGrpSpPr/>
+        <p:nvPr/>
+      </p:nvGrpSpPr>
+      <p:grpSpPr>
+        <a:xfrm>
+          <a:off x="0" y="0"/>
+          <a:ext cx="0" cy="0"/>
+          <a:chOff x="0" y="0"/>
+          <a:chExt cx="0" cy="0"/>
+        </a:xfrm>
+      </p:grpSpPr>
+      <p:sp>
+        <p:nvSpPr>
+          <p:cNvPr id="2" name="Text 0"/>
+          <p:cNvSpPr/>
+          <p:nvPr/>
+        </p:nvSpPr>
+        <p:spPr>
+          <a:xfrm>
+            <a:off x="566928" y="384048"/>
+            <a:ext cx="10789920" cy="201168"/>
+          </a:xfrm>
+          <a:prstGeom prst="rect">
+            <a:avLst/>
+          </a:prstGeom>
+          <a:noFill/>
+          <a:ln/>
+        </p:spPr>
+        <p:txBody>
+          <a:bodyPr wrap="square" lIns="0" tIns="0" rIns="0" bIns="0" rtlCol="0" anchor="ctr"/>
+          <a:lstStyle/>
+          <a:p>
+            <a:pPr indent="0" marL="0">
+              <a:buNone/>
+            </a:pPr>
+            <a:r>
+              <a:rPr lang="en-US" sz="800" b="1" dirty="0">
+                <a:solidFill>
+                  <a:srgbClr val="0F766E"/>
+                </a:solidFill>
+                <a:latin typeface="Aptos" pitchFamily="34" charset="0"/>
+                <a:ea typeface="Aptos" pitchFamily="34" charset="-122"/>
+                <a:cs typeface="Aptos" pitchFamily="34" charset="-120"/>
+              </a:rPr>
+              <a:t>SOURCE-GROUNDED BRIEFS</a:t>
+            </a:r>
+            <a:endParaRPr lang="en-US" sz="800" dirty="0"/>
+          </a:p>
+        </p:txBody>
+      </p:sp>
+      <p:sp>
+        <p:nvSpPr>
+          <p:cNvPr id="3" name="Text 1"/>
+          <p:cNvSpPr/>
+          <p:nvPr/>
+        </p:nvSpPr>
+        <p:spPr>
+          <a:xfrm>
+            <a:off x="548640" y="658368"/>
+            <a:ext cx="11064240" cy="502920"/>
+          </a:xfrm>
+          <a:prstGeom prst="rect">
+            <a:avLst/>
+          </a:prstGeom>
+          <a:noFill/>
+          <a:ln/>
+        </p:spPr>
+        <p:txBody>
+          <a:bodyPr wrap="square" lIns="0" tIns="0" rIns="0" bIns="0" rtlCol="0" anchor="ctr">
+            <a:normAutofit/>
+          </a:bodyPr>
+          <a:lstStyle/>
+          <a:p>
+            <a:pPr indent="0" marL="0">
+              <a:buNone/>
+            </a:pPr>
+            <a:r>
+              <a:rPr lang="en-US" sz="2300" b="1" dirty="0">
+                <a:solidFill>
+                  <a:srgbClr val="0B1220"/>
+                </a:solidFill>
+                <a:latin typeface="Aptos Display" pitchFamily="34" charset="0"/>
+                <a:ea typeface="Aptos Display" pitchFamily="34" charset="-122"/>
+                <a:cs typeface="Aptos Display" pitchFamily="34" charset="-120"/>
+              </a:rPr>
+              <a:t>Where to go deeper</a:t>
+            </a:r>
+            <a:endParaRPr lang="en-US" sz="2300" dirty="0"/>
+          </a:p>
+        </p:txBody>
+      </p:sp>
+      <p:sp>
+        <p:nvSpPr>
+          <p:cNvPr id="4" name="Shape 2"/>
+          <p:cNvSpPr/>
+          <p:nvPr/>
+        </p:nvSpPr>
+        <p:spPr>
+          <a:xfrm>
+            <a:off x="548640" y="1243584"/>
+            <a:ext cx="11064240" cy="0"/>
+          </a:xfrm>
+          <a:prstGeom prst="line">
+            <a:avLst/>
+          </a:prstGeom>
+          <a:noFill/>
+          <a:ln w="12700">
+            <a:solidFill>
+              <a:srgbClr val="CBD5E1"/>
+            </a:solidFill>
+            <a:prstDash val="solid"/>
+          </a:ln>
+        </p:spPr>
+      </p:sp>
+      <p:sp>
+        <p:nvSpPr>
+          <p:cNvPr id="5" name="Shape 3"/>
+          <p:cNvSpPr/>
+          <p:nvPr/>
+        </p:nvSpPr>
+        <p:spPr>
+          <a:xfrm>
+            <a:off x="640080" y="1463040"/>
+            <a:ext cx="5394960" cy="1737360"/>
           </a:xfrm>
           <a:prstGeom prst="roundRect">
             <a:avLst>
-              <a:gd name="adj" fmla="val 4706"/>
+              <a:gd name="adj" fmla="val 4211"/>
             </a:avLst>
           </a:prstGeom>
           <a:solidFill>
@@ -12332,6 +12721,429 @@
       </p:sp>
       <p:sp>
         <p:nvSpPr>
+          <p:cNvPr id="6" name="Shape 4"/>
+          <p:cNvSpPr/>
+          <p:nvPr/>
+        </p:nvSpPr>
+        <p:spPr>
+          <a:xfrm>
+            <a:off x="640080" y="1463040"/>
+            <a:ext cx="64008" cy="1737360"/>
+          </a:xfrm>
+          <a:prstGeom prst="rect">
+            <a:avLst/>
+          </a:prstGeom>
+          <a:solidFill>
+            <a:srgbClr val="0F766E"/>
+          </a:solidFill>
+          <a:ln w="12700">
+            <a:solidFill>
+              <a:srgbClr val="0F766E"/>
+            </a:solidFill>
+            <a:prstDash val="solid"/>
+          </a:ln>
+        </p:spPr>
+      </p:sp>
+      <p:sp>
+        <p:nvSpPr>
+          <p:cNvPr id="7" name="Text 5"/>
+          <p:cNvSpPr/>
+          <p:nvPr/>
+        </p:nvSpPr>
+        <p:spPr>
+          <a:xfrm>
+            <a:off x="841248" y="1609344"/>
+            <a:ext cx="5074920" cy="219456"/>
+          </a:xfrm>
+          <a:prstGeom prst="rect">
+            <a:avLst/>
+          </a:prstGeom>
+          <a:noFill/>
+          <a:ln/>
+        </p:spPr>
+        <p:txBody>
+          <a:bodyPr wrap="square" lIns="0" tIns="0" rIns="0" bIns="0" rtlCol="0" anchor="ctr">
+            <a:normAutofit/>
+          </a:bodyPr>
+          <a:lstStyle/>
+          <a:p>
+            <a:pPr indent="0" marL="0">
+              <a:buNone/>
+            </a:pPr>
+            <a:r>
+              <a:rPr lang="en-US" sz="1200" b="1" dirty="0">
+                <a:solidFill>
+                  <a:srgbClr val="0B1220"/>
+                </a:solidFill>
+                <a:latin typeface="Aptos" pitchFamily="34" charset="0"/>
+                <a:ea typeface="Aptos" pitchFamily="34" charset="-122"/>
+                <a:cs typeface="Aptos" pitchFamily="34" charset="-120"/>
+              </a:rPr>
+              <a:t>Tools + grounding</a:t>
+            </a:r>
+            <a:endParaRPr lang="en-US" sz="1200" dirty="0"/>
+          </a:p>
+        </p:txBody>
+      </p:sp>
+      <p:sp>
+        <p:nvSpPr>
+          <p:cNvPr id="8" name="Text 6"/>
+          <p:cNvSpPr/>
+          <p:nvPr/>
+        </p:nvSpPr>
+        <p:spPr>
+          <a:xfrm>
+            <a:off x="841248" y="1920240"/>
+            <a:ext cx="5074920" cy="1188720"/>
+          </a:xfrm>
+          <a:prstGeom prst="rect">
+            <a:avLst/>
+          </a:prstGeom>
+          <a:noFill/>
+          <a:ln/>
+        </p:spPr>
+        <p:txBody>
+          <a:bodyPr wrap="square" lIns="254" tIns="254" rIns="254" bIns="254" rtlCol="0" anchor="t">
+            <a:normAutofit/>
+          </a:bodyPr>
+          <a:lstStyle/>
+          <a:p>
+            <a:pPr indent="0" marL="0">
+              <a:buNone/>
+            </a:pPr>
+            <a:r>
+              <a:rPr lang="en-US" sz="920" dirty="0">
+                <a:solidFill>
+                  <a:srgbClr val="334155"/>
+                </a:solidFill>
+                <a:latin typeface="Aptos" pitchFamily="34" charset="0"/>
+                <a:ea typeface="Aptos" pitchFamily="34" charset="-122"/>
+                <a:cs typeface="Aptos" pitchFamily="34" charset="-120"/>
+              </a:rPr>
+              <a:t>Securing MCP tool servers; reusing capability-host Search and its cost; existing vs. Foundry search; SharePoint / O365 RAG ingest; RAG design guidance.</a:t>
+            </a:r>
+            <a:endParaRPr lang="en-US" sz="920" dirty="0"/>
+          </a:p>
+        </p:txBody>
+      </p:sp>
+      <p:sp>
+        <p:nvSpPr>
+          <p:cNvPr id="9" name="Shape 7"/>
+          <p:cNvSpPr/>
+          <p:nvPr/>
+        </p:nvSpPr>
+        <p:spPr>
+          <a:xfrm>
+            <a:off x="6217920" y="1463040"/>
+            <a:ext cx="5394960" cy="1737360"/>
+          </a:xfrm>
+          <a:prstGeom prst="roundRect">
+            <a:avLst>
+              <a:gd name="adj" fmla="val 4211"/>
+            </a:avLst>
+          </a:prstGeom>
+          <a:solidFill>
+            <a:srgbClr val="FFFFFF"/>
+          </a:solidFill>
+          <a:ln w="12700">
+            <a:solidFill>
+              <a:srgbClr val="E2E8F0"/>
+            </a:solidFill>
+            <a:prstDash val="solid"/>
+          </a:ln>
+          <a:effectLst>
+            <a:outerShdw sx="100000" sy="100000" kx="0" ky="0" algn="bl" rotWithShape="0" blurRad="25400" dist="50800" dir="2700000">
+              <a:srgbClr val="94A3B8">
+                <a:alpha val="12000"/>
+              </a:srgbClr>
+            </a:outerShdw>
+          </a:effectLst>
+        </p:spPr>
+      </p:sp>
+      <p:sp>
+        <p:nvSpPr>
+          <p:cNvPr id="10" name="Shape 8"/>
+          <p:cNvSpPr/>
+          <p:nvPr/>
+        </p:nvSpPr>
+        <p:spPr>
+          <a:xfrm>
+            <a:off x="6217920" y="1463040"/>
+            <a:ext cx="64008" cy="1737360"/>
+          </a:xfrm>
+          <a:prstGeom prst="rect">
+            <a:avLst/>
+          </a:prstGeom>
+          <a:solidFill>
+            <a:srgbClr val="7C3AED"/>
+          </a:solidFill>
+          <a:ln w="12700">
+            <a:solidFill>
+              <a:srgbClr val="7C3AED"/>
+            </a:solidFill>
+            <a:prstDash val="solid"/>
+          </a:ln>
+        </p:spPr>
+      </p:sp>
+      <p:sp>
+        <p:nvSpPr>
+          <p:cNvPr id="11" name="Text 9"/>
+          <p:cNvSpPr/>
+          <p:nvPr/>
+        </p:nvSpPr>
+        <p:spPr>
+          <a:xfrm>
+            <a:off x="6419088" y="1609344"/>
+            <a:ext cx="5074920" cy="219456"/>
+          </a:xfrm>
+          <a:prstGeom prst="rect">
+            <a:avLst/>
+          </a:prstGeom>
+          <a:noFill/>
+          <a:ln/>
+        </p:spPr>
+        <p:txBody>
+          <a:bodyPr wrap="square" lIns="0" tIns="0" rIns="0" bIns="0" rtlCol="0" anchor="ctr">
+            <a:normAutofit/>
+          </a:bodyPr>
+          <a:lstStyle/>
+          <a:p>
+            <a:pPr indent="0" marL="0">
+              <a:buNone/>
+            </a:pPr>
+            <a:r>
+              <a:rPr lang="en-US" sz="1200" b="1" dirty="0">
+                <a:solidFill>
+                  <a:srgbClr val="0B1220"/>
+                </a:solidFill>
+                <a:latin typeface="Aptos" pitchFamily="34" charset="0"/>
+                <a:ea typeface="Aptos" pitchFamily="34" charset="-122"/>
+                <a:cs typeface="Aptos" pitchFamily="34" charset="-120"/>
+              </a:rPr>
+              <a:t>Safety + agents</a:t>
+            </a:r>
+            <a:endParaRPr lang="en-US" sz="1200" dirty="0"/>
+          </a:p>
+        </p:txBody>
+      </p:sp>
+      <p:sp>
+        <p:nvSpPr>
+          <p:cNvPr id="12" name="Text 10"/>
+          <p:cNvSpPr/>
+          <p:nvPr/>
+        </p:nvSpPr>
+        <p:spPr>
+          <a:xfrm>
+            <a:off x="6419088" y="1920240"/>
+            <a:ext cx="5074920" cy="1188720"/>
+          </a:xfrm>
+          <a:prstGeom prst="rect">
+            <a:avLst/>
+          </a:prstGeom>
+          <a:noFill/>
+          <a:ln/>
+        </p:spPr>
+        <p:txBody>
+          <a:bodyPr wrap="square" lIns="254" tIns="254" rIns="254" bIns="254" rtlCol="0" anchor="t">
+            <a:normAutofit/>
+          </a:bodyPr>
+          <a:lstStyle/>
+          <a:p>
+            <a:pPr indent="0" marL="0">
+              <a:buNone/>
+            </a:pPr>
+            <a:r>
+              <a:rPr lang="en-US" sz="920" dirty="0">
+                <a:solidFill>
+                  <a:srgbClr val="334155"/>
+                </a:solidFill>
+                <a:latin typeface="Aptos" pitchFamily="34" charset="0"/>
+                <a:ea typeface="Aptos" pitchFamily="34" charset="-122"/>
+                <a:cs typeface="Aptos" pitchFamily="34" charset="-120"/>
+              </a:rPr>
+              <a:t>Healthcare content safety; choosing the right agent type; governance, security and observability; guardrail policy and its test matrix.</a:t>
+            </a:r>
+            <a:endParaRPr lang="en-US" sz="920" dirty="0"/>
+          </a:p>
+        </p:txBody>
+      </p:sp>
+      <p:sp>
+        <p:nvSpPr>
+          <p:cNvPr id="13" name="Shape 11"/>
+          <p:cNvSpPr/>
+          <p:nvPr/>
+        </p:nvSpPr>
+        <p:spPr>
+          <a:xfrm>
+            <a:off x="640080" y="3337560"/>
+            <a:ext cx="5394960" cy="1554480"/>
+          </a:xfrm>
+          <a:prstGeom prst="roundRect">
+            <a:avLst>
+              <a:gd name="adj" fmla="val 4706"/>
+            </a:avLst>
+          </a:prstGeom>
+          <a:solidFill>
+            <a:srgbClr val="FFFFFF"/>
+          </a:solidFill>
+          <a:ln w="12700">
+            <a:solidFill>
+              <a:srgbClr val="E2E8F0"/>
+            </a:solidFill>
+            <a:prstDash val="solid"/>
+          </a:ln>
+          <a:effectLst>
+            <a:outerShdw sx="100000" sy="100000" kx="0" ky="0" algn="bl" rotWithShape="0" blurRad="25400" dist="50800" dir="2700000">
+              <a:srgbClr val="94A3B8">
+                <a:alpha val="12000"/>
+              </a:srgbClr>
+            </a:outerShdw>
+          </a:effectLst>
+        </p:spPr>
+      </p:sp>
+      <p:sp>
+        <p:nvSpPr>
+          <p:cNvPr id="14" name="Shape 12"/>
+          <p:cNvSpPr/>
+          <p:nvPr/>
+        </p:nvSpPr>
+        <p:spPr>
+          <a:xfrm>
+            <a:off x="640080" y="3337560"/>
+            <a:ext cx="64008" cy="1554480"/>
+          </a:xfrm>
+          <a:prstGeom prst="rect">
+            <a:avLst/>
+          </a:prstGeom>
+          <a:solidFill>
+            <a:srgbClr val="2563EB"/>
+          </a:solidFill>
+          <a:ln w="12700">
+            <a:solidFill>
+              <a:srgbClr val="2563EB"/>
+            </a:solidFill>
+            <a:prstDash val="solid"/>
+          </a:ln>
+        </p:spPr>
+      </p:sp>
+      <p:sp>
+        <p:nvSpPr>
+          <p:cNvPr id="15" name="Text 13"/>
+          <p:cNvSpPr/>
+          <p:nvPr/>
+        </p:nvSpPr>
+        <p:spPr>
+          <a:xfrm>
+            <a:off x="841248" y="3483864"/>
+            <a:ext cx="5074920" cy="219456"/>
+          </a:xfrm>
+          <a:prstGeom prst="rect">
+            <a:avLst/>
+          </a:prstGeom>
+          <a:noFill/>
+          <a:ln/>
+        </p:spPr>
+        <p:txBody>
+          <a:bodyPr wrap="square" lIns="0" tIns="0" rIns="0" bIns="0" rtlCol="0" anchor="ctr">
+            <a:normAutofit/>
+          </a:bodyPr>
+          <a:lstStyle/>
+          <a:p>
+            <a:pPr indent="0" marL="0">
+              <a:buNone/>
+            </a:pPr>
+            <a:r>
+              <a:rPr lang="en-US" sz="1200" b="1" dirty="0">
+                <a:solidFill>
+                  <a:srgbClr val="0B1220"/>
+                </a:solidFill>
+                <a:latin typeface="Aptos" pitchFamily="34" charset="0"/>
+                <a:ea typeface="Aptos" pitchFamily="34" charset="-122"/>
+                <a:cs typeface="Aptos" pitchFamily="34" charset="-120"/>
+              </a:rPr>
+              <a:t>Operate</a:t>
+            </a:r>
+            <a:endParaRPr lang="en-US" sz="1200" dirty="0"/>
+          </a:p>
+        </p:txBody>
+      </p:sp>
+      <p:sp>
+        <p:nvSpPr>
+          <p:cNvPr id="16" name="Text 14"/>
+          <p:cNvSpPr/>
+          <p:nvPr/>
+        </p:nvSpPr>
+        <p:spPr>
+          <a:xfrm>
+            <a:off x="841248" y="3794760"/>
+            <a:ext cx="5074920" cy="1005840"/>
+          </a:xfrm>
+          <a:prstGeom prst="rect">
+            <a:avLst/>
+          </a:prstGeom>
+          <a:noFill/>
+          <a:ln/>
+        </p:spPr>
+        <p:txBody>
+          <a:bodyPr wrap="square" lIns="254" tIns="254" rIns="254" bIns="254" rtlCol="0" anchor="t">
+            <a:normAutofit/>
+          </a:bodyPr>
+          <a:lstStyle/>
+          <a:p>
+            <a:pPr indent="0" marL="0">
+              <a:buNone/>
+            </a:pPr>
+            <a:r>
+              <a:rPr lang="en-US" sz="920" dirty="0">
+                <a:solidFill>
+                  <a:srgbClr val="334155"/>
+                </a:solidFill>
+                <a:latin typeface="Aptos" pitchFamily="34" charset="0"/>
+                <a:ea typeface="Aptos" pitchFamily="34" charset="-122"/>
+                <a:cs typeface="Aptos" pitchFamily="34" charset="-120"/>
+              </a:rPr>
+              <a:t>Dedicated cluster with CMK and AMPLS; end-to-end trace correlation; human-in-the-loop with the Durable Task Scheduler.</a:t>
+            </a:r>
+            <a:endParaRPr lang="en-US" sz="920" dirty="0"/>
+          </a:p>
+        </p:txBody>
+      </p:sp>
+      <p:sp>
+        <p:nvSpPr>
+          <p:cNvPr id="17" name="Shape 15"/>
+          <p:cNvSpPr/>
+          <p:nvPr/>
+        </p:nvSpPr>
+        <p:spPr>
+          <a:xfrm>
+            <a:off x="6217920" y="3337560"/>
+            <a:ext cx="5394960" cy="1554480"/>
+          </a:xfrm>
+          <a:prstGeom prst="roundRect">
+            <a:avLst>
+              <a:gd name="adj" fmla="val 4706"/>
+            </a:avLst>
+          </a:prstGeom>
+          <a:solidFill>
+            <a:srgbClr val="FFFFFF"/>
+          </a:solidFill>
+          <a:ln w="12700">
+            <a:solidFill>
+              <a:srgbClr val="E2E8F0"/>
+            </a:solidFill>
+            <a:prstDash val="solid"/>
+          </a:ln>
+          <a:effectLst>
+            <a:outerShdw sx="100000" sy="100000" kx="0" ky="0" algn="bl" rotWithShape="0" blurRad="25400" dist="50800" dir="2700000">
+              <a:srgbClr val="94A3B8">
+                <a:alpha val="12000"/>
+              </a:srgbClr>
+            </a:outerShdw>
+          </a:effectLst>
+        </p:spPr>
+      </p:sp>
+      <p:sp>
+        <p:nvSpPr>
           <p:cNvPr id="18" name="Shape 16"/>
           <p:cNvSpPr/>
           <p:nvPr/>
@@ -12518,7 +13330,7 @@
             <a:pPr algn="l"/>
             <a:fld id="{F7021451-1387-4CA6-816F-3879F97B5CBC}" type="slidenum">
               <a:rPr b="0" lang="en-US"/>
-              <a:t>21</a:t>
+              <a:t>22</a:t>
             </a:fld>
             <a:endParaRPr lang="en-US"/>
           </a:p>
@@ -12532,9 +13344,9 @@
 </p:sld>
 </file>
 
-<file path=ppt/slides/slide22.xml><?xml version="1.0" encoding="utf-8"?>
+<file path=ppt/slides/slide23.xml><?xml version="1.0" encoding="utf-8"?>
 <p:sld xmlns:a="http://schemas.openxmlformats.org/drawingml/2006/main" xmlns:r="http://schemas.openxmlformats.org/officeDocument/2006/relationships" xmlns:p="http://schemas.openxmlformats.org/presentationml/2006/main">
-  <p:cSld name="Slide 22">
+  <p:cSld name="Slide 23">
     <p:bg>
       <p:bgPr>
         <a:solidFill>
@@ -16896,7 +17708,7 @@
                 <a:ea typeface="Aptos" pitchFamily="34" charset="-122"/>
                 <a:cs typeface="Aptos" pitchFamily="34" charset="-120"/>
               </a:rPr>
-              <a:t>Work IQ is a permission-aware pattern: the agent never bypasses user permissions.</a:t>
+              <a:t>Work IQ is Microsoft's governed M365 context service (next slide) - the agent never bypasses user permissions.</a:t>
             </a:r>
             <a:endParaRPr lang="en-US" sz="1150" dirty="0"/>
           </a:p>
@@ -17072,7 +17884,7 @@
                 <a:ea typeface="Aptos" pitchFamily="34" charset="-122"/>
                 <a:cs typeface="Aptos" pitchFamily="34" charset="-120"/>
               </a:rPr>
-              <a:t>PRIORITY - PAIRS WITH MCP</a:t>
+              <a:t>PRIORITY - SARITA/MATT: ENTERPRISE CONTEXT</a:t>
             </a:r>
             <a:endParaRPr lang="en-US" sz="800" dirty="0"/>
           </a:p>
@@ -17113,7 +17925,7 @@
                 <a:ea typeface="Aptos Display" pitchFamily="34" charset="-122"/>
                 <a:cs typeface="Aptos Display" pitchFamily="34" charset="-120"/>
               </a:rPr>
-              <a:t>Toolboxes: one governed endpoint</a:t>
+              <a:t>Work IQ: governed M365 work context</a:t>
             </a:r>
             <a:endParaRPr lang="en-US" sz="2300" dirty="0"/>
           </a:p>
@@ -17151,11 +17963,11 @@
         <p:spPr>
           <a:xfrm>
             <a:off x="640080" y="1463040"/>
-            <a:ext cx="3520440" cy="1783080"/>
+            <a:ext cx="3520440" cy="1965960"/>
           </a:xfrm>
           <a:prstGeom prst="roundRect">
             <a:avLst>
-              <a:gd name="adj" fmla="val 4103"/>
+              <a:gd name="adj" fmla="val 3721"/>
             </a:avLst>
           </a:prstGeom>
           <a:solidFill>
@@ -17185,17 +17997,17 @@
         <p:spPr>
           <a:xfrm>
             <a:off x="640080" y="1463040"/>
-            <a:ext cx="64008" cy="1783080"/>
+            <a:ext cx="64008" cy="1965960"/>
           </a:xfrm>
           <a:prstGeom prst="rect">
             <a:avLst/>
           </a:prstGeom>
           <a:solidFill>
-            <a:srgbClr val="F59E0B"/>
+            <a:srgbClr val="0F766E"/>
           </a:solidFill>
           <a:ln w="12700">
             <a:solidFill>
-              <a:srgbClr val="F59E0B"/>
+              <a:srgbClr val="0F766E"/>
             </a:solidFill>
             <a:prstDash val="solid"/>
           </a:ln>
@@ -17236,7 +18048,7 @@
                 <a:ea typeface="Aptos" pitchFamily="34" charset="-122"/>
                 <a:cs typeface="Aptos" pitchFamily="34" charset="-120"/>
               </a:rPr>
-              <a:t>The problem</a:t>
+              <a:t>What it is</a:t>
             </a:r>
             <a:endParaRPr lang="en-US" sz="1200" dirty="0"/>
           </a:p>
@@ -17251,7 +18063,7 @@
         <p:spPr>
           <a:xfrm>
             <a:off x="841248" y="1920240"/>
-            <a:ext cx="3200400" cy="1234440"/>
+            <a:ext cx="3200400" cy="1417320"/>
           </a:xfrm>
           <a:prstGeom prst="rect">
             <a:avLst/>
@@ -17277,7 +18089,7 @@
                 <a:ea typeface="Aptos" pitchFamily="34" charset="-122"/>
                 <a:cs typeface="Aptos" pitchFamily="34" charset="-120"/>
               </a:rPr>
-              <a:t>Configuring tools + credentials on every agent creates sprawl and drift - hard to govern, version, or rotate.</a:t>
+              <a:t>Microsoft's workplace intelligence layer over Microsoft 365. Reasons over mail, Teams, files, people, calendar, Planner, and enterprise search - with built-in permission-aware governance.</a:t>
             </a:r>
             <a:endParaRPr lang="en-US" sz="920" dirty="0"/>
           </a:p>
@@ -17292,11 +18104,11 @@
         <p:spPr>
           <a:xfrm>
             <a:off x="4343400" y="1463040"/>
-            <a:ext cx="3520440" cy="1783080"/>
+            <a:ext cx="3520440" cy="1965960"/>
           </a:xfrm>
           <a:prstGeom prst="roundRect">
             <a:avLst>
-              <a:gd name="adj" fmla="val 4103"/>
+              <a:gd name="adj" fmla="val 3721"/>
             </a:avLst>
           </a:prstGeom>
           <a:solidFill>
@@ -17326,17 +18138,17 @@
         <p:spPr>
           <a:xfrm>
             <a:off x="4343400" y="1463040"/>
-            <a:ext cx="64008" cy="1783080"/>
+            <a:ext cx="64008" cy="1965960"/>
           </a:xfrm>
           <a:prstGeom prst="rect">
             <a:avLst/>
           </a:prstGeom>
           <a:solidFill>
-            <a:srgbClr val="0F766E"/>
+            <a:srgbClr val="7C3AED"/>
           </a:solidFill>
           <a:ln w="12700">
             <a:solidFill>
-              <a:srgbClr val="0F766E"/>
+              <a:srgbClr val="7C3AED"/>
             </a:solidFill>
             <a:prstDash val="solid"/>
           </a:ln>
@@ -17377,7 +18189,7 @@
                 <a:ea typeface="Aptos" pitchFamily="34" charset="-122"/>
                 <a:cs typeface="Aptos" pitchFamily="34" charset="-120"/>
               </a:rPr>
-              <a:t>The pattern</a:t>
+              <a:t>How you consume it</a:t>
             </a:r>
             <a:endParaRPr lang="en-US" sz="1200" dirty="0"/>
           </a:p>
@@ -17392,7 +18204,7 @@
         <p:spPr>
           <a:xfrm>
             <a:off x="4544568" y="1920240"/>
-            <a:ext cx="3200400" cy="1234440"/>
+            <a:ext cx="3200400" cy="1417320"/>
           </a:xfrm>
           <a:prstGeom prst="rect">
             <a:avLst/>
@@ -17418,7 +18230,7 @@
                 <a:ea typeface="Aptos" pitchFamily="34" charset="-122"/>
                 <a:cs typeface="Aptos" pitchFamily="34" charset="-120"/>
               </a:rPr>
-              <a:t>Bundle tools (MCP servers, AI Search, OpenAPI, code interpreter, A2A) into one MCP-compatible Toolbox endpoint with central credentials, versioning, and policy.</a:t>
+              <a:t>A governed service, not something you build: a remote MCP server (about 10 generic fetch/create/update tools), plus A2A and REST. Point the agent at it.</a:t>
             </a:r>
             <a:endParaRPr lang="en-US" sz="920" dirty="0"/>
           </a:p>
@@ -17433,11 +18245,11 @@
         <p:spPr>
           <a:xfrm>
             <a:off x="8046720" y="1463040"/>
-            <a:ext cx="3520440" cy="1783080"/>
+            <a:ext cx="3520440" cy="1965960"/>
           </a:xfrm>
           <a:prstGeom prst="roundRect">
             <a:avLst>
-              <a:gd name="adj" fmla="val 4103"/>
+              <a:gd name="adj" fmla="val 3721"/>
             </a:avLst>
           </a:prstGeom>
           <a:solidFill>
@@ -17467,17 +18279,17 @@
         <p:spPr>
           <a:xfrm>
             <a:off x="8046720" y="1463040"/>
-            <a:ext cx="64008" cy="1783080"/>
+            <a:ext cx="64008" cy="1965960"/>
           </a:xfrm>
           <a:prstGeom prst="rect">
             <a:avLst/>
           </a:prstGeom>
           <a:solidFill>
-            <a:srgbClr val="16A34A"/>
+            <a:srgbClr val="2563EB"/>
           </a:solidFill>
           <a:ln w="12700">
             <a:solidFill>
-              <a:srgbClr val="16A34A"/>
+              <a:srgbClr val="2563EB"/>
             </a:solidFill>
             <a:prstDash val="solid"/>
           </a:ln>
@@ -17518,7 +18330,7 @@
                 <a:ea typeface="Aptos" pitchFamily="34" charset="-122"/>
                 <a:cs typeface="Aptos" pitchFamily="34" charset="-120"/>
               </a:rPr>
-              <a:t>The payoff</a:t>
+              <a:t>Governed by identity</a:t>
             </a:r>
             <a:endParaRPr lang="en-US" sz="1200" dirty="0"/>
           </a:p>
@@ -17533,7 +18345,7 @@
         <p:spPr>
           <a:xfrm>
             <a:off x="8247888" y="1920240"/>
-            <a:ext cx="3200400" cy="1234440"/>
+            <a:ext cx="3200400" cy="1417320"/>
           </a:xfrm>
           <a:prstGeom prst="rect">
             <a:avLst/>
@@ -17559,7 +18371,7 @@
                 <a:ea typeface="Aptos" pitchFamily="34" charset="-122"/>
                 <a:cs typeface="Aptos" pitchFamily="34" charset="-120"/>
               </a:rPr>
-              <a:t>Point agents at the Toolbox; add / remove / reconfigure tools without changing agent code. Any MCP-capable runtime can consume it.</a:t>
+              <a:t>Entra delegated / on-behalf-of only (no app-only). User-scoped: honors permissions, sensitivity labels, and DLP; an OPA policy engine and audit run on every call.</a:t>
             </a:r>
             <a:endParaRPr lang="en-US" sz="920" dirty="0"/>
           </a:p>
@@ -17573,8 +18385,8 @@
         </p:nvSpPr>
         <p:spPr>
           <a:xfrm>
-            <a:off x="640080" y="3474720"/>
-            <a:ext cx="10972800" cy="2011680"/>
+            <a:off x="640080" y="3657600"/>
+            <a:ext cx="10972800" cy="1920240"/>
           </a:xfrm>
           <a:prstGeom prst="rect">
             <a:avLst/>
@@ -17601,7 +18413,7 @@
                 <a:ea typeface="Aptos" pitchFamily="34" charset="-122"/>
                 <a:cs typeface="Aptos" pitchFamily="34" charset="-120"/>
               </a:rPr>
-              <a:t>Centralized authentication, governance, and versioning is the recommended way to run MCP at scale.</a:t>
+              <a:t>In our design: clinical / PHI data stays on our own governed MCP tools; Work IQ covers the surrounding M365 work context.</a:t>
             </a:r>
             <a:endParaRPr lang="en-US" sz="1150" dirty="0"/>
           </a:p>
@@ -17619,7 +18431,7 @@
                 <a:ea typeface="Aptos" pitchFamily="34" charset="-122"/>
                 <a:cs typeface="Aptos" pitchFamily="34" charset="-120"/>
               </a:rPr>
-              <a:t>One endpoint to secure and audit instead of per-agent credential management.</a:t>
+              <a:t>Usage-based billing via Copilot Credits, independent of Copilot licensing; governed and cost-managed in the M365 admin center.</a:t>
             </a:r>
             <a:endParaRPr lang="en-US" sz="1150" dirty="0"/>
           </a:p>
@@ -17637,7 +18449,7 @@
                 <a:ea typeface="Aptos" pitchFamily="34" charset="-122"/>
                 <a:cs typeface="Aptos" pitchFamily="34" charset="-120"/>
               </a:rPr>
-              <a:t>Reference: Foundry Toolboxes (see securing-mcp-servers.md).</a:t>
+              <a:t>Brief: docs/work-iq-overview.md (cites Microsoft Learn).</a:t>
             </a:r>
             <a:endParaRPr lang="en-US" sz="1150" dirty="0"/>
           </a:p>
@@ -17676,7 +18488,7 @@
                 <a:ea typeface="Aptos" pitchFamily="34" charset="-122"/>
                 <a:cs typeface="Aptos" pitchFamily="34" charset="-120"/>
               </a:rPr>
-              <a:t>Toolboxes turn 'many tools on many agents' into one governed surface.</a:t>
+              <a:t>Consume Microsoft's governed M365 context layer - you do not build or secure that server yourself.</a:t>
             </a:r>
             <a:endParaRPr lang="en-US" sz="1000" dirty="0"/>
           </a:p>

</xml_diff>

<commit_message>
Illustrate the RAG domain: pipeline diagram, architecture zone, and retrieval flow
- workshop-assets/rag-domain.svg (+ generator): sources -> ingest -> retrieve -> ground -> measure,
  diagnosis-scoping, claim-level citations, missing-evidence escalation, and local KnowledgeBase ->
  Foundry IQ/Azure AI Search graduation under one retrieval contract
- build_arch_diagram.py: promote RAG to a labeled 'RAG domain (grounding)' zone; also fixed a stale
  output path (was writing to the old repo dir) and regenerated architecture-diagram.svg
- docs/rag-retrieval-flow.md: Mermaid flowchart + sequence of the happy path and escalation
- deck slide 12 (Foundry IQ + RAG): compact flow line + pointers to the domain diagram and flow doc
- README: RAG domain section embedding the new diagram

Grounded in knowledge.py, data/rag-docs, and agent-service/eval. Geometry validated.

Co-authored-by: Copilot <223556219+Copilot@users.noreply.github.com>
</commit_message>
<xml_diff>
--- a/workshop-assets/kaiser-consolidated-customer-deck.pptx
+++ b/workshop-assets/kaiser-consolidated-customer-deck.pptx
@@ -5876,7 +5876,7 @@
                 <a:ea typeface="Aptos" pitchFamily="34" charset="-122"/>
                 <a:cs typeface="Aptos" pitchFamily="34" charset="-120"/>
               </a:rPr>
-              <a:t>Permission-trim with delegated identity (OBO); never rely on a service-identity test for user isolation.</a:t>
+              <a:t>Flow: retrieve -&gt; scope by diagnosis -&gt; cite -&gt; missing evidence escalates to human review, never a guess.</a:t>
             </a:r>
             <a:endParaRPr lang="en-US" sz="1150" dirty="0"/>
           </a:p>
@@ -5894,7 +5894,7 @@
                 <a:ea typeface="Aptos" pitchFamily="34" charset="-122"/>
                 <a:cs typeface="Aptos" pitchFamily="34" charset="-120"/>
               </a:rPr>
-              <a:t>A working local retrieval-eval harness ships in agent-service/eval/.</a:t>
+              <a:t>Permission-trim with delegated identity (OBO); never rely on a service-identity test for user isolation.</a:t>
             </a:r>
             <a:endParaRPr lang="en-US" sz="1150" dirty="0"/>
           </a:p>
@@ -5912,7 +5912,25 @@
                 <a:ea typeface="Aptos" pitchFamily="34" charset="-122"/>
                 <a:cs typeface="Aptos" pitchFamily="34" charset="-120"/>
               </a:rPr>
-              <a:t>Briefs: docs/rag-guidance-gpt-rag.md, docs/rag-development-patterns.md.</a:t>
+              <a:t>A working local retrieval-eval harness ships in agent-service/eval/.</a:t>
+            </a:r>
+            <a:endParaRPr lang="en-US" sz="1150" dirty="0"/>
+          </a:p>
+          <a:p>
+            <a:pPr marL="152400" indent="-152400">
+              <a:buSzPct val="100000"/>
+              <a:buChar char="•"/>
+            </a:pPr>
+            <a:r>
+              <a:rPr lang="en-US" sz="1150" dirty="0">
+                <a:solidFill>
+                  <a:srgbClr val="334155"/>
+                </a:solidFill>
+                <a:latin typeface="Aptos" pitchFamily="34" charset="0"/>
+                <a:ea typeface="Aptos" pitchFamily="34" charset="-122"/>
+                <a:cs typeface="Aptos" pitchFamily="34" charset="-120"/>
+              </a:rPr>
+              <a:t>Briefs: docs/rag-guidance-gpt-rag.md, docs/rag-development-patterns.md, docs/rag-retrieval-flow.md.</a:t>
             </a:r>
             <a:endParaRPr lang="en-US" sz="1150" dirty="0"/>
           </a:p>
@@ -5951,7 +5969,7 @@
                 <a:ea typeface="Aptos" pitchFamily="34" charset="-122"/>
                 <a:cs typeface="Aptos" pitchFamily="34" charset="-120"/>
               </a:rPr>
-              <a:t>RAG as a production engineering pattern - grounded, measured, and governed, not a demo trick.</a:t>
+              <a:t>RAG as a production engineering pattern - grounded, measured, and governed, not a demo trick. Domain view: workshop-assets/rag-domain.svg.</a:t>
             </a:r>
             <a:endParaRPr lang="en-US" sz="1000" dirty="0"/>
           </a:p>

</xml_diff>

<commit_message>
Replace MCP+Work IQ and RAG diagrams with supplied images; adopt proposed/validate framing
- Add 4 supplied PNGs: mcp-workiq-architecture, mcp-workiq-deployment, rag-domain-architecture,
  rag-domain-review-details (workshop-assets/)
- Remove superseded SVGs + their generators (rag-domain.svg, mcp-workiq-deployment.svg,
  build_rag_domain_diagram.py, build_mcp_deployment_diagram.py)
- Deck slides 10 + 13 now embed the supplied architecture images (still 25 slides); companions
  referenced in notes
- Update README, connections README, rag-retrieval-flow.md, facilitator plan to the new images and
  the cautious 'proposed / validation items' language (Work IQ endpoint/auth/pricing, no-PHI
  boundary, retrieval thresholds, backend parity all called out as to-validate)

Co-authored-by: Copilot <223556219+Copilot@users.noreply.github.com>
</commit_message>
<xml_diff>
--- a/workshop-assets/kaiser-consolidated-customer-deck.pptx
+++ b/workshop-assets/kaiser-consolidated-customer-deck.pptx
@@ -614,7 +614,7 @@
           <a:p>
             <a:r>
               <a:rPr lang="en-US" dirty="0"/>
-              <a:t>Answers 'how is the MCP server deployed?'. Same code runs stdio locally or as an internal-ingress Container App on Azure; the internal-ingress IS the private-network layer of secure MCP. Work IQ is the other lane - consumed via Entra OBO, never merged with the clinical PHI tools. Show mcp-workiq-deployment.svg if they want the picture.</a:t>
+              <a:t>MCP + Work IQ architecture - what talks to what. Two routes, different identity rules: the clinical MCP route (purple, optional, internal ingress, synthetic data) and the Work IQ route (orange, Microsoft 365 cloud, proposed Entra delegated on-behalf-of). Gray = shared Azure services under the app's managed identity - NOT the delegated user identity. PROPOSED design: Work IQ endpoint/auth, permission enforcement, supported protocols, and pricing still to validate; 'no PHI to Work IQ' is a design intent to test, not a guarantee. Companion deployment diagram in repo: workshop-assets/mcp-workiq-deployment.png.</a:t>
             </a:r>
             <a:endParaRPr lang="en-US" dirty="0"/>
           </a:p>
@@ -878,7 +878,7 @@
           <a:p>
             <a:r>
               <a:rPr lang="en-US" dirty="0"/>
-              <a:t>Deep-dive on RAG for Joshua/Matt. Walk the five stages left to right, then the two-lane graduation (local -&gt; Foundry IQ) under one retrieval contract, and the missing-evidence escalation. Tie to existing-vs-Foundry search and capability-host reuse/cost. Show rag-domain.svg if they want the full picture.</a:t>
+              <a:t>RAG architecture - evidence before answer. Read three bands: prepare the knowledge (dated protocols -&gt; preparation -&gt; retrieval store / backend options), handle a case (agent -&gt; retrieve -&gt; evidence -&gt; 'enough evidence?' -&gt; grounded draft with citations OR review_required to a care-manager HITL), and offline evaluation (qrels, precision@k / recall@k / MRR) feeding retrieval improvements. INTENDED design, synthetic data only. Retrieval rules (dates, diagnosis scope, caller auth), the local-&gt;Foundry IQ/Azure AI Search backend swap, and the minimum precision threshold still to validate - retrieval confidence is not answer correctness. Companion readiness checklist in repo: workshop-assets/rag-domain-review-details.png (flow: docs/rag-retrieval-flow.md).</a:t>
             </a:r>
             <a:endParaRPr lang="en-US" dirty="0"/>
           </a:p>
@@ -3657,7 +3657,7 @@
     <p:bg>
       <p:bgPr>
         <a:solidFill>
-          <a:srgbClr val="F8FAFC"/>
+          <a:srgbClr val="F5F6F8"/>
         </a:solidFill>
       </p:bgPr>
     </p:bg>
@@ -3675,979 +3675,30 @@
           <a:chExt cx="0" cy="0"/>
         </a:xfrm>
       </p:grpSpPr>
-      <p:sp>
-        <p:nvSpPr>
-          <p:cNvPr id="2" name="Text 0"/>
-          <p:cNvSpPr/>
-          <p:nvPr/>
-        </p:nvSpPr>
-        <p:spPr>
-          <a:xfrm>
-            <a:off x="566928" y="384048"/>
-            <a:ext cx="10789920" cy="201168"/>
-          </a:xfrm>
-          <a:prstGeom prst="rect">
-            <a:avLst/>
-          </a:prstGeom>
-          <a:noFill/>
-          <a:ln/>
-        </p:spPr>
-        <p:txBody>
-          <a:bodyPr wrap="square" lIns="0" tIns="0" rIns="0" bIns="0" rtlCol="0" anchor="ctr"/>
-          <a:lstStyle/>
-          <a:p>
-            <a:pPr indent="0" marL="0">
-              <a:buNone/>
-            </a:pPr>
-            <a:r>
-              <a:rPr lang="en-US" sz="800" b="1" dirty="0">
-                <a:solidFill>
-                  <a:srgbClr val="0F766E"/>
-                </a:solidFill>
-                <a:latin typeface="Aptos" pitchFamily="34" charset="0"/>
-                <a:ea typeface="Aptos" pitchFamily="34" charset="-122"/>
-                <a:cs typeface="Aptos" pitchFamily="34" charset="-120"/>
-              </a:rPr>
-              <a:t>PRIORITY - DEPLOYMENT: TWO LANES, ONE IDENTITY</a:t>
-            </a:r>
-            <a:endParaRPr lang="en-US" sz="800" dirty="0"/>
-          </a:p>
-        </p:txBody>
-      </p:sp>
-      <p:sp>
-        <p:nvSpPr>
-          <p:cNvPr id="3" name="Text 1"/>
-          <p:cNvSpPr/>
-          <p:nvPr/>
-        </p:nvSpPr>
-        <p:spPr>
-          <a:xfrm>
-            <a:off x="548640" y="658368"/>
-            <a:ext cx="11064240" cy="502920"/>
-          </a:xfrm>
-          <a:prstGeom prst="rect">
-            <a:avLst/>
-          </a:prstGeom>
-          <a:noFill/>
-          <a:ln/>
-        </p:spPr>
-        <p:txBody>
-          <a:bodyPr wrap="square" lIns="0" tIns="0" rIns="0" bIns="0" rtlCol="0" anchor="ctr">
-            <a:normAutofit/>
-          </a:bodyPr>
-          <a:lstStyle/>
-          <a:p>
-            <a:pPr indent="0" marL="0">
-              <a:buNone/>
-            </a:pPr>
-            <a:r>
-              <a:rPr lang="en-US" sz="2300" b="1" dirty="0">
-                <a:solidFill>
-                  <a:srgbClr val="0B1220"/>
-                </a:solidFill>
-                <a:latin typeface="Aptos Display" pitchFamily="34" charset="0"/>
-                <a:ea typeface="Aptos Display" pitchFamily="34" charset="-122"/>
-                <a:cs typeface="Aptos Display" pitchFamily="34" charset="-120"/>
-              </a:rPr>
-              <a:t>Where the MCP server runs</a:t>
-            </a:r>
-            <a:endParaRPr lang="en-US" sz="2300" dirty="0"/>
-          </a:p>
-        </p:txBody>
-      </p:sp>
-      <p:sp>
-        <p:nvSpPr>
-          <p:cNvPr id="4" name="Shape 2"/>
-          <p:cNvSpPr/>
-          <p:nvPr/>
-        </p:nvSpPr>
-        <p:spPr>
-          <a:xfrm>
-            <a:off x="548640" y="1243584"/>
-            <a:ext cx="11064240" cy="0"/>
-          </a:xfrm>
-          <a:prstGeom prst="line">
-            <a:avLst/>
-          </a:prstGeom>
-          <a:noFill/>
-          <a:ln w="12700">
-            <a:solidFill>
-              <a:srgbClr val="CBD5E1"/>
-            </a:solidFill>
-            <a:prstDash val="solid"/>
-          </a:ln>
-        </p:spPr>
-      </p:sp>
-      <p:sp>
-        <p:nvSpPr>
-          <p:cNvPr id="5" name="Text 3"/>
-          <p:cNvSpPr/>
-          <p:nvPr/>
-        </p:nvSpPr>
-        <p:spPr>
-          <a:xfrm>
-            <a:off x="640080" y="1371600"/>
-            <a:ext cx="7315200" cy="219456"/>
-          </a:xfrm>
-          <a:prstGeom prst="rect">
-            <a:avLst/>
-          </a:prstGeom>
-          <a:noFill/>
-          <a:ln/>
-        </p:spPr>
-        <p:txBody>
-          <a:bodyPr wrap="square" lIns="0" tIns="0" rIns="0" bIns="0" rtlCol="0" anchor="ctr"/>
-          <a:lstStyle/>
-          <a:p>
-            <a:pPr indent="0" marL="0">
-              <a:buNone/>
-            </a:pPr>
-            <a:r>
-              <a:rPr lang="en-US" sz="900" b="1" dirty="0">
-                <a:solidFill>
-                  <a:srgbClr val="7C3AED"/>
-                </a:solidFill>
-                <a:latin typeface="Aptos" pitchFamily="34" charset="0"/>
-                <a:ea typeface="Aptos" pitchFamily="34" charset="-122"/>
-                <a:cs typeface="Aptos" pitchFamily="34" charset="-120"/>
-              </a:rPr>
-              <a:t>CLINICAL / PHI  -&gt;  our governed MCP server</a:t>
-            </a:r>
-            <a:endParaRPr lang="en-US" sz="900" dirty="0"/>
-          </a:p>
-        </p:txBody>
-      </p:sp>
-      <p:sp>
-        <p:nvSpPr>
-          <p:cNvPr id="6" name="Shape 4"/>
-          <p:cNvSpPr/>
-          <p:nvPr/>
-        </p:nvSpPr>
-        <p:spPr>
-          <a:xfrm>
-            <a:off x="640080" y="1691640"/>
-            <a:ext cx="3520440" cy="1783080"/>
-          </a:xfrm>
-          <a:prstGeom prst="roundRect">
-            <a:avLst>
-              <a:gd name="adj" fmla="val 4103"/>
-            </a:avLst>
-          </a:prstGeom>
-          <a:solidFill>
-            <a:srgbClr val="FFFFFF"/>
-          </a:solidFill>
-          <a:ln w="12700">
-            <a:solidFill>
-              <a:srgbClr val="E2E8F0"/>
-            </a:solidFill>
-            <a:prstDash val="solid"/>
-          </a:ln>
-          <a:effectLst>
-            <a:outerShdw sx="100000" sy="100000" kx="0" ky="0" algn="bl" rotWithShape="0" blurRad="25400" dist="50800" dir="2700000">
-              <a:srgbClr val="94A3B8">
-                <a:alpha val="12000"/>
-              </a:srgbClr>
-            </a:outerShdw>
-          </a:effectLst>
-        </p:spPr>
-      </p:sp>
-      <p:sp>
-        <p:nvSpPr>
-          <p:cNvPr id="7" name="Shape 5"/>
-          <p:cNvSpPr/>
-          <p:nvPr/>
-        </p:nvSpPr>
-        <p:spPr>
-          <a:xfrm>
-            <a:off x="640080" y="1691640"/>
-            <a:ext cx="64008" cy="1783080"/>
-          </a:xfrm>
-          <a:prstGeom prst="rect">
-            <a:avLst/>
-          </a:prstGeom>
-          <a:solidFill>
-            <a:srgbClr val="7C3AED"/>
-          </a:solidFill>
-          <a:ln w="12700">
-            <a:solidFill>
-              <a:srgbClr val="7C3AED"/>
-            </a:solidFill>
-            <a:prstDash val="solid"/>
-          </a:ln>
-        </p:spPr>
-      </p:sp>
-      <p:sp>
-        <p:nvSpPr>
-          <p:cNvPr id="8" name="Text 6"/>
-          <p:cNvSpPr/>
-          <p:nvPr/>
-        </p:nvSpPr>
-        <p:spPr>
-          <a:xfrm>
-            <a:off x="841248" y="1837944"/>
-            <a:ext cx="3200400" cy="219456"/>
-          </a:xfrm>
-          <a:prstGeom prst="rect">
-            <a:avLst/>
-          </a:prstGeom>
-          <a:noFill/>
-          <a:ln/>
-        </p:spPr>
-        <p:txBody>
-          <a:bodyPr wrap="square" lIns="0" tIns="0" rIns="0" bIns="0" rtlCol="0" anchor="ctr">
-            <a:normAutofit/>
-          </a:bodyPr>
-          <a:lstStyle/>
-          <a:p>
-            <a:pPr indent="0" marL="0">
-              <a:buNone/>
-            </a:pPr>
-            <a:r>
-              <a:rPr lang="en-US" sz="1200" b="1" dirty="0">
-                <a:solidFill>
-                  <a:srgbClr val="0B1220"/>
-                </a:solidFill>
-                <a:latin typeface="Aptos" pitchFamily="34" charset="0"/>
-                <a:ea typeface="Aptos" pitchFamily="34" charset="-122"/>
-                <a:cs typeface="Aptos" pitchFamily="34" charset="-120"/>
-              </a:rPr>
-              <a:t>Local / stdio</a:t>
-            </a:r>
-            <a:endParaRPr lang="en-US" sz="1200" dirty="0"/>
-          </a:p>
-        </p:txBody>
-      </p:sp>
-      <p:sp>
-        <p:nvSpPr>
-          <p:cNvPr id="9" name="Text 7"/>
-          <p:cNvSpPr/>
-          <p:nvPr/>
-        </p:nvSpPr>
-        <p:spPr>
-          <a:xfrm>
-            <a:off x="841248" y="2148840"/>
-            <a:ext cx="3200400" cy="1234440"/>
-          </a:xfrm>
-          <a:prstGeom prst="rect">
-            <a:avLst/>
-          </a:prstGeom>
-          <a:noFill/>
-          <a:ln/>
-        </p:spPr>
-        <p:txBody>
-          <a:bodyPr wrap="square" lIns="254" tIns="254" rIns="254" bIns="254" rtlCol="0" anchor="t">
-            <a:normAutofit/>
-          </a:bodyPr>
-          <a:lstStyle/>
-          <a:p>
-            <a:pPr indent="0" marL="0">
-              <a:buNone/>
-            </a:pPr>
-            <a:r>
-              <a:rPr lang="en-US" sz="920" dirty="0">
-                <a:solidFill>
-                  <a:srgbClr val="334155"/>
-                </a:solidFill>
-                <a:latin typeface="Aptos" pitchFamily="34" charset="0"/>
-                <a:ea typeface="Aptos" pitchFamily="34" charset="-122"/>
-                <a:cs typeface="Aptos" pitchFamily="34" charset="-120"/>
-              </a:rPr>
-              <a:t>python mcp-server/server.py - a stdio subprocess. Zero infra; ships with the app. What you demo in the room.</a:t>
-            </a:r>
-            <a:endParaRPr lang="en-US" sz="920" dirty="0"/>
-          </a:p>
-        </p:txBody>
-      </p:sp>
-      <p:sp>
-        <p:nvSpPr>
-          <p:cNvPr id="10" name="Shape 8"/>
-          <p:cNvSpPr/>
-          <p:nvPr/>
-        </p:nvSpPr>
-        <p:spPr>
-          <a:xfrm>
-            <a:off x="4343400" y="1691640"/>
-            <a:ext cx="3520440" cy="1783080"/>
-          </a:xfrm>
-          <a:prstGeom prst="roundRect">
-            <a:avLst>
-              <a:gd name="adj" fmla="val 4103"/>
-            </a:avLst>
-          </a:prstGeom>
-          <a:solidFill>
-            <a:srgbClr val="FFFFFF"/>
-          </a:solidFill>
-          <a:ln w="12700">
-            <a:solidFill>
-              <a:srgbClr val="E2E8F0"/>
-            </a:solidFill>
-            <a:prstDash val="solid"/>
-          </a:ln>
-          <a:effectLst>
-            <a:outerShdw sx="100000" sy="100000" kx="0" ky="0" algn="bl" rotWithShape="0" blurRad="25400" dist="50800" dir="2700000">
-              <a:srgbClr val="94A3B8">
-                <a:alpha val="12000"/>
-              </a:srgbClr>
-            </a:outerShdw>
-          </a:effectLst>
-        </p:spPr>
-      </p:sp>
-      <p:sp>
-        <p:nvSpPr>
-          <p:cNvPr id="11" name="Shape 9"/>
-          <p:cNvSpPr/>
-          <p:nvPr/>
-        </p:nvSpPr>
-        <p:spPr>
-          <a:xfrm>
-            <a:off x="4343400" y="1691640"/>
-            <a:ext cx="64008" cy="1783080"/>
-          </a:xfrm>
-          <a:prstGeom prst="rect">
-            <a:avLst/>
-          </a:prstGeom>
-          <a:solidFill>
-            <a:srgbClr val="2563EB"/>
-          </a:solidFill>
-          <a:ln w="12700">
-            <a:solidFill>
-              <a:srgbClr val="2563EB"/>
-            </a:solidFill>
-            <a:prstDash val="solid"/>
-          </a:ln>
-        </p:spPr>
-      </p:sp>
-      <p:sp>
-        <p:nvSpPr>
-          <p:cNvPr id="12" name="Text 10"/>
-          <p:cNvSpPr/>
-          <p:nvPr/>
-        </p:nvSpPr>
-        <p:spPr>
-          <a:xfrm>
-            <a:off x="4544568" y="1837944"/>
-            <a:ext cx="3200400" cy="219456"/>
-          </a:xfrm>
-          <a:prstGeom prst="rect">
-            <a:avLst/>
-          </a:prstGeom>
-          <a:noFill/>
-          <a:ln/>
-        </p:spPr>
-        <p:txBody>
-          <a:bodyPr wrap="square" lIns="0" tIns="0" rIns="0" bIns="0" rtlCol="0" anchor="ctr">
-            <a:normAutofit/>
-          </a:bodyPr>
-          <a:lstStyle/>
-          <a:p>
-            <a:pPr indent="0" marL="0">
-              <a:buNone/>
-            </a:pPr>
-            <a:r>
-              <a:rPr lang="en-US" sz="1200" b="1" dirty="0">
-                <a:solidFill>
-                  <a:srgbClr val="0B1220"/>
-                </a:solidFill>
-                <a:latin typeface="Aptos" pitchFamily="34" charset="0"/>
-                <a:ea typeface="Aptos" pitchFamily="34" charset="-122"/>
-                <a:cs typeface="Aptos" pitchFamily="34" charset="-120"/>
-              </a:rPr>
-              <a:t>Hosted on Azure</a:t>
-            </a:r>
-            <a:endParaRPr lang="en-US" sz="1200" dirty="0"/>
-          </a:p>
-        </p:txBody>
-      </p:sp>
-      <p:sp>
-        <p:nvSpPr>
-          <p:cNvPr id="13" name="Text 11"/>
-          <p:cNvSpPr/>
-          <p:nvPr/>
-        </p:nvSpPr>
-        <p:spPr>
-          <a:xfrm>
-            <a:off x="4544568" y="2148840"/>
-            <a:ext cx="3200400" cy="1234440"/>
-          </a:xfrm>
-          <a:prstGeom prst="rect">
-            <a:avLst/>
-          </a:prstGeom>
-          <a:noFill/>
-          <a:ln/>
-        </p:spPr>
-        <p:txBody>
-          <a:bodyPr wrap="square" lIns="254" tIns="254" rIns="254" bIns="254" rtlCol="0" anchor="t">
-            <a:normAutofit/>
-          </a:bodyPr>
-          <a:lstStyle/>
-          <a:p>
-            <a:pPr indent="0" marL="0">
-              <a:buNone/>
-            </a:pPr>
-            <a:r>
-              <a:rPr lang="en-US" sz="920" dirty="0">
-                <a:solidFill>
-                  <a:srgbClr val="334155"/>
-                </a:solidFill>
-                <a:latin typeface="Aptos" pitchFamily="34" charset="0"/>
-                <a:ea typeface="Aptos" pitchFamily="34" charset="-122"/>
-                <a:cs typeface="Aptos" pitchFamily="34" charset="-120"/>
-              </a:rPr>
-              <a:t>Same server as a Container App with INTERNAL ingress - private to the environment / VNet (Layer 1 secure MCP). enable_mcp_server=true.</a:t>
-            </a:r>
-            <a:endParaRPr lang="en-US" sz="920" dirty="0"/>
-          </a:p>
-        </p:txBody>
-      </p:sp>
-      <p:sp>
-        <p:nvSpPr>
-          <p:cNvPr id="14" name="Shape 12"/>
-          <p:cNvSpPr/>
-          <p:nvPr/>
-        </p:nvSpPr>
-        <p:spPr>
-          <a:xfrm>
-            <a:off x="8046720" y="1691640"/>
-            <a:ext cx="3520440" cy="1783080"/>
-          </a:xfrm>
-          <a:prstGeom prst="roundRect">
-            <a:avLst>
-              <a:gd name="adj" fmla="val 4103"/>
-            </a:avLst>
-          </a:prstGeom>
-          <a:solidFill>
-            <a:srgbClr val="FFFFFF"/>
-          </a:solidFill>
-          <a:ln w="12700">
-            <a:solidFill>
-              <a:srgbClr val="E2E8F0"/>
-            </a:solidFill>
-            <a:prstDash val="solid"/>
-          </a:ln>
-          <a:effectLst>
-            <a:outerShdw sx="100000" sy="100000" kx="0" ky="0" algn="bl" rotWithShape="0" blurRad="25400" dist="50800" dir="2700000">
-              <a:srgbClr val="94A3B8">
-                <a:alpha val="12000"/>
-              </a:srgbClr>
-            </a:outerShdw>
-          </a:effectLst>
-        </p:spPr>
-      </p:sp>
-      <p:sp>
-        <p:nvSpPr>
-          <p:cNvPr id="15" name="Shape 13"/>
-          <p:cNvSpPr/>
-          <p:nvPr/>
-        </p:nvSpPr>
-        <p:spPr>
-          <a:xfrm>
-            <a:off x="8046720" y="1691640"/>
-            <a:ext cx="64008" cy="1783080"/>
-          </a:xfrm>
-          <a:prstGeom prst="rect">
-            <a:avLst/>
-          </a:prstGeom>
-          <a:solidFill>
-            <a:srgbClr val="0F766E"/>
-          </a:solidFill>
-          <a:ln w="12700">
-            <a:solidFill>
-              <a:srgbClr val="0F766E"/>
-            </a:solidFill>
-            <a:prstDash val="solid"/>
-          </a:ln>
-        </p:spPr>
-      </p:sp>
-      <p:sp>
-        <p:nvSpPr>
-          <p:cNvPr id="16" name="Text 14"/>
-          <p:cNvSpPr/>
-          <p:nvPr/>
-        </p:nvSpPr>
-        <p:spPr>
-          <a:xfrm>
-            <a:off x="8247888" y="1837944"/>
-            <a:ext cx="3200400" cy="219456"/>
-          </a:xfrm>
-          <a:prstGeom prst="rect">
-            <a:avLst/>
-          </a:prstGeom>
-          <a:noFill/>
-          <a:ln/>
-        </p:spPr>
-        <p:txBody>
-          <a:bodyPr wrap="square" lIns="0" tIns="0" rIns="0" bIns="0" rtlCol="0" anchor="ctr">
-            <a:normAutofit/>
-          </a:bodyPr>
-          <a:lstStyle/>
-          <a:p>
-            <a:pPr indent="0" marL="0">
-              <a:buNone/>
-            </a:pPr>
-            <a:r>
-              <a:rPr lang="en-US" sz="1200" b="1" dirty="0">
-                <a:solidFill>
-                  <a:srgbClr val="0B1220"/>
-                </a:solidFill>
-                <a:latin typeface="Aptos" pitchFamily="34" charset="0"/>
-                <a:ea typeface="Aptos" pitchFamily="34" charset="-122"/>
-                <a:cs typeface="Aptos" pitchFamily="34" charset="-120"/>
-              </a:rPr>
-              <a:t>Same contracts</a:t>
-            </a:r>
-            <a:endParaRPr lang="en-US" sz="1200" dirty="0"/>
-          </a:p>
-        </p:txBody>
-      </p:sp>
-      <p:sp>
-        <p:nvSpPr>
-          <p:cNvPr id="17" name="Text 15"/>
-          <p:cNvSpPr/>
-          <p:nvPr/>
-        </p:nvSpPr>
-        <p:spPr>
-          <a:xfrm>
-            <a:off x="8247888" y="2148840"/>
-            <a:ext cx="3200400" cy="1234440"/>
-          </a:xfrm>
-          <a:prstGeom prst="rect">
-            <a:avLst/>
-          </a:prstGeom>
-          <a:noFill/>
-          <a:ln/>
-        </p:spPr>
-        <p:txBody>
-          <a:bodyPr wrap="square" lIns="254" tIns="254" rIns="254" bIns="254" rtlCol="0" anchor="t">
-            <a:normAutofit/>
-          </a:bodyPr>
-          <a:lstStyle/>
-          <a:p>
-            <a:pPr indent="0" marL="0">
-              <a:buNone/>
-            </a:pPr>
-            <a:r>
-              <a:rPr lang="en-US" sz="920" dirty="0">
-                <a:solidFill>
-                  <a:srgbClr val="334155"/>
-                </a:solidFill>
-                <a:latin typeface="Aptos" pitchFamily="34" charset="0"/>
-                <a:ea typeface="Aptos" pitchFamily="34" charset="-122"/>
-                <a:cs typeface="Aptos" pitchFamily="34" charset="-120"/>
-              </a:rPr>
-              <a:t>Identical tools, JSON contracts, and decisions either way. Agent routes via USE_EXTERNAL_MCP + MCP_SERVER_URL; in-process stays the default.</a:t>
-            </a:r>
-            <a:endParaRPr lang="en-US" sz="920" dirty="0"/>
-          </a:p>
-        </p:txBody>
-      </p:sp>
-      <p:sp>
-        <p:nvSpPr>
-          <p:cNvPr id="18" name="Text 16"/>
-          <p:cNvSpPr/>
-          <p:nvPr/>
-        </p:nvSpPr>
-        <p:spPr>
-          <a:xfrm>
-            <a:off x="640080" y="3749040"/>
-            <a:ext cx="8229600" cy="219456"/>
-          </a:xfrm>
-          <a:prstGeom prst="rect">
-            <a:avLst/>
-          </a:prstGeom>
-          <a:noFill/>
-          <a:ln/>
-        </p:spPr>
-        <p:txBody>
-          <a:bodyPr wrap="square" lIns="0" tIns="0" rIns="0" bIns="0" rtlCol="0" anchor="ctr"/>
-          <a:lstStyle/>
-          <a:p>
-            <a:pPr indent="0" marL="0">
-              <a:buNone/>
-            </a:pPr>
-            <a:r>
-              <a:rPr lang="en-US" sz="900" b="1" dirty="0">
-                <a:solidFill>
-                  <a:srgbClr val="F59E0B"/>
-                </a:solidFill>
-                <a:latin typeface="Aptos" pitchFamily="34" charset="0"/>
-                <a:ea typeface="Aptos" pitchFamily="34" charset="-122"/>
-                <a:cs typeface="Aptos" pitchFamily="34" charset="-120"/>
-              </a:rPr>
-              <a:t>M365 CONTEXT  -&gt;  Work IQ (Microsoft-hosted, we consume)</a:t>
-            </a:r>
-            <a:endParaRPr lang="en-US" sz="900" dirty="0"/>
-          </a:p>
-        </p:txBody>
-      </p:sp>
-      <p:sp>
-        <p:nvSpPr>
-          <p:cNvPr id="19" name="Shape 17"/>
-          <p:cNvSpPr/>
-          <p:nvPr/>
-        </p:nvSpPr>
-        <p:spPr>
-          <a:xfrm>
-            <a:off x="640080" y="4069080"/>
-            <a:ext cx="5394960" cy="1554480"/>
-          </a:xfrm>
-          <a:prstGeom prst="roundRect">
-            <a:avLst>
-              <a:gd name="adj" fmla="val 4706"/>
-            </a:avLst>
-          </a:prstGeom>
-          <a:solidFill>
-            <a:srgbClr val="FFFFFF"/>
-          </a:solidFill>
-          <a:ln w="12700">
-            <a:solidFill>
-              <a:srgbClr val="E2E8F0"/>
-            </a:solidFill>
-            <a:prstDash val="solid"/>
-          </a:ln>
-          <a:effectLst>
-            <a:outerShdw sx="100000" sy="100000" kx="0" ky="0" algn="bl" rotWithShape="0" blurRad="25400" dist="50800" dir="2700000">
-              <a:srgbClr val="94A3B8">
-                <a:alpha val="12000"/>
-              </a:srgbClr>
-            </a:outerShdw>
-          </a:effectLst>
-        </p:spPr>
-      </p:sp>
-      <p:sp>
-        <p:nvSpPr>
-          <p:cNvPr id="20" name="Shape 18"/>
-          <p:cNvSpPr/>
-          <p:nvPr/>
-        </p:nvSpPr>
-        <p:spPr>
-          <a:xfrm>
-            <a:off x="640080" y="4069080"/>
-            <a:ext cx="64008" cy="1554480"/>
-          </a:xfrm>
-          <a:prstGeom prst="rect">
-            <a:avLst/>
-          </a:prstGeom>
-          <a:solidFill>
-            <a:srgbClr val="F59E0B"/>
-          </a:solidFill>
-          <a:ln w="12700">
-            <a:solidFill>
-              <a:srgbClr val="F59E0B"/>
-            </a:solidFill>
-            <a:prstDash val="solid"/>
-          </a:ln>
-        </p:spPr>
-      </p:sp>
-      <p:sp>
-        <p:nvSpPr>
-          <p:cNvPr id="21" name="Text 19"/>
-          <p:cNvSpPr/>
-          <p:nvPr/>
-        </p:nvSpPr>
-        <p:spPr>
-          <a:xfrm>
-            <a:off x="841248" y="4215384"/>
-            <a:ext cx="5074920" cy="219456"/>
-          </a:xfrm>
-          <a:prstGeom prst="rect">
-            <a:avLst/>
-          </a:prstGeom>
-          <a:noFill/>
-          <a:ln/>
-        </p:spPr>
-        <p:txBody>
-          <a:bodyPr wrap="square" lIns="0" tIns="0" rIns="0" bIns="0" rtlCol="0" anchor="ctr">
-            <a:normAutofit/>
-          </a:bodyPr>
-          <a:lstStyle/>
-          <a:p>
-            <a:pPr indent="0" marL="0">
-              <a:buNone/>
-            </a:pPr>
-            <a:r>
-              <a:rPr lang="en-US" sz="1200" b="1" dirty="0">
-                <a:solidFill>
-                  <a:srgbClr val="0B1220"/>
-                </a:solidFill>
-                <a:latin typeface="Aptos" pitchFamily="34" charset="0"/>
-                <a:ea typeface="Aptos" pitchFamily="34" charset="-122"/>
-                <a:cs typeface="Aptos" pitchFamily="34" charset="-120"/>
-              </a:rPr>
-              <a:t>Separate lane</a:t>
-            </a:r>
-            <a:endParaRPr lang="en-US" sz="1200" dirty="0"/>
-          </a:p>
-        </p:txBody>
-      </p:sp>
-      <p:sp>
-        <p:nvSpPr>
-          <p:cNvPr id="22" name="Text 20"/>
-          <p:cNvSpPr/>
-          <p:nvPr/>
-        </p:nvSpPr>
-        <p:spPr>
-          <a:xfrm>
-            <a:off x="841248" y="4526280"/>
-            <a:ext cx="5074920" cy="1005840"/>
-          </a:xfrm>
-          <a:prstGeom prst="rect">
-            <a:avLst/>
-          </a:prstGeom>
-          <a:noFill/>
-          <a:ln/>
-        </p:spPr>
-        <p:txBody>
-          <a:bodyPr wrap="square" lIns="254" tIns="254" rIns="254" bIns="254" rtlCol="0" anchor="t">
-            <a:normAutofit/>
-          </a:bodyPr>
-          <a:lstStyle/>
-          <a:p>
-            <a:pPr indent="0" marL="0">
-              <a:buNone/>
-            </a:pPr>
-            <a:r>
-              <a:rPr lang="en-US" sz="920" dirty="0">
-                <a:solidFill>
-                  <a:srgbClr val="334155"/>
-                </a:solidFill>
-                <a:latin typeface="Aptos" pitchFamily="34" charset="0"/>
-                <a:ea typeface="Aptos" pitchFamily="34" charset="-122"/>
-                <a:cs typeface="Aptos" pitchFamily="34" charset="-120"/>
-              </a:rPr>
-              <a:t>Work IQ is not something we deploy - it is Microsoft-hosted. The agent consumes it on the user's Entra on-behalf-of token; no app-only auth, no stored secret.</a:t>
-            </a:r>
-            <a:endParaRPr lang="en-US" sz="920" dirty="0"/>
-          </a:p>
-        </p:txBody>
-      </p:sp>
-      <p:sp>
-        <p:nvSpPr>
-          <p:cNvPr id="23" name="Shape 21"/>
-          <p:cNvSpPr/>
-          <p:nvPr/>
-        </p:nvSpPr>
-        <p:spPr>
-          <a:xfrm>
-            <a:off x="6217920" y="4069080"/>
-            <a:ext cx="5394960" cy="1554480"/>
-          </a:xfrm>
-          <a:prstGeom prst="roundRect">
-            <a:avLst>
-              <a:gd name="adj" fmla="val 4706"/>
-            </a:avLst>
-          </a:prstGeom>
-          <a:solidFill>
-            <a:srgbClr val="FFFFFF"/>
-          </a:solidFill>
-          <a:ln w="12700">
-            <a:solidFill>
-              <a:srgbClr val="E2E8F0"/>
-            </a:solidFill>
-            <a:prstDash val="solid"/>
-          </a:ln>
-          <a:effectLst>
-            <a:outerShdw sx="100000" sy="100000" kx="0" ky="0" algn="bl" rotWithShape="0" blurRad="25400" dist="50800" dir="2700000">
-              <a:srgbClr val="94A3B8">
-                <a:alpha val="12000"/>
-              </a:srgbClr>
-            </a:outerShdw>
-          </a:effectLst>
-        </p:spPr>
-      </p:sp>
-      <p:sp>
-        <p:nvSpPr>
-          <p:cNvPr id="24" name="Shape 22"/>
-          <p:cNvSpPr/>
-          <p:nvPr/>
-        </p:nvSpPr>
-        <p:spPr>
-          <a:xfrm>
-            <a:off x="6217920" y="4069080"/>
-            <a:ext cx="64008" cy="1554480"/>
-          </a:xfrm>
-          <a:prstGeom prst="rect">
-            <a:avLst/>
-          </a:prstGeom>
-          <a:solidFill>
-            <a:srgbClr val="DC2626"/>
-          </a:solidFill>
-          <a:ln w="12700">
-            <a:solidFill>
-              <a:srgbClr val="DC2626"/>
-            </a:solidFill>
-            <a:prstDash val="solid"/>
-          </a:ln>
-        </p:spPr>
-      </p:sp>
-      <p:sp>
-        <p:nvSpPr>
-          <p:cNvPr id="25" name="Text 23"/>
-          <p:cNvSpPr/>
-          <p:nvPr/>
-        </p:nvSpPr>
-        <p:spPr>
-          <a:xfrm>
-            <a:off x="6419088" y="4215384"/>
-            <a:ext cx="5074920" cy="219456"/>
-          </a:xfrm>
-          <a:prstGeom prst="rect">
-            <a:avLst/>
-          </a:prstGeom>
-          <a:noFill/>
-          <a:ln/>
-        </p:spPr>
-        <p:txBody>
-          <a:bodyPr wrap="square" lIns="0" tIns="0" rIns="0" bIns="0" rtlCol="0" anchor="ctr">
-            <a:normAutofit/>
-          </a:bodyPr>
-          <a:lstStyle/>
-          <a:p>
-            <a:pPr indent="0" marL="0">
-              <a:buNone/>
-            </a:pPr>
-            <a:r>
-              <a:rPr lang="en-US" sz="1200" b="1" dirty="0">
-                <a:solidFill>
-                  <a:srgbClr val="0B1220"/>
-                </a:solidFill>
-                <a:latin typeface="Aptos" pitchFamily="34" charset="0"/>
-                <a:ea typeface="Aptos" pitchFamily="34" charset="-122"/>
-                <a:cs typeface="Aptos" pitchFamily="34" charset="-120"/>
-              </a:rPr>
-              <a:t>Never merged</a:t>
-            </a:r>
-            <a:endParaRPr lang="en-US" sz="1200" dirty="0"/>
-          </a:p>
-        </p:txBody>
-      </p:sp>
-      <p:sp>
-        <p:nvSpPr>
-          <p:cNvPr id="26" name="Text 24"/>
-          <p:cNvSpPr/>
-          <p:nvPr/>
-        </p:nvSpPr>
-        <p:spPr>
-          <a:xfrm>
-            <a:off x="6419088" y="4526280"/>
-            <a:ext cx="5074920" cy="1005840"/>
-          </a:xfrm>
-          <a:prstGeom prst="rect">
-            <a:avLst/>
-          </a:prstGeom>
-          <a:noFill/>
-          <a:ln/>
-        </p:spPr>
-        <p:txBody>
-          <a:bodyPr wrap="square" lIns="254" tIns="254" rIns="254" bIns="254" rtlCol="0" anchor="t">
-            <a:normAutofit/>
-          </a:bodyPr>
-          <a:lstStyle/>
-          <a:p>
-            <a:pPr indent="0" marL="0">
-              <a:buNone/>
-            </a:pPr>
-            <a:r>
-              <a:rPr lang="en-US" sz="920" dirty="0">
-                <a:solidFill>
-                  <a:srgbClr val="334155"/>
-                </a:solidFill>
-                <a:latin typeface="Aptos" pitchFamily="34" charset="0"/>
-                <a:ea typeface="Aptos" pitchFamily="34" charset="-122"/>
-                <a:cs typeface="Aptos" pitchFamily="34" charset="-120"/>
-              </a:rPr>
-              <a:t>PHI stays on our MCP server; M365 work context comes from Work IQ. Two lanes under one identity - enable_workiq=true, usage-billed via Copilot Credits.</a:t>
-            </a:r>
-            <a:endParaRPr lang="en-US" sz="920" dirty="0"/>
-          </a:p>
-        </p:txBody>
-      </p:sp>
-      <p:sp>
-        <p:nvSpPr>
-          <p:cNvPr id="27" name="Text 25"/>
-          <p:cNvSpPr/>
-          <p:nvPr/>
-        </p:nvSpPr>
-        <p:spPr>
-          <a:xfrm>
-            <a:off x="640080" y="5806440"/>
-            <a:ext cx="10972800" cy="457200"/>
-          </a:xfrm>
-          <a:prstGeom prst="rect">
-            <a:avLst/>
-          </a:prstGeom>
-          <a:noFill/>
-          <a:ln/>
-        </p:spPr>
-        <p:txBody>
-          <a:bodyPr wrap="square" lIns="0" tIns="0" rIns="0" bIns="0" rtlCol="0" anchor="ctr"/>
-          <a:lstStyle/>
-          <a:p>
-            <a:pPr indent="0" marL="0">
-              <a:buNone/>
-            </a:pPr>
-            <a:r>
-              <a:rPr lang="en-US" sz="1000" i="1" dirty="0">
-                <a:solidFill>
-                  <a:srgbClr val="64748B"/>
-                </a:solidFill>
-                <a:latin typeface="Aptos" pitchFamily="34" charset="0"/>
-                <a:ea typeface="Aptos" pitchFamily="34" charset="-122"/>
-                <a:cs typeface="Aptos" pitchFamily="34" charset="-120"/>
-              </a:rPr>
-              <a:t>Diagram: workshop-assets/mcp-workiq-deployment.svg. Stdio and in-process always work; hosting is a toggle.</a:t>
-            </a:r>
-            <a:endParaRPr lang="en-US" sz="1000" dirty="0"/>
-          </a:p>
-        </p:txBody>
-      </p:sp>
-      <p:sp>
-        <p:nvSpPr>
-          <p:cNvPr id="25" name="Slide Number Placeholder 0"/>
-          <p:cNvSpPr>
-            <a:spLocks noGrp="1"/>
-          </p:cNvSpPr>
-          <p:nvPr>
-            <p:ph type="sldNum" sz="quarter" idx="4294967295"/>
-          </p:nvPr>
-        </p:nvSpPr>
-        <p:spPr>
-          <a:xfrm>
-            <a:off x="11475720" y="6565392"/>
-            <a:ext cx="800000" cy="300000"/>
-          </a:xfrm>
-          <a:prstGeom prst="rect">
-            <a:avLst/>
-          </a:prstGeom>
-          <a:extLst>
-            <a:ext uri="{C572A759-6A51-4108-AA02-DFA0A04FC94B}">
-              <ma14:wrappingTextBoxFlag xmlns:ma14="http://schemas.microsoft.com/office/mac/drawingml/2011/main" val="0"/>
-            </a:ext>
-          </a:extLst>
-        </p:spPr>
-        <p:txBody>
-          <a:bodyPr/>
-          <a:lstStyle>
-            <a:lvl1pPr>
-              <a:defRPr sz="700">
-                <a:solidFill>
-                  <a:srgbClr val="64748B"/>
-                </a:solidFill>
-                <a:latin typeface="Aptos"/>
-                <a:ea typeface="Aptos"/>
-                <a:cs typeface="Aptos"/>
-              </a:defRPr>
-            </a:lvl1pPr>
-          </a:lstStyle>
-          <a:p>
-            <a:pPr algn="l"/>
-            <a:fld id="{F7021451-1387-4CA6-816F-3879F97B5CBC}" type="slidenum">
-              <a:rPr b="0" lang="en-US"/>
-              <a:t>10</a:t>
-            </a:fld>
-            <a:endParaRPr lang="en-US"/>
-          </a:p>
-        </p:txBody>
-      </p:sp>
+      <p:pic>
+        <p:nvPicPr>
+          <p:cNvPr id="2" name="Image 0" descr="C:\Coding\governed-agents-workshop\workshop-assets\mcp-workiq-architecture.png">    </p:cNvPr>
+          <p:cNvPicPr>
+            <a:picLocks noChangeAspect="1"/>
+          </p:cNvPicPr>
+          <p:nvPr/>
+        </p:nvPicPr>
+        <p:blipFill>
+          <a:blip r:embed="rId1"/>
+          <a:stretch>
+            <a:fillRect/>
+          </a:stretch>
+        </p:blipFill>
+        <p:spPr>
+          <a:xfrm>
+            <a:off x="246888" y="137160"/>
+            <a:ext cx="11704320" cy="6583680"/>
+          </a:xfrm>
+          <a:prstGeom prst="rect">
+            <a:avLst/>
+          </a:prstGeom>
+        </p:spPr>
+      </p:pic>
     </p:spTree>
   </p:cSld>
   <p:clrMapOvr>
@@ -6058,7 +5109,7 @@
                 <a:ea typeface="Aptos" pitchFamily="34" charset="-122"/>
                 <a:cs typeface="Aptos" pitchFamily="34" charset="-120"/>
               </a:rPr>
-              <a:t>RAG as a production engineering pattern - grounded, measured, and governed, not a demo trick. Domain view: workshop-assets/rag-domain.svg.</a:t>
+              <a:t>RAG as a production engineering pattern - grounded, measured, and governed, not a demo trick. Architecture: workshop-assets/rag-domain-architecture.png (next slide).</a:t>
             </a:r>
             <a:endParaRPr lang="en-US" sz="1000" dirty="0"/>
           </a:p>
@@ -6126,7 +5177,7 @@
     <p:bg>
       <p:bgPr>
         <a:solidFill>
-          <a:srgbClr val="F8FAFC"/>
+          <a:srgbClr val="F5F6F8"/>
         </a:solidFill>
       </p:bgPr>
     </p:bg>
@@ -6144,1225 +5195,30 @@
           <a:chExt cx="0" cy="0"/>
         </a:xfrm>
       </p:grpSpPr>
-      <p:sp>
-        <p:nvSpPr>
-          <p:cNvPr id="2" name="Text 0"/>
-          <p:cNvSpPr/>
-          <p:nvPr/>
-        </p:nvSpPr>
-        <p:spPr>
-          <a:xfrm>
-            <a:off x="566928" y="384048"/>
-            <a:ext cx="10789920" cy="201168"/>
-          </a:xfrm>
-          <a:prstGeom prst="rect">
-            <a:avLst/>
-          </a:prstGeom>
-          <a:noFill/>
-          <a:ln/>
-        </p:spPr>
-        <p:txBody>
-          <a:bodyPr wrap="square" lIns="0" tIns="0" rIns="0" bIns="0" rtlCol="0" anchor="ctr"/>
-          <a:lstStyle/>
-          <a:p>
-            <a:pPr indent="0" marL="0">
-              <a:buNone/>
-            </a:pPr>
-            <a:r>
-              <a:rPr lang="en-US" sz="800" b="1" dirty="0">
-                <a:solidFill>
-                  <a:srgbClr val="0F766E"/>
-                </a:solidFill>
-                <a:latin typeface="Aptos" pitchFamily="34" charset="0"/>
-                <a:ea typeface="Aptos" pitchFamily="34" charset="-122"/>
-                <a:cs typeface="Aptos" pitchFamily="34" charset="-120"/>
-              </a:rPr>
-              <a:t>PRIORITY - RAG BEST PRACTICES (DEEP DIVE)</a:t>
-            </a:r>
-            <a:endParaRPr lang="en-US" sz="800" dirty="0"/>
-          </a:p>
-        </p:txBody>
-      </p:sp>
-      <p:sp>
-        <p:nvSpPr>
-          <p:cNvPr id="3" name="Text 1"/>
-          <p:cNvSpPr/>
-          <p:nvPr/>
-        </p:nvSpPr>
-        <p:spPr>
-          <a:xfrm>
-            <a:off x="548640" y="658368"/>
-            <a:ext cx="11064240" cy="502920"/>
-          </a:xfrm>
-          <a:prstGeom prst="rect">
-            <a:avLst/>
-          </a:prstGeom>
-          <a:noFill/>
-          <a:ln/>
-        </p:spPr>
-        <p:txBody>
-          <a:bodyPr wrap="square" lIns="0" tIns="0" rIns="0" bIns="0" rtlCol="0" anchor="ctr">
-            <a:normAutofit/>
-          </a:bodyPr>
-          <a:lstStyle/>
-          <a:p>
-            <a:pPr indent="0" marL="0">
-              <a:buNone/>
-            </a:pPr>
-            <a:r>
-              <a:rPr lang="en-US" sz="2300" b="1" dirty="0">
-                <a:solidFill>
-                  <a:srgbClr val="0B1220"/>
-                </a:solidFill>
-                <a:latin typeface="Aptos Display" pitchFamily="34" charset="0"/>
-                <a:ea typeface="Aptos Display" pitchFamily="34" charset="-122"/>
-                <a:cs typeface="Aptos Display" pitchFamily="34" charset="-120"/>
-              </a:rPr>
-              <a:t>The RAG domain: grounded, measured, governed</a:t>
-            </a:r>
-            <a:endParaRPr lang="en-US" sz="2300" dirty="0"/>
-          </a:p>
-        </p:txBody>
-      </p:sp>
-      <p:sp>
-        <p:nvSpPr>
-          <p:cNvPr id="4" name="Shape 2"/>
-          <p:cNvSpPr/>
-          <p:nvPr/>
-        </p:nvSpPr>
-        <p:spPr>
-          <a:xfrm>
-            <a:off x="548640" y="1243584"/>
-            <a:ext cx="11064240" cy="0"/>
-          </a:xfrm>
-          <a:prstGeom prst="line">
-            <a:avLst/>
-          </a:prstGeom>
-          <a:noFill/>
-          <a:ln w="12700">
-            <a:solidFill>
-              <a:srgbClr val="CBD5E1"/>
-            </a:solidFill>
-            <a:prstDash val="solid"/>
-          </a:ln>
-        </p:spPr>
-      </p:sp>
-      <p:sp>
-        <p:nvSpPr>
-          <p:cNvPr id="5" name="Shape 3"/>
-          <p:cNvSpPr/>
-          <p:nvPr/>
-        </p:nvSpPr>
-        <p:spPr>
-          <a:xfrm>
-            <a:off x="457200" y="1417320"/>
-            <a:ext cx="2148840" cy="1965960"/>
-          </a:xfrm>
-          <a:prstGeom prst="roundRect">
-            <a:avLst>
-              <a:gd name="adj" fmla="val 3721"/>
-            </a:avLst>
-          </a:prstGeom>
-          <a:solidFill>
-            <a:srgbClr val="FFFFFF"/>
-          </a:solidFill>
-          <a:ln w="12700">
-            <a:solidFill>
-              <a:srgbClr val="E2E8F0"/>
-            </a:solidFill>
-            <a:prstDash val="solid"/>
-          </a:ln>
-          <a:effectLst>
-            <a:outerShdw sx="100000" sy="100000" kx="0" ky="0" algn="bl" rotWithShape="0" blurRad="25400" dist="50800" dir="2700000">
-              <a:srgbClr val="94A3B8">
-                <a:alpha val="12000"/>
-              </a:srgbClr>
-            </a:outerShdw>
-          </a:effectLst>
-        </p:spPr>
-      </p:sp>
-      <p:sp>
-        <p:nvSpPr>
-          <p:cNvPr id="6" name="Shape 4"/>
-          <p:cNvSpPr/>
-          <p:nvPr/>
-        </p:nvSpPr>
-        <p:spPr>
-          <a:xfrm>
-            <a:off x="457200" y="1417320"/>
-            <a:ext cx="64008" cy="1965960"/>
-          </a:xfrm>
-          <a:prstGeom prst="rect">
-            <a:avLst/>
-          </a:prstGeom>
-          <a:solidFill>
-            <a:srgbClr val="F59E0B"/>
-          </a:solidFill>
-          <a:ln w="12700">
-            <a:solidFill>
-              <a:srgbClr val="F59E0B"/>
-            </a:solidFill>
-            <a:prstDash val="solid"/>
-          </a:ln>
-        </p:spPr>
-      </p:sp>
-      <p:sp>
-        <p:nvSpPr>
-          <p:cNvPr id="7" name="Text 5"/>
-          <p:cNvSpPr/>
-          <p:nvPr/>
-        </p:nvSpPr>
-        <p:spPr>
-          <a:xfrm>
-            <a:off x="658368" y="1563624"/>
-            <a:ext cx="1828800" cy="219456"/>
-          </a:xfrm>
-          <a:prstGeom prst="rect">
-            <a:avLst/>
-          </a:prstGeom>
-          <a:noFill/>
-          <a:ln/>
-        </p:spPr>
-        <p:txBody>
-          <a:bodyPr wrap="square" lIns="0" tIns="0" rIns="0" bIns="0" rtlCol="0" anchor="ctr">
-            <a:normAutofit/>
-          </a:bodyPr>
-          <a:lstStyle/>
-          <a:p>
-            <a:pPr indent="0" marL="0">
-              <a:buNone/>
-            </a:pPr>
-            <a:r>
-              <a:rPr lang="en-US" sz="1200" b="1" dirty="0">
-                <a:solidFill>
-                  <a:srgbClr val="0B1220"/>
-                </a:solidFill>
-                <a:latin typeface="Aptos" pitchFamily="34" charset="0"/>
-                <a:ea typeface="Aptos" pitchFamily="34" charset="-122"/>
-                <a:cs typeface="Aptos" pitchFamily="34" charset="-120"/>
-              </a:rPr>
-              <a:t>1 Sources</a:t>
-            </a:r>
-            <a:endParaRPr lang="en-US" sz="1200" dirty="0"/>
-          </a:p>
-        </p:txBody>
-      </p:sp>
-      <p:sp>
-        <p:nvSpPr>
-          <p:cNvPr id="8" name="Text 6"/>
-          <p:cNvSpPr/>
-          <p:nvPr/>
-        </p:nvSpPr>
-        <p:spPr>
-          <a:xfrm>
-            <a:off x="658368" y="1874520"/>
-            <a:ext cx="1828800" cy="1417320"/>
-          </a:xfrm>
-          <a:prstGeom prst="rect">
-            <a:avLst/>
-          </a:prstGeom>
-          <a:noFill/>
-          <a:ln/>
-        </p:spPr>
-        <p:txBody>
-          <a:bodyPr wrap="square" lIns="254" tIns="254" rIns="254" bIns="254" rtlCol="0" anchor="t">
-            <a:normAutofit/>
-          </a:bodyPr>
-          <a:lstStyle/>
-          <a:p>
-            <a:pPr indent="0" marL="0">
-              <a:buNone/>
-            </a:pPr>
-            <a:r>
-              <a:rPr lang="en-US" sz="920" dirty="0">
-                <a:solidFill>
-                  <a:srgbClr val="334155"/>
-                </a:solidFill>
-                <a:latin typeface="Aptos" pitchFamily="34" charset="0"/>
-                <a:ea typeface="Aptos" pitchFamily="34" charset="-122"/>
-                <a:cs typeface="Aptos" pitchFamily="34" charset="-120"/>
-              </a:rPr>
-              <a:t>Effective-dated protocols (data/rag-docs); SharePoint / O365 (future). Each carries ACLs + labels.</a:t>
-            </a:r>
-            <a:endParaRPr lang="en-US" sz="920" dirty="0"/>
-          </a:p>
-        </p:txBody>
-      </p:sp>
-      <p:sp>
-        <p:nvSpPr>
-          <p:cNvPr id="9" name="Shape 7"/>
-          <p:cNvSpPr/>
-          <p:nvPr/>
-        </p:nvSpPr>
-        <p:spPr>
-          <a:xfrm>
-            <a:off x="2761488" y="1417320"/>
-            <a:ext cx="2148840" cy="1965960"/>
-          </a:xfrm>
-          <a:prstGeom prst="roundRect">
-            <a:avLst>
-              <a:gd name="adj" fmla="val 3721"/>
-            </a:avLst>
-          </a:prstGeom>
-          <a:solidFill>
-            <a:srgbClr val="FFFFFF"/>
-          </a:solidFill>
-          <a:ln w="12700">
-            <a:solidFill>
-              <a:srgbClr val="E2E8F0"/>
-            </a:solidFill>
-            <a:prstDash val="solid"/>
-          </a:ln>
-          <a:effectLst>
-            <a:outerShdw sx="100000" sy="100000" kx="0" ky="0" algn="bl" rotWithShape="0" blurRad="25400" dist="50800" dir="2700000">
-              <a:srgbClr val="94A3B8">
-                <a:alpha val="12000"/>
-              </a:srgbClr>
-            </a:outerShdw>
-          </a:effectLst>
-        </p:spPr>
-      </p:sp>
-      <p:sp>
-        <p:nvSpPr>
-          <p:cNvPr id="10" name="Shape 8"/>
-          <p:cNvSpPr/>
-          <p:nvPr/>
-        </p:nvSpPr>
-        <p:spPr>
-          <a:xfrm>
-            <a:off x="2761488" y="1417320"/>
-            <a:ext cx="64008" cy="1965960"/>
-          </a:xfrm>
-          <a:prstGeom prst="rect">
-            <a:avLst/>
-          </a:prstGeom>
-          <a:solidFill>
-            <a:srgbClr val="06B6D4"/>
-          </a:solidFill>
-          <a:ln w="12700">
-            <a:solidFill>
-              <a:srgbClr val="06B6D4"/>
-            </a:solidFill>
-            <a:prstDash val="solid"/>
-          </a:ln>
-        </p:spPr>
-      </p:sp>
-      <p:sp>
-        <p:nvSpPr>
-          <p:cNvPr id="11" name="Text 9"/>
-          <p:cNvSpPr/>
-          <p:nvPr/>
-        </p:nvSpPr>
-        <p:spPr>
-          <a:xfrm>
-            <a:off x="2962656" y="1563624"/>
-            <a:ext cx="1828800" cy="219456"/>
-          </a:xfrm>
-          <a:prstGeom prst="rect">
-            <a:avLst/>
-          </a:prstGeom>
-          <a:noFill/>
-          <a:ln/>
-        </p:spPr>
-        <p:txBody>
-          <a:bodyPr wrap="square" lIns="0" tIns="0" rIns="0" bIns="0" rtlCol="0" anchor="ctr">
-            <a:normAutofit/>
-          </a:bodyPr>
-          <a:lstStyle/>
-          <a:p>
-            <a:pPr indent="0" marL="0">
-              <a:buNone/>
-            </a:pPr>
-            <a:r>
-              <a:rPr lang="en-US" sz="1200" b="1" dirty="0">
-                <a:solidFill>
-                  <a:srgbClr val="0B1220"/>
-                </a:solidFill>
-                <a:latin typeface="Aptos" pitchFamily="34" charset="0"/>
-                <a:ea typeface="Aptos" pitchFamily="34" charset="-122"/>
-                <a:cs typeface="Aptos" pitchFamily="34" charset="-120"/>
-              </a:rPr>
-              <a:t>2 Ingest</a:t>
-            </a:r>
-            <a:endParaRPr lang="en-US" sz="1200" dirty="0"/>
-          </a:p>
-        </p:txBody>
-      </p:sp>
-      <p:sp>
-        <p:nvSpPr>
-          <p:cNvPr id="12" name="Text 10"/>
-          <p:cNvSpPr/>
-          <p:nvPr/>
-        </p:nvSpPr>
-        <p:spPr>
-          <a:xfrm>
-            <a:off x="2962656" y="1874520"/>
-            <a:ext cx="1828800" cy="1417320"/>
-          </a:xfrm>
-          <a:prstGeom prst="rect">
-            <a:avLst/>
-          </a:prstGeom>
-          <a:noFill/>
-          <a:ln/>
-        </p:spPr>
-        <p:txBody>
-          <a:bodyPr wrap="square" lIns="254" tIns="254" rIns="254" bIns="254" rtlCol="0" anchor="t">
-            <a:normAutofit/>
-          </a:bodyPr>
-          <a:lstStyle/>
-          <a:p>
-            <a:pPr indent="0" marL="0">
-              <a:buNone/>
-            </a:pPr>
-            <a:r>
-              <a:rPr lang="en-US" sz="920" dirty="0">
-                <a:solidFill>
-                  <a:srgbClr val="334155"/>
-                </a:solidFill>
-                <a:latin typeface="Aptos" pitchFamily="34" charset="0"/>
-                <a:ea typeface="Aptos" pitchFamily="34" charset="-122"/>
-                <a:cs typeface="Aptos" pitchFamily="34" charset="-120"/>
-              </a:rPr>
-              <a:t>Extract, chunk, embed, index. ACL-trimmed at index time so permissions are honored.</a:t>
-            </a:r>
-            <a:endParaRPr lang="en-US" sz="920" dirty="0"/>
-          </a:p>
-        </p:txBody>
-      </p:sp>
-      <p:sp>
-        <p:nvSpPr>
-          <p:cNvPr id="13" name="Shape 11"/>
-          <p:cNvSpPr/>
-          <p:nvPr/>
-        </p:nvSpPr>
-        <p:spPr>
-          <a:xfrm>
-            <a:off x="5065776" y="1417320"/>
-            <a:ext cx="2148840" cy="1965960"/>
-          </a:xfrm>
-          <a:prstGeom prst="roundRect">
-            <a:avLst>
-              <a:gd name="adj" fmla="val 3721"/>
-            </a:avLst>
-          </a:prstGeom>
-          <a:solidFill>
-            <a:srgbClr val="FFFFFF"/>
-          </a:solidFill>
-          <a:ln w="12700">
-            <a:solidFill>
-              <a:srgbClr val="E2E8F0"/>
-            </a:solidFill>
-            <a:prstDash val="solid"/>
-          </a:ln>
-          <a:effectLst>
-            <a:outerShdw sx="100000" sy="100000" kx="0" ky="0" algn="bl" rotWithShape="0" blurRad="25400" dist="50800" dir="2700000">
-              <a:srgbClr val="94A3B8">
-                <a:alpha val="12000"/>
-              </a:srgbClr>
-            </a:outerShdw>
-          </a:effectLst>
-        </p:spPr>
-      </p:sp>
-      <p:sp>
-        <p:nvSpPr>
-          <p:cNvPr id="14" name="Shape 12"/>
-          <p:cNvSpPr/>
-          <p:nvPr/>
-        </p:nvSpPr>
-        <p:spPr>
-          <a:xfrm>
-            <a:off x="5065776" y="1417320"/>
-            <a:ext cx="64008" cy="1965960"/>
-          </a:xfrm>
-          <a:prstGeom prst="rect">
-            <a:avLst/>
-          </a:prstGeom>
-          <a:solidFill>
-            <a:srgbClr val="2563EB"/>
-          </a:solidFill>
-          <a:ln w="12700">
-            <a:solidFill>
-              <a:srgbClr val="2563EB"/>
-            </a:solidFill>
-            <a:prstDash val="solid"/>
-          </a:ln>
-        </p:spPr>
-      </p:sp>
-      <p:sp>
-        <p:nvSpPr>
-          <p:cNvPr id="15" name="Text 13"/>
-          <p:cNvSpPr/>
-          <p:nvPr/>
-        </p:nvSpPr>
-        <p:spPr>
-          <a:xfrm>
-            <a:off x="5266944" y="1563624"/>
-            <a:ext cx="1828800" cy="219456"/>
-          </a:xfrm>
-          <a:prstGeom prst="rect">
-            <a:avLst/>
-          </a:prstGeom>
-          <a:noFill/>
-          <a:ln/>
-        </p:spPr>
-        <p:txBody>
-          <a:bodyPr wrap="square" lIns="0" tIns="0" rIns="0" bIns="0" rtlCol="0" anchor="ctr">
-            <a:normAutofit/>
-          </a:bodyPr>
-          <a:lstStyle/>
-          <a:p>
-            <a:pPr indent="0" marL="0">
-              <a:buNone/>
-            </a:pPr>
-            <a:r>
-              <a:rPr lang="en-US" sz="1200" b="1" dirty="0">
-                <a:solidFill>
-                  <a:srgbClr val="0B1220"/>
-                </a:solidFill>
-                <a:latin typeface="Aptos" pitchFamily="34" charset="0"/>
-                <a:ea typeface="Aptos" pitchFamily="34" charset="-122"/>
-                <a:cs typeface="Aptos" pitchFamily="34" charset="-120"/>
-              </a:rPr>
-              <a:t>3 Retrieve</a:t>
-            </a:r>
-            <a:endParaRPr lang="en-US" sz="1200" dirty="0"/>
-          </a:p>
-        </p:txBody>
-      </p:sp>
-      <p:sp>
-        <p:nvSpPr>
-          <p:cNvPr id="16" name="Text 14"/>
-          <p:cNvSpPr/>
-          <p:nvPr/>
-        </p:nvSpPr>
-        <p:spPr>
-          <a:xfrm>
-            <a:off x="5266944" y="1874520"/>
-            <a:ext cx="1828800" cy="1417320"/>
-          </a:xfrm>
-          <a:prstGeom prst="rect">
-            <a:avLst/>
-          </a:prstGeom>
-          <a:noFill/>
-          <a:ln/>
-        </p:spPr>
-        <p:txBody>
-          <a:bodyPr wrap="square" lIns="254" tIns="254" rIns="254" bIns="254" rtlCol="0" anchor="t">
-            <a:normAutofit/>
-          </a:bodyPr>
-          <a:lstStyle/>
-          <a:p>
-            <a:pPr indent="0" marL="0">
-              <a:buNone/>
-            </a:pPr>
-            <a:r>
-              <a:rPr lang="en-US" sz="920" dirty="0">
-                <a:solidFill>
-                  <a:srgbClr val="334155"/>
-                </a:solidFill>
-                <a:latin typeface="Aptos" pitchFamily="34" charset="0"/>
-                <a:ea typeface="Aptos" pitchFamily="34" charset="-122"/>
-                <a:cs typeface="Aptos" pitchFamily="34" charset="-120"/>
-              </a:rPr>
-              <a:t>Query from the case; diagnosis-scoping filter (CHF never surfaces for COPD); top-k + confidence.</a:t>
-            </a:r>
-            <a:endParaRPr lang="en-US" sz="920" dirty="0"/>
-          </a:p>
-        </p:txBody>
-      </p:sp>
-      <p:sp>
-        <p:nvSpPr>
-          <p:cNvPr id="17" name="Shape 15"/>
-          <p:cNvSpPr/>
-          <p:nvPr/>
-        </p:nvSpPr>
-        <p:spPr>
-          <a:xfrm>
-            <a:off x="7370064" y="1417320"/>
-            <a:ext cx="2148840" cy="1965960"/>
-          </a:xfrm>
-          <a:prstGeom prst="roundRect">
-            <a:avLst>
-              <a:gd name="adj" fmla="val 3721"/>
-            </a:avLst>
-          </a:prstGeom>
-          <a:solidFill>
-            <a:srgbClr val="FFFFFF"/>
-          </a:solidFill>
-          <a:ln w="12700">
-            <a:solidFill>
-              <a:srgbClr val="E2E8F0"/>
-            </a:solidFill>
-            <a:prstDash val="solid"/>
-          </a:ln>
-          <a:effectLst>
-            <a:outerShdw sx="100000" sy="100000" kx="0" ky="0" algn="bl" rotWithShape="0" blurRad="25400" dist="50800" dir="2700000">
-              <a:srgbClr val="94A3B8">
-                <a:alpha val="12000"/>
-              </a:srgbClr>
-            </a:outerShdw>
-          </a:effectLst>
-        </p:spPr>
-      </p:sp>
-      <p:sp>
-        <p:nvSpPr>
-          <p:cNvPr id="18" name="Shape 16"/>
-          <p:cNvSpPr/>
-          <p:nvPr/>
-        </p:nvSpPr>
-        <p:spPr>
-          <a:xfrm>
-            <a:off x="7370064" y="1417320"/>
-            <a:ext cx="64008" cy="1965960"/>
-          </a:xfrm>
-          <a:prstGeom prst="rect">
-            <a:avLst/>
-          </a:prstGeom>
-          <a:solidFill>
-            <a:srgbClr val="7C3AED"/>
-          </a:solidFill>
-          <a:ln w="12700">
-            <a:solidFill>
-              <a:srgbClr val="7C3AED"/>
-            </a:solidFill>
-            <a:prstDash val="solid"/>
-          </a:ln>
-        </p:spPr>
-      </p:sp>
-      <p:sp>
-        <p:nvSpPr>
-          <p:cNvPr id="19" name="Text 17"/>
-          <p:cNvSpPr/>
-          <p:nvPr/>
-        </p:nvSpPr>
-        <p:spPr>
-          <a:xfrm>
-            <a:off x="7571232" y="1563624"/>
-            <a:ext cx="1828800" cy="219456"/>
-          </a:xfrm>
-          <a:prstGeom prst="rect">
-            <a:avLst/>
-          </a:prstGeom>
-          <a:noFill/>
-          <a:ln/>
-        </p:spPr>
-        <p:txBody>
-          <a:bodyPr wrap="square" lIns="0" tIns="0" rIns="0" bIns="0" rtlCol="0" anchor="ctr">
-            <a:normAutofit/>
-          </a:bodyPr>
-          <a:lstStyle/>
-          <a:p>
-            <a:pPr indent="0" marL="0">
-              <a:buNone/>
-            </a:pPr>
-            <a:r>
-              <a:rPr lang="en-US" sz="1200" b="1" dirty="0">
-                <a:solidFill>
-                  <a:srgbClr val="0B1220"/>
-                </a:solidFill>
-                <a:latin typeface="Aptos" pitchFamily="34" charset="0"/>
-                <a:ea typeface="Aptos" pitchFamily="34" charset="-122"/>
-                <a:cs typeface="Aptos" pitchFamily="34" charset="-120"/>
-              </a:rPr>
-              <a:t>4 Ground</a:t>
-            </a:r>
-            <a:endParaRPr lang="en-US" sz="1200" dirty="0"/>
-          </a:p>
-        </p:txBody>
-      </p:sp>
-      <p:sp>
-        <p:nvSpPr>
-          <p:cNvPr id="20" name="Text 18"/>
-          <p:cNvSpPr/>
-          <p:nvPr/>
-        </p:nvSpPr>
-        <p:spPr>
-          <a:xfrm>
-            <a:off x="7571232" y="1874520"/>
-            <a:ext cx="1828800" cy="1417320"/>
-          </a:xfrm>
-          <a:prstGeom prst="rect">
-            <a:avLst/>
-          </a:prstGeom>
-          <a:noFill/>
-          <a:ln/>
-        </p:spPr>
-        <p:txBody>
-          <a:bodyPr wrap="square" lIns="254" tIns="254" rIns="254" bIns="254" rtlCol="0" anchor="t">
-            <a:normAutofit/>
-          </a:bodyPr>
-          <a:lstStyle/>
-          <a:p>
-            <a:pPr indent="0" marL="0">
-              <a:buNone/>
-            </a:pPr>
-            <a:r>
-              <a:rPr lang="en-US" sz="920" dirty="0">
-                <a:solidFill>
-                  <a:srgbClr val="334155"/>
-                </a:solidFill>
-                <a:latin typeface="Aptos" pitchFamily="34" charset="0"/>
-                <a:ea typeface="Aptos" pitchFamily="34" charset="-122"/>
-                <a:cs typeface="Aptos" pitchFamily="34" charset="-120"/>
-              </a:rPr>
-              <a:t>Evidence packet BEFORE answer; claim-level citations; missing protocol -&gt; review_required.</a:t>
-            </a:r>
-            <a:endParaRPr lang="en-US" sz="920" dirty="0"/>
-          </a:p>
-        </p:txBody>
-      </p:sp>
-      <p:sp>
-        <p:nvSpPr>
-          <p:cNvPr id="21" name="Shape 19"/>
-          <p:cNvSpPr/>
-          <p:nvPr/>
-        </p:nvSpPr>
-        <p:spPr>
-          <a:xfrm>
-            <a:off x="9674352" y="1417320"/>
-            <a:ext cx="2148840" cy="1965960"/>
-          </a:xfrm>
-          <a:prstGeom prst="roundRect">
-            <a:avLst>
-              <a:gd name="adj" fmla="val 3721"/>
-            </a:avLst>
-          </a:prstGeom>
-          <a:solidFill>
-            <a:srgbClr val="FFFFFF"/>
-          </a:solidFill>
-          <a:ln w="12700">
-            <a:solidFill>
-              <a:srgbClr val="E2E8F0"/>
-            </a:solidFill>
-            <a:prstDash val="solid"/>
-          </a:ln>
-          <a:effectLst>
-            <a:outerShdw sx="100000" sy="100000" kx="0" ky="0" algn="bl" rotWithShape="0" blurRad="25400" dist="50800" dir="2700000">
-              <a:srgbClr val="94A3B8">
-                <a:alpha val="12000"/>
-              </a:srgbClr>
-            </a:outerShdw>
-          </a:effectLst>
-        </p:spPr>
-      </p:sp>
-      <p:sp>
-        <p:nvSpPr>
-          <p:cNvPr id="22" name="Shape 20"/>
-          <p:cNvSpPr/>
-          <p:nvPr/>
-        </p:nvSpPr>
-        <p:spPr>
-          <a:xfrm>
-            <a:off x="9674352" y="1417320"/>
-            <a:ext cx="64008" cy="1965960"/>
-          </a:xfrm>
-          <a:prstGeom prst="rect">
-            <a:avLst/>
-          </a:prstGeom>
-          <a:solidFill>
-            <a:srgbClr val="16A34A"/>
-          </a:solidFill>
-          <a:ln w="12700">
-            <a:solidFill>
-              <a:srgbClr val="16A34A"/>
-            </a:solidFill>
-            <a:prstDash val="solid"/>
-          </a:ln>
-        </p:spPr>
-      </p:sp>
-      <p:sp>
-        <p:nvSpPr>
-          <p:cNvPr id="23" name="Text 21"/>
-          <p:cNvSpPr/>
-          <p:nvPr/>
-        </p:nvSpPr>
-        <p:spPr>
-          <a:xfrm>
-            <a:off x="9875520" y="1563624"/>
-            <a:ext cx="1828800" cy="219456"/>
-          </a:xfrm>
-          <a:prstGeom prst="rect">
-            <a:avLst/>
-          </a:prstGeom>
-          <a:noFill/>
-          <a:ln/>
-        </p:spPr>
-        <p:txBody>
-          <a:bodyPr wrap="square" lIns="0" tIns="0" rIns="0" bIns="0" rtlCol="0" anchor="ctr">
-            <a:normAutofit/>
-          </a:bodyPr>
-          <a:lstStyle/>
-          <a:p>
-            <a:pPr indent="0" marL="0">
-              <a:buNone/>
-            </a:pPr>
-            <a:r>
-              <a:rPr lang="en-US" sz="1200" b="1" dirty="0">
-                <a:solidFill>
-                  <a:srgbClr val="0B1220"/>
-                </a:solidFill>
-                <a:latin typeface="Aptos" pitchFamily="34" charset="0"/>
-                <a:ea typeface="Aptos" pitchFamily="34" charset="-122"/>
-                <a:cs typeface="Aptos" pitchFamily="34" charset="-120"/>
-              </a:rPr>
-              <a:t>5 Measure</a:t>
-            </a:r>
-            <a:endParaRPr lang="en-US" sz="1200" dirty="0"/>
-          </a:p>
-        </p:txBody>
-      </p:sp>
-      <p:sp>
-        <p:nvSpPr>
-          <p:cNvPr id="24" name="Text 22"/>
-          <p:cNvSpPr/>
-          <p:nvPr/>
-        </p:nvSpPr>
-        <p:spPr>
-          <a:xfrm>
-            <a:off x="9875520" y="1874520"/>
-            <a:ext cx="1828800" cy="1417320"/>
-          </a:xfrm>
-          <a:prstGeom prst="rect">
-            <a:avLst/>
-          </a:prstGeom>
-          <a:noFill/>
-          <a:ln/>
-        </p:spPr>
-        <p:txBody>
-          <a:bodyPr wrap="square" lIns="254" tIns="254" rIns="254" bIns="254" rtlCol="0" anchor="t">
-            <a:normAutofit/>
-          </a:bodyPr>
-          <a:lstStyle/>
-          <a:p>
-            <a:pPr indent="0" marL="0">
-              <a:buNone/>
-            </a:pPr>
-            <a:r>
-              <a:rPr lang="en-US" sz="920" dirty="0">
-                <a:solidFill>
-                  <a:srgbClr val="334155"/>
-                </a:solidFill>
-                <a:latin typeface="Aptos" pitchFamily="34" charset="0"/>
-                <a:ea typeface="Aptos" pitchFamily="34" charset="-122"/>
-                <a:cs typeface="Aptos" pitchFamily="34" charset="-120"/>
-              </a:rPr>
-              <a:t>precision@k / recall@k / MRR over qrels; gate on a minimum; measure before you tune.</a:t>
-            </a:r>
-            <a:endParaRPr lang="en-US" sz="920" dirty="0"/>
-          </a:p>
-        </p:txBody>
-      </p:sp>
-      <p:sp>
-        <p:nvSpPr>
-          <p:cNvPr id="25" name="Shape 23"/>
-          <p:cNvSpPr/>
-          <p:nvPr/>
-        </p:nvSpPr>
-        <p:spPr>
-          <a:xfrm>
-            <a:off x="457200" y="3657600"/>
-            <a:ext cx="5394960" cy="1371600"/>
-          </a:xfrm>
-          <a:prstGeom prst="roundRect">
-            <a:avLst>
-              <a:gd name="adj" fmla="val 5333"/>
-            </a:avLst>
-          </a:prstGeom>
-          <a:solidFill>
-            <a:srgbClr val="FFFFFF"/>
-          </a:solidFill>
-          <a:ln w="12700">
-            <a:solidFill>
-              <a:srgbClr val="E2E8F0"/>
-            </a:solidFill>
-            <a:prstDash val="solid"/>
-          </a:ln>
-          <a:effectLst>
-            <a:outerShdw sx="100000" sy="100000" kx="0" ky="0" algn="bl" rotWithShape="0" blurRad="25400" dist="50800" dir="2700000">
-              <a:srgbClr val="94A3B8">
-                <a:alpha val="12000"/>
-              </a:srgbClr>
-            </a:outerShdw>
-          </a:effectLst>
-        </p:spPr>
-      </p:sp>
-      <p:sp>
-        <p:nvSpPr>
-          <p:cNvPr id="26" name="Shape 24"/>
-          <p:cNvSpPr/>
-          <p:nvPr/>
-        </p:nvSpPr>
-        <p:spPr>
-          <a:xfrm>
-            <a:off x="457200" y="3657600"/>
-            <a:ext cx="64008" cy="1371600"/>
-          </a:xfrm>
-          <a:prstGeom prst="rect">
-            <a:avLst/>
-          </a:prstGeom>
-          <a:solidFill>
-            <a:srgbClr val="0F766E"/>
-          </a:solidFill>
-          <a:ln w="12700">
-            <a:solidFill>
-              <a:srgbClr val="0F766E"/>
-            </a:solidFill>
-            <a:prstDash val="solid"/>
-          </a:ln>
-        </p:spPr>
-      </p:sp>
-      <p:sp>
-        <p:nvSpPr>
-          <p:cNvPr id="27" name="Text 25"/>
-          <p:cNvSpPr/>
-          <p:nvPr/>
-        </p:nvSpPr>
-        <p:spPr>
-          <a:xfrm>
-            <a:off x="658368" y="3803904"/>
-            <a:ext cx="5074920" cy="219456"/>
-          </a:xfrm>
-          <a:prstGeom prst="rect">
-            <a:avLst/>
-          </a:prstGeom>
-          <a:noFill/>
-          <a:ln/>
-        </p:spPr>
-        <p:txBody>
-          <a:bodyPr wrap="square" lIns="0" tIns="0" rIns="0" bIns="0" rtlCol="0" anchor="ctr">
-            <a:normAutofit/>
-          </a:bodyPr>
-          <a:lstStyle/>
-          <a:p>
-            <a:pPr indent="0" marL="0">
-              <a:buNone/>
-            </a:pPr>
-            <a:r>
-              <a:rPr lang="en-US" sz="1200" b="1" dirty="0">
-                <a:solidFill>
-                  <a:srgbClr val="0B1220"/>
-                </a:solidFill>
-                <a:latin typeface="Aptos" pitchFamily="34" charset="0"/>
-                <a:ea typeface="Aptos" pitchFamily="34" charset="-122"/>
-                <a:cs typeface="Aptos" pitchFamily="34" charset="-120"/>
-              </a:rPr>
-              <a:t>Today - local KnowledgeBase</a:t>
-            </a:r>
-            <a:endParaRPr lang="en-US" sz="1200" dirty="0"/>
-          </a:p>
-        </p:txBody>
-      </p:sp>
-      <p:sp>
-        <p:nvSpPr>
-          <p:cNvPr id="28" name="Text 26"/>
-          <p:cNvSpPr/>
-          <p:nvPr/>
-        </p:nvSpPr>
-        <p:spPr>
-          <a:xfrm>
-            <a:off x="658368" y="4114800"/>
-            <a:ext cx="5074920" cy="822960"/>
-          </a:xfrm>
-          <a:prstGeom prst="rect">
-            <a:avLst/>
-          </a:prstGeom>
-          <a:noFill/>
-          <a:ln/>
-        </p:spPr>
-        <p:txBody>
-          <a:bodyPr wrap="square" lIns="254" tIns="254" rIns="254" bIns="254" rtlCol="0" anchor="t">
-            <a:normAutofit/>
-          </a:bodyPr>
-          <a:lstStyle/>
-          <a:p>
-            <a:pPr indent="0" marL="0">
-              <a:buNone/>
-            </a:pPr>
-            <a:r>
-              <a:rPr lang="en-US" sz="920" dirty="0">
-                <a:solidFill>
-                  <a:srgbClr val="334155"/>
-                </a:solidFill>
-                <a:latin typeface="Aptos" pitchFamily="34" charset="0"/>
-                <a:ea typeface="Aptos" pitchFamily="34" charset="-122"/>
-                <a:cs typeface="Aptos" pitchFamily="34" charset="-120"/>
-              </a:rPr>
-              <a:t>agent-service/knowledge.py: keyword scoring over rag-docs. Offline, deterministic, diagnosis-scoped, cited. No vector store to manage.</a:t>
-            </a:r>
-            <a:endParaRPr lang="en-US" sz="920" dirty="0"/>
-          </a:p>
-        </p:txBody>
-      </p:sp>
-      <p:sp>
-        <p:nvSpPr>
-          <p:cNvPr id="29" name="Shape 27"/>
-          <p:cNvSpPr/>
-          <p:nvPr/>
-        </p:nvSpPr>
-        <p:spPr>
-          <a:xfrm>
-            <a:off x="6309360" y="3657600"/>
-            <a:ext cx="5394960" cy="1371600"/>
-          </a:xfrm>
-          <a:prstGeom prst="roundRect">
-            <a:avLst>
-              <a:gd name="adj" fmla="val 5333"/>
-            </a:avLst>
-          </a:prstGeom>
-          <a:solidFill>
-            <a:srgbClr val="FFFFFF"/>
-          </a:solidFill>
-          <a:ln w="12700">
-            <a:solidFill>
-              <a:srgbClr val="E2E8F0"/>
-            </a:solidFill>
-            <a:prstDash val="solid"/>
-          </a:ln>
-          <a:effectLst>
-            <a:outerShdw sx="100000" sy="100000" kx="0" ky="0" algn="bl" rotWithShape="0" blurRad="25400" dist="50800" dir="2700000">
-              <a:srgbClr val="94A3B8">
-                <a:alpha val="12000"/>
-              </a:srgbClr>
-            </a:outerShdw>
-          </a:effectLst>
-        </p:spPr>
-      </p:sp>
-      <p:sp>
-        <p:nvSpPr>
-          <p:cNvPr id="30" name="Shape 28"/>
-          <p:cNvSpPr/>
-          <p:nvPr/>
-        </p:nvSpPr>
-        <p:spPr>
-          <a:xfrm>
-            <a:off x="6309360" y="3657600"/>
-            <a:ext cx="64008" cy="1371600"/>
-          </a:xfrm>
-          <a:prstGeom prst="rect">
-            <a:avLst/>
-          </a:prstGeom>
-          <a:solidFill>
-            <a:srgbClr val="06B6D4"/>
-          </a:solidFill>
-          <a:ln w="12700">
-            <a:solidFill>
-              <a:srgbClr val="06B6D4"/>
-            </a:solidFill>
-            <a:prstDash val="solid"/>
-          </a:ln>
-        </p:spPr>
-      </p:sp>
-      <p:sp>
-        <p:nvSpPr>
-          <p:cNvPr id="31" name="Text 29"/>
-          <p:cNvSpPr/>
-          <p:nvPr/>
-        </p:nvSpPr>
-        <p:spPr>
-          <a:xfrm>
-            <a:off x="6510528" y="3803904"/>
-            <a:ext cx="5074920" cy="219456"/>
-          </a:xfrm>
-          <a:prstGeom prst="rect">
-            <a:avLst/>
-          </a:prstGeom>
-          <a:noFill/>
-          <a:ln/>
-        </p:spPr>
-        <p:txBody>
-          <a:bodyPr wrap="square" lIns="0" tIns="0" rIns="0" bIns="0" rtlCol="0" anchor="ctr">
-            <a:normAutofit/>
-          </a:bodyPr>
-          <a:lstStyle/>
-          <a:p>
-            <a:pPr indent="0" marL="0">
-              <a:buNone/>
-            </a:pPr>
-            <a:r>
-              <a:rPr lang="en-US" sz="1200" b="1" dirty="0">
-                <a:solidFill>
-                  <a:srgbClr val="0B1220"/>
-                </a:solidFill>
-                <a:latin typeface="Aptos" pitchFamily="34" charset="0"/>
-                <a:ea typeface="Aptos" pitchFamily="34" charset="-122"/>
-                <a:cs typeface="Aptos" pitchFamily="34" charset="-120"/>
-              </a:rPr>
-              <a:t>Graduation - Foundry IQ / Azure AI Search</a:t>
-            </a:r>
-            <a:endParaRPr lang="en-US" sz="1200" dirty="0"/>
-          </a:p>
-        </p:txBody>
-      </p:sp>
-      <p:sp>
-        <p:nvSpPr>
-          <p:cNvPr id="32" name="Text 30"/>
-          <p:cNvSpPr/>
-          <p:nvPr/>
-        </p:nvSpPr>
-        <p:spPr>
-          <a:xfrm>
-            <a:off x="6510528" y="4114800"/>
-            <a:ext cx="5074920" cy="822960"/>
-          </a:xfrm>
-          <a:prstGeom prst="rect">
-            <a:avLst/>
-          </a:prstGeom>
-          <a:noFill/>
-          <a:ln/>
-        </p:spPr>
-        <p:txBody>
-          <a:bodyPr wrap="square" lIns="254" tIns="254" rIns="254" bIns="254" rtlCol="0" anchor="t">
-            <a:normAutofit/>
-          </a:bodyPr>
-          <a:lstStyle/>
-          <a:p>
-            <a:pPr indent="0" marL="0">
-              <a:buNone/>
-            </a:pPr>
-            <a:r>
-              <a:rPr lang="en-US" sz="920" dirty="0">
-                <a:solidFill>
-                  <a:srgbClr val="334155"/>
-                </a:solidFill>
-                <a:latin typeface="Aptos" pitchFamily="34" charset="0"/>
-                <a:ea typeface="Aptos" pitchFamily="34" charset="-122"/>
-                <a:cs typeface="Aptos" pitchFamily="34" charset="-120"/>
-              </a:rPr>
-              <a:t>Swap the retriever; agents unchanged (same query -&gt; cited-evidence contract). Reuse one always-on Search for cost - build on SEPARATE indexes (immutable connections).</a:t>
-            </a:r>
-            <a:endParaRPr lang="en-US" sz="920" dirty="0"/>
-          </a:p>
-        </p:txBody>
-      </p:sp>
-      <p:sp>
-        <p:nvSpPr>
-          <p:cNvPr id="33" name="Text 31"/>
-          <p:cNvSpPr/>
-          <p:nvPr/>
-        </p:nvSpPr>
-        <p:spPr>
-          <a:xfrm>
-            <a:off x="457200" y="5212080"/>
-            <a:ext cx="11338560" cy="640080"/>
-          </a:xfrm>
-          <a:prstGeom prst="rect">
-            <a:avLst/>
-          </a:prstGeom>
-          <a:noFill/>
-          <a:ln/>
-        </p:spPr>
-        <p:txBody>
-          <a:bodyPr wrap="square" lIns="381" tIns="381" rIns="381" bIns="381" rtlCol="0" anchor="ctr">
-            <a:normAutofit/>
-          </a:bodyPr>
-          <a:lstStyle/>
-          <a:p>
-            <a:pPr marL="152400" indent="-152400">
-              <a:buSzPct val="100000"/>
-              <a:buChar char="•"/>
-            </a:pPr>
-            <a:r>
-              <a:rPr lang="en-US" sz="1150" dirty="0">
-                <a:solidFill>
-                  <a:srgbClr val="334155"/>
-                </a:solidFill>
-                <a:latin typeface="Aptos" pitchFamily="34" charset="0"/>
-                <a:ea typeface="Aptos" pitchFamily="34" charset="-122"/>
-                <a:cs typeface="Aptos" pitchFamily="34" charset="-120"/>
-              </a:rPr>
-              <a:t>Missing / low-coverage evidence -&gt; review_required -&gt; care-manager approval (Durable Task Scheduler). The agent drafts and cites; a human decides. Never guess.</a:t>
-            </a:r>
-            <a:endParaRPr lang="en-US" sz="1150" dirty="0"/>
-          </a:p>
-        </p:txBody>
-      </p:sp>
-      <p:sp>
-        <p:nvSpPr>
-          <p:cNvPr id="34" name="Text 32"/>
-          <p:cNvSpPr/>
-          <p:nvPr/>
-        </p:nvSpPr>
-        <p:spPr>
-          <a:xfrm>
-            <a:off x="640080" y="5806440"/>
-            <a:ext cx="10972800" cy="457200"/>
-          </a:xfrm>
-          <a:prstGeom prst="rect">
-            <a:avLst/>
-          </a:prstGeom>
-          <a:noFill/>
-          <a:ln/>
-        </p:spPr>
-        <p:txBody>
-          <a:bodyPr wrap="square" lIns="0" tIns="0" rIns="0" bIns="0" rtlCol="0" anchor="ctr"/>
-          <a:lstStyle/>
-          <a:p>
-            <a:pPr indent="0" marL="0">
-              <a:buNone/>
-            </a:pPr>
-            <a:r>
-              <a:rPr lang="en-US" sz="1000" i="1" dirty="0">
-                <a:solidFill>
-                  <a:srgbClr val="64748B"/>
-                </a:solidFill>
-                <a:latin typeface="Aptos" pitchFamily="34" charset="0"/>
-                <a:ea typeface="Aptos" pitchFamily="34" charset="-122"/>
-                <a:cs typeface="Aptos" pitchFamily="34" charset="-120"/>
-              </a:rPr>
-              <a:t>Same retrieval contract on graduation - keep the qrels and metrics, swap the backend. Domain diagram: workshop-assets/rag-domain.svg; flow: docs/rag-retrieval-flow.md.</a:t>
-            </a:r>
-            <a:endParaRPr lang="en-US" sz="1000" dirty="0"/>
-          </a:p>
-        </p:txBody>
-      </p:sp>
-      <p:sp>
-        <p:nvSpPr>
-          <p:cNvPr id="25" name="Slide Number Placeholder 0"/>
-          <p:cNvSpPr>
-            <a:spLocks noGrp="1"/>
-          </p:cNvSpPr>
-          <p:nvPr>
-            <p:ph type="sldNum" sz="quarter" idx="4294967295"/>
-          </p:nvPr>
-        </p:nvSpPr>
-        <p:spPr>
-          <a:xfrm>
-            <a:off x="11475720" y="6565392"/>
-            <a:ext cx="800000" cy="300000"/>
-          </a:xfrm>
-          <a:prstGeom prst="rect">
-            <a:avLst/>
-          </a:prstGeom>
-          <a:extLst>
-            <a:ext uri="{C572A759-6A51-4108-AA02-DFA0A04FC94B}">
-              <ma14:wrappingTextBoxFlag xmlns:ma14="http://schemas.microsoft.com/office/mac/drawingml/2011/main" val="0"/>
-            </a:ext>
-          </a:extLst>
-        </p:spPr>
-        <p:txBody>
-          <a:bodyPr/>
-          <a:lstStyle>
-            <a:lvl1pPr>
-              <a:defRPr sz="700">
-                <a:solidFill>
-                  <a:srgbClr val="64748B"/>
-                </a:solidFill>
-                <a:latin typeface="Aptos"/>
-                <a:ea typeface="Aptos"/>
-                <a:cs typeface="Aptos"/>
-              </a:defRPr>
-            </a:lvl1pPr>
-          </a:lstStyle>
-          <a:p>
-            <a:pPr algn="l"/>
-            <a:fld id="{F7021451-1387-4CA6-816F-3879F97B5CBC}" type="slidenum">
-              <a:rPr b="0" lang="en-US"/>
-              <a:t>13</a:t>
-            </a:fld>
-            <a:endParaRPr lang="en-US"/>
-          </a:p>
-        </p:txBody>
-      </p:sp>
+      <p:pic>
+        <p:nvPicPr>
+          <p:cNvPr id="2" name="Image 0" descr="C:\Coding\governed-agents-workshop\workshop-assets\rag-domain-architecture.png">    </p:cNvPr>
+          <p:cNvPicPr>
+            <a:picLocks noChangeAspect="1"/>
+          </p:cNvPicPr>
+          <p:nvPr/>
+        </p:nvPicPr>
+        <p:blipFill>
+          <a:blip r:embed="rId1"/>
+          <a:stretch>
+            <a:fillRect/>
+          </a:stretch>
+        </p:blipFill>
+        <p:spPr>
+          <a:xfrm>
+            <a:off x="246888" y="137160"/>
+            <a:ext cx="11704320" cy="6583680"/>
+          </a:xfrm>
+          <a:prstGeom prst="rect">
+            <a:avLst/>
+          </a:prstGeom>
+        </p:spPr>
+      </p:pic>
     </p:spTree>
   </p:cSld>
   <p:clrMapOvr>

</xml_diff>

<commit_message>
Add timed-agenda/owners appendix slide (26) captured from the planning Loop
Native table: Day 1 + Day 2 sessions, owners, and core questions/outcomes as stated in the Loop.
Times left TBD except the fixed 1:45-2:00 closeout; appended as a reference slide so the 1-25
narrative and facilitator plan are unchanged.

Co-authored-by: Copilot <223556219+Copilot@users.noreply.github.com>
</commit_message>
<xml_diff>
--- a/workshop-assets/kaiser-consolidated-customer-deck.pptx
+++ b/workshop-assets/kaiser-consolidated-customer-deck.pptx
@@ -30,9 +30,10 @@
     <p:sldId id="278" r:id="rId24"/>
     <p:sldId id="279" r:id="rId25"/>
     <p:sldId id="280" r:id="rId26"/>
+    <p:sldId id="281" r:id="rId27"/>
   </p:sldIdLst>
   <p:notesMasterIdLst>
-    <p:notesMasterId r:id="rId27"/>
+    <p:notesMasterId r:id="rId28"/>
   </p:notesMasterIdLst>
   <p:sldSz cx="12192000" cy="6858000"/>
   <p:notesSz cx="6858000" cy="12192000"/>
@@ -2046,6 +2047,94 @@
             <a:fld id="{F7021451-1387-4CA6-816F-3879F97B5CBC}" type="slidenum">
               <a:rPr lang="en-US"/>
               <a:t>25</a:t>
+            </a:fld>
+            <a:endParaRPr lang="en-US"/>
+          </a:p>
+        </p:txBody>
+      </p:sp>
+    </p:spTree>
+    <p:extLst>
+      <p:ext uri="{BB962C8B-B14F-4D97-AF65-F5344CB8AC3E}">
+        <p14:creationId xmlns:p14="http://schemas.microsoft.com/office/powerpoint/2010/main" val="1024086991"/>
+      </p:ext>
+    </p:extLst>
+  </p:cSld>
+  <p:clrMapOvr>
+    <a:masterClrMapping/>
+  </p:clrMapOvr>
+</p:notes>
+</file>
+
+<file path=ppt/notesSlides/notesSlide26.xml><?xml version="1.0" encoding="utf-8"?>
+<p:notes xmlns:a="http://schemas.openxmlformats.org/drawingml/2006/main" xmlns:r="http://schemas.openxmlformats.org/officeDocument/2006/relationships" xmlns:p="http://schemas.openxmlformats.org/presentationml/2006/main">
+  <p:cSld>
+    <p:spTree>
+      <p:nvGrpSpPr>
+        <p:cNvPr id="1" name=""/>
+        <p:cNvGrpSpPr/>
+        <p:nvPr/>
+      </p:nvGrpSpPr>
+      <p:grpSpPr>
+        <a:xfrm>
+          <a:off x="0" y="0"/>
+          <a:ext cx="0" cy="0"/>
+          <a:chOff x="0" y="0"/>
+          <a:chExt cx="0" cy="0"/>
+        </a:xfrm>
+      </p:grpSpPr>
+      <p:sp>
+        <p:nvSpPr>
+          <p:cNvPr id="2" name="Slide Image Placeholder 1"/>
+          <p:cNvSpPr>
+            <a:spLocks noGrp="1" noRot="1" noChangeAspect="1"/>
+          </p:cNvSpPr>
+          <p:nvPr>
+            <p:ph type="sldImg"/>
+          </p:nvPr>
+        </p:nvSpPr>
+        <p:spPr/>
+      </p:sp>
+      <p:sp>
+        <p:nvSpPr>
+          <p:cNvPr id="3" name="Notes Placeholder 2"/>
+          <p:cNvSpPr>
+            <a:spLocks noGrp="1"/>
+          </p:cNvSpPr>
+          <p:nvPr>
+            <p:ph type="body" idx="1"/>
+          </p:nvPr>
+        </p:nvSpPr>
+        <p:spPr/>
+        <p:txBody>
+          <a:bodyPr/>
+          <a:lstStyle/>
+          <a:p>
+            <a:r>
+              <a:rPr lang="en-US" dirty="0"/>
+              <a:t>Reference / leave-behind agenda captured from the planning Loop. Owners as assigned; most session times are still being finalized (only the closeout 1:45-2:00 is fixed in the source). Note the Loop run sheet still lists BYO Registry hands-on, a product-team HA/observability call, and an SRE agent deep dive - reconcile with the 9/29 reordered narrative (these are tactical/futures in the customer deck).</a:t>
+            </a:r>
+            <a:endParaRPr lang="en-US" dirty="0"/>
+          </a:p>
+        </p:txBody>
+      </p:sp>
+      <p:sp>
+        <p:nvSpPr>
+          <p:cNvPr id="4" name="Slide Number Placeholder 3"/>
+          <p:cNvSpPr>
+            <a:spLocks noGrp="1"/>
+          </p:cNvSpPr>
+          <p:nvPr>
+            <p:ph type="sldNum" sz="quarter" idx="10"/>
+          </p:nvPr>
+        </p:nvSpPr>
+        <p:spPr/>
+        <p:txBody>
+          <a:bodyPr/>
+          <a:lstStyle/>
+          <a:p>
+            <a:fld id="{F7021451-1387-4CA6-816F-3879F97B5CBC}" type="slidenum">
+              <a:rPr lang="en-US"/>
+              <a:t>26</a:t>
             </a:fld>
             <a:endParaRPr lang="en-US"/>
           </a:p>
@@ -14050,6 +14139,3697 @@
               <a:t>Your priorities first</a:t>
             </a:r>
             <a:endParaRPr lang="en-US" sz="720" dirty="0"/>
+          </a:p>
+        </p:txBody>
+      </p:sp>
+    </p:spTree>
+  </p:cSld>
+  <p:clrMapOvr>
+    <a:masterClrMapping/>
+  </p:clrMapOvr>
+</p:sld>
+</file>
+
+<file path=ppt/slides/slide26.xml><?xml version="1.0" encoding="utf-8"?>
+<p:sld xmlns:a="http://schemas.openxmlformats.org/drawingml/2006/main" xmlns:r="http://schemas.openxmlformats.org/officeDocument/2006/relationships" xmlns:p="http://schemas.openxmlformats.org/presentationml/2006/main">
+  <p:cSld name="Slide 26">
+    <p:bg>
+      <p:bgPr>
+        <a:solidFill>
+          <a:srgbClr val="F8FAFC"/>
+        </a:solidFill>
+      </p:bgPr>
+    </p:bg>
+    <p:spTree>
+      <p:nvGrpSpPr>
+        <p:cNvPr id="1" name=""/>
+        <p:cNvGrpSpPr/>
+        <p:nvPr/>
+      </p:nvGrpSpPr>
+      <p:grpSpPr>
+        <a:xfrm>
+          <a:off x="0" y="0"/>
+          <a:ext cx="0" cy="0"/>
+          <a:chOff x="0" y="0"/>
+          <a:chExt cx="0" cy="0"/>
+        </a:xfrm>
+      </p:grpSpPr>
+      <p:sp>
+        <p:nvSpPr>
+          <p:cNvPr id="2" name="Text 0"/>
+          <p:cNvSpPr/>
+          <p:nvPr/>
+        </p:nvSpPr>
+        <p:spPr>
+          <a:xfrm>
+            <a:off x="457200" y="310896"/>
+            <a:ext cx="11247120" cy="201168"/>
+          </a:xfrm>
+          <a:prstGeom prst="rect">
+            <a:avLst/>
+          </a:prstGeom>
+          <a:noFill/>
+          <a:ln/>
+        </p:spPr>
+        <p:txBody>
+          <a:bodyPr wrap="square" lIns="0" tIns="0" rIns="0" bIns="0" rtlCol="0" anchor="ctr"/>
+          <a:lstStyle/>
+          <a:p>
+            <a:pPr indent="0" marL="0">
+              <a:buNone/>
+            </a:pPr>
+            <a:r>
+              <a:rPr lang="en-US" sz="800" b="1" dirty="0">
+                <a:solidFill>
+                  <a:srgbClr val="0F766E"/>
+                </a:solidFill>
+                <a:latin typeface="Aptos" pitchFamily="34" charset="0"/>
+                <a:ea typeface="Aptos" pitchFamily="34" charset="-122"/>
+                <a:cs typeface="Aptos" pitchFamily="34" charset="-120"/>
+              </a:rPr>
+              <a:t>WORKSHOP AGENDA &amp; OWNERS</a:t>
+            </a:r>
+            <a:endParaRPr lang="en-US" sz="800" dirty="0"/>
+          </a:p>
+        </p:txBody>
+      </p:sp>
+      <p:sp>
+        <p:nvSpPr>
+          <p:cNvPr id="3" name="Text 1"/>
+          <p:cNvSpPr/>
+          <p:nvPr/>
+        </p:nvSpPr>
+        <p:spPr>
+          <a:xfrm>
+            <a:off x="457200" y="548640"/>
+            <a:ext cx="11247120" cy="274320"/>
+          </a:xfrm>
+          <a:prstGeom prst="rect">
+            <a:avLst/>
+          </a:prstGeom>
+          <a:noFill/>
+          <a:ln/>
+        </p:spPr>
+        <p:txBody>
+          <a:bodyPr wrap="square" lIns="0" tIns="0" rIns="0" bIns="0" rtlCol="0" anchor="ctr">
+            <a:normAutofit/>
+          </a:bodyPr>
+          <a:lstStyle/>
+          <a:p>
+            <a:pPr indent="0" marL="0">
+              <a:buNone/>
+            </a:pPr>
+            <a:r>
+              <a:rPr lang="en-US" sz="1600" b="1" dirty="0">
+                <a:solidFill>
+                  <a:srgbClr val="0B1220"/>
+                </a:solidFill>
+                <a:latin typeface="Aptos Display" pitchFamily="34" charset="0"/>
+                <a:ea typeface="Aptos Display" pitchFamily="34" charset="-122"/>
+                <a:cs typeface="Aptos Display" pitchFamily="34" charset="-120"/>
+              </a:rPr>
+              <a:t>Two-day run sheet (from the planning Loop) - times being finalized; only closeout is fixed</a:t>
+            </a:r>
+            <a:endParaRPr lang="en-US" sz="1600" dirty="0"/>
+          </a:p>
+        </p:txBody>
+      </p:sp>
+      <p:graphicFrame>
+        <p:nvGraphicFramePr>
+          <p:cNvPr id="27" name="Table 0"/>
+          <p:cNvGraphicFramePr>
+            <a:graphicFrameLocks noGrp="1"/>
+          </p:cNvGraphicFramePr>
+          <p:nvPr>
+            <p:extLst>
+              <p:ext uri="{D42A27DB-BD31-4B8C-83A1-F6EECF244321}">
+                <p14:modId xmlns:p14="http://schemas.microsoft.com/office/powerpoint/2010/main" val="1579011935"/>
+              </p:ext>
+            </p:extLst>
+          </p:nvPr>
+        </p:nvGraphicFramePr>
+        <p:xfrm>
+          <a:off x="457200" y="960120"/>
+          <a:ext cx="11274552" cy="914400"/>
+        </p:xfrm>
+        <a:graphic>
+          <a:graphicData uri="http://schemas.openxmlformats.org/drawingml/2006/table">
+            <a:tbl>
+              <a:tblPr/>
+              <a:tblGrid>
+                <a:gridCol w="1234440"/>
+                <a:gridCol w="4114800"/>
+                <a:gridCol w="2423160"/>
+                <a:gridCol w="3502152"/>
+              </a:tblGrid>
+              <a:tr h="292608">
+                <a:tc>
+                  <a:txBody>
+                    <a:bodyPr/>
+                    <a:lstStyle/>
+                    <a:p>
+                      <a:pPr algn="l" indent="0" marL="0">
+                        <a:buNone/>
+                      </a:pPr>
+                      <a:r>
+                        <a:rPr lang="en-US" sz="900" b="1" dirty="0">
+                          <a:solidFill>
+                            <a:srgbClr val="FFFFFF"/>
+                          </a:solidFill>
+                          <a:latin typeface="Aptos" pitchFamily="34" charset="0"/>
+                          <a:ea typeface="Aptos" pitchFamily="34" charset="-122"/>
+                          <a:cs typeface="Aptos" pitchFamily="34" charset="-120"/>
+                        </a:rPr>
+                        <a:t>Time</a:t>
+                      </a:r>
+                      <a:endParaRPr lang="en-US" sz="900" dirty="0">
+                        <a:latin typeface="Aptos" charset="0"/>
+                        <a:ea typeface="Aptos" charset="0"/>
+                        <a:cs typeface="Aptos" charset="0"/>
+                      </a:endParaRPr>
+                    </a:p>
+                  </a:txBody>
+                  <a:tcPr marL="91440" marR="91440" marT="45720" marB="45720" anchor="ctr">
+                    <a:lnL w="6350" cap="flat" cmpd="sng" algn="ctr">
+                      <a:solidFill>
+                        <a:srgbClr val="E2E8F0"/>
+                      </a:solidFill>
+                      <a:prstDash val="solid"/>
+                      <a:round/>
+                      <a:headEnd type="none" w="med" len="med"/>
+                      <a:tailEnd type="none" w="med" len="med"/>
+                    </a:lnL>
+                    <a:lnR w="6350" cap="flat" cmpd="sng" algn="ctr">
+                      <a:solidFill>
+                        <a:srgbClr val="E2E8F0"/>
+                      </a:solidFill>
+                      <a:prstDash val="solid"/>
+                      <a:round/>
+                      <a:headEnd type="none" w="med" len="med"/>
+                      <a:tailEnd type="none" w="med" len="med"/>
+                    </a:lnR>
+                    <a:lnT w="6350" cap="flat" cmpd="sng" algn="ctr">
+                      <a:solidFill>
+                        <a:srgbClr val="E2E8F0"/>
+                      </a:solidFill>
+                      <a:prstDash val="solid"/>
+                      <a:round/>
+                      <a:headEnd type="none" w="med" len="med"/>
+                      <a:tailEnd type="none" w="med" len="med"/>
+                    </a:lnT>
+                    <a:lnB w="6350" cap="flat" cmpd="sng" algn="ctr">
+                      <a:solidFill>
+                        <a:srgbClr val="E2E8F0"/>
+                      </a:solidFill>
+                      <a:prstDash val="solid"/>
+                      <a:round/>
+                      <a:headEnd type="none" w="med" len="med"/>
+                      <a:tailEnd type="none" w="med" len="med"/>
+                    </a:lnB>
+                    <a:solidFill>
+                      <a:srgbClr val="0F766E"/>
+                    </a:solidFill>
+                  </a:tcPr>
+                </a:tc>
+                <a:tc>
+                  <a:txBody>
+                    <a:bodyPr/>
+                    <a:lstStyle/>
+                    <a:p>
+                      <a:pPr algn="l" indent="0" marL="0">
+                        <a:buNone/>
+                      </a:pPr>
+                      <a:r>
+                        <a:rPr lang="en-US" sz="900" b="1" dirty="0">
+                          <a:solidFill>
+                            <a:srgbClr val="FFFFFF"/>
+                          </a:solidFill>
+                          <a:latin typeface="Aptos" pitchFamily="34" charset="0"/>
+                          <a:ea typeface="Aptos" pitchFamily="34" charset="-122"/>
+                          <a:cs typeface="Aptos" pitchFamily="34" charset="-120"/>
+                        </a:rPr>
+                        <a:t>Session / Topic</a:t>
+                      </a:r>
+                      <a:endParaRPr lang="en-US" sz="900" dirty="0">
+                        <a:latin typeface="Aptos" charset="0"/>
+                        <a:ea typeface="Aptos" charset="0"/>
+                        <a:cs typeface="Aptos" charset="0"/>
+                      </a:endParaRPr>
+                    </a:p>
+                  </a:txBody>
+                  <a:tcPr marL="91440" marR="91440" marT="45720" marB="45720" anchor="ctr">
+                    <a:lnL w="6350" cap="flat" cmpd="sng" algn="ctr">
+                      <a:solidFill>
+                        <a:srgbClr val="E2E8F0"/>
+                      </a:solidFill>
+                      <a:prstDash val="solid"/>
+                      <a:round/>
+                      <a:headEnd type="none" w="med" len="med"/>
+                      <a:tailEnd type="none" w="med" len="med"/>
+                    </a:lnL>
+                    <a:lnR w="6350" cap="flat" cmpd="sng" algn="ctr">
+                      <a:solidFill>
+                        <a:srgbClr val="E2E8F0"/>
+                      </a:solidFill>
+                      <a:prstDash val="solid"/>
+                      <a:round/>
+                      <a:headEnd type="none" w="med" len="med"/>
+                      <a:tailEnd type="none" w="med" len="med"/>
+                    </a:lnR>
+                    <a:lnT w="6350" cap="flat" cmpd="sng" algn="ctr">
+                      <a:solidFill>
+                        <a:srgbClr val="E2E8F0"/>
+                      </a:solidFill>
+                      <a:prstDash val="solid"/>
+                      <a:round/>
+                      <a:headEnd type="none" w="med" len="med"/>
+                      <a:tailEnd type="none" w="med" len="med"/>
+                    </a:lnT>
+                    <a:lnB w="6350" cap="flat" cmpd="sng" algn="ctr">
+                      <a:solidFill>
+                        <a:srgbClr val="E2E8F0"/>
+                      </a:solidFill>
+                      <a:prstDash val="solid"/>
+                      <a:round/>
+                      <a:headEnd type="none" w="med" len="med"/>
+                      <a:tailEnd type="none" w="med" len="med"/>
+                    </a:lnB>
+                    <a:solidFill>
+                      <a:srgbClr val="0F766E"/>
+                    </a:solidFill>
+                  </a:tcPr>
+                </a:tc>
+                <a:tc>
+                  <a:txBody>
+                    <a:bodyPr/>
+                    <a:lstStyle/>
+                    <a:p>
+                      <a:pPr algn="l" indent="0" marL="0">
+                        <a:buNone/>
+                      </a:pPr>
+                      <a:r>
+                        <a:rPr lang="en-US" sz="900" b="1" dirty="0">
+                          <a:solidFill>
+                            <a:srgbClr val="FFFFFF"/>
+                          </a:solidFill>
+                          <a:latin typeface="Aptos" pitchFamily="34" charset="0"/>
+                          <a:ea typeface="Aptos" pitchFamily="34" charset="-122"/>
+                          <a:cs typeface="Aptos" pitchFamily="34" charset="-120"/>
+                        </a:rPr>
+                        <a:t>Owner</a:t>
+                      </a:r>
+                      <a:endParaRPr lang="en-US" sz="900" dirty="0">
+                        <a:latin typeface="Aptos" charset="0"/>
+                        <a:ea typeface="Aptos" charset="0"/>
+                        <a:cs typeface="Aptos" charset="0"/>
+                      </a:endParaRPr>
+                    </a:p>
+                  </a:txBody>
+                  <a:tcPr marL="91440" marR="91440" marT="45720" marB="45720" anchor="ctr">
+                    <a:lnL w="6350" cap="flat" cmpd="sng" algn="ctr">
+                      <a:solidFill>
+                        <a:srgbClr val="E2E8F0"/>
+                      </a:solidFill>
+                      <a:prstDash val="solid"/>
+                      <a:round/>
+                      <a:headEnd type="none" w="med" len="med"/>
+                      <a:tailEnd type="none" w="med" len="med"/>
+                    </a:lnL>
+                    <a:lnR w="6350" cap="flat" cmpd="sng" algn="ctr">
+                      <a:solidFill>
+                        <a:srgbClr val="E2E8F0"/>
+                      </a:solidFill>
+                      <a:prstDash val="solid"/>
+                      <a:round/>
+                      <a:headEnd type="none" w="med" len="med"/>
+                      <a:tailEnd type="none" w="med" len="med"/>
+                    </a:lnR>
+                    <a:lnT w="6350" cap="flat" cmpd="sng" algn="ctr">
+                      <a:solidFill>
+                        <a:srgbClr val="E2E8F0"/>
+                      </a:solidFill>
+                      <a:prstDash val="solid"/>
+                      <a:round/>
+                      <a:headEnd type="none" w="med" len="med"/>
+                      <a:tailEnd type="none" w="med" len="med"/>
+                    </a:lnT>
+                    <a:lnB w="6350" cap="flat" cmpd="sng" algn="ctr">
+                      <a:solidFill>
+                        <a:srgbClr val="E2E8F0"/>
+                      </a:solidFill>
+                      <a:prstDash val="solid"/>
+                      <a:round/>
+                      <a:headEnd type="none" w="med" len="med"/>
+                      <a:tailEnd type="none" w="med" len="med"/>
+                    </a:lnB>
+                    <a:solidFill>
+                      <a:srgbClr val="0F766E"/>
+                    </a:solidFill>
+                  </a:tcPr>
+                </a:tc>
+                <a:tc>
+                  <a:txBody>
+                    <a:bodyPr/>
+                    <a:lstStyle/>
+                    <a:p>
+                      <a:pPr algn="l" indent="0" marL="0">
+                        <a:buNone/>
+                      </a:pPr>
+                      <a:r>
+                        <a:rPr lang="en-US" sz="900" b="1" dirty="0">
+                          <a:solidFill>
+                            <a:srgbClr val="FFFFFF"/>
+                          </a:solidFill>
+                          <a:latin typeface="Aptos" pitchFamily="34" charset="0"/>
+                          <a:ea typeface="Aptos" pitchFamily="34" charset="-122"/>
+                          <a:cs typeface="Aptos" pitchFamily="34" charset="-120"/>
+                        </a:rPr>
+                        <a:t>Core questions / outcome</a:t>
+                      </a:r>
+                      <a:endParaRPr lang="en-US" sz="900" dirty="0">
+                        <a:latin typeface="Aptos" charset="0"/>
+                        <a:ea typeface="Aptos" charset="0"/>
+                        <a:cs typeface="Aptos" charset="0"/>
+                      </a:endParaRPr>
+                    </a:p>
+                  </a:txBody>
+                  <a:tcPr marL="91440" marR="91440" marT="45720" marB="45720" anchor="ctr">
+                    <a:lnL w="6350" cap="flat" cmpd="sng" algn="ctr">
+                      <a:solidFill>
+                        <a:srgbClr val="E2E8F0"/>
+                      </a:solidFill>
+                      <a:prstDash val="solid"/>
+                      <a:round/>
+                      <a:headEnd type="none" w="med" len="med"/>
+                      <a:tailEnd type="none" w="med" len="med"/>
+                    </a:lnL>
+                    <a:lnR w="6350" cap="flat" cmpd="sng" algn="ctr">
+                      <a:solidFill>
+                        <a:srgbClr val="E2E8F0"/>
+                      </a:solidFill>
+                      <a:prstDash val="solid"/>
+                      <a:round/>
+                      <a:headEnd type="none" w="med" len="med"/>
+                      <a:tailEnd type="none" w="med" len="med"/>
+                    </a:lnR>
+                    <a:lnT w="6350" cap="flat" cmpd="sng" algn="ctr">
+                      <a:solidFill>
+                        <a:srgbClr val="E2E8F0"/>
+                      </a:solidFill>
+                      <a:prstDash val="solid"/>
+                      <a:round/>
+                      <a:headEnd type="none" w="med" len="med"/>
+                      <a:tailEnd type="none" w="med" len="med"/>
+                    </a:lnT>
+                    <a:lnB w="6350" cap="flat" cmpd="sng" algn="ctr">
+                      <a:solidFill>
+                        <a:srgbClr val="E2E8F0"/>
+                      </a:solidFill>
+                      <a:prstDash val="solid"/>
+                      <a:round/>
+                      <a:headEnd type="none" w="med" len="med"/>
+                      <a:tailEnd type="none" w="med" len="med"/>
+                    </a:lnB>
+                    <a:solidFill>
+                      <a:srgbClr val="0F766E"/>
+                    </a:solidFill>
+                  </a:tcPr>
+                </a:tc>
+              </a:tr>
+              <a:tr h="292608">
+                <a:tc gridSpan="4">
+                  <a:txBody>
+                    <a:bodyPr/>
+                    <a:lstStyle/>
+                    <a:p>
+                      <a:pPr algn="l" indent="0" marL="0">
+                        <a:buNone/>
+                      </a:pPr>
+                      <a:r>
+                        <a:rPr lang="en-US" sz="950" b="1" dirty="0">
+                          <a:solidFill>
+                            <a:srgbClr val="FFFFFF"/>
+                          </a:solidFill>
+                          <a:latin typeface="Aptos" pitchFamily="34" charset="0"/>
+                          <a:ea typeface="Aptos" pitchFamily="34" charset="-122"/>
+                          <a:cs typeface="Aptos" pitchFamily="34" charset="-120"/>
+                        </a:rPr>
+                        <a:t>DAY 1</a:t>
+                      </a:r>
+                      <a:endParaRPr lang="en-US" sz="950" dirty="0">
+                        <a:latin typeface="Aptos" charset="0"/>
+                        <a:ea typeface="Aptos" charset="0"/>
+                        <a:cs typeface="Aptos" charset="0"/>
+                      </a:endParaRPr>
+                    </a:p>
+                  </a:txBody>
+                  <a:tcPr marL="91440" marR="91440" marT="45720" marB="45720" anchor="ctr">
+                    <a:lnL w="6350" cap="flat" cmpd="sng" algn="ctr">
+                      <a:solidFill>
+                        <a:srgbClr val="E2E8F0"/>
+                      </a:solidFill>
+                      <a:prstDash val="solid"/>
+                      <a:round/>
+                      <a:headEnd type="none" w="med" len="med"/>
+                      <a:tailEnd type="none" w="med" len="med"/>
+                    </a:lnL>
+                    <a:lnR w="6350" cap="flat" cmpd="sng" algn="ctr">
+                      <a:solidFill>
+                        <a:srgbClr val="E2E8F0"/>
+                      </a:solidFill>
+                      <a:prstDash val="solid"/>
+                      <a:round/>
+                      <a:headEnd type="none" w="med" len="med"/>
+                      <a:tailEnd type="none" w="med" len="med"/>
+                    </a:lnR>
+                    <a:lnT w="6350" cap="flat" cmpd="sng" algn="ctr">
+                      <a:solidFill>
+                        <a:srgbClr val="E2E8F0"/>
+                      </a:solidFill>
+                      <a:prstDash val="solid"/>
+                      <a:round/>
+                      <a:headEnd type="none" w="med" len="med"/>
+                      <a:tailEnd type="none" w="med" len="med"/>
+                    </a:lnT>
+                    <a:lnB w="6350" cap="flat" cmpd="sng" algn="ctr">
+                      <a:solidFill>
+                        <a:srgbClr val="E2E8F0"/>
+                      </a:solidFill>
+                      <a:prstDash val="solid"/>
+                      <a:round/>
+                      <a:headEnd type="none" w="med" len="med"/>
+                      <a:tailEnd type="none" w="med" len="med"/>
+                    </a:lnB>
+                    <a:solidFill>
+                      <a:srgbClr val="0B1220"/>
+                    </a:solidFill>
+                  </a:tcPr>
+                </a:tc>
+                <a:tc hMerge="1">
+                  <a:tcPr/>
+                </a:tc>
+                <a:tc hMerge="1">
+                  <a:tcPr/>
+                </a:tc>
+                <a:tc hMerge="1">
+                  <a:tcPr/>
+                </a:tc>
+              </a:tr>
+              <a:tr h="292608">
+                <a:tc>
+                  <a:txBody>
+                    <a:bodyPr/>
+                    <a:lstStyle/>
+                    <a:p>
+                      <a:pPr algn="l" indent="0" marL="0">
+                        <a:buNone/>
+                      </a:pPr>
+                      <a:r>
+                        <a:rPr lang="en-US" sz="850" dirty="0">
+                          <a:solidFill>
+                            <a:srgbClr val="334155"/>
+                          </a:solidFill>
+                          <a:latin typeface="Aptos" pitchFamily="34" charset="0"/>
+                          <a:ea typeface="Aptos" pitchFamily="34" charset="-122"/>
+                          <a:cs typeface="Aptos" pitchFamily="34" charset="-120"/>
+                        </a:rPr>
+                        <a:t>TBD</a:t>
+                      </a:r>
+                      <a:endParaRPr lang="en-US" sz="850" dirty="0">
+                        <a:latin typeface="Aptos" charset="0"/>
+                        <a:ea typeface="Aptos" charset="0"/>
+                        <a:cs typeface="Aptos" charset="0"/>
+                      </a:endParaRPr>
+                    </a:p>
+                  </a:txBody>
+                  <a:tcPr marL="91440" marR="91440" marT="45720" marB="45720" anchor="ctr">
+                    <a:lnL w="6350" cap="flat" cmpd="sng" algn="ctr">
+                      <a:solidFill>
+                        <a:srgbClr val="E2E8F0"/>
+                      </a:solidFill>
+                      <a:prstDash val="solid"/>
+                      <a:round/>
+                      <a:headEnd type="none" w="med" len="med"/>
+                      <a:tailEnd type="none" w="med" len="med"/>
+                    </a:lnL>
+                    <a:lnR w="6350" cap="flat" cmpd="sng" algn="ctr">
+                      <a:solidFill>
+                        <a:srgbClr val="E2E8F0"/>
+                      </a:solidFill>
+                      <a:prstDash val="solid"/>
+                      <a:round/>
+                      <a:headEnd type="none" w="med" len="med"/>
+                      <a:tailEnd type="none" w="med" len="med"/>
+                    </a:lnR>
+                    <a:lnT w="6350" cap="flat" cmpd="sng" algn="ctr">
+                      <a:solidFill>
+                        <a:srgbClr val="E2E8F0"/>
+                      </a:solidFill>
+                      <a:prstDash val="solid"/>
+                      <a:round/>
+                      <a:headEnd type="none" w="med" len="med"/>
+                      <a:tailEnd type="none" w="med" len="med"/>
+                    </a:lnT>
+                    <a:lnB w="6350" cap="flat" cmpd="sng" algn="ctr">
+                      <a:solidFill>
+                        <a:srgbClr val="E2E8F0"/>
+                      </a:solidFill>
+                      <a:prstDash val="solid"/>
+                      <a:round/>
+                      <a:headEnd type="none" w="med" len="med"/>
+                      <a:tailEnd type="none" w="med" len="med"/>
+                    </a:lnB>
+                  </a:tcPr>
+                </a:tc>
+                <a:tc>
+                  <a:txBody>
+                    <a:bodyPr/>
+                    <a:lstStyle/>
+                    <a:p>
+                      <a:pPr algn="l" indent="0" marL="0">
+                        <a:buNone/>
+                      </a:pPr>
+                      <a:r>
+                        <a:rPr lang="en-US" sz="850" b="1" dirty="0">
+                          <a:solidFill>
+                            <a:srgbClr val="0B1220"/>
+                          </a:solidFill>
+                          <a:latin typeface="Aptos" pitchFamily="34" charset="0"/>
+                          <a:ea typeface="Aptos" pitchFamily="34" charset="-122"/>
+                          <a:cs typeface="Aptos" pitchFamily="34" charset="-120"/>
+                        </a:rPr>
+                        <a:t>Overview - MCP Server, Work IQ, Toolbox</a:t>
+                      </a:r>
+                      <a:endParaRPr lang="en-US" sz="850" dirty="0">
+                        <a:latin typeface="Aptos" charset="0"/>
+                        <a:ea typeface="Aptos" charset="0"/>
+                        <a:cs typeface="Aptos" charset="0"/>
+                      </a:endParaRPr>
+                    </a:p>
+                  </a:txBody>
+                  <a:tcPr marL="91440" marR="91440" marT="45720" marB="45720" anchor="ctr">
+                    <a:lnL w="6350" cap="flat" cmpd="sng" algn="ctr">
+                      <a:solidFill>
+                        <a:srgbClr val="E2E8F0"/>
+                      </a:solidFill>
+                      <a:prstDash val="solid"/>
+                      <a:round/>
+                      <a:headEnd type="none" w="med" len="med"/>
+                      <a:tailEnd type="none" w="med" len="med"/>
+                    </a:lnL>
+                    <a:lnR w="6350" cap="flat" cmpd="sng" algn="ctr">
+                      <a:solidFill>
+                        <a:srgbClr val="E2E8F0"/>
+                      </a:solidFill>
+                      <a:prstDash val="solid"/>
+                      <a:round/>
+                      <a:headEnd type="none" w="med" len="med"/>
+                      <a:tailEnd type="none" w="med" len="med"/>
+                    </a:lnR>
+                    <a:lnT w="6350" cap="flat" cmpd="sng" algn="ctr">
+                      <a:solidFill>
+                        <a:srgbClr val="E2E8F0"/>
+                      </a:solidFill>
+                      <a:prstDash val="solid"/>
+                      <a:round/>
+                      <a:headEnd type="none" w="med" len="med"/>
+                      <a:tailEnd type="none" w="med" len="med"/>
+                    </a:lnT>
+                    <a:lnB w="6350" cap="flat" cmpd="sng" algn="ctr">
+                      <a:solidFill>
+                        <a:srgbClr val="E2E8F0"/>
+                      </a:solidFill>
+                      <a:prstDash val="solid"/>
+                      <a:round/>
+                      <a:headEnd type="none" w="med" len="med"/>
+                      <a:tailEnd type="none" w="med" len="med"/>
+                    </a:lnB>
+                  </a:tcPr>
+                </a:tc>
+                <a:tc>
+                  <a:txBody>
+                    <a:bodyPr/>
+                    <a:lstStyle/>
+                    <a:p>
+                      <a:pPr algn="l" indent="0" marL="0">
+                        <a:buNone/>
+                      </a:pPr>
+                      <a:r>
+                        <a:rPr lang="en-US" sz="850" dirty="0">
+                          <a:solidFill>
+                            <a:srgbClr val="334155"/>
+                          </a:solidFill>
+                          <a:latin typeface="Aptos" pitchFamily="34" charset="0"/>
+                          <a:ea typeface="Aptos" pitchFamily="34" charset="-122"/>
+                          <a:cs typeface="Aptos" pitchFamily="34" charset="-120"/>
+                        </a:rPr>
+                        <a:t>David Barkol</a:t>
+                      </a:r>
+                      <a:endParaRPr lang="en-US" sz="850" dirty="0">
+                        <a:latin typeface="Aptos" charset="0"/>
+                        <a:ea typeface="Aptos" charset="0"/>
+                        <a:cs typeface="Aptos" charset="0"/>
+                      </a:endParaRPr>
+                    </a:p>
+                  </a:txBody>
+                  <a:tcPr marL="91440" marR="91440" marT="45720" marB="45720" anchor="ctr">
+                    <a:lnL w="6350" cap="flat" cmpd="sng" algn="ctr">
+                      <a:solidFill>
+                        <a:srgbClr val="E2E8F0"/>
+                      </a:solidFill>
+                      <a:prstDash val="solid"/>
+                      <a:round/>
+                      <a:headEnd type="none" w="med" len="med"/>
+                      <a:tailEnd type="none" w="med" len="med"/>
+                    </a:lnL>
+                    <a:lnR w="6350" cap="flat" cmpd="sng" algn="ctr">
+                      <a:solidFill>
+                        <a:srgbClr val="E2E8F0"/>
+                      </a:solidFill>
+                      <a:prstDash val="solid"/>
+                      <a:round/>
+                      <a:headEnd type="none" w="med" len="med"/>
+                      <a:tailEnd type="none" w="med" len="med"/>
+                    </a:lnR>
+                    <a:lnT w="6350" cap="flat" cmpd="sng" algn="ctr">
+                      <a:solidFill>
+                        <a:srgbClr val="E2E8F0"/>
+                      </a:solidFill>
+                      <a:prstDash val="solid"/>
+                      <a:round/>
+                      <a:headEnd type="none" w="med" len="med"/>
+                      <a:tailEnd type="none" w="med" len="med"/>
+                    </a:lnT>
+                    <a:lnB w="6350" cap="flat" cmpd="sng" algn="ctr">
+                      <a:solidFill>
+                        <a:srgbClr val="E2E8F0"/>
+                      </a:solidFill>
+                      <a:prstDash val="solid"/>
+                      <a:round/>
+                      <a:headEnd type="none" w="med" len="med"/>
+                      <a:tailEnd type="none" w="med" len="med"/>
+                    </a:lnB>
+                  </a:tcPr>
+                </a:tc>
+                <a:tc>
+                  <a:txBody>
+                    <a:bodyPr/>
+                    <a:lstStyle/>
+                    <a:p>
+                      <a:pPr algn="l" indent="0" marL="0">
+                        <a:buNone/>
+                      </a:pPr>
+                      <a:r>
+                        <a:rPr lang="en-US" sz="800" dirty="0">
+                          <a:solidFill>
+                            <a:srgbClr val="64748B"/>
+                          </a:solidFill>
+                          <a:latin typeface="Aptos" pitchFamily="34" charset="0"/>
+                          <a:ea typeface="Aptos" pitchFamily="34" charset="-122"/>
+                          <a:cs typeface="Aptos" pitchFamily="34" charset="-120"/>
+                        </a:rPr>
+                        <a:t>Tool boundary + scope model; secure MCP server; operationalize</a:t>
+                      </a:r>
+                      <a:endParaRPr lang="en-US" sz="800" dirty="0">
+                        <a:latin typeface="Aptos" charset="0"/>
+                        <a:ea typeface="Aptos" charset="0"/>
+                        <a:cs typeface="Aptos" charset="0"/>
+                      </a:endParaRPr>
+                    </a:p>
+                  </a:txBody>
+                  <a:tcPr marL="91440" marR="91440" marT="45720" marB="45720" anchor="ctr">
+                    <a:lnL w="6350" cap="flat" cmpd="sng" algn="ctr">
+                      <a:solidFill>
+                        <a:srgbClr val="E2E8F0"/>
+                      </a:solidFill>
+                      <a:prstDash val="solid"/>
+                      <a:round/>
+                      <a:headEnd type="none" w="med" len="med"/>
+                      <a:tailEnd type="none" w="med" len="med"/>
+                    </a:lnL>
+                    <a:lnR w="6350" cap="flat" cmpd="sng" algn="ctr">
+                      <a:solidFill>
+                        <a:srgbClr val="E2E8F0"/>
+                      </a:solidFill>
+                      <a:prstDash val="solid"/>
+                      <a:round/>
+                      <a:headEnd type="none" w="med" len="med"/>
+                      <a:tailEnd type="none" w="med" len="med"/>
+                    </a:lnR>
+                    <a:lnT w="6350" cap="flat" cmpd="sng" algn="ctr">
+                      <a:solidFill>
+                        <a:srgbClr val="E2E8F0"/>
+                      </a:solidFill>
+                      <a:prstDash val="solid"/>
+                      <a:round/>
+                      <a:headEnd type="none" w="med" len="med"/>
+                      <a:tailEnd type="none" w="med" len="med"/>
+                    </a:lnT>
+                    <a:lnB w="6350" cap="flat" cmpd="sng" algn="ctr">
+                      <a:solidFill>
+                        <a:srgbClr val="E2E8F0"/>
+                      </a:solidFill>
+                      <a:prstDash val="solid"/>
+                      <a:round/>
+                      <a:headEnd type="none" w="med" len="med"/>
+                      <a:tailEnd type="none" w="med" len="med"/>
+                    </a:lnB>
+                  </a:tcPr>
+                </a:tc>
+              </a:tr>
+              <a:tr h="292608">
+                <a:tc>
+                  <a:txBody>
+                    <a:bodyPr/>
+                    <a:lstStyle/>
+                    <a:p>
+                      <a:pPr algn="l" indent="0" marL="0">
+                        <a:buNone/>
+                      </a:pPr>
+                      <a:r>
+                        <a:rPr lang="en-US" sz="850" dirty="0">
+                          <a:solidFill>
+                            <a:srgbClr val="334155"/>
+                          </a:solidFill>
+                          <a:latin typeface="Aptos" pitchFamily="34" charset="0"/>
+                          <a:ea typeface="Aptos" pitchFamily="34" charset="-122"/>
+                          <a:cs typeface="Aptos" pitchFamily="34" charset="-120"/>
+                        </a:rPr>
+                        <a:t>TBD</a:t>
+                      </a:r>
+                      <a:endParaRPr lang="en-US" sz="850" dirty="0">
+                        <a:latin typeface="Aptos" charset="0"/>
+                        <a:ea typeface="Aptos" charset="0"/>
+                        <a:cs typeface="Aptos" charset="0"/>
+                      </a:endParaRPr>
+                    </a:p>
+                  </a:txBody>
+                  <a:tcPr marL="91440" marR="91440" marT="45720" marB="45720" anchor="ctr">
+                    <a:lnL w="6350" cap="flat" cmpd="sng" algn="ctr">
+                      <a:solidFill>
+                        <a:srgbClr val="E2E8F0"/>
+                      </a:solidFill>
+                      <a:prstDash val="solid"/>
+                      <a:round/>
+                      <a:headEnd type="none" w="med" len="med"/>
+                      <a:tailEnd type="none" w="med" len="med"/>
+                    </a:lnL>
+                    <a:lnR w="6350" cap="flat" cmpd="sng" algn="ctr">
+                      <a:solidFill>
+                        <a:srgbClr val="E2E8F0"/>
+                      </a:solidFill>
+                      <a:prstDash val="solid"/>
+                      <a:round/>
+                      <a:headEnd type="none" w="med" len="med"/>
+                      <a:tailEnd type="none" w="med" len="med"/>
+                    </a:lnR>
+                    <a:lnT w="6350" cap="flat" cmpd="sng" algn="ctr">
+                      <a:solidFill>
+                        <a:srgbClr val="E2E8F0"/>
+                      </a:solidFill>
+                      <a:prstDash val="solid"/>
+                      <a:round/>
+                      <a:headEnd type="none" w="med" len="med"/>
+                      <a:tailEnd type="none" w="med" len="med"/>
+                    </a:lnT>
+                    <a:lnB w="6350" cap="flat" cmpd="sng" algn="ctr">
+                      <a:solidFill>
+                        <a:srgbClr val="E2E8F0"/>
+                      </a:solidFill>
+                      <a:prstDash val="solid"/>
+                      <a:round/>
+                      <a:headEnd type="none" w="med" len="med"/>
+                      <a:tailEnd type="none" w="med" len="med"/>
+                    </a:lnB>
+                  </a:tcPr>
+                </a:tc>
+                <a:tc>
+                  <a:txBody>
+                    <a:bodyPr/>
+                    <a:lstStyle/>
+                    <a:p>
+                      <a:pPr algn="l" indent="0" marL="0">
+                        <a:buNone/>
+                      </a:pPr>
+                      <a:r>
+                        <a:rPr lang="en-US" sz="850" b="1" dirty="0">
+                          <a:solidFill>
+                            <a:srgbClr val="0B1220"/>
+                          </a:solidFill>
+                          <a:latin typeface="Aptos" pitchFamily="34" charset="0"/>
+                          <a:ea typeface="Aptos" pitchFamily="34" charset="-122"/>
+                          <a:cs typeface="Aptos" pitchFamily="34" charset="-120"/>
+                        </a:rPr>
+                        <a:t>Demo - MCP Server, Work IQ, Toolbox</a:t>
+                      </a:r>
+                      <a:endParaRPr lang="en-US" sz="850" dirty="0">
+                        <a:latin typeface="Aptos" charset="0"/>
+                        <a:ea typeface="Aptos" charset="0"/>
+                        <a:cs typeface="Aptos" charset="0"/>
+                      </a:endParaRPr>
+                    </a:p>
+                  </a:txBody>
+                  <a:tcPr marL="91440" marR="91440" marT="45720" marB="45720" anchor="ctr">
+                    <a:lnL w="6350" cap="flat" cmpd="sng" algn="ctr">
+                      <a:solidFill>
+                        <a:srgbClr val="E2E8F0"/>
+                      </a:solidFill>
+                      <a:prstDash val="solid"/>
+                      <a:round/>
+                      <a:headEnd type="none" w="med" len="med"/>
+                      <a:tailEnd type="none" w="med" len="med"/>
+                    </a:lnL>
+                    <a:lnR w="6350" cap="flat" cmpd="sng" algn="ctr">
+                      <a:solidFill>
+                        <a:srgbClr val="E2E8F0"/>
+                      </a:solidFill>
+                      <a:prstDash val="solid"/>
+                      <a:round/>
+                      <a:headEnd type="none" w="med" len="med"/>
+                      <a:tailEnd type="none" w="med" len="med"/>
+                    </a:lnR>
+                    <a:lnT w="6350" cap="flat" cmpd="sng" algn="ctr">
+                      <a:solidFill>
+                        <a:srgbClr val="E2E8F0"/>
+                      </a:solidFill>
+                      <a:prstDash val="solid"/>
+                      <a:round/>
+                      <a:headEnd type="none" w="med" len="med"/>
+                      <a:tailEnd type="none" w="med" len="med"/>
+                    </a:lnT>
+                    <a:lnB w="6350" cap="flat" cmpd="sng" algn="ctr">
+                      <a:solidFill>
+                        <a:srgbClr val="E2E8F0"/>
+                      </a:solidFill>
+                      <a:prstDash val="solid"/>
+                      <a:round/>
+                      <a:headEnd type="none" w="med" len="med"/>
+                      <a:tailEnd type="none" w="med" len="med"/>
+                    </a:lnB>
+                  </a:tcPr>
+                </a:tc>
+                <a:tc>
+                  <a:txBody>
+                    <a:bodyPr/>
+                    <a:lstStyle/>
+                    <a:p>
+                      <a:pPr algn="l" indent="0" marL="0">
+                        <a:buNone/>
+                      </a:pPr>
+                      <a:r>
+                        <a:rPr lang="en-US" sz="850" dirty="0">
+                          <a:solidFill>
+                            <a:srgbClr val="334155"/>
+                          </a:solidFill>
+                          <a:latin typeface="Aptos" pitchFamily="34" charset="0"/>
+                          <a:ea typeface="Aptos" pitchFamily="34" charset="-122"/>
+                          <a:cs typeface="Aptos" pitchFamily="34" charset="-120"/>
+                        </a:rPr>
+                        <a:t>Chris Lekkas</a:t>
+                      </a:r>
+                      <a:endParaRPr lang="en-US" sz="850" dirty="0">
+                        <a:latin typeface="Aptos" charset="0"/>
+                        <a:ea typeface="Aptos" charset="0"/>
+                        <a:cs typeface="Aptos" charset="0"/>
+                      </a:endParaRPr>
+                    </a:p>
+                  </a:txBody>
+                  <a:tcPr marL="91440" marR="91440" marT="45720" marB="45720" anchor="ctr">
+                    <a:lnL w="6350" cap="flat" cmpd="sng" algn="ctr">
+                      <a:solidFill>
+                        <a:srgbClr val="E2E8F0"/>
+                      </a:solidFill>
+                      <a:prstDash val="solid"/>
+                      <a:round/>
+                      <a:headEnd type="none" w="med" len="med"/>
+                      <a:tailEnd type="none" w="med" len="med"/>
+                    </a:lnL>
+                    <a:lnR w="6350" cap="flat" cmpd="sng" algn="ctr">
+                      <a:solidFill>
+                        <a:srgbClr val="E2E8F0"/>
+                      </a:solidFill>
+                      <a:prstDash val="solid"/>
+                      <a:round/>
+                      <a:headEnd type="none" w="med" len="med"/>
+                      <a:tailEnd type="none" w="med" len="med"/>
+                    </a:lnR>
+                    <a:lnT w="6350" cap="flat" cmpd="sng" algn="ctr">
+                      <a:solidFill>
+                        <a:srgbClr val="E2E8F0"/>
+                      </a:solidFill>
+                      <a:prstDash val="solid"/>
+                      <a:round/>
+                      <a:headEnd type="none" w="med" len="med"/>
+                      <a:tailEnd type="none" w="med" len="med"/>
+                    </a:lnT>
+                    <a:lnB w="6350" cap="flat" cmpd="sng" algn="ctr">
+                      <a:solidFill>
+                        <a:srgbClr val="E2E8F0"/>
+                      </a:solidFill>
+                      <a:prstDash val="solid"/>
+                      <a:round/>
+                      <a:headEnd type="none" w="med" len="med"/>
+                      <a:tailEnd type="none" w="med" len="med"/>
+                    </a:lnB>
+                  </a:tcPr>
+                </a:tc>
+                <a:tc>
+                  <a:txBody>
+                    <a:bodyPr/>
+                    <a:lstStyle/>
+                    <a:p>
+                      <a:pPr algn="l" indent="0" marL="0">
+                        <a:buNone/>
+                      </a:pPr>
+                      <a:endParaRPr lang="en-US" sz="800" dirty="0">
+                        <a:latin typeface="Aptos" charset="0"/>
+                        <a:ea typeface="Aptos" charset="0"/>
+                        <a:cs typeface="Aptos" charset="0"/>
+                      </a:endParaRPr>
+                    </a:p>
+                  </a:txBody>
+                  <a:tcPr marL="91440" marR="91440" marT="45720" marB="45720" anchor="ctr">
+                    <a:lnL w="6350" cap="flat" cmpd="sng" algn="ctr">
+                      <a:solidFill>
+                        <a:srgbClr val="E2E8F0"/>
+                      </a:solidFill>
+                      <a:prstDash val="solid"/>
+                      <a:round/>
+                      <a:headEnd type="none" w="med" len="med"/>
+                      <a:tailEnd type="none" w="med" len="med"/>
+                    </a:lnL>
+                    <a:lnR w="6350" cap="flat" cmpd="sng" algn="ctr">
+                      <a:solidFill>
+                        <a:srgbClr val="E2E8F0"/>
+                      </a:solidFill>
+                      <a:prstDash val="solid"/>
+                      <a:round/>
+                      <a:headEnd type="none" w="med" len="med"/>
+                      <a:tailEnd type="none" w="med" len="med"/>
+                    </a:lnR>
+                    <a:lnT w="6350" cap="flat" cmpd="sng" algn="ctr">
+                      <a:solidFill>
+                        <a:srgbClr val="E2E8F0"/>
+                      </a:solidFill>
+                      <a:prstDash val="solid"/>
+                      <a:round/>
+                      <a:headEnd type="none" w="med" len="med"/>
+                      <a:tailEnd type="none" w="med" len="med"/>
+                    </a:lnT>
+                    <a:lnB w="6350" cap="flat" cmpd="sng" algn="ctr">
+                      <a:solidFill>
+                        <a:srgbClr val="E2E8F0"/>
+                      </a:solidFill>
+                      <a:prstDash val="solid"/>
+                      <a:round/>
+                      <a:headEnd type="none" w="med" len="med"/>
+                      <a:tailEnd type="none" w="med" len="med"/>
+                    </a:lnB>
+                  </a:tcPr>
+                </a:tc>
+              </a:tr>
+              <a:tr h="292608">
+                <a:tc>
+                  <a:txBody>
+                    <a:bodyPr/>
+                    <a:lstStyle/>
+                    <a:p>
+                      <a:pPr algn="l" indent="0" marL="0">
+                        <a:buNone/>
+                      </a:pPr>
+                      <a:r>
+                        <a:rPr lang="en-US" sz="850" dirty="0">
+                          <a:solidFill>
+                            <a:srgbClr val="334155"/>
+                          </a:solidFill>
+                          <a:latin typeface="Aptos" pitchFamily="34" charset="0"/>
+                          <a:ea typeface="Aptos" pitchFamily="34" charset="-122"/>
+                          <a:cs typeface="Aptos" pitchFamily="34" charset="-120"/>
+                        </a:rPr>
+                        <a:t>TBD</a:t>
+                      </a:r>
+                      <a:endParaRPr lang="en-US" sz="850" dirty="0">
+                        <a:latin typeface="Aptos" charset="0"/>
+                        <a:ea typeface="Aptos" charset="0"/>
+                        <a:cs typeface="Aptos" charset="0"/>
+                      </a:endParaRPr>
+                    </a:p>
+                  </a:txBody>
+                  <a:tcPr marL="91440" marR="91440" marT="45720" marB="45720" anchor="ctr">
+                    <a:lnL w="6350" cap="flat" cmpd="sng" algn="ctr">
+                      <a:solidFill>
+                        <a:srgbClr val="E2E8F0"/>
+                      </a:solidFill>
+                      <a:prstDash val="solid"/>
+                      <a:round/>
+                      <a:headEnd type="none" w="med" len="med"/>
+                      <a:tailEnd type="none" w="med" len="med"/>
+                    </a:lnL>
+                    <a:lnR w="6350" cap="flat" cmpd="sng" algn="ctr">
+                      <a:solidFill>
+                        <a:srgbClr val="E2E8F0"/>
+                      </a:solidFill>
+                      <a:prstDash val="solid"/>
+                      <a:round/>
+                      <a:headEnd type="none" w="med" len="med"/>
+                      <a:tailEnd type="none" w="med" len="med"/>
+                    </a:lnR>
+                    <a:lnT w="6350" cap="flat" cmpd="sng" algn="ctr">
+                      <a:solidFill>
+                        <a:srgbClr val="E2E8F0"/>
+                      </a:solidFill>
+                      <a:prstDash val="solid"/>
+                      <a:round/>
+                      <a:headEnd type="none" w="med" len="med"/>
+                      <a:tailEnd type="none" w="med" len="med"/>
+                    </a:lnT>
+                    <a:lnB w="6350" cap="flat" cmpd="sng" algn="ctr">
+                      <a:solidFill>
+                        <a:srgbClr val="E2E8F0"/>
+                      </a:solidFill>
+                      <a:prstDash val="solid"/>
+                      <a:round/>
+                      <a:headEnd type="none" w="med" len="med"/>
+                      <a:tailEnd type="none" w="med" len="med"/>
+                    </a:lnB>
+                  </a:tcPr>
+                </a:tc>
+                <a:tc>
+                  <a:txBody>
+                    <a:bodyPr/>
+                    <a:lstStyle/>
+                    <a:p>
+                      <a:pPr algn="l" indent="0" marL="0">
+                        <a:buNone/>
+                      </a:pPr>
+                      <a:r>
+                        <a:rPr lang="en-US" sz="850" b="1" dirty="0">
+                          <a:solidFill>
+                            <a:srgbClr val="0B1220"/>
+                          </a:solidFill>
+                          <a:latin typeface="Aptos" pitchFamily="34" charset="0"/>
+                          <a:ea typeface="Aptos" pitchFamily="34" charset="-122"/>
+                          <a:cs typeface="Aptos" pitchFamily="34" charset="-120"/>
+                        </a:rPr>
+                        <a:t>Agentic RAG - Foundry IQ</a:t>
+                      </a:r>
+                      <a:endParaRPr lang="en-US" sz="850" dirty="0">
+                        <a:latin typeface="Aptos" charset="0"/>
+                        <a:ea typeface="Aptos" charset="0"/>
+                        <a:cs typeface="Aptos" charset="0"/>
+                      </a:endParaRPr>
+                    </a:p>
+                  </a:txBody>
+                  <a:tcPr marL="91440" marR="91440" marT="45720" marB="45720" anchor="ctr">
+                    <a:lnL w="6350" cap="flat" cmpd="sng" algn="ctr">
+                      <a:solidFill>
+                        <a:srgbClr val="E2E8F0"/>
+                      </a:solidFill>
+                      <a:prstDash val="solid"/>
+                      <a:round/>
+                      <a:headEnd type="none" w="med" len="med"/>
+                      <a:tailEnd type="none" w="med" len="med"/>
+                    </a:lnL>
+                    <a:lnR w="6350" cap="flat" cmpd="sng" algn="ctr">
+                      <a:solidFill>
+                        <a:srgbClr val="E2E8F0"/>
+                      </a:solidFill>
+                      <a:prstDash val="solid"/>
+                      <a:round/>
+                      <a:headEnd type="none" w="med" len="med"/>
+                      <a:tailEnd type="none" w="med" len="med"/>
+                    </a:lnR>
+                    <a:lnT w="6350" cap="flat" cmpd="sng" algn="ctr">
+                      <a:solidFill>
+                        <a:srgbClr val="E2E8F0"/>
+                      </a:solidFill>
+                      <a:prstDash val="solid"/>
+                      <a:round/>
+                      <a:headEnd type="none" w="med" len="med"/>
+                      <a:tailEnd type="none" w="med" len="med"/>
+                    </a:lnT>
+                    <a:lnB w="6350" cap="flat" cmpd="sng" algn="ctr">
+                      <a:solidFill>
+                        <a:srgbClr val="E2E8F0"/>
+                      </a:solidFill>
+                      <a:prstDash val="solid"/>
+                      <a:round/>
+                      <a:headEnd type="none" w="med" len="med"/>
+                      <a:tailEnd type="none" w="med" len="med"/>
+                    </a:lnB>
+                  </a:tcPr>
+                </a:tc>
+                <a:tc>
+                  <a:txBody>
+                    <a:bodyPr/>
+                    <a:lstStyle/>
+                    <a:p>
+                      <a:pPr algn="l" indent="0" marL="0">
+                        <a:buNone/>
+                      </a:pPr>
+                      <a:r>
+                        <a:rPr lang="en-US" sz="850" dirty="0">
+                          <a:solidFill>
+                            <a:srgbClr val="334155"/>
+                          </a:solidFill>
+                          <a:latin typeface="Aptos" pitchFamily="34" charset="0"/>
+                          <a:ea typeface="Aptos" pitchFamily="34" charset="-122"/>
+                          <a:cs typeface="Aptos" pitchFamily="34" charset="-120"/>
+                        </a:rPr>
+                        <a:t>Chris Lekkas + Shivang Vora</a:t>
+                      </a:r>
+                      <a:endParaRPr lang="en-US" sz="850" dirty="0">
+                        <a:latin typeface="Aptos" charset="0"/>
+                        <a:ea typeface="Aptos" charset="0"/>
+                        <a:cs typeface="Aptos" charset="0"/>
+                      </a:endParaRPr>
+                    </a:p>
+                  </a:txBody>
+                  <a:tcPr marL="91440" marR="91440" marT="45720" marB="45720" anchor="ctr">
+                    <a:lnL w="6350" cap="flat" cmpd="sng" algn="ctr">
+                      <a:solidFill>
+                        <a:srgbClr val="E2E8F0"/>
+                      </a:solidFill>
+                      <a:prstDash val="solid"/>
+                      <a:round/>
+                      <a:headEnd type="none" w="med" len="med"/>
+                      <a:tailEnd type="none" w="med" len="med"/>
+                    </a:lnL>
+                    <a:lnR w="6350" cap="flat" cmpd="sng" algn="ctr">
+                      <a:solidFill>
+                        <a:srgbClr val="E2E8F0"/>
+                      </a:solidFill>
+                      <a:prstDash val="solid"/>
+                      <a:round/>
+                      <a:headEnd type="none" w="med" len="med"/>
+                      <a:tailEnd type="none" w="med" len="med"/>
+                    </a:lnR>
+                    <a:lnT w="6350" cap="flat" cmpd="sng" algn="ctr">
+                      <a:solidFill>
+                        <a:srgbClr val="E2E8F0"/>
+                      </a:solidFill>
+                      <a:prstDash val="solid"/>
+                      <a:round/>
+                      <a:headEnd type="none" w="med" len="med"/>
+                      <a:tailEnd type="none" w="med" len="med"/>
+                    </a:lnT>
+                    <a:lnB w="6350" cap="flat" cmpd="sng" algn="ctr">
+                      <a:solidFill>
+                        <a:srgbClr val="E2E8F0"/>
+                      </a:solidFill>
+                      <a:prstDash val="solid"/>
+                      <a:round/>
+                      <a:headEnd type="none" w="med" len="med"/>
+                      <a:tailEnd type="none" w="med" len="med"/>
+                    </a:lnB>
+                  </a:tcPr>
+                </a:tc>
+                <a:tc>
+                  <a:txBody>
+                    <a:bodyPr/>
+                    <a:lstStyle/>
+                    <a:p>
+                      <a:pPr algn="l" indent="0" marL="0">
+                        <a:buNone/>
+                      </a:pPr>
+                      <a:r>
+                        <a:rPr lang="en-US" sz="800" dirty="0">
+                          <a:solidFill>
+                            <a:srgbClr val="64748B"/>
+                          </a:solidFill>
+                          <a:latin typeface="Aptos" pitchFamily="34" charset="0"/>
+                          <a:ea typeface="Aptos" pitchFamily="34" charset="-122"/>
+                          <a:cs typeface="Aptos" pitchFamily="34" charset="-120"/>
+                        </a:rPr>
+                        <a:t>Best practice; existing AI Search vs capability / project-host AI Search</a:t>
+                      </a:r>
+                      <a:endParaRPr lang="en-US" sz="800" dirty="0">
+                        <a:latin typeface="Aptos" charset="0"/>
+                        <a:ea typeface="Aptos" charset="0"/>
+                        <a:cs typeface="Aptos" charset="0"/>
+                      </a:endParaRPr>
+                    </a:p>
+                  </a:txBody>
+                  <a:tcPr marL="91440" marR="91440" marT="45720" marB="45720" anchor="ctr">
+                    <a:lnL w="6350" cap="flat" cmpd="sng" algn="ctr">
+                      <a:solidFill>
+                        <a:srgbClr val="E2E8F0"/>
+                      </a:solidFill>
+                      <a:prstDash val="solid"/>
+                      <a:round/>
+                      <a:headEnd type="none" w="med" len="med"/>
+                      <a:tailEnd type="none" w="med" len="med"/>
+                    </a:lnL>
+                    <a:lnR w="6350" cap="flat" cmpd="sng" algn="ctr">
+                      <a:solidFill>
+                        <a:srgbClr val="E2E8F0"/>
+                      </a:solidFill>
+                      <a:prstDash val="solid"/>
+                      <a:round/>
+                      <a:headEnd type="none" w="med" len="med"/>
+                      <a:tailEnd type="none" w="med" len="med"/>
+                    </a:lnR>
+                    <a:lnT w="6350" cap="flat" cmpd="sng" algn="ctr">
+                      <a:solidFill>
+                        <a:srgbClr val="E2E8F0"/>
+                      </a:solidFill>
+                      <a:prstDash val="solid"/>
+                      <a:round/>
+                      <a:headEnd type="none" w="med" len="med"/>
+                      <a:tailEnd type="none" w="med" len="med"/>
+                    </a:lnT>
+                    <a:lnB w="6350" cap="flat" cmpd="sng" algn="ctr">
+                      <a:solidFill>
+                        <a:srgbClr val="E2E8F0"/>
+                      </a:solidFill>
+                      <a:prstDash val="solid"/>
+                      <a:round/>
+                      <a:headEnd type="none" w="med" len="med"/>
+                      <a:tailEnd type="none" w="med" len="med"/>
+                    </a:lnB>
+                  </a:tcPr>
+                </a:tc>
+              </a:tr>
+              <a:tr h="292608">
+                <a:tc>
+                  <a:txBody>
+                    <a:bodyPr/>
+                    <a:lstStyle/>
+                    <a:p>
+                      <a:pPr algn="l" indent="0" marL="0">
+                        <a:buNone/>
+                      </a:pPr>
+                      <a:r>
+                        <a:rPr lang="en-US" sz="850" dirty="0">
+                          <a:solidFill>
+                            <a:srgbClr val="334155"/>
+                          </a:solidFill>
+                          <a:latin typeface="Aptos" pitchFamily="34" charset="0"/>
+                          <a:ea typeface="Aptos" pitchFamily="34" charset="-122"/>
+                          <a:cs typeface="Aptos" pitchFamily="34" charset="-120"/>
+                        </a:rPr>
+                        <a:t>TBD</a:t>
+                      </a:r>
+                      <a:endParaRPr lang="en-US" sz="850" dirty="0">
+                        <a:latin typeface="Aptos" charset="0"/>
+                        <a:ea typeface="Aptos" charset="0"/>
+                        <a:cs typeface="Aptos" charset="0"/>
+                      </a:endParaRPr>
+                    </a:p>
+                  </a:txBody>
+                  <a:tcPr marL="91440" marR="91440" marT="45720" marB="45720" anchor="ctr">
+                    <a:lnL w="6350" cap="flat" cmpd="sng" algn="ctr">
+                      <a:solidFill>
+                        <a:srgbClr val="E2E8F0"/>
+                      </a:solidFill>
+                      <a:prstDash val="solid"/>
+                      <a:round/>
+                      <a:headEnd type="none" w="med" len="med"/>
+                      <a:tailEnd type="none" w="med" len="med"/>
+                    </a:lnL>
+                    <a:lnR w="6350" cap="flat" cmpd="sng" algn="ctr">
+                      <a:solidFill>
+                        <a:srgbClr val="E2E8F0"/>
+                      </a:solidFill>
+                      <a:prstDash val="solid"/>
+                      <a:round/>
+                      <a:headEnd type="none" w="med" len="med"/>
+                      <a:tailEnd type="none" w="med" len="med"/>
+                    </a:lnR>
+                    <a:lnT w="6350" cap="flat" cmpd="sng" algn="ctr">
+                      <a:solidFill>
+                        <a:srgbClr val="E2E8F0"/>
+                      </a:solidFill>
+                      <a:prstDash val="solid"/>
+                      <a:round/>
+                      <a:headEnd type="none" w="med" len="med"/>
+                      <a:tailEnd type="none" w="med" len="med"/>
+                    </a:lnT>
+                    <a:lnB w="6350" cap="flat" cmpd="sng" algn="ctr">
+                      <a:solidFill>
+                        <a:srgbClr val="E2E8F0"/>
+                      </a:solidFill>
+                      <a:prstDash val="solid"/>
+                      <a:round/>
+                      <a:headEnd type="none" w="med" len="med"/>
+                      <a:tailEnd type="none" w="med" len="med"/>
+                    </a:lnB>
+                  </a:tcPr>
+                </a:tc>
+                <a:tc>
+                  <a:txBody>
+                    <a:bodyPr/>
+                    <a:lstStyle/>
+                    <a:p>
+                      <a:pPr algn="l" indent="0" marL="0">
+                        <a:buNone/>
+                      </a:pPr>
+                      <a:r>
+                        <a:rPr lang="en-US" sz="850" b="1" dirty="0">
+                          <a:solidFill>
+                            <a:srgbClr val="0B1220"/>
+                          </a:solidFill>
+                          <a:latin typeface="Aptos" pitchFamily="34" charset="0"/>
+                          <a:ea typeface="Aptos" pitchFamily="34" charset="-122"/>
+                          <a:cs typeface="Aptos" pitchFamily="34" charset="-120"/>
+                        </a:rPr>
+                        <a:t>Lunch</a:t>
+                      </a:r>
+                      <a:endParaRPr lang="en-US" sz="850" dirty="0">
+                        <a:latin typeface="Aptos" charset="0"/>
+                        <a:ea typeface="Aptos" charset="0"/>
+                        <a:cs typeface="Aptos" charset="0"/>
+                      </a:endParaRPr>
+                    </a:p>
+                  </a:txBody>
+                  <a:tcPr marL="91440" marR="91440" marT="45720" marB="45720" anchor="ctr">
+                    <a:lnL w="6350" cap="flat" cmpd="sng" algn="ctr">
+                      <a:solidFill>
+                        <a:srgbClr val="E2E8F0"/>
+                      </a:solidFill>
+                      <a:prstDash val="solid"/>
+                      <a:round/>
+                      <a:headEnd type="none" w="med" len="med"/>
+                      <a:tailEnd type="none" w="med" len="med"/>
+                    </a:lnL>
+                    <a:lnR w="6350" cap="flat" cmpd="sng" algn="ctr">
+                      <a:solidFill>
+                        <a:srgbClr val="E2E8F0"/>
+                      </a:solidFill>
+                      <a:prstDash val="solid"/>
+                      <a:round/>
+                      <a:headEnd type="none" w="med" len="med"/>
+                      <a:tailEnd type="none" w="med" len="med"/>
+                    </a:lnR>
+                    <a:lnT w="6350" cap="flat" cmpd="sng" algn="ctr">
+                      <a:solidFill>
+                        <a:srgbClr val="E2E8F0"/>
+                      </a:solidFill>
+                      <a:prstDash val="solid"/>
+                      <a:round/>
+                      <a:headEnd type="none" w="med" len="med"/>
+                      <a:tailEnd type="none" w="med" len="med"/>
+                    </a:lnT>
+                    <a:lnB w="6350" cap="flat" cmpd="sng" algn="ctr">
+                      <a:solidFill>
+                        <a:srgbClr val="E2E8F0"/>
+                      </a:solidFill>
+                      <a:prstDash val="solid"/>
+                      <a:round/>
+                      <a:headEnd type="none" w="med" len="med"/>
+                      <a:tailEnd type="none" w="med" len="med"/>
+                    </a:lnB>
+                  </a:tcPr>
+                </a:tc>
+                <a:tc>
+                  <a:txBody>
+                    <a:bodyPr/>
+                    <a:lstStyle/>
+                    <a:p>
+                      <a:pPr algn="l" indent="0" marL="0">
+                        <a:buNone/>
+                      </a:pPr>
+                      <a:endParaRPr lang="en-US" sz="850" dirty="0">
+                        <a:latin typeface="Aptos" charset="0"/>
+                        <a:ea typeface="Aptos" charset="0"/>
+                        <a:cs typeface="Aptos" charset="0"/>
+                      </a:endParaRPr>
+                    </a:p>
+                  </a:txBody>
+                  <a:tcPr marL="91440" marR="91440" marT="45720" marB="45720" anchor="ctr">
+                    <a:lnL w="6350" cap="flat" cmpd="sng" algn="ctr">
+                      <a:solidFill>
+                        <a:srgbClr val="E2E8F0"/>
+                      </a:solidFill>
+                      <a:prstDash val="solid"/>
+                      <a:round/>
+                      <a:headEnd type="none" w="med" len="med"/>
+                      <a:tailEnd type="none" w="med" len="med"/>
+                    </a:lnL>
+                    <a:lnR w="6350" cap="flat" cmpd="sng" algn="ctr">
+                      <a:solidFill>
+                        <a:srgbClr val="E2E8F0"/>
+                      </a:solidFill>
+                      <a:prstDash val="solid"/>
+                      <a:round/>
+                      <a:headEnd type="none" w="med" len="med"/>
+                      <a:tailEnd type="none" w="med" len="med"/>
+                    </a:lnR>
+                    <a:lnT w="6350" cap="flat" cmpd="sng" algn="ctr">
+                      <a:solidFill>
+                        <a:srgbClr val="E2E8F0"/>
+                      </a:solidFill>
+                      <a:prstDash val="solid"/>
+                      <a:round/>
+                      <a:headEnd type="none" w="med" len="med"/>
+                      <a:tailEnd type="none" w="med" len="med"/>
+                    </a:lnT>
+                    <a:lnB w="6350" cap="flat" cmpd="sng" algn="ctr">
+                      <a:solidFill>
+                        <a:srgbClr val="E2E8F0"/>
+                      </a:solidFill>
+                      <a:prstDash val="solid"/>
+                      <a:round/>
+                      <a:headEnd type="none" w="med" len="med"/>
+                      <a:tailEnd type="none" w="med" len="med"/>
+                    </a:lnB>
+                  </a:tcPr>
+                </a:tc>
+                <a:tc>
+                  <a:txBody>
+                    <a:bodyPr/>
+                    <a:lstStyle/>
+                    <a:p>
+                      <a:pPr algn="l" indent="0" marL="0">
+                        <a:buNone/>
+                      </a:pPr>
+                      <a:endParaRPr lang="en-US" sz="800" dirty="0">
+                        <a:latin typeface="Aptos" charset="0"/>
+                        <a:ea typeface="Aptos" charset="0"/>
+                        <a:cs typeface="Aptos" charset="0"/>
+                      </a:endParaRPr>
+                    </a:p>
+                  </a:txBody>
+                  <a:tcPr marL="91440" marR="91440" marT="45720" marB="45720" anchor="ctr">
+                    <a:lnL w="6350" cap="flat" cmpd="sng" algn="ctr">
+                      <a:solidFill>
+                        <a:srgbClr val="E2E8F0"/>
+                      </a:solidFill>
+                      <a:prstDash val="solid"/>
+                      <a:round/>
+                      <a:headEnd type="none" w="med" len="med"/>
+                      <a:tailEnd type="none" w="med" len="med"/>
+                    </a:lnL>
+                    <a:lnR w="6350" cap="flat" cmpd="sng" algn="ctr">
+                      <a:solidFill>
+                        <a:srgbClr val="E2E8F0"/>
+                      </a:solidFill>
+                      <a:prstDash val="solid"/>
+                      <a:round/>
+                      <a:headEnd type="none" w="med" len="med"/>
+                      <a:tailEnd type="none" w="med" len="med"/>
+                    </a:lnR>
+                    <a:lnT w="6350" cap="flat" cmpd="sng" algn="ctr">
+                      <a:solidFill>
+                        <a:srgbClr val="E2E8F0"/>
+                      </a:solidFill>
+                      <a:prstDash val="solid"/>
+                      <a:round/>
+                      <a:headEnd type="none" w="med" len="med"/>
+                      <a:tailEnd type="none" w="med" len="med"/>
+                    </a:lnT>
+                    <a:lnB w="6350" cap="flat" cmpd="sng" algn="ctr">
+                      <a:solidFill>
+                        <a:srgbClr val="E2E8F0"/>
+                      </a:solidFill>
+                      <a:prstDash val="solid"/>
+                      <a:round/>
+                      <a:headEnd type="none" w="med" len="med"/>
+                      <a:tailEnd type="none" w="med" len="med"/>
+                    </a:lnB>
+                  </a:tcPr>
+                </a:tc>
+              </a:tr>
+              <a:tr h="292608">
+                <a:tc>
+                  <a:txBody>
+                    <a:bodyPr/>
+                    <a:lstStyle/>
+                    <a:p>
+                      <a:pPr algn="l" indent="0" marL="0">
+                        <a:buNone/>
+                      </a:pPr>
+                      <a:r>
+                        <a:rPr lang="en-US" sz="850" dirty="0">
+                          <a:solidFill>
+                            <a:srgbClr val="334155"/>
+                          </a:solidFill>
+                          <a:latin typeface="Aptos" pitchFamily="34" charset="0"/>
+                          <a:ea typeface="Aptos" pitchFamily="34" charset="-122"/>
+                          <a:cs typeface="Aptos" pitchFamily="34" charset="-120"/>
+                        </a:rPr>
+                        <a:t>TBD</a:t>
+                      </a:r>
+                      <a:endParaRPr lang="en-US" sz="850" dirty="0">
+                        <a:latin typeface="Aptos" charset="0"/>
+                        <a:ea typeface="Aptos" charset="0"/>
+                        <a:cs typeface="Aptos" charset="0"/>
+                      </a:endParaRPr>
+                    </a:p>
+                  </a:txBody>
+                  <a:tcPr marL="91440" marR="91440" marT="45720" marB="45720" anchor="ctr">
+                    <a:lnL w="6350" cap="flat" cmpd="sng" algn="ctr">
+                      <a:solidFill>
+                        <a:srgbClr val="E2E8F0"/>
+                      </a:solidFill>
+                      <a:prstDash val="solid"/>
+                      <a:round/>
+                      <a:headEnd type="none" w="med" len="med"/>
+                      <a:tailEnd type="none" w="med" len="med"/>
+                    </a:lnL>
+                    <a:lnR w="6350" cap="flat" cmpd="sng" algn="ctr">
+                      <a:solidFill>
+                        <a:srgbClr val="E2E8F0"/>
+                      </a:solidFill>
+                      <a:prstDash val="solid"/>
+                      <a:round/>
+                      <a:headEnd type="none" w="med" len="med"/>
+                      <a:tailEnd type="none" w="med" len="med"/>
+                    </a:lnR>
+                    <a:lnT w="6350" cap="flat" cmpd="sng" algn="ctr">
+                      <a:solidFill>
+                        <a:srgbClr val="E2E8F0"/>
+                      </a:solidFill>
+                      <a:prstDash val="solid"/>
+                      <a:round/>
+                      <a:headEnd type="none" w="med" len="med"/>
+                      <a:tailEnd type="none" w="med" len="med"/>
+                    </a:lnT>
+                    <a:lnB w="6350" cap="flat" cmpd="sng" algn="ctr">
+                      <a:solidFill>
+                        <a:srgbClr val="E2E8F0"/>
+                      </a:solidFill>
+                      <a:prstDash val="solid"/>
+                      <a:round/>
+                      <a:headEnd type="none" w="med" len="med"/>
+                      <a:tailEnd type="none" w="med" len="med"/>
+                    </a:lnB>
+                  </a:tcPr>
+                </a:tc>
+                <a:tc>
+                  <a:txBody>
+                    <a:bodyPr/>
+                    <a:lstStyle/>
+                    <a:p>
+                      <a:pPr algn="l" indent="0" marL="0">
+                        <a:buNone/>
+                      </a:pPr>
+                      <a:r>
+                        <a:rPr lang="en-US" sz="850" b="1" dirty="0">
+                          <a:solidFill>
+                            <a:srgbClr val="0B1220"/>
+                          </a:solidFill>
+                          <a:latin typeface="Aptos" pitchFamily="34" charset="0"/>
+                          <a:ea typeface="Aptos" pitchFamily="34" charset="-122"/>
+                          <a:cs typeface="Aptos" pitchFamily="34" charset="-120"/>
+                        </a:rPr>
+                        <a:t>BYO Registry for Hosted Agents</a:t>
+                      </a:r>
+                      <a:endParaRPr lang="en-US" sz="850" dirty="0">
+                        <a:latin typeface="Aptos" charset="0"/>
+                        <a:ea typeface="Aptos" charset="0"/>
+                        <a:cs typeface="Aptos" charset="0"/>
+                      </a:endParaRPr>
+                    </a:p>
+                  </a:txBody>
+                  <a:tcPr marL="91440" marR="91440" marT="45720" marB="45720" anchor="ctr">
+                    <a:lnL w="6350" cap="flat" cmpd="sng" algn="ctr">
+                      <a:solidFill>
+                        <a:srgbClr val="E2E8F0"/>
+                      </a:solidFill>
+                      <a:prstDash val="solid"/>
+                      <a:round/>
+                      <a:headEnd type="none" w="med" len="med"/>
+                      <a:tailEnd type="none" w="med" len="med"/>
+                    </a:lnL>
+                    <a:lnR w="6350" cap="flat" cmpd="sng" algn="ctr">
+                      <a:solidFill>
+                        <a:srgbClr val="E2E8F0"/>
+                      </a:solidFill>
+                      <a:prstDash val="solid"/>
+                      <a:round/>
+                      <a:headEnd type="none" w="med" len="med"/>
+                      <a:tailEnd type="none" w="med" len="med"/>
+                    </a:lnR>
+                    <a:lnT w="6350" cap="flat" cmpd="sng" algn="ctr">
+                      <a:solidFill>
+                        <a:srgbClr val="E2E8F0"/>
+                      </a:solidFill>
+                      <a:prstDash val="solid"/>
+                      <a:round/>
+                      <a:headEnd type="none" w="med" len="med"/>
+                      <a:tailEnd type="none" w="med" len="med"/>
+                    </a:lnT>
+                    <a:lnB w="6350" cap="flat" cmpd="sng" algn="ctr">
+                      <a:solidFill>
+                        <a:srgbClr val="E2E8F0"/>
+                      </a:solidFill>
+                      <a:prstDash val="solid"/>
+                      <a:round/>
+                      <a:headEnd type="none" w="med" len="med"/>
+                      <a:tailEnd type="none" w="med" len="med"/>
+                    </a:lnB>
+                  </a:tcPr>
+                </a:tc>
+                <a:tc>
+                  <a:txBody>
+                    <a:bodyPr/>
+                    <a:lstStyle/>
+                    <a:p>
+                      <a:pPr algn="l" indent="0" marL="0">
+                        <a:buNone/>
+                      </a:pPr>
+                      <a:r>
+                        <a:rPr lang="en-US" sz="850" dirty="0">
+                          <a:solidFill>
+                            <a:srgbClr val="334155"/>
+                          </a:solidFill>
+                          <a:latin typeface="Aptos" pitchFamily="34" charset="0"/>
+                          <a:ea typeface="Aptos" pitchFamily="34" charset="-122"/>
+                          <a:cs typeface="Aptos" pitchFamily="34" charset="-120"/>
+                        </a:rPr>
+                        <a:t>Chris Lekkas</a:t>
+                      </a:r>
+                      <a:endParaRPr lang="en-US" sz="850" dirty="0">
+                        <a:latin typeface="Aptos" charset="0"/>
+                        <a:ea typeface="Aptos" charset="0"/>
+                        <a:cs typeface="Aptos" charset="0"/>
+                      </a:endParaRPr>
+                    </a:p>
+                  </a:txBody>
+                  <a:tcPr marL="91440" marR="91440" marT="45720" marB="45720" anchor="ctr">
+                    <a:lnL w="6350" cap="flat" cmpd="sng" algn="ctr">
+                      <a:solidFill>
+                        <a:srgbClr val="E2E8F0"/>
+                      </a:solidFill>
+                      <a:prstDash val="solid"/>
+                      <a:round/>
+                      <a:headEnd type="none" w="med" len="med"/>
+                      <a:tailEnd type="none" w="med" len="med"/>
+                    </a:lnL>
+                    <a:lnR w="6350" cap="flat" cmpd="sng" algn="ctr">
+                      <a:solidFill>
+                        <a:srgbClr val="E2E8F0"/>
+                      </a:solidFill>
+                      <a:prstDash val="solid"/>
+                      <a:round/>
+                      <a:headEnd type="none" w="med" len="med"/>
+                      <a:tailEnd type="none" w="med" len="med"/>
+                    </a:lnR>
+                    <a:lnT w="6350" cap="flat" cmpd="sng" algn="ctr">
+                      <a:solidFill>
+                        <a:srgbClr val="E2E8F0"/>
+                      </a:solidFill>
+                      <a:prstDash val="solid"/>
+                      <a:round/>
+                      <a:headEnd type="none" w="med" len="med"/>
+                      <a:tailEnd type="none" w="med" len="med"/>
+                    </a:lnT>
+                    <a:lnB w="6350" cap="flat" cmpd="sng" algn="ctr">
+                      <a:solidFill>
+                        <a:srgbClr val="E2E8F0"/>
+                      </a:solidFill>
+                      <a:prstDash val="solid"/>
+                      <a:round/>
+                      <a:headEnd type="none" w="med" len="med"/>
+                      <a:tailEnd type="none" w="med" len="med"/>
+                    </a:lnB>
+                  </a:tcPr>
+                </a:tc>
+                <a:tc>
+                  <a:txBody>
+                    <a:bodyPr/>
+                    <a:lstStyle/>
+                    <a:p>
+                      <a:pPr algn="l" indent="0" marL="0">
+                        <a:buNone/>
+                      </a:pPr>
+                      <a:r>
+                        <a:rPr lang="en-US" sz="800" dirty="0">
+                          <a:solidFill>
+                            <a:srgbClr val="64748B"/>
+                          </a:solidFill>
+                          <a:latin typeface="Aptos" pitchFamily="34" charset="0"/>
+                          <a:ea typeface="Aptos" pitchFamily="34" charset="-122"/>
+                          <a:cs typeface="Aptos" pitchFamily="34" charset="-120"/>
+                        </a:rPr>
+                        <a:t>Hands-on lab session</a:t>
+                      </a:r>
+                      <a:endParaRPr lang="en-US" sz="800" dirty="0">
+                        <a:latin typeface="Aptos" charset="0"/>
+                        <a:ea typeface="Aptos" charset="0"/>
+                        <a:cs typeface="Aptos" charset="0"/>
+                      </a:endParaRPr>
+                    </a:p>
+                  </a:txBody>
+                  <a:tcPr marL="91440" marR="91440" marT="45720" marB="45720" anchor="ctr">
+                    <a:lnL w="6350" cap="flat" cmpd="sng" algn="ctr">
+                      <a:solidFill>
+                        <a:srgbClr val="E2E8F0"/>
+                      </a:solidFill>
+                      <a:prstDash val="solid"/>
+                      <a:round/>
+                      <a:headEnd type="none" w="med" len="med"/>
+                      <a:tailEnd type="none" w="med" len="med"/>
+                    </a:lnL>
+                    <a:lnR w="6350" cap="flat" cmpd="sng" algn="ctr">
+                      <a:solidFill>
+                        <a:srgbClr val="E2E8F0"/>
+                      </a:solidFill>
+                      <a:prstDash val="solid"/>
+                      <a:round/>
+                      <a:headEnd type="none" w="med" len="med"/>
+                      <a:tailEnd type="none" w="med" len="med"/>
+                    </a:lnR>
+                    <a:lnT w="6350" cap="flat" cmpd="sng" algn="ctr">
+                      <a:solidFill>
+                        <a:srgbClr val="E2E8F0"/>
+                      </a:solidFill>
+                      <a:prstDash val="solid"/>
+                      <a:round/>
+                      <a:headEnd type="none" w="med" len="med"/>
+                      <a:tailEnd type="none" w="med" len="med"/>
+                    </a:lnT>
+                    <a:lnB w="6350" cap="flat" cmpd="sng" algn="ctr">
+                      <a:solidFill>
+                        <a:srgbClr val="E2E8F0"/>
+                      </a:solidFill>
+                      <a:prstDash val="solid"/>
+                      <a:round/>
+                      <a:headEnd type="none" w="med" len="med"/>
+                      <a:tailEnd type="none" w="med" len="med"/>
+                    </a:lnB>
+                  </a:tcPr>
+                </a:tc>
+              </a:tr>
+              <a:tr h="292608">
+                <a:tc>
+                  <a:txBody>
+                    <a:bodyPr/>
+                    <a:lstStyle/>
+                    <a:p>
+                      <a:pPr algn="l" indent="0" marL="0">
+                        <a:buNone/>
+                      </a:pPr>
+                      <a:r>
+                        <a:rPr lang="en-US" sz="850" dirty="0">
+                          <a:solidFill>
+                            <a:srgbClr val="334155"/>
+                          </a:solidFill>
+                          <a:latin typeface="Aptos" pitchFamily="34" charset="0"/>
+                          <a:ea typeface="Aptos" pitchFamily="34" charset="-122"/>
+                          <a:cs typeface="Aptos" pitchFamily="34" charset="-120"/>
+                        </a:rPr>
+                        <a:t>TBD</a:t>
+                      </a:r>
+                      <a:endParaRPr lang="en-US" sz="850" dirty="0">
+                        <a:latin typeface="Aptos" charset="0"/>
+                        <a:ea typeface="Aptos" charset="0"/>
+                        <a:cs typeface="Aptos" charset="0"/>
+                      </a:endParaRPr>
+                    </a:p>
+                  </a:txBody>
+                  <a:tcPr marL="91440" marR="91440" marT="45720" marB="45720" anchor="ctr">
+                    <a:lnL w="6350" cap="flat" cmpd="sng" algn="ctr">
+                      <a:solidFill>
+                        <a:srgbClr val="E2E8F0"/>
+                      </a:solidFill>
+                      <a:prstDash val="solid"/>
+                      <a:round/>
+                      <a:headEnd type="none" w="med" len="med"/>
+                      <a:tailEnd type="none" w="med" len="med"/>
+                    </a:lnL>
+                    <a:lnR w="6350" cap="flat" cmpd="sng" algn="ctr">
+                      <a:solidFill>
+                        <a:srgbClr val="E2E8F0"/>
+                      </a:solidFill>
+                      <a:prstDash val="solid"/>
+                      <a:round/>
+                      <a:headEnd type="none" w="med" len="med"/>
+                      <a:tailEnd type="none" w="med" len="med"/>
+                    </a:lnR>
+                    <a:lnT w="6350" cap="flat" cmpd="sng" algn="ctr">
+                      <a:solidFill>
+                        <a:srgbClr val="E2E8F0"/>
+                      </a:solidFill>
+                      <a:prstDash val="solid"/>
+                      <a:round/>
+                      <a:headEnd type="none" w="med" len="med"/>
+                      <a:tailEnd type="none" w="med" len="med"/>
+                    </a:lnT>
+                    <a:lnB w="6350" cap="flat" cmpd="sng" algn="ctr">
+                      <a:solidFill>
+                        <a:srgbClr val="E2E8F0"/>
+                      </a:solidFill>
+                      <a:prstDash val="solid"/>
+                      <a:round/>
+                      <a:headEnd type="none" w="med" len="med"/>
+                      <a:tailEnd type="none" w="med" len="med"/>
+                    </a:lnB>
+                  </a:tcPr>
+                </a:tc>
+                <a:tc>
+                  <a:txBody>
+                    <a:bodyPr/>
+                    <a:lstStyle/>
+                    <a:p>
+                      <a:pPr algn="l" indent="0" marL="0">
+                        <a:buNone/>
+                      </a:pPr>
+                      <a:r>
+                        <a:rPr lang="en-US" sz="850" b="1" dirty="0">
+                          <a:solidFill>
+                            <a:srgbClr val="0B1220"/>
+                          </a:solidFill>
+                          <a:latin typeface="Aptos" pitchFamily="34" charset="0"/>
+                          <a:ea typeface="Aptos" pitchFamily="34" charset="-122"/>
+                          <a:cs typeface="Aptos" pitchFamily="34" charset="-120"/>
+                        </a:rPr>
+                        <a:t>Hosted Agents technical deep dive</a:t>
+                      </a:r>
+                      <a:endParaRPr lang="en-US" sz="850" dirty="0">
+                        <a:latin typeface="Aptos" charset="0"/>
+                        <a:ea typeface="Aptos" charset="0"/>
+                        <a:cs typeface="Aptos" charset="0"/>
+                      </a:endParaRPr>
+                    </a:p>
+                  </a:txBody>
+                  <a:tcPr marL="91440" marR="91440" marT="45720" marB="45720" anchor="ctr">
+                    <a:lnL w="6350" cap="flat" cmpd="sng" algn="ctr">
+                      <a:solidFill>
+                        <a:srgbClr val="E2E8F0"/>
+                      </a:solidFill>
+                      <a:prstDash val="solid"/>
+                      <a:round/>
+                      <a:headEnd type="none" w="med" len="med"/>
+                      <a:tailEnd type="none" w="med" len="med"/>
+                    </a:lnL>
+                    <a:lnR w="6350" cap="flat" cmpd="sng" algn="ctr">
+                      <a:solidFill>
+                        <a:srgbClr val="E2E8F0"/>
+                      </a:solidFill>
+                      <a:prstDash val="solid"/>
+                      <a:round/>
+                      <a:headEnd type="none" w="med" len="med"/>
+                      <a:tailEnd type="none" w="med" len="med"/>
+                    </a:lnR>
+                    <a:lnT w="6350" cap="flat" cmpd="sng" algn="ctr">
+                      <a:solidFill>
+                        <a:srgbClr val="E2E8F0"/>
+                      </a:solidFill>
+                      <a:prstDash val="solid"/>
+                      <a:round/>
+                      <a:headEnd type="none" w="med" len="med"/>
+                      <a:tailEnd type="none" w="med" len="med"/>
+                    </a:lnT>
+                    <a:lnB w="6350" cap="flat" cmpd="sng" algn="ctr">
+                      <a:solidFill>
+                        <a:srgbClr val="E2E8F0"/>
+                      </a:solidFill>
+                      <a:prstDash val="solid"/>
+                      <a:round/>
+                      <a:headEnd type="none" w="med" len="med"/>
+                      <a:tailEnd type="none" w="med" len="med"/>
+                    </a:lnB>
+                  </a:tcPr>
+                </a:tc>
+                <a:tc>
+                  <a:txBody>
+                    <a:bodyPr/>
+                    <a:lstStyle/>
+                    <a:p>
+                      <a:pPr algn="l" indent="0" marL="0">
+                        <a:buNone/>
+                      </a:pPr>
+                      <a:r>
+                        <a:rPr lang="en-US" sz="850" dirty="0">
+                          <a:solidFill>
+                            <a:srgbClr val="334155"/>
+                          </a:solidFill>
+                          <a:latin typeface="Aptos" pitchFamily="34" charset="0"/>
+                          <a:ea typeface="Aptos" pitchFamily="34" charset="-122"/>
+                          <a:cs typeface="Aptos" pitchFamily="34" charset="-120"/>
+                        </a:rPr>
+                        <a:t>Chris Lekkas + Shivang Vora</a:t>
+                      </a:r>
+                      <a:endParaRPr lang="en-US" sz="850" dirty="0">
+                        <a:latin typeface="Aptos" charset="0"/>
+                        <a:ea typeface="Aptos" charset="0"/>
+                        <a:cs typeface="Aptos" charset="0"/>
+                      </a:endParaRPr>
+                    </a:p>
+                  </a:txBody>
+                  <a:tcPr marL="91440" marR="91440" marT="45720" marB="45720" anchor="ctr">
+                    <a:lnL w="6350" cap="flat" cmpd="sng" algn="ctr">
+                      <a:solidFill>
+                        <a:srgbClr val="E2E8F0"/>
+                      </a:solidFill>
+                      <a:prstDash val="solid"/>
+                      <a:round/>
+                      <a:headEnd type="none" w="med" len="med"/>
+                      <a:tailEnd type="none" w="med" len="med"/>
+                    </a:lnL>
+                    <a:lnR w="6350" cap="flat" cmpd="sng" algn="ctr">
+                      <a:solidFill>
+                        <a:srgbClr val="E2E8F0"/>
+                      </a:solidFill>
+                      <a:prstDash val="solid"/>
+                      <a:round/>
+                      <a:headEnd type="none" w="med" len="med"/>
+                      <a:tailEnd type="none" w="med" len="med"/>
+                    </a:lnR>
+                    <a:lnT w="6350" cap="flat" cmpd="sng" algn="ctr">
+                      <a:solidFill>
+                        <a:srgbClr val="E2E8F0"/>
+                      </a:solidFill>
+                      <a:prstDash val="solid"/>
+                      <a:round/>
+                      <a:headEnd type="none" w="med" len="med"/>
+                      <a:tailEnd type="none" w="med" len="med"/>
+                    </a:lnT>
+                    <a:lnB w="6350" cap="flat" cmpd="sng" algn="ctr">
+                      <a:solidFill>
+                        <a:srgbClr val="E2E8F0"/>
+                      </a:solidFill>
+                      <a:prstDash val="solid"/>
+                      <a:round/>
+                      <a:headEnd type="none" w="med" len="med"/>
+                      <a:tailEnd type="none" w="med" len="med"/>
+                    </a:lnB>
+                  </a:tcPr>
+                </a:tc>
+                <a:tc>
+                  <a:txBody>
+                    <a:bodyPr/>
+                    <a:lstStyle/>
+                    <a:p>
+                      <a:pPr algn="l" indent="0" marL="0">
+                        <a:buNone/>
+                      </a:pPr>
+                      <a:endParaRPr lang="en-US" sz="800" dirty="0">
+                        <a:latin typeface="Aptos" charset="0"/>
+                        <a:ea typeface="Aptos" charset="0"/>
+                        <a:cs typeface="Aptos" charset="0"/>
+                      </a:endParaRPr>
+                    </a:p>
+                  </a:txBody>
+                  <a:tcPr marL="91440" marR="91440" marT="45720" marB="45720" anchor="ctr">
+                    <a:lnL w="6350" cap="flat" cmpd="sng" algn="ctr">
+                      <a:solidFill>
+                        <a:srgbClr val="E2E8F0"/>
+                      </a:solidFill>
+                      <a:prstDash val="solid"/>
+                      <a:round/>
+                      <a:headEnd type="none" w="med" len="med"/>
+                      <a:tailEnd type="none" w="med" len="med"/>
+                    </a:lnL>
+                    <a:lnR w="6350" cap="flat" cmpd="sng" algn="ctr">
+                      <a:solidFill>
+                        <a:srgbClr val="E2E8F0"/>
+                      </a:solidFill>
+                      <a:prstDash val="solid"/>
+                      <a:round/>
+                      <a:headEnd type="none" w="med" len="med"/>
+                      <a:tailEnd type="none" w="med" len="med"/>
+                    </a:lnR>
+                    <a:lnT w="6350" cap="flat" cmpd="sng" algn="ctr">
+                      <a:solidFill>
+                        <a:srgbClr val="E2E8F0"/>
+                      </a:solidFill>
+                      <a:prstDash val="solid"/>
+                      <a:round/>
+                      <a:headEnd type="none" w="med" len="med"/>
+                      <a:tailEnd type="none" w="med" len="med"/>
+                    </a:lnT>
+                    <a:lnB w="6350" cap="flat" cmpd="sng" algn="ctr">
+                      <a:solidFill>
+                        <a:srgbClr val="E2E8F0"/>
+                      </a:solidFill>
+                      <a:prstDash val="solid"/>
+                      <a:round/>
+                      <a:headEnd type="none" w="med" len="med"/>
+                      <a:tailEnd type="none" w="med" len="med"/>
+                    </a:lnB>
+                  </a:tcPr>
+                </a:tc>
+              </a:tr>
+              <a:tr h="292608">
+                <a:tc>
+                  <a:txBody>
+                    <a:bodyPr/>
+                    <a:lstStyle/>
+                    <a:p>
+                      <a:pPr algn="l" indent="0" marL="0">
+                        <a:buNone/>
+                      </a:pPr>
+                      <a:r>
+                        <a:rPr lang="en-US" sz="850" dirty="0">
+                          <a:solidFill>
+                            <a:srgbClr val="334155"/>
+                          </a:solidFill>
+                          <a:latin typeface="Aptos" pitchFamily="34" charset="0"/>
+                          <a:ea typeface="Aptos" pitchFamily="34" charset="-122"/>
+                          <a:cs typeface="Aptos" pitchFamily="34" charset="-120"/>
+                        </a:rPr>
+                        <a:t>TBD</a:t>
+                      </a:r>
+                      <a:endParaRPr lang="en-US" sz="850" dirty="0">
+                        <a:latin typeface="Aptos" charset="0"/>
+                        <a:ea typeface="Aptos" charset="0"/>
+                        <a:cs typeface="Aptos" charset="0"/>
+                      </a:endParaRPr>
+                    </a:p>
+                  </a:txBody>
+                  <a:tcPr marL="91440" marR="91440" marT="45720" marB="45720" anchor="ctr">
+                    <a:lnL w="6350" cap="flat" cmpd="sng" algn="ctr">
+                      <a:solidFill>
+                        <a:srgbClr val="E2E8F0"/>
+                      </a:solidFill>
+                      <a:prstDash val="solid"/>
+                      <a:round/>
+                      <a:headEnd type="none" w="med" len="med"/>
+                      <a:tailEnd type="none" w="med" len="med"/>
+                    </a:lnL>
+                    <a:lnR w="6350" cap="flat" cmpd="sng" algn="ctr">
+                      <a:solidFill>
+                        <a:srgbClr val="E2E8F0"/>
+                      </a:solidFill>
+                      <a:prstDash val="solid"/>
+                      <a:round/>
+                      <a:headEnd type="none" w="med" len="med"/>
+                      <a:tailEnd type="none" w="med" len="med"/>
+                    </a:lnR>
+                    <a:lnT w="6350" cap="flat" cmpd="sng" algn="ctr">
+                      <a:solidFill>
+                        <a:srgbClr val="E2E8F0"/>
+                      </a:solidFill>
+                      <a:prstDash val="solid"/>
+                      <a:round/>
+                      <a:headEnd type="none" w="med" len="med"/>
+                      <a:tailEnd type="none" w="med" len="med"/>
+                    </a:lnT>
+                    <a:lnB w="6350" cap="flat" cmpd="sng" algn="ctr">
+                      <a:solidFill>
+                        <a:srgbClr val="E2E8F0"/>
+                      </a:solidFill>
+                      <a:prstDash val="solid"/>
+                      <a:round/>
+                      <a:headEnd type="none" w="med" len="med"/>
+                      <a:tailEnd type="none" w="med" len="med"/>
+                    </a:lnB>
+                  </a:tcPr>
+                </a:tc>
+                <a:tc>
+                  <a:txBody>
+                    <a:bodyPr/>
+                    <a:lstStyle/>
+                    <a:p>
+                      <a:pPr algn="l" indent="0" marL="0">
+                        <a:buNone/>
+                      </a:pPr>
+                      <a:r>
+                        <a:rPr lang="en-US" sz="850" b="1" dirty="0">
+                          <a:solidFill>
+                            <a:srgbClr val="0B1220"/>
+                          </a:solidFill>
+                          <a:latin typeface="Aptos" pitchFamily="34" charset="0"/>
+                          <a:ea typeface="Aptos" pitchFamily="34" charset="-122"/>
+                          <a:cs typeface="Aptos" pitchFamily="34" charset="-120"/>
+                        </a:rPr>
+                        <a:t>Compliance - Policy, Guardrails</a:t>
+                      </a:r>
+                      <a:endParaRPr lang="en-US" sz="850" dirty="0">
+                        <a:latin typeface="Aptos" charset="0"/>
+                        <a:ea typeface="Aptos" charset="0"/>
+                        <a:cs typeface="Aptos" charset="0"/>
+                      </a:endParaRPr>
+                    </a:p>
+                  </a:txBody>
+                  <a:tcPr marL="91440" marR="91440" marT="45720" marB="45720" anchor="ctr">
+                    <a:lnL w="6350" cap="flat" cmpd="sng" algn="ctr">
+                      <a:solidFill>
+                        <a:srgbClr val="E2E8F0"/>
+                      </a:solidFill>
+                      <a:prstDash val="solid"/>
+                      <a:round/>
+                      <a:headEnd type="none" w="med" len="med"/>
+                      <a:tailEnd type="none" w="med" len="med"/>
+                    </a:lnL>
+                    <a:lnR w="6350" cap="flat" cmpd="sng" algn="ctr">
+                      <a:solidFill>
+                        <a:srgbClr val="E2E8F0"/>
+                      </a:solidFill>
+                      <a:prstDash val="solid"/>
+                      <a:round/>
+                      <a:headEnd type="none" w="med" len="med"/>
+                      <a:tailEnd type="none" w="med" len="med"/>
+                    </a:lnR>
+                    <a:lnT w="6350" cap="flat" cmpd="sng" algn="ctr">
+                      <a:solidFill>
+                        <a:srgbClr val="E2E8F0"/>
+                      </a:solidFill>
+                      <a:prstDash val="solid"/>
+                      <a:round/>
+                      <a:headEnd type="none" w="med" len="med"/>
+                      <a:tailEnd type="none" w="med" len="med"/>
+                    </a:lnT>
+                    <a:lnB w="6350" cap="flat" cmpd="sng" algn="ctr">
+                      <a:solidFill>
+                        <a:srgbClr val="E2E8F0"/>
+                      </a:solidFill>
+                      <a:prstDash val="solid"/>
+                      <a:round/>
+                      <a:headEnd type="none" w="med" len="med"/>
+                      <a:tailEnd type="none" w="med" len="med"/>
+                    </a:lnB>
+                  </a:tcPr>
+                </a:tc>
+                <a:tc>
+                  <a:txBody>
+                    <a:bodyPr/>
+                    <a:lstStyle/>
+                    <a:p>
+                      <a:pPr algn="l" indent="0" marL="0">
+                        <a:buNone/>
+                      </a:pPr>
+                      <a:r>
+                        <a:rPr lang="en-US" sz="850" dirty="0">
+                          <a:solidFill>
+                            <a:srgbClr val="334155"/>
+                          </a:solidFill>
+                          <a:latin typeface="Aptos" pitchFamily="34" charset="0"/>
+                          <a:ea typeface="Aptos" pitchFamily="34" charset="-122"/>
+                          <a:cs typeface="Aptos" pitchFamily="34" charset="-120"/>
+                        </a:rPr>
+                        <a:t>Chris Lekkas + Shivang Vora</a:t>
+                      </a:r>
+                      <a:endParaRPr lang="en-US" sz="850" dirty="0">
+                        <a:latin typeface="Aptos" charset="0"/>
+                        <a:ea typeface="Aptos" charset="0"/>
+                        <a:cs typeface="Aptos" charset="0"/>
+                      </a:endParaRPr>
+                    </a:p>
+                  </a:txBody>
+                  <a:tcPr marL="91440" marR="91440" marT="45720" marB="45720" anchor="ctr">
+                    <a:lnL w="6350" cap="flat" cmpd="sng" algn="ctr">
+                      <a:solidFill>
+                        <a:srgbClr val="E2E8F0"/>
+                      </a:solidFill>
+                      <a:prstDash val="solid"/>
+                      <a:round/>
+                      <a:headEnd type="none" w="med" len="med"/>
+                      <a:tailEnd type="none" w="med" len="med"/>
+                    </a:lnL>
+                    <a:lnR w="6350" cap="flat" cmpd="sng" algn="ctr">
+                      <a:solidFill>
+                        <a:srgbClr val="E2E8F0"/>
+                      </a:solidFill>
+                      <a:prstDash val="solid"/>
+                      <a:round/>
+                      <a:headEnd type="none" w="med" len="med"/>
+                      <a:tailEnd type="none" w="med" len="med"/>
+                    </a:lnR>
+                    <a:lnT w="6350" cap="flat" cmpd="sng" algn="ctr">
+                      <a:solidFill>
+                        <a:srgbClr val="E2E8F0"/>
+                      </a:solidFill>
+                      <a:prstDash val="solid"/>
+                      <a:round/>
+                      <a:headEnd type="none" w="med" len="med"/>
+                      <a:tailEnd type="none" w="med" len="med"/>
+                    </a:lnT>
+                    <a:lnB w="6350" cap="flat" cmpd="sng" algn="ctr">
+                      <a:solidFill>
+                        <a:srgbClr val="E2E8F0"/>
+                      </a:solidFill>
+                      <a:prstDash val="solid"/>
+                      <a:round/>
+                      <a:headEnd type="none" w="med" len="med"/>
+                      <a:tailEnd type="none" w="med" len="med"/>
+                    </a:lnB>
+                  </a:tcPr>
+                </a:tc>
+                <a:tc>
+                  <a:txBody>
+                    <a:bodyPr/>
+                    <a:lstStyle/>
+                    <a:p>
+                      <a:pPr algn="l" indent="0" marL="0">
+                        <a:buNone/>
+                      </a:pPr>
+                      <a:r>
+                        <a:rPr lang="en-US" sz="800" dirty="0">
+                          <a:solidFill>
+                            <a:srgbClr val="64748B"/>
+                          </a:solidFill>
+                          <a:latin typeface="Aptos" pitchFamily="34" charset="0"/>
+                          <a:ea typeface="Aptos" pitchFamily="34" charset="-122"/>
+                          <a:cs typeface="Aptos" pitchFamily="34" charset="-120"/>
+                        </a:rPr>
+                        <a:t>Guardrail + PHI-minimization matrix</a:t>
+                      </a:r>
+                      <a:endParaRPr lang="en-US" sz="800" dirty="0">
+                        <a:latin typeface="Aptos" charset="0"/>
+                        <a:ea typeface="Aptos" charset="0"/>
+                        <a:cs typeface="Aptos" charset="0"/>
+                      </a:endParaRPr>
+                    </a:p>
+                  </a:txBody>
+                  <a:tcPr marL="91440" marR="91440" marT="45720" marB="45720" anchor="ctr">
+                    <a:lnL w="6350" cap="flat" cmpd="sng" algn="ctr">
+                      <a:solidFill>
+                        <a:srgbClr val="E2E8F0"/>
+                      </a:solidFill>
+                      <a:prstDash val="solid"/>
+                      <a:round/>
+                      <a:headEnd type="none" w="med" len="med"/>
+                      <a:tailEnd type="none" w="med" len="med"/>
+                    </a:lnL>
+                    <a:lnR w="6350" cap="flat" cmpd="sng" algn="ctr">
+                      <a:solidFill>
+                        <a:srgbClr val="E2E8F0"/>
+                      </a:solidFill>
+                      <a:prstDash val="solid"/>
+                      <a:round/>
+                      <a:headEnd type="none" w="med" len="med"/>
+                      <a:tailEnd type="none" w="med" len="med"/>
+                    </a:lnR>
+                    <a:lnT w="6350" cap="flat" cmpd="sng" algn="ctr">
+                      <a:solidFill>
+                        <a:srgbClr val="E2E8F0"/>
+                      </a:solidFill>
+                      <a:prstDash val="solid"/>
+                      <a:round/>
+                      <a:headEnd type="none" w="med" len="med"/>
+                      <a:tailEnd type="none" w="med" len="med"/>
+                    </a:lnT>
+                    <a:lnB w="6350" cap="flat" cmpd="sng" algn="ctr">
+                      <a:solidFill>
+                        <a:srgbClr val="E2E8F0"/>
+                      </a:solidFill>
+                      <a:prstDash val="solid"/>
+                      <a:round/>
+                      <a:headEnd type="none" w="med" len="med"/>
+                      <a:tailEnd type="none" w="med" len="med"/>
+                    </a:lnB>
+                  </a:tcPr>
+                </a:tc>
+              </a:tr>
+              <a:tr h="292608">
+                <a:tc gridSpan="4">
+                  <a:txBody>
+                    <a:bodyPr/>
+                    <a:lstStyle/>
+                    <a:p>
+                      <a:pPr algn="l" indent="0" marL="0">
+                        <a:buNone/>
+                      </a:pPr>
+                      <a:r>
+                        <a:rPr lang="en-US" sz="950" b="1" dirty="0">
+                          <a:solidFill>
+                            <a:srgbClr val="FFFFFF"/>
+                          </a:solidFill>
+                          <a:latin typeface="Aptos" pitchFamily="34" charset="0"/>
+                          <a:ea typeface="Aptos" pitchFamily="34" charset="-122"/>
+                          <a:cs typeface="Aptos" pitchFamily="34" charset="-120"/>
+                        </a:rPr>
+                        <a:t>DAY 2</a:t>
+                      </a:r>
+                      <a:endParaRPr lang="en-US" sz="950" dirty="0">
+                        <a:latin typeface="Aptos" charset="0"/>
+                        <a:ea typeface="Aptos" charset="0"/>
+                        <a:cs typeface="Aptos" charset="0"/>
+                      </a:endParaRPr>
+                    </a:p>
+                  </a:txBody>
+                  <a:tcPr marL="91440" marR="91440" marT="45720" marB="45720" anchor="ctr">
+                    <a:lnL w="6350" cap="flat" cmpd="sng" algn="ctr">
+                      <a:solidFill>
+                        <a:srgbClr val="E2E8F0"/>
+                      </a:solidFill>
+                      <a:prstDash val="solid"/>
+                      <a:round/>
+                      <a:headEnd type="none" w="med" len="med"/>
+                      <a:tailEnd type="none" w="med" len="med"/>
+                    </a:lnL>
+                    <a:lnR w="6350" cap="flat" cmpd="sng" algn="ctr">
+                      <a:solidFill>
+                        <a:srgbClr val="E2E8F0"/>
+                      </a:solidFill>
+                      <a:prstDash val="solid"/>
+                      <a:round/>
+                      <a:headEnd type="none" w="med" len="med"/>
+                      <a:tailEnd type="none" w="med" len="med"/>
+                    </a:lnR>
+                    <a:lnT w="6350" cap="flat" cmpd="sng" algn="ctr">
+                      <a:solidFill>
+                        <a:srgbClr val="E2E8F0"/>
+                      </a:solidFill>
+                      <a:prstDash val="solid"/>
+                      <a:round/>
+                      <a:headEnd type="none" w="med" len="med"/>
+                      <a:tailEnd type="none" w="med" len="med"/>
+                    </a:lnT>
+                    <a:lnB w="6350" cap="flat" cmpd="sng" algn="ctr">
+                      <a:solidFill>
+                        <a:srgbClr val="E2E8F0"/>
+                      </a:solidFill>
+                      <a:prstDash val="solid"/>
+                      <a:round/>
+                      <a:headEnd type="none" w="med" len="med"/>
+                      <a:tailEnd type="none" w="med" len="med"/>
+                    </a:lnB>
+                    <a:solidFill>
+                      <a:srgbClr val="0B1220"/>
+                    </a:solidFill>
+                  </a:tcPr>
+                </a:tc>
+                <a:tc hMerge="1">
+                  <a:tcPr/>
+                </a:tc>
+                <a:tc hMerge="1">
+                  <a:tcPr/>
+                </a:tc>
+                <a:tc hMerge="1">
+                  <a:tcPr/>
+                </a:tc>
+              </a:tr>
+              <a:tr h="292608">
+                <a:tc>
+                  <a:txBody>
+                    <a:bodyPr/>
+                    <a:lstStyle/>
+                    <a:p>
+                      <a:pPr algn="l" indent="0" marL="0">
+                        <a:buNone/>
+                      </a:pPr>
+                      <a:r>
+                        <a:rPr lang="en-US" sz="850" dirty="0">
+                          <a:solidFill>
+                            <a:srgbClr val="334155"/>
+                          </a:solidFill>
+                          <a:latin typeface="Aptos" pitchFamily="34" charset="0"/>
+                          <a:ea typeface="Aptos" pitchFamily="34" charset="-122"/>
+                          <a:cs typeface="Aptos" pitchFamily="34" charset="-120"/>
+                        </a:rPr>
+                        <a:t>TBD</a:t>
+                      </a:r>
+                      <a:endParaRPr lang="en-US" sz="850" dirty="0">
+                        <a:latin typeface="Aptos" charset="0"/>
+                        <a:ea typeface="Aptos" charset="0"/>
+                        <a:cs typeface="Aptos" charset="0"/>
+                      </a:endParaRPr>
+                    </a:p>
+                  </a:txBody>
+                  <a:tcPr marL="91440" marR="91440" marT="45720" marB="45720" anchor="ctr">
+                    <a:lnL w="6350" cap="flat" cmpd="sng" algn="ctr">
+                      <a:solidFill>
+                        <a:srgbClr val="E2E8F0"/>
+                      </a:solidFill>
+                      <a:prstDash val="solid"/>
+                      <a:round/>
+                      <a:headEnd type="none" w="med" len="med"/>
+                      <a:tailEnd type="none" w="med" len="med"/>
+                    </a:lnL>
+                    <a:lnR w="6350" cap="flat" cmpd="sng" algn="ctr">
+                      <a:solidFill>
+                        <a:srgbClr val="E2E8F0"/>
+                      </a:solidFill>
+                      <a:prstDash val="solid"/>
+                      <a:round/>
+                      <a:headEnd type="none" w="med" len="med"/>
+                      <a:tailEnd type="none" w="med" len="med"/>
+                    </a:lnR>
+                    <a:lnT w="6350" cap="flat" cmpd="sng" algn="ctr">
+                      <a:solidFill>
+                        <a:srgbClr val="E2E8F0"/>
+                      </a:solidFill>
+                      <a:prstDash val="solid"/>
+                      <a:round/>
+                      <a:headEnd type="none" w="med" len="med"/>
+                      <a:tailEnd type="none" w="med" len="med"/>
+                    </a:lnT>
+                    <a:lnB w="6350" cap="flat" cmpd="sng" algn="ctr">
+                      <a:solidFill>
+                        <a:srgbClr val="E2E8F0"/>
+                      </a:solidFill>
+                      <a:prstDash val="solid"/>
+                      <a:round/>
+                      <a:headEnd type="none" w="med" len="med"/>
+                      <a:tailEnd type="none" w="med" len="med"/>
+                    </a:lnB>
+                  </a:tcPr>
+                </a:tc>
+                <a:tc>
+                  <a:txBody>
+                    <a:bodyPr/>
+                    <a:lstStyle/>
+                    <a:p>
+                      <a:pPr algn="l" indent="0" marL="0">
+                        <a:buNone/>
+                      </a:pPr>
+                      <a:r>
+                        <a:rPr lang="en-US" sz="850" b="1" dirty="0">
+                          <a:solidFill>
+                            <a:srgbClr val="0B1220"/>
+                          </a:solidFill>
+                          <a:latin typeface="Aptos" pitchFamily="34" charset="0"/>
+                          <a:ea typeface="Aptos" pitchFamily="34" charset="-122"/>
+                          <a:cs typeface="Aptos" pitchFamily="34" charset="-120"/>
+                        </a:rPr>
+                        <a:t>Foundry Observability - LAW + Application Insights</a:t>
+                      </a:r>
+                      <a:endParaRPr lang="en-US" sz="850" dirty="0">
+                        <a:latin typeface="Aptos" charset="0"/>
+                        <a:ea typeface="Aptos" charset="0"/>
+                        <a:cs typeface="Aptos" charset="0"/>
+                      </a:endParaRPr>
+                    </a:p>
+                  </a:txBody>
+                  <a:tcPr marL="91440" marR="91440" marT="45720" marB="45720" anchor="ctr">
+                    <a:lnL w="6350" cap="flat" cmpd="sng" algn="ctr">
+                      <a:solidFill>
+                        <a:srgbClr val="E2E8F0"/>
+                      </a:solidFill>
+                      <a:prstDash val="solid"/>
+                      <a:round/>
+                      <a:headEnd type="none" w="med" len="med"/>
+                      <a:tailEnd type="none" w="med" len="med"/>
+                    </a:lnL>
+                    <a:lnR w="6350" cap="flat" cmpd="sng" algn="ctr">
+                      <a:solidFill>
+                        <a:srgbClr val="E2E8F0"/>
+                      </a:solidFill>
+                      <a:prstDash val="solid"/>
+                      <a:round/>
+                      <a:headEnd type="none" w="med" len="med"/>
+                      <a:tailEnd type="none" w="med" len="med"/>
+                    </a:lnR>
+                    <a:lnT w="6350" cap="flat" cmpd="sng" algn="ctr">
+                      <a:solidFill>
+                        <a:srgbClr val="E2E8F0"/>
+                      </a:solidFill>
+                      <a:prstDash val="solid"/>
+                      <a:round/>
+                      <a:headEnd type="none" w="med" len="med"/>
+                      <a:tailEnd type="none" w="med" len="med"/>
+                    </a:lnT>
+                    <a:lnB w="6350" cap="flat" cmpd="sng" algn="ctr">
+                      <a:solidFill>
+                        <a:srgbClr val="E2E8F0"/>
+                      </a:solidFill>
+                      <a:prstDash val="solid"/>
+                      <a:round/>
+                      <a:headEnd type="none" w="med" len="med"/>
+                      <a:tailEnd type="none" w="med" len="med"/>
+                    </a:lnB>
+                  </a:tcPr>
+                </a:tc>
+                <a:tc>
+                  <a:txBody>
+                    <a:bodyPr/>
+                    <a:lstStyle/>
+                    <a:p>
+                      <a:pPr algn="l" indent="0" marL="0">
+                        <a:buNone/>
+                      </a:pPr>
+                      <a:r>
+                        <a:rPr lang="en-US" sz="850" dirty="0">
+                          <a:solidFill>
+                            <a:srgbClr val="334155"/>
+                          </a:solidFill>
+                          <a:latin typeface="Aptos" pitchFamily="34" charset="0"/>
+                          <a:ea typeface="Aptos" pitchFamily="34" charset="-122"/>
+                          <a:cs typeface="Aptos" pitchFamily="34" charset="-120"/>
+                        </a:rPr>
+                        <a:t>Lee Schuenemeyer</a:t>
+                      </a:r>
+                      <a:endParaRPr lang="en-US" sz="850" dirty="0">
+                        <a:latin typeface="Aptos" charset="0"/>
+                        <a:ea typeface="Aptos" charset="0"/>
+                        <a:cs typeface="Aptos" charset="0"/>
+                      </a:endParaRPr>
+                    </a:p>
+                  </a:txBody>
+                  <a:tcPr marL="91440" marR="91440" marT="45720" marB="45720" anchor="ctr">
+                    <a:lnL w="6350" cap="flat" cmpd="sng" algn="ctr">
+                      <a:solidFill>
+                        <a:srgbClr val="E2E8F0"/>
+                      </a:solidFill>
+                      <a:prstDash val="solid"/>
+                      <a:round/>
+                      <a:headEnd type="none" w="med" len="med"/>
+                      <a:tailEnd type="none" w="med" len="med"/>
+                    </a:lnL>
+                    <a:lnR w="6350" cap="flat" cmpd="sng" algn="ctr">
+                      <a:solidFill>
+                        <a:srgbClr val="E2E8F0"/>
+                      </a:solidFill>
+                      <a:prstDash val="solid"/>
+                      <a:round/>
+                      <a:headEnd type="none" w="med" len="med"/>
+                      <a:tailEnd type="none" w="med" len="med"/>
+                    </a:lnR>
+                    <a:lnT w="6350" cap="flat" cmpd="sng" algn="ctr">
+                      <a:solidFill>
+                        <a:srgbClr val="E2E8F0"/>
+                      </a:solidFill>
+                      <a:prstDash val="solid"/>
+                      <a:round/>
+                      <a:headEnd type="none" w="med" len="med"/>
+                      <a:tailEnd type="none" w="med" len="med"/>
+                    </a:lnT>
+                    <a:lnB w="6350" cap="flat" cmpd="sng" algn="ctr">
+                      <a:solidFill>
+                        <a:srgbClr val="E2E8F0"/>
+                      </a:solidFill>
+                      <a:prstDash val="solid"/>
+                      <a:round/>
+                      <a:headEnd type="none" w="med" len="med"/>
+                      <a:tailEnd type="none" w="med" len="med"/>
+                    </a:lnB>
+                  </a:tcPr>
+                </a:tc>
+                <a:tc>
+                  <a:txBody>
+                    <a:bodyPr/>
+                    <a:lstStyle/>
+                    <a:p>
+                      <a:pPr algn="l" indent="0" marL="0">
+                        <a:buNone/>
+                      </a:pPr>
+                      <a:endParaRPr lang="en-US" sz="800" dirty="0">
+                        <a:latin typeface="Aptos" charset="0"/>
+                        <a:ea typeface="Aptos" charset="0"/>
+                        <a:cs typeface="Aptos" charset="0"/>
+                      </a:endParaRPr>
+                    </a:p>
+                  </a:txBody>
+                  <a:tcPr marL="91440" marR="91440" marT="45720" marB="45720" anchor="ctr">
+                    <a:lnL w="6350" cap="flat" cmpd="sng" algn="ctr">
+                      <a:solidFill>
+                        <a:srgbClr val="E2E8F0"/>
+                      </a:solidFill>
+                      <a:prstDash val="solid"/>
+                      <a:round/>
+                      <a:headEnd type="none" w="med" len="med"/>
+                      <a:tailEnd type="none" w="med" len="med"/>
+                    </a:lnL>
+                    <a:lnR w="6350" cap="flat" cmpd="sng" algn="ctr">
+                      <a:solidFill>
+                        <a:srgbClr val="E2E8F0"/>
+                      </a:solidFill>
+                      <a:prstDash val="solid"/>
+                      <a:round/>
+                      <a:headEnd type="none" w="med" len="med"/>
+                      <a:tailEnd type="none" w="med" len="med"/>
+                    </a:lnR>
+                    <a:lnT w="6350" cap="flat" cmpd="sng" algn="ctr">
+                      <a:solidFill>
+                        <a:srgbClr val="E2E8F0"/>
+                      </a:solidFill>
+                      <a:prstDash val="solid"/>
+                      <a:round/>
+                      <a:headEnd type="none" w="med" len="med"/>
+                      <a:tailEnd type="none" w="med" len="med"/>
+                    </a:lnT>
+                    <a:lnB w="6350" cap="flat" cmpd="sng" algn="ctr">
+                      <a:solidFill>
+                        <a:srgbClr val="E2E8F0"/>
+                      </a:solidFill>
+                      <a:prstDash val="solid"/>
+                      <a:round/>
+                      <a:headEnd type="none" w="med" len="med"/>
+                      <a:tailEnd type="none" w="med" len="med"/>
+                    </a:lnB>
+                  </a:tcPr>
+                </a:tc>
+              </a:tr>
+              <a:tr h="292608">
+                <a:tc>
+                  <a:txBody>
+                    <a:bodyPr/>
+                    <a:lstStyle/>
+                    <a:p>
+                      <a:pPr algn="l" indent="0" marL="0">
+                        <a:buNone/>
+                      </a:pPr>
+                      <a:r>
+                        <a:rPr lang="en-US" sz="850" dirty="0">
+                          <a:solidFill>
+                            <a:srgbClr val="334155"/>
+                          </a:solidFill>
+                          <a:latin typeface="Aptos" pitchFamily="34" charset="0"/>
+                          <a:ea typeface="Aptos" pitchFamily="34" charset="-122"/>
+                          <a:cs typeface="Aptos" pitchFamily="34" charset="-120"/>
+                        </a:rPr>
+                        <a:t>TBD</a:t>
+                      </a:r>
+                      <a:endParaRPr lang="en-US" sz="850" dirty="0">
+                        <a:latin typeface="Aptos" charset="0"/>
+                        <a:ea typeface="Aptos" charset="0"/>
+                        <a:cs typeface="Aptos" charset="0"/>
+                      </a:endParaRPr>
+                    </a:p>
+                  </a:txBody>
+                  <a:tcPr marL="91440" marR="91440" marT="45720" marB="45720" anchor="ctr">
+                    <a:lnL w="6350" cap="flat" cmpd="sng" algn="ctr">
+                      <a:solidFill>
+                        <a:srgbClr val="E2E8F0"/>
+                      </a:solidFill>
+                      <a:prstDash val="solid"/>
+                      <a:round/>
+                      <a:headEnd type="none" w="med" len="med"/>
+                      <a:tailEnd type="none" w="med" len="med"/>
+                    </a:lnL>
+                    <a:lnR w="6350" cap="flat" cmpd="sng" algn="ctr">
+                      <a:solidFill>
+                        <a:srgbClr val="E2E8F0"/>
+                      </a:solidFill>
+                      <a:prstDash val="solid"/>
+                      <a:round/>
+                      <a:headEnd type="none" w="med" len="med"/>
+                      <a:tailEnd type="none" w="med" len="med"/>
+                    </a:lnR>
+                    <a:lnT w="6350" cap="flat" cmpd="sng" algn="ctr">
+                      <a:solidFill>
+                        <a:srgbClr val="E2E8F0"/>
+                      </a:solidFill>
+                      <a:prstDash val="solid"/>
+                      <a:round/>
+                      <a:headEnd type="none" w="med" len="med"/>
+                      <a:tailEnd type="none" w="med" len="med"/>
+                    </a:lnT>
+                    <a:lnB w="6350" cap="flat" cmpd="sng" algn="ctr">
+                      <a:solidFill>
+                        <a:srgbClr val="E2E8F0"/>
+                      </a:solidFill>
+                      <a:prstDash val="solid"/>
+                      <a:round/>
+                      <a:headEnd type="none" w="med" len="med"/>
+                      <a:tailEnd type="none" w="med" len="med"/>
+                    </a:lnB>
+                  </a:tcPr>
+                </a:tc>
+                <a:tc>
+                  <a:txBody>
+                    <a:bodyPr/>
+                    <a:lstStyle/>
+                    <a:p>
+                      <a:pPr algn="l" indent="0" marL="0">
+                        <a:buNone/>
+                      </a:pPr>
+                      <a:r>
+                        <a:rPr lang="en-US" sz="850" b="1" dirty="0">
+                          <a:solidFill>
+                            <a:srgbClr val="0B1220"/>
+                          </a:solidFill>
+                          <a:latin typeface="Aptos" pitchFamily="34" charset="0"/>
+                          <a:ea typeface="Aptos" pitchFamily="34" charset="-122"/>
+                          <a:cs typeface="Aptos" pitchFamily="34" charset="-120"/>
+                        </a:rPr>
+                        <a:t>Product team call - HA &amp; Observability</a:t>
+                      </a:r>
+                      <a:endParaRPr lang="en-US" sz="850" dirty="0">
+                        <a:latin typeface="Aptos" charset="0"/>
+                        <a:ea typeface="Aptos" charset="0"/>
+                        <a:cs typeface="Aptos" charset="0"/>
+                      </a:endParaRPr>
+                    </a:p>
+                  </a:txBody>
+                  <a:tcPr marL="91440" marR="91440" marT="45720" marB="45720" anchor="ctr">
+                    <a:lnL w="6350" cap="flat" cmpd="sng" algn="ctr">
+                      <a:solidFill>
+                        <a:srgbClr val="E2E8F0"/>
+                      </a:solidFill>
+                      <a:prstDash val="solid"/>
+                      <a:round/>
+                      <a:headEnd type="none" w="med" len="med"/>
+                      <a:tailEnd type="none" w="med" len="med"/>
+                    </a:lnL>
+                    <a:lnR w="6350" cap="flat" cmpd="sng" algn="ctr">
+                      <a:solidFill>
+                        <a:srgbClr val="E2E8F0"/>
+                      </a:solidFill>
+                      <a:prstDash val="solid"/>
+                      <a:round/>
+                      <a:headEnd type="none" w="med" len="med"/>
+                      <a:tailEnd type="none" w="med" len="med"/>
+                    </a:lnR>
+                    <a:lnT w="6350" cap="flat" cmpd="sng" algn="ctr">
+                      <a:solidFill>
+                        <a:srgbClr val="E2E8F0"/>
+                      </a:solidFill>
+                      <a:prstDash val="solid"/>
+                      <a:round/>
+                      <a:headEnd type="none" w="med" len="med"/>
+                      <a:tailEnd type="none" w="med" len="med"/>
+                    </a:lnT>
+                    <a:lnB w="6350" cap="flat" cmpd="sng" algn="ctr">
+                      <a:solidFill>
+                        <a:srgbClr val="E2E8F0"/>
+                      </a:solidFill>
+                      <a:prstDash val="solid"/>
+                      <a:round/>
+                      <a:headEnd type="none" w="med" len="med"/>
+                      <a:tailEnd type="none" w="med" len="med"/>
+                    </a:lnB>
+                  </a:tcPr>
+                </a:tc>
+                <a:tc>
+                  <a:txBody>
+                    <a:bodyPr/>
+                    <a:lstStyle/>
+                    <a:p>
+                      <a:pPr algn="l" indent="0" marL="0">
+                        <a:buNone/>
+                      </a:pPr>
+                      <a:r>
+                        <a:rPr lang="en-US" sz="850" dirty="0">
+                          <a:solidFill>
+                            <a:srgbClr val="334155"/>
+                          </a:solidFill>
+                          <a:latin typeface="Aptos" pitchFamily="34" charset="0"/>
+                          <a:ea typeface="Aptos" pitchFamily="34" charset="-122"/>
+                          <a:cs typeface="Aptos" pitchFamily="34" charset="-120"/>
+                        </a:rPr>
+                        <a:t>TBD</a:t>
+                      </a:r>
+                      <a:endParaRPr lang="en-US" sz="850" dirty="0">
+                        <a:latin typeface="Aptos" charset="0"/>
+                        <a:ea typeface="Aptos" charset="0"/>
+                        <a:cs typeface="Aptos" charset="0"/>
+                      </a:endParaRPr>
+                    </a:p>
+                  </a:txBody>
+                  <a:tcPr marL="91440" marR="91440" marT="45720" marB="45720" anchor="ctr">
+                    <a:lnL w="6350" cap="flat" cmpd="sng" algn="ctr">
+                      <a:solidFill>
+                        <a:srgbClr val="E2E8F0"/>
+                      </a:solidFill>
+                      <a:prstDash val="solid"/>
+                      <a:round/>
+                      <a:headEnd type="none" w="med" len="med"/>
+                      <a:tailEnd type="none" w="med" len="med"/>
+                    </a:lnL>
+                    <a:lnR w="6350" cap="flat" cmpd="sng" algn="ctr">
+                      <a:solidFill>
+                        <a:srgbClr val="E2E8F0"/>
+                      </a:solidFill>
+                      <a:prstDash val="solid"/>
+                      <a:round/>
+                      <a:headEnd type="none" w="med" len="med"/>
+                      <a:tailEnd type="none" w="med" len="med"/>
+                    </a:lnR>
+                    <a:lnT w="6350" cap="flat" cmpd="sng" algn="ctr">
+                      <a:solidFill>
+                        <a:srgbClr val="E2E8F0"/>
+                      </a:solidFill>
+                      <a:prstDash val="solid"/>
+                      <a:round/>
+                      <a:headEnd type="none" w="med" len="med"/>
+                      <a:tailEnd type="none" w="med" len="med"/>
+                    </a:lnT>
+                    <a:lnB w="6350" cap="flat" cmpd="sng" algn="ctr">
+                      <a:solidFill>
+                        <a:srgbClr val="E2E8F0"/>
+                      </a:solidFill>
+                      <a:prstDash val="solid"/>
+                      <a:round/>
+                      <a:headEnd type="none" w="med" len="med"/>
+                      <a:tailEnd type="none" w="med" len="med"/>
+                    </a:lnB>
+                  </a:tcPr>
+                </a:tc>
+                <a:tc>
+                  <a:txBody>
+                    <a:bodyPr/>
+                    <a:lstStyle/>
+                    <a:p>
+                      <a:pPr algn="l" indent="0" marL="0">
+                        <a:buNone/>
+                      </a:pPr>
+                      <a:endParaRPr lang="en-US" sz="800" dirty="0">
+                        <a:latin typeface="Aptos" charset="0"/>
+                        <a:ea typeface="Aptos" charset="0"/>
+                        <a:cs typeface="Aptos" charset="0"/>
+                      </a:endParaRPr>
+                    </a:p>
+                  </a:txBody>
+                  <a:tcPr marL="91440" marR="91440" marT="45720" marB="45720" anchor="ctr">
+                    <a:lnL w="6350" cap="flat" cmpd="sng" algn="ctr">
+                      <a:solidFill>
+                        <a:srgbClr val="E2E8F0"/>
+                      </a:solidFill>
+                      <a:prstDash val="solid"/>
+                      <a:round/>
+                      <a:headEnd type="none" w="med" len="med"/>
+                      <a:tailEnd type="none" w="med" len="med"/>
+                    </a:lnL>
+                    <a:lnR w="6350" cap="flat" cmpd="sng" algn="ctr">
+                      <a:solidFill>
+                        <a:srgbClr val="E2E8F0"/>
+                      </a:solidFill>
+                      <a:prstDash val="solid"/>
+                      <a:round/>
+                      <a:headEnd type="none" w="med" len="med"/>
+                      <a:tailEnd type="none" w="med" len="med"/>
+                    </a:lnR>
+                    <a:lnT w="6350" cap="flat" cmpd="sng" algn="ctr">
+                      <a:solidFill>
+                        <a:srgbClr val="E2E8F0"/>
+                      </a:solidFill>
+                      <a:prstDash val="solid"/>
+                      <a:round/>
+                      <a:headEnd type="none" w="med" len="med"/>
+                      <a:tailEnd type="none" w="med" len="med"/>
+                    </a:lnT>
+                    <a:lnB w="6350" cap="flat" cmpd="sng" algn="ctr">
+                      <a:solidFill>
+                        <a:srgbClr val="E2E8F0"/>
+                      </a:solidFill>
+                      <a:prstDash val="solid"/>
+                      <a:round/>
+                      <a:headEnd type="none" w="med" len="med"/>
+                      <a:tailEnd type="none" w="med" len="med"/>
+                    </a:lnB>
+                  </a:tcPr>
+                </a:tc>
+              </a:tr>
+              <a:tr h="292608">
+                <a:tc>
+                  <a:txBody>
+                    <a:bodyPr/>
+                    <a:lstStyle/>
+                    <a:p>
+                      <a:pPr algn="l" indent="0" marL="0">
+                        <a:buNone/>
+                      </a:pPr>
+                      <a:r>
+                        <a:rPr lang="en-US" sz="850" dirty="0">
+                          <a:solidFill>
+                            <a:srgbClr val="334155"/>
+                          </a:solidFill>
+                          <a:latin typeface="Aptos" pitchFamily="34" charset="0"/>
+                          <a:ea typeface="Aptos" pitchFamily="34" charset="-122"/>
+                          <a:cs typeface="Aptos" pitchFamily="34" charset="-120"/>
+                        </a:rPr>
+                        <a:t>TBD</a:t>
+                      </a:r>
+                      <a:endParaRPr lang="en-US" sz="850" dirty="0">
+                        <a:latin typeface="Aptos" charset="0"/>
+                        <a:ea typeface="Aptos" charset="0"/>
+                        <a:cs typeface="Aptos" charset="0"/>
+                      </a:endParaRPr>
+                    </a:p>
+                  </a:txBody>
+                  <a:tcPr marL="91440" marR="91440" marT="45720" marB="45720" anchor="ctr">
+                    <a:lnL w="6350" cap="flat" cmpd="sng" algn="ctr">
+                      <a:solidFill>
+                        <a:srgbClr val="E2E8F0"/>
+                      </a:solidFill>
+                      <a:prstDash val="solid"/>
+                      <a:round/>
+                      <a:headEnd type="none" w="med" len="med"/>
+                      <a:tailEnd type="none" w="med" len="med"/>
+                    </a:lnL>
+                    <a:lnR w="6350" cap="flat" cmpd="sng" algn="ctr">
+                      <a:solidFill>
+                        <a:srgbClr val="E2E8F0"/>
+                      </a:solidFill>
+                      <a:prstDash val="solid"/>
+                      <a:round/>
+                      <a:headEnd type="none" w="med" len="med"/>
+                      <a:tailEnd type="none" w="med" len="med"/>
+                    </a:lnR>
+                    <a:lnT w="6350" cap="flat" cmpd="sng" algn="ctr">
+                      <a:solidFill>
+                        <a:srgbClr val="E2E8F0"/>
+                      </a:solidFill>
+                      <a:prstDash val="solid"/>
+                      <a:round/>
+                      <a:headEnd type="none" w="med" len="med"/>
+                      <a:tailEnd type="none" w="med" len="med"/>
+                    </a:lnT>
+                    <a:lnB w="6350" cap="flat" cmpd="sng" algn="ctr">
+                      <a:solidFill>
+                        <a:srgbClr val="E2E8F0"/>
+                      </a:solidFill>
+                      <a:prstDash val="solid"/>
+                      <a:round/>
+                      <a:headEnd type="none" w="med" len="med"/>
+                      <a:tailEnd type="none" w="med" len="med"/>
+                    </a:lnB>
+                  </a:tcPr>
+                </a:tc>
+                <a:tc>
+                  <a:txBody>
+                    <a:bodyPr/>
+                    <a:lstStyle/>
+                    <a:p>
+                      <a:pPr algn="l" indent="0" marL="0">
+                        <a:buNone/>
+                      </a:pPr>
+                      <a:r>
+                        <a:rPr lang="en-US" sz="850" b="1" dirty="0">
+                          <a:solidFill>
+                            <a:srgbClr val="0B1220"/>
+                          </a:solidFill>
+                          <a:latin typeface="Aptos" pitchFamily="34" charset="0"/>
+                          <a:ea typeface="Aptos" pitchFamily="34" charset="-122"/>
+                          <a:cs typeface="Aptos" pitchFamily="34" charset="-120"/>
+                        </a:rPr>
+                        <a:t>SRE Agent deep dive</a:t>
+                      </a:r>
+                      <a:endParaRPr lang="en-US" sz="850" dirty="0">
+                        <a:latin typeface="Aptos" charset="0"/>
+                        <a:ea typeface="Aptos" charset="0"/>
+                        <a:cs typeface="Aptos" charset="0"/>
+                      </a:endParaRPr>
+                    </a:p>
+                  </a:txBody>
+                  <a:tcPr marL="91440" marR="91440" marT="45720" marB="45720" anchor="ctr">
+                    <a:lnL w="6350" cap="flat" cmpd="sng" algn="ctr">
+                      <a:solidFill>
+                        <a:srgbClr val="E2E8F0"/>
+                      </a:solidFill>
+                      <a:prstDash val="solid"/>
+                      <a:round/>
+                      <a:headEnd type="none" w="med" len="med"/>
+                      <a:tailEnd type="none" w="med" len="med"/>
+                    </a:lnL>
+                    <a:lnR w="6350" cap="flat" cmpd="sng" algn="ctr">
+                      <a:solidFill>
+                        <a:srgbClr val="E2E8F0"/>
+                      </a:solidFill>
+                      <a:prstDash val="solid"/>
+                      <a:round/>
+                      <a:headEnd type="none" w="med" len="med"/>
+                      <a:tailEnd type="none" w="med" len="med"/>
+                    </a:lnR>
+                    <a:lnT w="6350" cap="flat" cmpd="sng" algn="ctr">
+                      <a:solidFill>
+                        <a:srgbClr val="E2E8F0"/>
+                      </a:solidFill>
+                      <a:prstDash val="solid"/>
+                      <a:round/>
+                      <a:headEnd type="none" w="med" len="med"/>
+                      <a:tailEnd type="none" w="med" len="med"/>
+                    </a:lnT>
+                    <a:lnB w="6350" cap="flat" cmpd="sng" algn="ctr">
+                      <a:solidFill>
+                        <a:srgbClr val="E2E8F0"/>
+                      </a:solidFill>
+                      <a:prstDash val="solid"/>
+                      <a:round/>
+                      <a:headEnd type="none" w="med" len="med"/>
+                      <a:tailEnd type="none" w="med" len="med"/>
+                    </a:lnB>
+                  </a:tcPr>
+                </a:tc>
+                <a:tc>
+                  <a:txBody>
+                    <a:bodyPr/>
+                    <a:lstStyle/>
+                    <a:p>
+                      <a:pPr algn="l" indent="0" marL="0">
+                        <a:buNone/>
+                      </a:pPr>
+                      <a:r>
+                        <a:rPr lang="en-US" sz="850" dirty="0">
+                          <a:solidFill>
+                            <a:srgbClr val="334155"/>
+                          </a:solidFill>
+                          <a:latin typeface="Aptos" pitchFamily="34" charset="0"/>
+                          <a:ea typeface="Aptos" pitchFamily="34" charset="-122"/>
+                          <a:cs typeface="Aptos" pitchFamily="34" charset="-120"/>
+                        </a:rPr>
+                        <a:t>TBD</a:t>
+                      </a:r>
+                      <a:endParaRPr lang="en-US" sz="850" dirty="0">
+                        <a:latin typeface="Aptos" charset="0"/>
+                        <a:ea typeface="Aptos" charset="0"/>
+                        <a:cs typeface="Aptos" charset="0"/>
+                      </a:endParaRPr>
+                    </a:p>
+                  </a:txBody>
+                  <a:tcPr marL="91440" marR="91440" marT="45720" marB="45720" anchor="ctr">
+                    <a:lnL w="6350" cap="flat" cmpd="sng" algn="ctr">
+                      <a:solidFill>
+                        <a:srgbClr val="E2E8F0"/>
+                      </a:solidFill>
+                      <a:prstDash val="solid"/>
+                      <a:round/>
+                      <a:headEnd type="none" w="med" len="med"/>
+                      <a:tailEnd type="none" w="med" len="med"/>
+                    </a:lnL>
+                    <a:lnR w="6350" cap="flat" cmpd="sng" algn="ctr">
+                      <a:solidFill>
+                        <a:srgbClr val="E2E8F0"/>
+                      </a:solidFill>
+                      <a:prstDash val="solid"/>
+                      <a:round/>
+                      <a:headEnd type="none" w="med" len="med"/>
+                      <a:tailEnd type="none" w="med" len="med"/>
+                    </a:lnR>
+                    <a:lnT w="6350" cap="flat" cmpd="sng" algn="ctr">
+                      <a:solidFill>
+                        <a:srgbClr val="E2E8F0"/>
+                      </a:solidFill>
+                      <a:prstDash val="solid"/>
+                      <a:round/>
+                      <a:headEnd type="none" w="med" len="med"/>
+                      <a:tailEnd type="none" w="med" len="med"/>
+                    </a:lnT>
+                    <a:lnB w="6350" cap="flat" cmpd="sng" algn="ctr">
+                      <a:solidFill>
+                        <a:srgbClr val="E2E8F0"/>
+                      </a:solidFill>
+                      <a:prstDash val="solid"/>
+                      <a:round/>
+                      <a:headEnd type="none" w="med" len="med"/>
+                      <a:tailEnd type="none" w="med" len="med"/>
+                    </a:lnB>
+                  </a:tcPr>
+                </a:tc>
+                <a:tc>
+                  <a:txBody>
+                    <a:bodyPr/>
+                    <a:lstStyle/>
+                    <a:p>
+                      <a:pPr algn="l" indent="0" marL="0">
+                        <a:buNone/>
+                      </a:pPr>
+                      <a:endParaRPr lang="en-US" sz="800" dirty="0">
+                        <a:latin typeface="Aptos" charset="0"/>
+                        <a:ea typeface="Aptos" charset="0"/>
+                        <a:cs typeface="Aptos" charset="0"/>
+                      </a:endParaRPr>
+                    </a:p>
+                  </a:txBody>
+                  <a:tcPr marL="91440" marR="91440" marT="45720" marB="45720" anchor="ctr">
+                    <a:lnL w="6350" cap="flat" cmpd="sng" algn="ctr">
+                      <a:solidFill>
+                        <a:srgbClr val="E2E8F0"/>
+                      </a:solidFill>
+                      <a:prstDash val="solid"/>
+                      <a:round/>
+                      <a:headEnd type="none" w="med" len="med"/>
+                      <a:tailEnd type="none" w="med" len="med"/>
+                    </a:lnL>
+                    <a:lnR w="6350" cap="flat" cmpd="sng" algn="ctr">
+                      <a:solidFill>
+                        <a:srgbClr val="E2E8F0"/>
+                      </a:solidFill>
+                      <a:prstDash val="solid"/>
+                      <a:round/>
+                      <a:headEnd type="none" w="med" len="med"/>
+                      <a:tailEnd type="none" w="med" len="med"/>
+                    </a:lnR>
+                    <a:lnT w="6350" cap="flat" cmpd="sng" algn="ctr">
+                      <a:solidFill>
+                        <a:srgbClr val="E2E8F0"/>
+                      </a:solidFill>
+                      <a:prstDash val="solid"/>
+                      <a:round/>
+                      <a:headEnd type="none" w="med" len="med"/>
+                      <a:tailEnd type="none" w="med" len="med"/>
+                    </a:lnT>
+                    <a:lnB w="6350" cap="flat" cmpd="sng" algn="ctr">
+                      <a:solidFill>
+                        <a:srgbClr val="E2E8F0"/>
+                      </a:solidFill>
+                      <a:prstDash val="solid"/>
+                      <a:round/>
+                      <a:headEnd type="none" w="med" len="med"/>
+                      <a:tailEnd type="none" w="med" len="med"/>
+                    </a:lnB>
+                  </a:tcPr>
+                </a:tc>
+              </a:tr>
+              <a:tr h="292608">
+                <a:tc>
+                  <a:txBody>
+                    <a:bodyPr/>
+                    <a:lstStyle/>
+                    <a:p>
+                      <a:pPr algn="l" indent="0" marL="0">
+                        <a:buNone/>
+                      </a:pPr>
+                      <a:r>
+                        <a:rPr lang="en-US" sz="850" dirty="0">
+                          <a:solidFill>
+                            <a:srgbClr val="334155"/>
+                          </a:solidFill>
+                          <a:latin typeface="Aptos" pitchFamily="34" charset="0"/>
+                          <a:ea typeface="Aptos" pitchFamily="34" charset="-122"/>
+                          <a:cs typeface="Aptos" pitchFamily="34" charset="-120"/>
+                        </a:rPr>
+                        <a:t>TBD</a:t>
+                      </a:r>
+                      <a:endParaRPr lang="en-US" sz="850" dirty="0">
+                        <a:latin typeface="Aptos" charset="0"/>
+                        <a:ea typeface="Aptos" charset="0"/>
+                        <a:cs typeface="Aptos" charset="0"/>
+                      </a:endParaRPr>
+                    </a:p>
+                  </a:txBody>
+                  <a:tcPr marL="91440" marR="91440" marT="45720" marB="45720" anchor="ctr">
+                    <a:lnL w="6350" cap="flat" cmpd="sng" algn="ctr">
+                      <a:solidFill>
+                        <a:srgbClr val="E2E8F0"/>
+                      </a:solidFill>
+                      <a:prstDash val="solid"/>
+                      <a:round/>
+                      <a:headEnd type="none" w="med" len="med"/>
+                      <a:tailEnd type="none" w="med" len="med"/>
+                    </a:lnL>
+                    <a:lnR w="6350" cap="flat" cmpd="sng" algn="ctr">
+                      <a:solidFill>
+                        <a:srgbClr val="E2E8F0"/>
+                      </a:solidFill>
+                      <a:prstDash val="solid"/>
+                      <a:round/>
+                      <a:headEnd type="none" w="med" len="med"/>
+                      <a:tailEnd type="none" w="med" len="med"/>
+                    </a:lnR>
+                    <a:lnT w="6350" cap="flat" cmpd="sng" algn="ctr">
+                      <a:solidFill>
+                        <a:srgbClr val="E2E8F0"/>
+                      </a:solidFill>
+                      <a:prstDash val="solid"/>
+                      <a:round/>
+                      <a:headEnd type="none" w="med" len="med"/>
+                      <a:tailEnd type="none" w="med" len="med"/>
+                    </a:lnT>
+                    <a:lnB w="6350" cap="flat" cmpd="sng" algn="ctr">
+                      <a:solidFill>
+                        <a:srgbClr val="E2E8F0"/>
+                      </a:solidFill>
+                      <a:prstDash val="solid"/>
+                      <a:round/>
+                      <a:headEnd type="none" w="med" len="med"/>
+                      <a:tailEnd type="none" w="med" len="med"/>
+                    </a:lnB>
+                  </a:tcPr>
+                </a:tc>
+                <a:tc>
+                  <a:txBody>
+                    <a:bodyPr/>
+                    <a:lstStyle/>
+                    <a:p>
+                      <a:pPr algn="l" indent="0" marL="0">
+                        <a:buNone/>
+                      </a:pPr>
+                      <a:r>
+                        <a:rPr lang="en-US" sz="850" b="1" dirty="0">
+                          <a:solidFill>
+                            <a:srgbClr val="0B1220"/>
+                          </a:solidFill>
+                          <a:latin typeface="Aptos" pitchFamily="34" charset="0"/>
+                          <a:ea typeface="Aptos" pitchFamily="34" charset="-122"/>
+                          <a:cs typeface="Aptos" pitchFamily="34" charset="-120"/>
+                        </a:rPr>
+                        <a:t>HITL - DTS</a:t>
+                      </a:r>
+                      <a:endParaRPr lang="en-US" sz="850" dirty="0">
+                        <a:latin typeface="Aptos" charset="0"/>
+                        <a:ea typeface="Aptos" charset="0"/>
+                        <a:cs typeface="Aptos" charset="0"/>
+                      </a:endParaRPr>
+                    </a:p>
+                  </a:txBody>
+                  <a:tcPr marL="91440" marR="91440" marT="45720" marB="45720" anchor="ctr">
+                    <a:lnL w="6350" cap="flat" cmpd="sng" algn="ctr">
+                      <a:solidFill>
+                        <a:srgbClr val="E2E8F0"/>
+                      </a:solidFill>
+                      <a:prstDash val="solid"/>
+                      <a:round/>
+                      <a:headEnd type="none" w="med" len="med"/>
+                      <a:tailEnd type="none" w="med" len="med"/>
+                    </a:lnL>
+                    <a:lnR w="6350" cap="flat" cmpd="sng" algn="ctr">
+                      <a:solidFill>
+                        <a:srgbClr val="E2E8F0"/>
+                      </a:solidFill>
+                      <a:prstDash val="solid"/>
+                      <a:round/>
+                      <a:headEnd type="none" w="med" len="med"/>
+                      <a:tailEnd type="none" w="med" len="med"/>
+                    </a:lnR>
+                    <a:lnT w="6350" cap="flat" cmpd="sng" algn="ctr">
+                      <a:solidFill>
+                        <a:srgbClr val="E2E8F0"/>
+                      </a:solidFill>
+                      <a:prstDash val="solid"/>
+                      <a:round/>
+                      <a:headEnd type="none" w="med" len="med"/>
+                      <a:tailEnd type="none" w="med" len="med"/>
+                    </a:lnT>
+                    <a:lnB w="6350" cap="flat" cmpd="sng" algn="ctr">
+                      <a:solidFill>
+                        <a:srgbClr val="E2E8F0"/>
+                      </a:solidFill>
+                      <a:prstDash val="solid"/>
+                      <a:round/>
+                      <a:headEnd type="none" w="med" len="med"/>
+                      <a:tailEnd type="none" w="med" len="med"/>
+                    </a:lnB>
+                  </a:tcPr>
+                </a:tc>
+                <a:tc>
+                  <a:txBody>
+                    <a:bodyPr/>
+                    <a:lstStyle/>
+                    <a:p>
+                      <a:pPr algn="l" indent="0" marL="0">
+                        <a:buNone/>
+                      </a:pPr>
+                      <a:r>
+                        <a:rPr lang="en-US" sz="850" dirty="0">
+                          <a:solidFill>
+                            <a:srgbClr val="334155"/>
+                          </a:solidFill>
+                          <a:latin typeface="Aptos" pitchFamily="34" charset="0"/>
+                          <a:ea typeface="Aptos" pitchFamily="34" charset="-122"/>
+                          <a:cs typeface="Aptos" pitchFamily="34" charset="-120"/>
+                        </a:rPr>
+                        <a:t>David Barkol</a:t>
+                      </a:r>
+                      <a:endParaRPr lang="en-US" sz="850" dirty="0">
+                        <a:latin typeface="Aptos" charset="0"/>
+                        <a:ea typeface="Aptos" charset="0"/>
+                        <a:cs typeface="Aptos" charset="0"/>
+                      </a:endParaRPr>
+                    </a:p>
+                  </a:txBody>
+                  <a:tcPr marL="91440" marR="91440" marT="45720" marB="45720" anchor="ctr">
+                    <a:lnL w="6350" cap="flat" cmpd="sng" algn="ctr">
+                      <a:solidFill>
+                        <a:srgbClr val="E2E8F0"/>
+                      </a:solidFill>
+                      <a:prstDash val="solid"/>
+                      <a:round/>
+                      <a:headEnd type="none" w="med" len="med"/>
+                      <a:tailEnd type="none" w="med" len="med"/>
+                    </a:lnL>
+                    <a:lnR w="6350" cap="flat" cmpd="sng" algn="ctr">
+                      <a:solidFill>
+                        <a:srgbClr val="E2E8F0"/>
+                      </a:solidFill>
+                      <a:prstDash val="solid"/>
+                      <a:round/>
+                      <a:headEnd type="none" w="med" len="med"/>
+                      <a:tailEnd type="none" w="med" len="med"/>
+                    </a:lnR>
+                    <a:lnT w="6350" cap="flat" cmpd="sng" algn="ctr">
+                      <a:solidFill>
+                        <a:srgbClr val="E2E8F0"/>
+                      </a:solidFill>
+                      <a:prstDash val="solid"/>
+                      <a:round/>
+                      <a:headEnd type="none" w="med" len="med"/>
+                      <a:tailEnd type="none" w="med" len="med"/>
+                    </a:lnT>
+                    <a:lnB w="6350" cap="flat" cmpd="sng" algn="ctr">
+                      <a:solidFill>
+                        <a:srgbClr val="E2E8F0"/>
+                      </a:solidFill>
+                      <a:prstDash val="solid"/>
+                      <a:round/>
+                      <a:headEnd type="none" w="med" len="med"/>
+                      <a:tailEnd type="none" w="med" len="med"/>
+                    </a:lnB>
+                  </a:tcPr>
+                </a:tc>
+                <a:tc>
+                  <a:txBody>
+                    <a:bodyPr/>
+                    <a:lstStyle/>
+                    <a:p>
+                      <a:pPr algn="l" indent="0" marL="0">
+                        <a:buNone/>
+                      </a:pPr>
+                      <a:r>
+                        <a:rPr lang="en-US" sz="800" dirty="0">
+                          <a:solidFill>
+                            <a:srgbClr val="64748B"/>
+                          </a:solidFill>
+                          <a:latin typeface="Aptos" pitchFamily="34" charset="0"/>
+                          <a:ea typeface="Aptos" pitchFamily="34" charset="-122"/>
+                          <a:cs typeface="Aptos" pitchFamily="34" charset="-120"/>
+                        </a:rPr>
+                        <a:t>KP Eng TBD</a:t>
+                      </a:r>
+                      <a:endParaRPr lang="en-US" sz="800" dirty="0">
+                        <a:latin typeface="Aptos" charset="0"/>
+                        <a:ea typeface="Aptos" charset="0"/>
+                        <a:cs typeface="Aptos" charset="0"/>
+                      </a:endParaRPr>
+                    </a:p>
+                  </a:txBody>
+                  <a:tcPr marL="91440" marR="91440" marT="45720" marB="45720" anchor="ctr">
+                    <a:lnL w="6350" cap="flat" cmpd="sng" algn="ctr">
+                      <a:solidFill>
+                        <a:srgbClr val="E2E8F0"/>
+                      </a:solidFill>
+                      <a:prstDash val="solid"/>
+                      <a:round/>
+                      <a:headEnd type="none" w="med" len="med"/>
+                      <a:tailEnd type="none" w="med" len="med"/>
+                    </a:lnL>
+                    <a:lnR w="6350" cap="flat" cmpd="sng" algn="ctr">
+                      <a:solidFill>
+                        <a:srgbClr val="E2E8F0"/>
+                      </a:solidFill>
+                      <a:prstDash val="solid"/>
+                      <a:round/>
+                      <a:headEnd type="none" w="med" len="med"/>
+                      <a:tailEnd type="none" w="med" len="med"/>
+                    </a:lnR>
+                    <a:lnT w="6350" cap="flat" cmpd="sng" algn="ctr">
+                      <a:solidFill>
+                        <a:srgbClr val="E2E8F0"/>
+                      </a:solidFill>
+                      <a:prstDash val="solid"/>
+                      <a:round/>
+                      <a:headEnd type="none" w="med" len="med"/>
+                      <a:tailEnd type="none" w="med" len="med"/>
+                    </a:lnT>
+                    <a:lnB w="6350" cap="flat" cmpd="sng" algn="ctr">
+                      <a:solidFill>
+                        <a:srgbClr val="E2E8F0"/>
+                      </a:solidFill>
+                      <a:prstDash val="solid"/>
+                      <a:round/>
+                      <a:headEnd type="none" w="med" len="med"/>
+                      <a:tailEnd type="none" w="med" len="med"/>
+                    </a:lnB>
+                  </a:tcPr>
+                </a:tc>
+              </a:tr>
+              <a:tr h="292608">
+                <a:tc>
+                  <a:txBody>
+                    <a:bodyPr/>
+                    <a:lstStyle/>
+                    <a:p>
+                      <a:pPr algn="l" indent="0" marL="0">
+                        <a:buNone/>
+                      </a:pPr>
+                      <a:r>
+                        <a:rPr lang="en-US" sz="850" dirty="0">
+                          <a:solidFill>
+                            <a:srgbClr val="334155"/>
+                          </a:solidFill>
+                          <a:latin typeface="Aptos" pitchFamily="34" charset="0"/>
+                          <a:ea typeface="Aptos" pitchFamily="34" charset="-122"/>
+                          <a:cs typeface="Aptos" pitchFamily="34" charset="-120"/>
+                        </a:rPr>
+                        <a:t>1:45 - 2:00</a:t>
+                      </a:r>
+                      <a:endParaRPr lang="en-US" sz="850" dirty="0">
+                        <a:latin typeface="Aptos" charset="0"/>
+                        <a:ea typeface="Aptos" charset="0"/>
+                        <a:cs typeface="Aptos" charset="0"/>
+                      </a:endParaRPr>
+                    </a:p>
+                  </a:txBody>
+                  <a:tcPr marL="91440" marR="91440" marT="45720" marB="45720" anchor="ctr">
+                    <a:lnL w="6350" cap="flat" cmpd="sng" algn="ctr">
+                      <a:solidFill>
+                        <a:srgbClr val="E2E8F0"/>
+                      </a:solidFill>
+                      <a:prstDash val="solid"/>
+                      <a:round/>
+                      <a:headEnd type="none" w="med" len="med"/>
+                      <a:tailEnd type="none" w="med" len="med"/>
+                    </a:lnL>
+                    <a:lnR w="6350" cap="flat" cmpd="sng" algn="ctr">
+                      <a:solidFill>
+                        <a:srgbClr val="E2E8F0"/>
+                      </a:solidFill>
+                      <a:prstDash val="solid"/>
+                      <a:round/>
+                      <a:headEnd type="none" w="med" len="med"/>
+                      <a:tailEnd type="none" w="med" len="med"/>
+                    </a:lnR>
+                    <a:lnT w="6350" cap="flat" cmpd="sng" algn="ctr">
+                      <a:solidFill>
+                        <a:srgbClr val="E2E8F0"/>
+                      </a:solidFill>
+                      <a:prstDash val="solid"/>
+                      <a:round/>
+                      <a:headEnd type="none" w="med" len="med"/>
+                      <a:tailEnd type="none" w="med" len="med"/>
+                    </a:lnT>
+                    <a:lnB w="6350" cap="flat" cmpd="sng" algn="ctr">
+                      <a:solidFill>
+                        <a:srgbClr val="E2E8F0"/>
+                      </a:solidFill>
+                      <a:prstDash val="solid"/>
+                      <a:round/>
+                      <a:headEnd type="none" w="med" len="med"/>
+                      <a:tailEnd type="none" w="med" len="med"/>
+                    </a:lnB>
+                  </a:tcPr>
+                </a:tc>
+                <a:tc>
+                  <a:txBody>
+                    <a:bodyPr/>
+                    <a:lstStyle/>
+                    <a:p>
+                      <a:pPr algn="l" indent="0" marL="0">
+                        <a:buNone/>
+                      </a:pPr>
+                      <a:r>
+                        <a:rPr lang="en-US" sz="850" b="1" dirty="0">
+                          <a:solidFill>
+                            <a:srgbClr val="0B1220"/>
+                          </a:solidFill>
+                          <a:latin typeface="Aptos" pitchFamily="34" charset="0"/>
+                          <a:ea typeface="Aptos" pitchFamily="34" charset="-122"/>
+                          <a:cs typeface="Aptos" pitchFamily="34" charset="-120"/>
+                        </a:rPr>
+                        <a:t>Closeout &amp; roadmap</a:t>
+                      </a:r>
+                      <a:endParaRPr lang="en-US" sz="850" dirty="0">
+                        <a:latin typeface="Aptos" charset="0"/>
+                        <a:ea typeface="Aptos" charset="0"/>
+                        <a:cs typeface="Aptos" charset="0"/>
+                      </a:endParaRPr>
+                    </a:p>
+                  </a:txBody>
+                  <a:tcPr marL="91440" marR="91440" marT="45720" marB="45720" anchor="ctr">
+                    <a:lnL w="6350" cap="flat" cmpd="sng" algn="ctr">
+                      <a:solidFill>
+                        <a:srgbClr val="E2E8F0"/>
+                      </a:solidFill>
+                      <a:prstDash val="solid"/>
+                      <a:round/>
+                      <a:headEnd type="none" w="med" len="med"/>
+                      <a:tailEnd type="none" w="med" len="med"/>
+                    </a:lnL>
+                    <a:lnR w="6350" cap="flat" cmpd="sng" algn="ctr">
+                      <a:solidFill>
+                        <a:srgbClr val="E2E8F0"/>
+                      </a:solidFill>
+                      <a:prstDash val="solid"/>
+                      <a:round/>
+                      <a:headEnd type="none" w="med" len="med"/>
+                      <a:tailEnd type="none" w="med" len="med"/>
+                    </a:lnR>
+                    <a:lnT w="6350" cap="flat" cmpd="sng" algn="ctr">
+                      <a:solidFill>
+                        <a:srgbClr val="E2E8F0"/>
+                      </a:solidFill>
+                      <a:prstDash val="solid"/>
+                      <a:round/>
+                      <a:headEnd type="none" w="med" len="med"/>
+                      <a:tailEnd type="none" w="med" len="med"/>
+                    </a:lnT>
+                    <a:lnB w="6350" cap="flat" cmpd="sng" algn="ctr">
+                      <a:solidFill>
+                        <a:srgbClr val="E2E8F0"/>
+                      </a:solidFill>
+                      <a:prstDash val="solid"/>
+                      <a:round/>
+                      <a:headEnd type="none" w="med" len="med"/>
+                      <a:tailEnd type="none" w="med" len="med"/>
+                    </a:lnB>
+                  </a:tcPr>
+                </a:tc>
+                <a:tc>
+                  <a:txBody>
+                    <a:bodyPr/>
+                    <a:lstStyle/>
+                    <a:p>
+                      <a:pPr algn="l" indent="0" marL="0">
+                        <a:buNone/>
+                      </a:pPr>
+                      <a:r>
+                        <a:rPr lang="en-US" sz="850" dirty="0">
+                          <a:solidFill>
+                            <a:srgbClr val="334155"/>
+                          </a:solidFill>
+                          <a:latin typeface="Aptos" pitchFamily="34" charset="0"/>
+                          <a:ea typeface="Aptos" pitchFamily="34" charset="-122"/>
+                          <a:cs typeface="Aptos" pitchFamily="34" charset="-120"/>
+                        </a:rPr>
+                        <a:t>Shivang Vora</a:t>
+                      </a:r>
+                      <a:endParaRPr lang="en-US" sz="850" dirty="0">
+                        <a:latin typeface="Aptos" charset="0"/>
+                        <a:ea typeface="Aptos" charset="0"/>
+                        <a:cs typeface="Aptos" charset="0"/>
+                      </a:endParaRPr>
+                    </a:p>
+                  </a:txBody>
+                  <a:tcPr marL="91440" marR="91440" marT="45720" marB="45720" anchor="ctr">
+                    <a:lnL w="6350" cap="flat" cmpd="sng" algn="ctr">
+                      <a:solidFill>
+                        <a:srgbClr val="E2E8F0"/>
+                      </a:solidFill>
+                      <a:prstDash val="solid"/>
+                      <a:round/>
+                      <a:headEnd type="none" w="med" len="med"/>
+                      <a:tailEnd type="none" w="med" len="med"/>
+                    </a:lnL>
+                    <a:lnR w="6350" cap="flat" cmpd="sng" algn="ctr">
+                      <a:solidFill>
+                        <a:srgbClr val="E2E8F0"/>
+                      </a:solidFill>
+                      <a:prstDash val="solid"/>
+                      <a:round/>
+                      <a:headEnd type="none" w="med" len="med"/>
+                      <a:tailEnd type="none" w="med" len="med"/>
+                    </a:lnR>
+                    <a:lnT w="6350" cap="flat" cmpd="sng" algn="ctr">
+                      <a:solidFill>
+                        <a:srgbClr val="E2E8F0"/>
+                      </a:solidFill>
+                      <a:prstDash val="solid"/>
+                      <a:round/>
+                      <a:headEnd type="none" w="med" len="med"/>
+                      <a:tailEnd type="none" w="med" len="med"/>
+                    </a:lnT>
+                    <a:lnB w="6350" cap="flat" cmpd="sng" algn="ctr">
+                      <a:solidFill>
+                        <a:srgbClr val="E2E8F0"/>
+                      </a:solidFill>
+                      <a:prstDash val="solid"/>
+                      <a:round/>
+                      <a:headEnd type="none" w="med" len="med"/>
+                      <a:tailEnd type="none" w="med" len="med"/>
+                    </a:lnB>
+                  </a:tcPr>
+                </a:tc>
+                <a:tc>
+                  <a:txBody>
+                    <a:bodyPr/>
+                    <a:lstStyle/>
+                    <a:p>
+                      <a:pPr algn="l" indent="0" marL="0">
+                        <a:buNone/>
+                      </a:pPr>
+                      <a:r>
+                        <a:rPr lang="en-US" sz="800" dirty="0">
+                          <a:solidFill>
+                            <a:srgbClr val="64748B"/>
+                          </a:solidFill>
+                          <a:latin typeface="Aptos" pitchFamily="34" charset="0"/>
+                          <a:ea typeface="Aptos" pitchFamily="34" charset="-122"/>
+                          <a:cs typeface="Aptos" pitchFamily="34" charset="-120"/>
+                        </a:rPr>
+                        <a:t>30 / 60 / 90-day pilot roadmap</a:t>
+                      </a:r>
+                      <a:endParaRPr lang="en-US" sz="800" dirty="0">
+                        <a:latin typeface="Aptos" charset="0"/>
+                        <a:ea typeface="Aptos" charset="0"/>
+                        <a:cs typeface="Aptos" charset="0"/>
+                      </a:endParaRPr>
+                    </a:p>
+                  </a:txBody>
+                  <a:tcPr marL="91440" marR="91440" marT="45720" marB="45720" anchor="ctr">
+                    <a:lnL w="6350" cap="flat" cmpd="sng" algn="ctr">
+                      <a:solidFill>
+                        <a:srgbClr val="E2E8F0"/>
+                      </a:solidFill>
+                      <a:prstDash val="solid"/>
+                      <a:round/>
+                      <a:headEnd type="none" w="med" len="med"/>
+                      <a:tailEnd type="none" w="med" len="med"/>
+                    </a:lnL>
+                    <a:lnR w="6350" cap="flat" cmpd="sng" algn="ctr">
+                      <a:solidFill>
+                        <a:srgbClr val="E2E8F0"/>
+                      </a:solidFill>
+                      <a:prstDash val="solid"/>
+                      <a:round/>
+                      <a:headEnd type="none" w="med" len="med"/>
+                      <a:tailEnd type="none" w="med" len="med"/>
+                    </a:lnR>
+                    <a:lnT w="6350" cap="flat" cmpd="sng" algn="ctr">
+                      <a:solidFill>
+                        <a:srgbClr val="E2E8F0"/>
+                      </a:solidFill>
+                      <a:prstDash val="solid"/>
+                      <a:round/>
+                      <a:headEnd type="none" w="med" len="med"/>
+                      <a:tailEnd type="none" w="med" len="med"/>
+                    </a:lnT>
+                    <a:lnB w="6350" cap="flat" cmpd="sng" algn="ctr">
+                      <a:solidFill>
+                        <a:srgbClr val="E2E8F0"/>
+                      </a:solidFill>
+                      <a:prstDash val="solid"/>
+                      <a:round/>
+                      <a:headEnd type="none" w="med" len="med"/>
+                      <a:tailEnd type="none" w="med" len="med"/>
+                    </a:lnB>
+                  </a:tcPr>
+                </a:tc>
+              </a:tr>
+            </a:tbl>
+          </a:graphicData>
+        </a:graphic>
+      </p:graphicFrame>
+      <p:sp>
+        <p:nvSpPr>
+          <p:cNvPr id="25" name="Slide Number Placeholder 0"/>
+          <p:cNvSpPr>
+            <a:spLocks noGrp="1"/>
+          </p:cNvSpPr>
+          <p:nvPr>
+            <p:ph type="sldNum" sz="quarter" idx="4294967295"/>
+          </p:nvPr>
+        </p:nvSpPr>
+        <p:spPr>
+          <a:xfrm>
+            <a:off x="11475720" y="6565392"/>
+            <a:ext cx="800000" cy="300000"/>
+          </a:xfrm>
+          <a:prstGeom prst="rect">
+            <a:avLst/>
+          </a:prstGeom>
+          <a:extLst>
+            <a:ext uri="{C572A759-6A51-4108-AA02-DFA0A04FC94B}">
+              <ma14:wrappingTextBoxFlag xmlns:ma14="http://schemas.microsoft.com/office/mac/drawingml/2011/main" val="0"/>
+            </a:ext>
+          </a:extLst>
+        </p:spPr>
+        <p:txBody>
+          <a:bodyPr/>
+          <a:lstStyle>
+            <a:lvl1pPr>
+              <a:defRPr sz="700">
+                <a:solidFill>
+                  <a:srgbClr val="64748B"/>
+                </a:solidFill>
+                <a:latin typeface="Aptos"/>
+                <a:ea typeface="Aptos"/>
+                <a:cs typeface="Aptos"/>
+              </a:defRPr>
+            </a:lvl1pPr>
+          </a:lstStyle>
+          <a:p>
+            <a:pPr algn="l"/>
+            <a:fld id="{F7021451-1387-4CA6-816F-3879F97B5CBC}" type="slidenum">
+              <a:rPr b="0" lang="en-US"/>
+              <a:t>26</a:t>
+            </a:fld>
+            <a:endParaRPr lang="en-US"/>
           </a:p>
         </p:txBody>
       </p:sp>

</xml_diff>

<commit_message>
Wire DTS diagram into deck+HITL doc; add BYOR (JFrog + GitHub Actions) architecture diagram
- Deck HITL slide (20) now embeds dts-hitl-architecture.png (deck stays 26 slides, no renumber)
- docs/hitl-durable-task-scheduler.md embeds the DTS diagram
- New Azure-style BYOR diagram (build_byor_diagram.py + SVG/PNG): GitHub Actions builds/tests/gates
  the agent image and pushes to JFrog Artifactory with keyless OIDC; Foundry Hosted Agents / ACA pull
  via managed identity; identity-and-keyless-trust band (OIDC/WIF, no stored creds). Proposed/reference.
- README BYO Registry section rewritten with the diagram

Co-authored-by: Copilot <223556219+Copilot@users.noreply.github.com>
</commit_message>
<xml_diff>
--- a/workshop-assets/kaiser-consolidated-customer-deck.pptx
+++ b/workshop-assets/kaiser-consolidated-customer-deck.pptx
@@ -1583,7 +1583,7 @@
           <a:p>
             <a:r>
               <a:rPr lang="en-US" dirty="0"/>
-              <a:t>The human-control capstone. This is built and running today; demo approve, a blocked illegal transition, and SLA auto-escalation.</a:t>
+              <a:t>The human-control capstone. Durable Task Scheduler HITL: every run drafts an exception packet then STOPS at a care-manager approval gate - the agent drafts/reworks only; a human owns approve/reject. The orchestrator waits on an external event (ReviewDecision) raced with a durable SLA timer (24h), so a review can take hours/days consuming no compute, and resumes after restart. States: PendingReview -&gt; Approved / NeedsRework / Rejected; timer/policy -&gt; Escalated, each an append-only audit record. Guardrails in code: illegal transition -&gt; 409; an agent trying to approve -&gt; 403. Built and running today; demo approve, a blocked illegal transition, and SLA auto-escalation. Doc: docs/hitl-durable-task-scheduler.md. Icons are simplified glyphs (not official Azure product icons); synthetic data only.</a:t>
             </a:r>
             <a:endParaRPr lang="en-US" dirty="0"/>
           </a:p>
@@ -13351,7 +13351,7 @@
     <p:bg>
       <p:bgPr>
         <a:solidFill>
-          <a:srgbClr val="F8FAFC"/>
+          <a:srgbClr val="F5F6F8"/>
         </a:solidFill>
       </p:bgPr>
     </p:bg>
@@ -13369,697 +13369,30 @@
           <a:chExt cx="0" cy="0"/>
         </a:xfrm>
       </p:grpSpPr>
-      <p:sp>
-        <p:nvSpPr>
-          <p:cNvPr id="2" name="Text 0"/>
-          <p:cNvSpPr/>
-          <p:nvPr/>
-        </p:nvSpPr>
-        <p:spPr>
-          <a:xfrm>
-            <a:off x="566928" y="384048"/>
-            <a:ext cx="10789920" cy="201168"/>
-          </a:xfrm>
-          <a:prstGeom prst="rect">
-            <a:avLst/>
-          </a:prstGeom>
-          <a:noFill/>
-          <a:ln/>
-        </p:spPr>
-        <p:txBody>
-          <a:bodyPr wrap="square" lIns="0" tIns="0" rIns="0" bIns="0" rtlCol="0" anchor="ctr"/>
-          <a:lstStyle/>
-          <a:p>
-            <a:pPr indent="0" marL="0">
-              <a:buNone/>
-            </a:pPr>
-            <a:r>
-              <a:rPr lang="en-US" sz="800" b="1" dirty="0">
-                <a:solidFill>
-                  <a:srgbClr val="0F766E"/>
-                </a:solidFill>
-                <a:latin typeface="Aptos" pitchFamily="34" charset="0"/>
-                <a:ea typeface="Aptos" pitchFamily="34" charset="-122"/>
-                <a:cs typeface="Aptos" pitchFamily="34" charset="-120"/>
-              </a:rPr>
-              <a:t>PRIORITY - DAY 2</a:t>
-            </a:r>
-            <a:endParaRPr lang="en-US" sz="800" dirty="0"/>
-          </a:p>
-        </p:txBody>
-      </p:sp>
-      <p:sp>
-        <p:nvSpPr>
-          <p:cNvPr id="3" name="Text 1"/>
-          <p:cNvSpPr/>
-          <p:nvPr/>
-        </p:nvSpPr>
-        <p:spPr>
-          <a:xfrm>
-            <a:off x="548640" y="658368"/>
-            <a:ext cx="11064240" cy="502920"/>
-          </a:xfrm>
-          <a:prstGeom prst="rect">
-            <a:avLst/>
-          </a:prstGeom>
-          <a:noFill/>
-          <a:ln/>
-        </p:spPr>
-        <p:txBody>
-          <a:bodyPr wrap="square" lIns="0" tIns="0" rIns="0" bIns="0" rtlCol="0" anchor="ctr">
-            <a:normAutofit/>
-          </a:bodyPr>
-          <a:lstStyle/>
-          <a:p>
-            <a:pPr indent="0" marL="0">
-              <a:buNone/>
-            </a:pPr>
-            <a:r>
-              <a:rPr lang="en-US" sz="2300" b="1" dirty="0">
-                <a:solidFill>
-                  <a:srgbClr val="0B1220"/>
-                </a:solidFill>
-                <a:latin typeface="Aptos Display" pitchFamily="34" charset="0"/>
-                <a:ea typeface="Aptos Display" pitchFamily="34" charset="-122"/>
-                <a:cs typeface="Aptos Display" pitchFamily="34" charset="-120"/>
-              </a:rPr>
-              <a:t>Human in the loop: the durable approval gate</a:t>
-            </a:r>
-            <a:endParaRPr lang="en-US" sz="2300" dirty="0"/>
-          </a:p>
-        </p:txBody>
-      </p:sp>
-      <p:sp>
-        <p:nvSpPr>
-          <p:cNvPr id="4" name="Shape 2"/>
-          <p:cNvSpPr/>
-          <p:nvPr/>
-        </p:nvSpPr>
-        <p:spPr>
-          <a:xfrm>
-            <a:off x="548640" y="1243584"/>
-            <a:ext cx="11064240" cy="0"/>
-          </a:xfrm>
-          <a:prstGeom prst="line">
-            <a:avLst/>
-          </a:prstGeom>
-          <a:noFill/>
-          <a:ln w="12700">
-            <a:solidFill>
-              <a:srgbClr val="CBD5E1"/>
-            </a:solidFill>
-            <a:prstDash val="solid"/>
-          </a:ln>
-        </p:spPr>
-      </p:sp>
-      <p:sp>
-        <p:nvSpPr>
-          <p:cNvPr id="5" name="Shape 3"/>
-          <p:cNvSpPr/>
-          <p:nvPr/>
-        </p:nvSpPr>
-        <p:spPr>
-          <a:xfrm>
-            <a:off x="640080" y="1463040"/>
-            <a:ext cx="3520440" cy="1828800"/>
-          </a:xfrm>
-          <a:prstGeom prst="roundRect">
-            <a:avLst>
-              <a:gd name="adj" fmla="val 4000"/>
-            </a:avLst>
-          </a:prstGeom>
-          <a:solidFill>
-            <a:srgbClr val="FFFFFF"/>
-          </a:solidFill>
-          <a:ln w="12700">
-            <a:solidFill>
-              <a:srgbClr val="E2E8F0"/>
-            </a:solidFill>
-            <a:prstDash val="solid"/>
-          </a:ln>
-          <a:effectLst>
-            <a:outerShdw sx="100000" sy="100000" kx="0" ky="0" algn="bl" rotWithShape="0" blurRad="25400" dist="50800" dir="2700000">
-              <a:srgbClr val="94A3B8">
-                <a:alpha val="12000"/>
-              </a:srgbClr>
-            </a:outerShdw>
-          </a:effectLst>
-        </p:spPr>
-      </p:sp>
-      <p:sp>
-        <p:nvSpPr>
-          <p:cNvPr id="6" name="Shape 4"/>
-          <p:cNvSpPr/>
-          <p:nvPr/>
-        </p:nvSpPr>
-        <p:spPr>
-          <a:xfrm>
-            <a:off x="640080" y="1463040"/>
-            <a:ext cx="64008" cy="1828800"/>
-          </a:xfrm>
-          <a:prstGeom prst="rect">
-            <a:avLst/>
-          </a:prstGeom>
-          <a:solidFill>
-            <a:srgbClr val="F59E0B"/>
-          </a:solidFill>
-          <a:ln w="12700">
-            <a:solidFill>
-              <a:srgbClr val="F59E0B"/>
-            </a:solidFill>
-            <a:prstDash val="solid"/>
-          </a:ln>
-        </p:spPr>
-      </p:sp>
-      <p:sp>
-        <p:nvSpPr>
-          <p:cNvPr id="7" name="Text 5"/>
-          <p:cNvSpPr/>
-          <p:nvPr/>
-        </p:nvSpPr>
-        <p:spPr>
-          <a:xfrm>
-            <a:off x="841248" y="1609344"/>
-            <a:ext cx="3200400" cy="219456"/>
-          </a:xfrm>
-          <a:prstGeom prst="rect">
-            <a:avLst/>
-          </a:prstGeom>
-          <a:noFill/>
-          <a:ln/>
-        </p:spPr>
-        <p:txBody>
-          <a:bodyPr wrap="square" lIns="0" tIns="0" rIns="0" bIns="0" rtlCol="0" anchor="ctr">
-            <a:normAutofit/>
-          </a:bodyPr>
-          <a:lstStyle/>
-          <a:p>
-            <a:pPr indent="0" marL="0">
-              <a:buNone/>
-            </a:pPr>
-            <a:r>
-              <a:rPr lang="en-US" sz="1200" b="1" dirty="0">
-                <a:solidFill>
-                  <a:srgbClr val="0B1220"/>
-                </a:solidFill>
-                <a:latin typeface="Aptos" pitchFamily="34" charset="0"/>
-                <a:ea typeface="Aptos" pitchFamily="34" charset="-122"/>
-                <a:cs typeface="Aptos" pitchFamily="34" charset="-120"/>
-              </a:rPr>
-              <a:t>The gate</a:t>
-            </a:r>
-            <a:endParaRPr lang="en-US" sz="1200" dirty="0"/>
-          </a:p>
-        </p:txBody>
-      </p:sp>
-      <p:sp>
-        <p:nvSpPr>
-          <p:cNvPr id="8" name="Text 6"/>
-          <p:cNvSpPr/>
-          <p:nvPr/>
-        </p:nvSpPr>
-        <p:spPr>
-          <a:xfrm>
-            <a:off x="841248" y="1920240"/>
-            <a:ext cx="3200400" cy="1280160"/>
-          </a:xfrm>
-          <a:prstGeom prst="rect">
-            <a:avLst/>
-          </a:prstGeom>
-          <a:noFill/>
-          <a:ln/>
-        </p:spPr>
-        <p:txBody>
-          <a:bodyPr wrap="square" lIns="254" tIns="254" rIns="254" bIns="254" rtlCol="0" anchor="t">
-            <a:normAutofit/>
-          </a:bodyPr>
-          <a:lstStyle/>
-          <a:p>
-            <a:pPr indent="0" marL="0">
-              <a:buNone/>
-            </a:pPr>
-            <a:r>
-              <a:rPr lang="en-US" sz="920" dirty="0">
-                <a:solidFill>
-                  <a:srgbClr val="334155"/>
-                </a:solidFill>
-                <a:latin typeface="Aptos" pitchFamily="34" charset="0"/>
-                <a:ea typeface="Aptos" pitchFamily="34" charset="-122"/>
-                <a:cs typeface="Aptos" pitchFamily="34" charset="-120"/>
-              </a:rPr>
-              <a:t>Every run drafts an exception packet, then STOPS at a care-manager approval gate. The agent drafts and reworks only; a human owns approve / reject.</a:t>
-            </a:r>
-            <a:endParaRPr lang="en-US" sz="920" dirty="0"/>
-          </a:p>
-        </p:txBody>
-      </p:sp>
-      <p:sp>
-        <p:nvSpPr>
-          <p:cNvPr id="9" name="Shape 7"/>
-          <p:cNvSpPr/>
-          <p:nvPr/>
-        </p:nvSpPr>
-        <p:spPr>
-          <a:xfrm>
-            <a:off x="4343400" y="1463040"/>
-            <a:ext cx="3520440" cy="1828800"/>
-          </a:xfrm>
-          <a:prstGeom prst="roundRect">
-            <a:avLst>
-              <a:gd name="adj" fmla="val 4000"/>
-            </a:avLst>
-          </a:prstGeom>
-          <a:solidFill>
-            <a:srgbClr val="FFFFFF"/>
-          </a:solidFill>
-          <a:ln w="12700">
-            <a:solidFill>
-              <a:srgbClr val="E2E8F0"/>
-            </a:solidFill>
-            <a:prstDash val="solid"/>
-          </a:ln>
-          <a:effectLst>
-            <a:outerShdw sx="100000" sy="100000" kx="0" ky="0" algn="bl" rotWithShape="0" blurRad="25400" dist="50800" dir="2700000">
-              <a:srgbClr val="94A3B8">
-                <a:alpha val="12000"/>
-              </a:srgbClr>
-            </a:outerShdw>
-          </a:effectLst>
-        </p:spPr>
-      </p:sp>
-      <p:sp>
-        <p:nvSpPr>
-          <p:cNvPr id="10" name="Shape 8"/>
-          <p:cNvSpPr/>
-          <p:nvPr/>
-        </p:nvSpPr>
-        <p:spPr>
-          <a:xfrm>
-            <a:off x="4343400" y="1463040"/>
-            <a:ext cx="64008" cy="1828800"/>
-          </a:xfrm>
-          <a:prstGeom prst="rect">
-            <a:avLst/>
-          </a:prstGeom>
-          <a:solidFill>
-            <a:srgbClr val="0F766E"/>
-          </a:solidFill>
-          <a:ln w="12700">
-            <a:solidFill>
-              <a:srgbClr val="0F766E"/>
-            </a:solidFill>
-            <a:prstDash val="solid"/>
-          </a:ln>
-        </p:spPr>
-      </p:sp>
-      <p:sp>
-        <p:nvSpPr>
-          <p:cNvPr id="11" name="Text 9"/>
-          <p:cNvSpPr/>
-          <p:nvPr/>
-        </p:nvSpPr>
-        <p:spPr>
-          <a:xfrm>
-            <a:off x="4544568" y="1609344"/>
-            <a:ext cx="3200400" cy="219456"/>
-          </a:xfrm>
-          <a:prstGeom prst="rect">
-            <a:avLst/>
-          </a:prstGeom>
-          <a:noFill/>
-          <a:ln/>
-        </p:spPr>
-        <p:txBody>
-          <a:bodyPr wrap="square" lIns="0" tIns="0" rIns="0" bIns="0" rtlCol="0" anchor="ctr">
-            <a:normAutofit/>
-          </a:bodyPr>
-          <a:lstStyle/>
-          <a:p>
-            <a:pPr indent="0" marL="0">
-              <a:buNone/>
-            </a:pPr>
-            <a:r>
-              <a:rPr lang="en-US" sz="1200" b="1" dirty="0">
-                <a:solidFill>
-                  <a:srgbClr val="0B1220"/>
-                </a:solidFill>
-                <a:latin typeface="Aptos" pitchFamily="34" charset="0"/>
-                <a:ea typeface="Aptos" pitchFamily="34" charset="-122"/>
-                <a:cs typeface="Aptos" pitchFamily="34" charset="-120"/>
-              </a:rPr>
-              <a:t>Durable + auditable</a:t>
-            </a:r>
-            <a:endParaRPr lang="en-US" sz="1200" dirty="0"/>
-          </a:p>
-        </p:txBody>
-      </p:sp>
-      <p:sp>
-        <p:nvSpPr>
-          <p:cNvPr id="12" name="Text 10"/>
-          <p:cNvSpPr/>
-          <p:nvPr/>
-        </p:nvSpPr>
-        <p:spPr>
-          <a:xfrm>
-            <a:off x="4544568" y="1920240"/>
-            <a:ext cx="3200400" cy="1280160"/>
-          </a:xfrm>
-          <a:prstGeom prst="rect">
-            <a:avLst/>
-          </a:prstGeom>
-          <a:noFill/>
-          <a:ln/>
-        </p:spPr>
-        <p:txBody>
-          <a:bodyPr wrap="square" lIns="254" tIns="254" rIns="254" bIns="254" rtlCol="0" anchor="t">
-            <a:normAutofit/>
-          </a:bodyPr>
-          <a:lstStyle/>
-          <a:p>
-            <a:pPr indent="0" marL="0">
-              <a:buNone/>
-            </a:pPr>
-            <a:r>
-              <a:rPr lang="en-US" sz="920" dirty="0">
-                <a:solidFill>
-                  <a:srgbClr val="334155"/>
-                </a:solidFill>
-                <a:latin typeface="Aptos" pitchFamily="34" charset="0"/>
-                <a:ea typeface="Aptos" pitchFamily="34" charset="-122"/>
-                <a:cs typeface="Aptos" pitchFamily="34" charset="-120"/>
-              </a:rPr>
-              <a:t>PendingReview -&gt; Approved / NeedsRework / Rejected; SLA timeout or policy -&gt; Escalated. Every transition writes an append-only audit record.</a:t>
-            </a:r>
-            <a:endParaRPr lang="en-US" sz="920" dirty="0"/>
-          </a:p>
-        </p:txBody>
-      </p:sp>
-      <p:sp>
-        <p:nvSpPr>
-          <p:cNvPr id="13" name="Shape 11"/>
-          <p:cNvSpPr/>
-          <p:nvPr/>
-        </p:nvSpPr>
-        <p:spPr>
-          <a:xfrm>
-            <a:off x="8046720" y="1463040"/>
-            <a:ext cx="3520440" cy="1828800"/>
-          </a:xfrm>
-          <a:prstGeom prst="roundRect">
-            <a:avLst>
-              <a:gd name="adj" fmla="val 4000"/>
-            </a:avLst>
-          </a:prstGeom>
-          <a:solidFill>
-            <a:srgbClr val="FFFFFF"/>
-          </a:solidFill>
-          <a:ln w="12700">
-            <a:solidFill>
-              <a:srgbClr val="E2E8F0"/>
-            </a:solidFill>
-            <a:prstDash val="solid"/>
-          </a:ln>
-          <a:effectLst>
-            <a:outerShdw sx="100000" sy="100000" kx="0" ky="0" algn="bl" rotWithShape="0" blurRad="25400" dist="50800" dir="2700000">
-              <a:srgbClr val="94A3B8">
-                <a:alpha val="12000"/>
-              </a:srgbClr>
-            </a:outerShdw>
-          </a:effectLst>
-        </p:spPr>
-      </p:sp>
-      <p:sp>
-        <p:nvSpPr>
-          <p:cNvPr id="14" name="Shape 12"/>
-          <p:cNvSpPr/>
-          <p:nvPr/>
-        </p:nvSpPr>
-        <p:spPr>
-          <a:xfrm>
-            <a:off x="8046720" y="1463040"/>
-            <a:ext cx="64008" cy="1828800"/>
-          </a:xfrm>
-          <a:prstGeom prst="rect">
-            <a:avLst/>
-          </a:prstGeom>
-          <a:solidFill>
-            <a:srgbClr val="7C3AED"/>
-          </a:solidFill>
-          <a:ln w="12700">
-            <a:solidFill>
-              <a:srgbClr val="7C3AED"/>
-            </a:solidFill>
-            <a:prstDash val="solid"/>
-          </a:ln>
-        </p:spPr>
-      </p:sp>
-      <p:sp>
-        <p:nvSpPr>
-          <p:cNvPr id="15" name="Text 13"/>
-          <p:cNvSpPr/>
-          <p:nvPr/>
-        </p:nvSpPr>
-        <p:spPr>
-          <a:xfrm>
-            <a:off x="8247888" y="1609344"/>
-            <a:ext cx="3200400" cy="219456"/>
-          </a:xfrm>
-          <a:prstGeom prst="rect">
-            <a:avLst/>
-          </a:prstGeom>
-          <a:noFill/>
-          <a:ln/>
-        </p:spPr>
-        <p:txBody>
-          <a:bodyPr wrap="square" lIns="0" tIns="0" rIns="0" bIns="0" rtlCol="0" anchor="ctr">
-            <a:normAutofit/>
-          </a:bodyPr>
-          <a:lstStyle/>
-          <a:p>
-            <a:pPr indent="0" marL="0">
-              <a:buNone/>
-            </a:pPr>
-            <a:r>
-              <a:rPr lang="en-US" sz="1200" b="1" dirty="0">
-                <a:solidFill>
-                  <a:srgbClr val="0B1220"/>
-                </a:solidFill>
-                <a:latin typeface="Aptos" pitchFamily="34" charset="0"/>
-                <a:ea typeface="Aptos" pitchFamily="34" charset="-122"/>
-                <a:cs typeface="Aptos" pitchFamily="34" charset="-120"/>
-              </a:rPr>
-              <a:t>Scales to zero waiting</a:t>
-            </a:r>
-            <a:endParaRPr lang="en-US" sz="1200" dirty="0"/>
-          </a:p>
-        </p:txBody>
-      </p:sp>
-      <p:sp>
-        <p:nvSpPr>
-          <p:cNvPr id="16" name="Text 14"/>
-          <p:cNvSpPr/>
-          <p:nvPr/>
-        </p:nvSpPr>
-        <p:spPr>
-          <a:xfrm>
-            <a:off x="8247888" y="1920240"/>
-            <a:ext cx="3200400" cy="1280160"/>
-          </a:xfrm>
-          <a:prstGeom prst="rect">
-            <a:avLst/>
-          </a:prstGeom>
-          <a:noFill/>
-          <a:ln/>
-        </p:spPr>
-        <p:txBody>
-          <a:bodyPr wrap="square" lIns="254" tIns="254" rIns="254" bIns="254" rtlCol="0" anchor="t">
-            <a:normAutofit/>
-          </a:bodyPr>
-          <a:lstStyle/>
-          <a:p>
-            <a:pPr indent="0" marL="0">
-              <a:buNone/>
-            </a:pPr>
-            <a:r>
-              <a:rPr lang="en-US" sz="920" dirty="0">
-                <a:solidFill>
-                  <a:srgbClr val="334155"/>
-                </a:solidFill>
-                <a:latin typeface="Aptos" pitchFamily="34" charset="0"/>
-                <a:ea typeface="Aptos" pitchFamily="34" charset="-122"/>
-                <a:cs typeface="Aptos" pitchFamily="34" charset="-120"/>
-              </a:rPr>
-              <a:t>On the Durable Task Scheduler the run pauses on an external event + durable timer - a review can safely take hours or days, consuming no compute.</a:t>
-            </a:r>
-            <a:endParaRPr lang="en-US" sz="920" dirty="0"/>
-          </a:p>
-        </p:txBody>
-      </p:sp>
-      <p:sp>
-        <p:nvSpPr>
-          <p:cNvPr id="17" name="Text 15"/>
-          <p:cNvSpPr/>
-          <p:nvPr/>
-        </p:nvSpPr>
-        <p:spPr>
-          <a:xfrm>
-            <a:off x="640080" y="3520440"/>
-            <a:ext cx="10972800" cy="2011680"/>
-          </a:xfrm>
-          <a:prstGeom prst="rect">
-            <a:avLst/>
-          </a:prstGeom>
-          <a:noFill/>
-          <a:ln/>
-        </p:spPr>
-        <p:txBody>
-          <a:bodyPr wrap="square" lIns="381" tIns="381" rIns="381" bIns="381" rtlCol="0" anchor="ctr">
-            <a:normAutofit/>
-          </a:bodyPr>
-          <a:lstStyle/>
-          <a:p>
-            <a:pPr marL="152400" indent="-152400">
-              <a:buSzPct val="100000"/>
-              <a:buChar char="•"/>
-            </a:pPr>
-            <a:r>
-              <a:rPr lang="en-US" sz="1150" dirty="0">
-                <a:solidFill>
-                  <a:srgbClr val="334155"/>
-                </a:solidFill>
-                <a:latin typeface="Aptos" pitchFamily="34" charset="0"/>
-                <a:ea typeface="Aptos" pitchFamily="34" charset="-122"/>
-                <a:cs typeface="Aptos" pitchFamily="34" charset="-120"/>
-              </a:rPr>
-              <a:t>Guardrails in code: illegal transition -&gt; 409; an agent trying to approve -&gt; 403.</a:t>
-            </a:r>
-            <a:endParaRPr lang="en-US" sz="1150" dirty="0"/>
-          </a:p>
-          <a:p>
-            <a:pPr marL="152400" indent="-152400">
-              <a:buSzPct val="100000"/>
-              <a:buChar char="•"/>
-            </a:pPr>
-            <a:r>
-              <a:rPr lang="en-US" sz="1150" dirty="0">
-                <a:solidFill>
-                  <a:srgbClr val="334155"/>
-                </a:solidFill>
-                <a:latin typeface="Aptos" pitchFamily="34" charset="0"/>
-                <a:ea typeface="Aptos" pitchFamily="34" charset="-122"/>
-                <a:cs typeface="Aptos" pitchFamily="34" charset="-120"/>
-              </a:rPr>
-              <a:t>Live and verified end to end in the deployed app against the real Durable Task Scheduler.</a:t>
-            </a:r>
-            <a:endParaRPr lang="en-US" sz="1150" dirty="0"/>
-          </a:p>
-          <a:p>
-            <a:pPr marL="152400" indent="-152400">
-              <a:buSzPct val="100000"/>
-              <a:buChar char="•"/>
-            </a:pPr>
-            <a:r>
-              <a:rPr lang="en-US" sz="1150" dirty="0">
-                <a:solidFill>
-                  <a:srgbClr val="334155"/>
-                </a:solidFill>
-                <a:latin typeface="Aptos" pitchFamily="34" charset="0"/>
-                <a:ea typeface="Aptos" pitchFamily="34" charset="-122"/>
-                <a:cs typeface="Aptos" pitchFamily="34" charset="-120"/>
-              </a:rPr>
-              <a:t>Brief / doc: docs/hitl-durable-task-scheduler.md.</a:t>
-            </a:r>
-            <a:endParaRPr lang="en-US" sz="1150" dirty="0"/>
-          </a:p>
-        </p:txBody>
-      </p:sp>
-      <p:sp>
-        <p:nvSpPr>
-          <p:cNvPr id="18" name="Text 16"/>
-          <p:cNvSpPr/>
-          <p:nvPr/>
-        </p:nvSpPr>
-        <p:spPr>
-          <a:xfrm>
-            <a:off x="640080" y="5806440"/>
-            <a:ext cx="10972800" cy="457200"/>
-          </a:xfrm>
-          <a:prstGeom prst="rect">
-            <a:avLst/>
-          </a:prstGeom>
-          <a:noFill/>
-          <a:ln/>
-        </p:spPr>
-        <p:txBody>
-          <a:bodyPr wrap="square" lIns="0" tIns="0" rIns="0" bIns="0" rtlCol="0" anchor="ctr"/>
-          <a:lstStyle/>
-          <a:p>
-            <a:pPr indent="0" marL="0">
-              <a:buNone/>
-            </a:pPr>
-            <a:r>
-              <a:rPr lang="en-US" sz="1000" i="1" dirty="0">
-                <a:solidFill>
-                  <a:srgbClr val="64748B"/>
-                </a:solidFill>
-                <a:latin typeface="Aptos" pitchFamily="34" charset="0"/>
-                <a:ea typeface="Aptos" pitchFamily="34" charset="-122"/>
-                <a:cs typeface="Aptos" pitchFamily="34" charset="-120"/>
-              </a:rPr>
-              <a:t>A governed workflow must pause for a human - durably, with an audit trail.</a:t>
-            </a:r>
-            <a:endParaRPr lang="en-US" sz="1000" dirty="0"/>
-          </a:p>
-        </p:txBody>
-      </p:sp>
-      <p:sp>
-        <p:nvSpPr>
-          <p:cNvPr id="25" name="Slide Number Placeholder 0"/>
-          <p:cNvSpPr>
-            <a:spLocks noGrp="1"/>
-          </p:cNvSpPr>
-          <p:nvPr>
-            <p:ph type="sldNum" sz="quarter" idx="4294967295"/>
-          </p:nvPr>
-        </p:nvSpPr>
-        <p:spPr>
-          <a:xfrm>
-            <a:off x="11475720" y="6565392"/>
-            <a:ext cx="800000" cy="300000"/>
-          </a:xfrm>
-          <a:prstGeom prst="rect">
-            <a:avLst/>
-          </a:prstGeom>
-          <a:extLst>
-            <a:ext uri="{C572A759-6A51-4108-AA02-DFA0A04FC94B}">
-              <ma14:wrappingTextBoxFlag xmlns:ma14="http://schemas.microsoft.com/office/mac/drawingml/2011/main" val="0"/>
-            </a:ext>
-          </a:extLst>
-        </p:spPr>
-        <p:txBody>
-          <a:bodyPr/>
-          <a:lstStyle>
-            <a:lvl1pPr>
-              <a:defRPr sz="700">
-                <a:solidFill>
-                  <a:srgbClr val="64748B"/>
-                </a:solidFill>
-                <a:latin typeface="Aptos"/>
-                <a:ea typeface="Aptos"/>
-                <a:cs typeface="Aptos"/>
-              </a:defRPr>
-            </a:lvl1pPr>
-          </a:lstStyle>
-          <a:p>
-            <a:pPr algn="l"/>
-            <a:fld id="{F7021451-1387-4CA6-816F-3879F97B5CBC}" type="slidenum">
-              <a:rPr b="0" lang="en-US"/>
-              <a:t>20</a:t>
-            </a:fld>
-            <a:endParaRPr lang="en-US"/>
-          </a:p>
-        </p:txBody>
-      </p:sp>
+      <p:pic>
+        <p:nvPicPr>
+          <p:cNvPr id="2" name="Image 0" descr="C:\Coding\governed-agents-workshop\workshop-assets\dts-hitl-architecture.png">    </p:cNvPr>
+          <p:cNvPicPr>
+            <a:picLocks noChangeAspect="1"/>
+          </p:cNvPicPr>
+          <p:nvPr/>
+        </p:nvPicPr>
+        <p:blipFill>
+          <a:blip r:embed="rId1"/>
+          <a:stretch>
+            <a:fillRect/>
+          </a:stretch>
+        </p:blipFill>
+        <p:spPr>
+          <a:xfrm>
+            <a:off x="246888" y="137160"/>
+            <a:ext cx="11704320" cy="6583680"/>
+          </a:xfrm>
+          <a:prstGeom prst="rect">
+            <a:avLst/>
+          </a:prstGeom>
+        </p:spPr>
+      </p:pic>
     </p:spTree>
   </p:cSld>
   <p:clrMapOvr>

</xml_diff>

<commit_message>
Add BYOR diagram slide to deck (19); renumber facilitator plan (+1 for >=19)
Deck is 27 slides: BYOR (JFrog + GitHub Actions) inserted after the hosted-agents agent-type slide.
Facilitator delivery plan adds a Slide 19 BYOR talk track and re-syncs all downstream slide numbers
and ranges.

Co-authored-by: Copilot <223556219+Copilot@users.noreply.github.com>
</commit_message>
<xml_diff>
--- a/workshop-assets/kaiser-consolidated-customer-deck.pptx
+++ b/workshop-assets/kaiser-consolidated-customer-deck.pptx
@@ -31,9 +31,10 @@
     <p:sldId id="279" r:id="rId25"/>
     <p:sldId id="280" r:id="rId26"/>
     <p:sldId id="281" r:id="rId27"/>
+    <p:sldId id="282" r:id="rId28"/>
   </p:sldIdLst>
   <p:notesMasterIdLst>
-    <p:notesMasterId r:id="rId28"/>
+    <p:notesMasterId r:id="rId29"/>
   </p:notesMasterIdLst>
   <p:sldSz cx="12192000" cy="6858000"/>
   <p:notesSz cx="6858000" cy="12192000"/>
@@ -1407,7 +1408,7 @@
           <a:p>
             <a:r>
               <a:rPr lang="en-US" dirty="0"/>
-              <a:t>Two-in-one: the correlation-trace story plus the PHI-protection posture. The driver is request/response content in Foundry logs.</a:t>
+              <a:t>Bring Your Own Registry for hosted agents - the supply-chain slide (agenda: hands-on lab). GitHub Actions builds the agent image, runs the eval release gate + contract/policy checks, and pushes to JFrog Artifactory with KEYLESS OIDC (no stored creds); Foundry Hosted Agents / Azure Container Apps pull the governed image via managed identity. The point for KP: KP keeps image provenance, Xray scanning, and dev-&gt;staging-&gt;prod promotion in its OWN registry - Foundry consumes, does not own, the supply chain. Every hop uses short-lived federated identity (GitHub OIDC -&gt; Entra WIF; Azure MI -&gt; JFrog OIDC). Proposed / reference design, synthetic data only; icons are simplified glyphs. Diagram source: workshop-assets/build_byor_diagram.py.</a:t>
             </a:r>
             <a:endParaRPr lang="en-US" dirty="0"/>
           </a:p>
@@ -1583,7 +1584,7 @@
           <a:p>
             <a:r>
               <a:rPr lang="en-US" dirty="0"/>
-              <a:t>The human-control capstone. Durable Task Scheduler HITL: every run drafts an exception packet then STOPS at a care-manager approval gate - the agent drafts/reworks only; a human owns approve/reject. The orchestrator waits on an external event (ReviewDecision) raced with a durable SLA timer (24h), so a review can take hours/days consuming no compute, and resumes after restart. States: PendingReview -&gt; Approved / NeedsRework / Rejected; timer/policy -&gt; Escalated, each an append-only audit record. Guardrails in code: illegal transition -&gt; 409; an agent trying to approve -&gt; 403. Built and running today; demo approve, a blocked illegal transition, and SLA auto-escalation. Doc: docs/hitl-durable-task-scheduler.md. Icons are simplified glyphs (not official Azure product icons); synthetic data only.</a:t>
+              <a:t>Two-in-one: the correlation-trace story plus the PHI-protection posture. The driver is request/response content in Foundry logs.</a:t>
             </a:r>
             <a:endParaRPr lang="en-US" dirty="0"/>
           </a:p>
@@ -1671,7 +1672,7 @@
           <a:p>
             <a:r>
               <a:rPr lang="en-US" dirty="0"/>
-              <a:t/>
+              <a:t>The human-control capstone. Durable Task Scheduler HITL: every run drafts an exception packet then STOPS at a care-manager approval gate - the agent drafts/reworks only; a human owns approve/reject. The orchestrator waits on an external event (ReviewDecision) raced with a durable SLA timer (24h), so a review can take hours/days consuming no compute, and resumes after restart. States: PendingReview -&gt; Approved / NeedsRework / Rejected; timer/policy -&gt; Escalated, each an append-only audit record. Guardrails in code: illegal transition -&gt; 409; an agent trying to approve -&gt; 403. Built and running today; demo approve, a blocked illegal transition, and SLA auto-escalation. Doc: docs/hitl-durable-task-scheduler.md. Icons are simplified glyphs (not official Azure product icons); synthetic data only.</a:t>
             </a:r>
             <a:endParaRPr lang="en-US" dirty="0"/>
           </a:p>
@@ -1759,7 +1760,7 @@
           <a:p>
             <a:r>
               <a:rPr lang="en-US" dirty="0"/>
-              <a:t>The integrated demo. Run one case start to finish; let the trace and the human gate tell the story.</a:t>
+              <a:t/>
             </a:r>
             <a:endParaRPr lang="en-US" dirty="0"/>
           </a:p>
@@ -1847,7 +1848,7 @@
           <a:p>
             <a:r>
               <a:rPr lang="en-US" dirty="0"/>
-              <a:t>Show that safety is testable and enforced in CI. The score-override adversarial case is the one to highlight.</a:t>
+              <a:t>The integrated demo. Run one case start to finish; let the trace and the human gate tell the story.</a:t>
             </a:r>
             <a:endParaRPr lang="en-US" dirty="0"/>
           </a:p>
@@ -1935,7 +1936,7 @@
           <a:p>
             <a:r>
               <a:rPr lang="en-US" dirty="0"/>
-              <a:t>Close with a concrete, cost-aware plan. Tie each phase back to the priorities and the two-quarter window Kaiser cares about.</a:t>
+              <a:t>Show that safety is testable and enforced in CI. The score-override adversarial case is the one to highlight.</a:t>
             </a:r>
             <a:endParaRPr lang="en-US" dirty="0"/>
           </a:p>
@@ -2023,7 +2024,7 @@
           <a:p>
             <a:r>
               <a:rPr lang="en-US" dirty="0"/>
-              <a:t>Leave-behind slide. Point each persona to their briefs; the facilitator cheat-sheet has the full question -&gt; doc lookup.</a:t>
+              <a:t>Close with a concrete, cost-aware plan. Tie each phase back to the priorities and the two-quarter window Kaiser cares about.</a:t>
             </a:r>
             <a:endParaRPr lang="en-US" dirty="0"/>
           </a:p>
@@ -2111,7 +2112,7 @@
           <a:p>
             <a:r>
               <a:rPr lang="en-US" dirty="0"/>
-              <a:t>Close on the through-line: we do not choose between capability and governance - we build them together, sequenced around what Kaiser asked for.</a:t>
+              <a:t>Leave-behind slide. Point each persona to their briefs; the facilitator cheat-sheet has the full question -&gt; doc lookup.</a:t>
             </a:r>
             <a:endParaRPr lang="en-US" dirty="0"/>
           </a:p>
@@ -2135,6 +2136,94 @@
             <a:fld id="{F7021451-1387-4CA6-816F-3879F97B5CBC}" type="slidenum">
               <a:rPr lang="en-US"/>
               <a:t>26</a:t>
+            </a:fld>
+            <a:endParaRPr lang="en-US"/>
+          </a:p>
+        </p:txBody>
+      </p:sp>
+    </p:spTree>
+    <p:extLst>
+      <p:ext uri="{BB962C8B-B14F-4D97-AF65-F5344CB8AC3E}">
+        <p14:creationId xmlns:p14="http://schemas.microsoft.com/office/powerpoint/2010/main" val="1024086991"/>
+      </p:ext>
+    </p:extLst>
+  </p:cSld>
+  <p:clrMapOvr>
+    <a:masterClrMapping/>
+  </p:clrMapOvr>
+</p:notes>
+</file>
+
+<file path=ppt/notesSlides/notesSlide27.xml><?xml version="1.0" encoding="utf-8"?>
+<p:notes xmlns:a="http://schemas.openxmlformats.org/drawingml/2006/main" xmlns:r="http://schemas.openxmlformats.org/officeDocument/2006/relationships" xmlns:p="http://schemas.openxmlformats.org/presentationml/2006/main">
+  <p:cSld>
+    <p:spTree>
+      <p:nvGrpSpPr>
+        <p:cNvPr id="1" name=""/>
+        <p:cNvGrpSpPr/>
+        <p:nvPr/>
+      </p:nvGrpSpPr>
+      <p:grpSpPr>
+        <a:xfrm>
+          <a:off x="0" y="0"/>
+          <a:ext cx="0" cy="0"/>
+          <a:chOff x="0" y="0"/>
+          <a:chExt cx="0" cy="0"/>
+        </a:xfrm>
+      </p:grpSpPr>
+      <p:sp>
+        <p:nvSpPr>
+          <p:cNvPr id="2" name="Slide Image Placeholder 1"/>
+          <p:cNvSpPr>
+            <a:spLocks noGrp="1" noRot="1" noChangeAspect="1"/>
+          </p:cNvSpPr>
+          <p:nvPr>
+            <p:ph type="sldImg"/>
+          </p:nvPr>
+        </p:nvSpPr>
+        <p:spPr/>
+      </p:sp>
+      <p:sp>
+        <p:nvSpPr>
+          <p:cNvPr id="3" name="Notes Placeholder 2"/>
+          <p:cNvSpPr>
+            <a:spLocks noGrp="1"/>
+          </p:cNvSpPr>
+          <p:nvPr>
+            <p:ph type="body" idx="1"/>
+          </p:nvPr>
+        </p:nvSpPr>
+        <p:spPr/>
+        <p:txBody>
+          <a:bodyPr/>
+          <a:lstStyle/>
+          <a:p>
+            <a:r>
+              <a:rPr lang="en-US" dirty="0"/>
+              <a:t>Close on the through-line: we do not choose between capability and governance - we build them together, sequenced around what Kaiser asked for.</a:t>
+            </a:r>
+            <a:endParaRPr lang="en-US" dirty="0"/>
+          </a:p>
+        </p:txBody>
+      </p:sp>
+      <p:sp>
+        <p:nvSpPr>
+          <p:cNvPr id="4" name="Slide Number Placeholder 3"/>
+          <p:cNvSpPr>
+            <a:spLocks noGrp="1"/>
+          </p:cNvSpPr>
+          <p:nvPr>
+            <p:ph type="sldNum" sz="quarter" idx="10"/>
+          </p:nvPr>
+        </p:nvSpPr>
+        <p:spPr/>
+        <p:txBody>
+          <a:bodyPr/>
+          <a:lstStyle/>
+          <a:p>
+            <a:fld id="{F7021451-1387-4CA6-816F-3879F97B5CBC}" type="slidenum">
+              <a:rPr lang="en-US"/>
+              <a:t>27</a:t>
             </a:fld>
             <a:endParaRPr lang="en-US"/>
           </a:p>
@@ -8937,7 +9026,7 @@
     <p:bg>
       <p:bgPr>
         <a:solidFill>
-          <a:srgbClr val="F8FAFC"/>
+          <a:srgbClr val="F5F6F8"/>
         </a:solidFill>
       </p:bgPr>
     </p:bg>
@@ -8955,697 +9044,30 @@
           <a:chExt cx="0" cy="0"/>
         </a:xfrm>
       </p:grpSpPr>
-      <p:sp>
-        <p:nvSpPr>
-          <p:cNvPr id="2" name="Text 0"/>
-          <p:cNvSpPr/>
-          <p:nvPr/>
-        </p:nvSpPr>
-        <p:spPr>
-          <a:xfrm>
-            <a:off x="566928" y="384048"/>
-            <a:ext cx="10789920" cy="201168"/>
-          </a:xfrm>
-          <a:prstGeom prst="rect">
-            <a:avLst/>
-          </a:prstGeom>
-          <a:noFill/>
-          <a:ln/>
-        </p:spPr>
-        <p:txBody>
-          <a:bodyPr wrap="square" lIns="0" tIns="0" rIns="0" bIns="0" rtlCol="0" anchor="ctr"/>
-          <a:lstStyle/>
-          <a:p>
-            <a:pPr indent="0" marL="0">
-              <a:buNone/>
-            </a:pPr>
-            <a:r>
-              <a:rPr lang="en-US" sz="800" b="1" dirty="0">
-                <a:solidFill>
-                  <a:srgbClr val="0F766E"/>
-                </a:solidFill>
-                <a:latin typeface="Aptos" pitchFamily="34" charset="0"/>
-                <a:ea typeface="Aptos" pitchFamily="34" charset="-122"/>
-                <a:cs typeface="Aptos" pitchFamily="34" charset="-120"/>
-              </a:rPr>
-              <a:t>PRIORITY - LEE / DAY 2</a:t>
-            </a:r>
-            <a:endParaRPr lang="en-US" sz="800" dirty="0"/>
-          </a:p>
-        </p:txBody>
-      </p:sp>
-      <p:sp>
-        <p:nvSpPr>
-          <p:cNvPr id="3" name="Text 1"/>
-          <p:cNvSpPr/>
-          <p:nvPr/>
-        </p:nvSpPr>
-        <p:spPr>
-          <a:xfrm>
-            <a:off x="548640" y="658368"/>
-            <a:ext cx="11064240" cy="502920"/>
-          </a:xfrm>
-          <a:prstGeom prst="rect">
-            <a:avLst/>
-          </a:prstGeom>
-          <a:noFill/>
-          <a:ln/>
-        </p:spPr>
-        <p:txBody>
-          <a:bodyPr wrap="square" lIns="0" tIns="0" rIns="0" bIns="0" rtlCol="0" anchor="ctr">
-            <a:normAutofit/>
-          </a:bodyPr>
-          <a:lstStyle/>
-          <a:p>
-            <a:pPr indent="0" marL="0">
-              <a:buNone/>
-            </a:pPr>
-            <a:r>
-              <a:rPr lang="en-US" sz="2300" b="1" dirty="0">
-                <a:solidFill>
-                  <a:srgbClr val="0B1220"/>
-                </a:solidFill>
-                <a:latin typeface="Aptos Display" pitchFamily="34" charset="0"/>
-                <a:ea typeface="Aptos Display" pitchFamily="34" charset="-122"/>
-                <a:cs typeface="Aptos Display" pitchFamily="34" charset="-120"/>
-              </a:rPr>
-              <a:t>Observability, and protecting PHI in logs</a:t>
-            </a:r>
-            <a:endParaRPr lang="en-US" sz="2300" dirty="0"/>
-          </a:p>
-        </p:txBody>
-      </p:sp>
-      <p:sp>
-        <p:nvSpPr>
-          <p:cNvPr id="4" name="Shape 2"/>
-          <p:cNvSpPr/>
-          <p:nvPr/>
-        </p:nvSpPr>
-        <p:spPr>
-          <a:xfrm>
-            <a:off x="548640" y="1243584"/>
-            <a:ext cx="11064240" cy="0"/>
-          </a:xfrm>
-          <a:prstGeom prst="line">
-            <a:avLst/>
-          </a:prstGeom>
-          <a:noFill/>
-          <a:ln w="12700">
-            <a:solidFill>
-              <a:srgbClr val="CBD5E1"/>
-            </a:solidFill>
-            <a:prstDash val="solid"/>
-          </a:ln>
-        </p:spPr>
-      </p:sp>
-      <p:sp>
-        <p:nvSpPr>
-          <p:cNvPr id="5" name="Shape 3"/>
-          <p:cNvSpPr/>
-          <p:nvPr/>
-        </p:nvSpPr>
-        <p:spPr>
-          <a:xfrm>
-            <a:off x="640080" y="1463040"/>
-            <a:ext cx="3520440" cy="1828800"/>
-          </a:xfrm>
-          <a:prstGeom prst="roundRect">
-            <a:avLst>
-              <a:gd name="adj" fmla="val 4000"/>
-            </a:avLst>
-          </a:prstGeom>
-          <a:solidFill>
-            <a:srgbClr val="FFFFFF"/>
-          </a:solidFill>
-          <a:ln w="12700">
-            <a:solidFill>
-              <a:srgbClr val="E2E8F0"/>
-            </a:solidFill>
-            <a:prstDash val="solid"/>
-          </a:ln>
-          <a:effectLst>
-            <a:outerShdw sx="100000" sy="100000" kx="0" ky="0" algn="bl" rotWithShape="0" blurRad="25400" dist="50800" dir="2700000">
-              <a:srgbClr val="94A3B8">
-                <a:alpha val="12000"/>
-              </a:srgbClr>
-            </a:outerShdw>
-          </a:effectLst>
-        </p:spPr>
-      </p:sp>
-      <p:sp>
-        <p:nvSpPr>
-          <p:cNvPr id="6" name="Shape 4"/>
-          <p:cNvSpPr/>
-          <p:nvPr/>
-        </p:nvSpPr>
-        <p:spPr>
-          <a:xfrm>
-            <a:off x="640080" y="1463040"/>
-            <a:ext cx="64008" cy="1828800"/>
-          </a:xfrm>
-          <a:prstGeom prst="rect">
-            <a:avLst/>
-          </a:prstGeom>
-          <a:solidFill>
-            <a:srgbClr val="06B6D4"/>
-          </a:solidFill>
-          <a:ln w="12700">
-            <a:solidFill>
-              <a:srgbClr val="06B6D4"/>
-            </a:solidFill>
-            <a:prstDash val="solid"/>
-          </a:ln>
-        </p:spPr>
-      </p:sp>
-      <p:sp>
-        <p:nvSpPr>
-          <p:cNvPr id="7" name="Text 5"/>
-          <p:cNvSpPr/>
-          <p:nvPr/>
-        </p:nvSpPr>
-        <p:spPr>
-          <a:xfrm>
-            <a:off x="841248" y="1609344"/>
-            <a:ext cx="3200400" cy="219456"/>
-          </a:xfrm>
-          <a:prstGeom prst="rect">
-            <a:avLst/>
-          </a:prstGeom>
-          <a:noFill/>
-          <a:ln/>
-        </p:spPr>
-        <p:txBody>
-          <a:bodyPr wrap="square" lIns="0" tIns="0" rIns="0" bIns="0" rtlCol="0" anchor="ctr">
-            <a:normAutofit/>
-          </a:bodyPr>
-          <a:lstStyle/>
-          <a:p>
-            <a:pPr indent="0" marL="0">
-              <a:buNone/>
-            </a:pPr>
-            <a:r>
-              <a:rPr lang="en-US" sz="1200" b="1" dirty="0">
-                <a:solidFill>
-                  <a:srgbClr val="0B1220"/>
-                </a:solidFill>
-                <a:latin typeface="Aptos" pitchFamily="34" charset="0"/>
-                <a:ea typeface="Aptos" pitchFamily="34" charset="-122"/>
-                <a:cs typeface="Aptos" pitchFamily="34" charset="-120"/>
-              </a:rPr>
-              <a:t>See every decision</a:t>
-            </a:r>
-            <a:endParaRPr lang="en-US" sz="1200" dirty="0"/>
-          </a:p>
-        </p:txBody>
-      </p:sp>
-      <p:sp>
-        <p:nvSpPr>
-          <p:cNvPr id="8" name="Text 6"/>
-          <p:cNvSpPr/>
-          <p:nvPr/>
-        </p:nvSpPr>
-        <p:spPr>
-          <a:xfrm>
-            <a:off x="841248" y="1920240"/>
-            <a:ext cx="3200400" cy="1280160"/>
-          </a:xfrm>
-          <a:prstGeom prst="rect">
-            <a:avLst/>
-          </a:prstGeom>
-          <a:noFill/>
-          <a:ln/>
-        </p:spPr>
-        <p:txBody>
-          <a:bodyPr wrap="square" lIns="254" tIns="254" rIns="254" bIns="254" rtlCol="0" anchor="t">
-            <a:normAutofit/>
-          </a:bodyPr>
-          <a:lstStyle/>
-          <a:p>
-            <a:pPr indent="0" marL="0">
-              <a:buNone/>
-            </a:pPr>
-            <a:r>
-              <a:rPr lang="en-US" sz="920" dirty="0">
-                <a:solidFill>
-                  <a:srgbClr val="334155"/>
-                </a:solidFill>
-                <a:latin typeface="Aptos" pitchFamily="34" charset="0"/>
-                <a:ea typeface="Aptos" pitchFamily="34" charset="-122"/>
-                <a:cs typeface="Aptos" pitchFamily="34" charset="-120"/>
-              </a:rPr>
-              <a:t>One correlation ID joins agents, tools, policy, retrieval, and the human gate. A stable event taxonomy maps to App Insights custom events.</a:t>
-            </a:r>
-            <a:endParaRPr lang="en-US" sz="920" dirty="0"/>
-          </a:p>
-        </p:txBody>
-      </p:sp>
-      <p:sp>
-        <p:nvSpPr>
-          <p:cNvPr id="9" name="Shape 7"/>
-          <p:cNvSpPr/>
-          <p:nvPr/>
-        </p:nvSpPr>
-        <p:spPr>
-          <a:xfrm>
-            <a:off x="4343400" y="1463040"/>
-            <a:ext cx="3520440" cy="1828800"/>
-          </a:xfrm>
-          <a:prstGeom prst="roundRect">
-            <a:avLst>
-              <a:gd name="adj" fmla="val 4000"/>
-            </a:avLst>
-          </a:prstGeom>
-          <a:solidFill>
-            <a:srgbClr val="FFFFFF"/>
-          </a:solidFill>
-          <a:ln w="12700">
-            <a:solidFill>
-              <a:srgbClr val="E2E8F0"/>
-            </a:solidFill>
-            <a:prstDash val="solid"/>
-          </a:ln>
-          <a:effectLst>
-            <a:outerShdw sx="100000" sy="100000" kx="0" ky="0" algn="bl" rotWithShape="0" blurRad="25400" dist="50800" dir="2700000">
-              <a:srgbClr val="94A3B8">
-                <a:alpha val="12000"/>
-              </a:srgbClr>
-            </a:outerShdw>
-          </a:effectLst>
-        </p:spPr>
-      </p:sp>
-      <p:sp>
-        <p:nvSpPr>
-          <p:cNvPr id="10" name="Shape 8"/>
-          <p:cNvSpPr/>
-          <p:nvPr/>
-        </p:nvSpPr>
-        <p:spPr>
-          <a:xfrm>
-            <a:off x="4343400" y="1463040"/>
-            <a:ext cx="64008" cy="1828800"/>
-          </a:xfrm>
-          <a:prstGeom prst="rect">
-            <a:avLst/>
-          </a:prstGeom>
-          <a:solidFill>
-            <a:srgbClr val="F59E0B"/>
-          </a:solidFill>
-          <a:ln w="12700">
-            <a:solidFill>
-              <a:srgbClr val="F59E0B"/>
-            </a:solidFill>
-            <a:prstDash val="solid"/>
-          </a:ln>
-        </p:spPr>
-      </p:sp>
-      <p:sp>
-        <p:nvSpPr>
-          <p:cNvPr id="11" name="Text 9"/>
-          <p:cNvSpPr/>
-          <p:nvPr/>
-        </p:nvSpPr>
-        <p:spPr>
-          <a:xfrm>
-            <a:off x="4544568" y="1609344"/>
-            <a:ext cx="3200400" cy="219456"/>
-          </a:xfrm>
-          <a:prstGeom prst="rect">
-            <a:avLst/>
-          </a:prstGeom>
-          <a:noFill/>
-          <a:ln/>
-        </p:spPr>
-        <p:txBody>
-          <a:bodyPr wrap="square" lIns="0" tIns="0" rIns="0" bIns="0" rtlCol="0" anchor="ctr">
-            <a:normAutofit/>
-          </a:bodyPr>
-          <a:lstStyle/>
-          <a:p>
-            <a:pPr indent="0" marL="0">
-              <a:buNone/>
-            </a:pPr>
-            <a:r>
-              <a:rPr lang="en-US" sz="1200" b="1" dirty="0">
-                <a:solidFill>
-                  <a:srgbClr val="0B1220"/>
-                </a:solidFill>
-                <a:latin typeface="Aptos" pitchFamily="34" charset="0"/>
-                <a:ea typeface="Aptos" pitchFamily="34" charset="-122"/>
-                <a:cs typeface="Aptos" pitchFamily="34" charset="-120"/>
-              </a:rPr>
-              <a:t>Foundry changes the posture</a:t>
-            </a:r>
-            <a:endParaRPr lang="en-US" sz="1200" dirty="0"/>
-          </a:p>
-        </p:txBody>
-      </p:sp>
-      <p:sp>
-        <p:nvSpPr>
-          <p:cNvPr id="12" name="Text 10"/>
-          <p:cNvSpPr/>
-          <p:nvPr/>
-        </p:nvSpPr>
-        <p:spPr>
-          <a:xfrm>
-            <a:off x="4544568" y="1920240"/>
-            <a:ext cx="3200400" cy="1280160"/>
-          </a:xfrm>
-          <a:prstGeom prst="rect">
-            <a:avLst/>
-          </a:prstGeom>
-          <a:noFill/>
-          <a:ln/>
-        </p:spPr>
-        <p:txBody>
-          <a:bodyPr wrap="square" lIns="254" tIns="254" rIns="254" bIns="254" rtlCol="0" anchor="t">
-            <a:normAutofit/>
-          </a:bodyPr>
-          <a:lstStyle/>
-          <a:p>
-            <a:pPr indent="0" marL="0">
-              <a:buNone/>
-            </a:pPr>
-            <a:r>
-              <a:rPr lang="en-US" sz="920" dirty="0">
-                <a:solidFill>
-                  <a:srgbClr val="334155"/>
-                </a:solidFill>
-                <a:latin typeface="Aptos" pitchFamily="34" charset="0"/>
-                <a:ea typeface="Aptos" pitchFamily="34" charset="-122"/>
-                <a:cs typeface="Aptos" pitchFamily="34" charset="-120"/>
-              </a:rPr>
-              <a:t>Logs can now hold request / response content - possibly PHI. That reclassifies the store from telemetry to regulated data at rest.</a:t>
-            </a:r>
-            <a:endParaRPr lang="en-US" sz="920" dirty="0"/>
-          </a:p>
-        </p:txBody>
-      </p:sp>
-      <p:sp>
-        <p:nvSpPr>
-          <p:cNvPr id="13" name="Shape 11"/>
-          <p:cNvSpPr/>
-          <p:nvPr/>
-        </p:nvSpPr>
-        <p:spPr>
-          <a:xfrm>
-            <a:off x="8046720" y="1463040"/>
-            <a:ext cx="3520440" cy="1828800"/>
-          </a:xfrm>
-          <a:prstGeom prst="roundRect">
-            <a:avLst>
-              <a:gd name="adj" fmla="val 4000"/>
-            </a:avLst>
-          </a:prstGeom>
-          <a:solidFill>
-            <a:srgbClr val="FFFFFF"/>
-          </a:solidFill>
-          <a:ln w="12700">
-            <a:solidFill>
-              <a:srgbClr val="E2E8F0"/>
-            </a:solidFill>
-            <a:prstDash val="solid"/>
-          </a:ln>
-          <a:effectLst>
-            <a:outerShdw sx="100000" sy="100000" kx="0" ky="0" algn="bl" rotWithShape="0" blurRad="25400" dist="50800" dir="2700000">
-              <a:srgbClr val="94A3B8">
-                <a:alpha val="12000"/>
-              </a:srgbClr>
-            </a:outerShdw>
-          </a:effectLst>
-        </p:spPr>
-      </p:sp>
-      <p:sp>
-        <p:nvSpPr>
-          <p:cNvPr id="14" name="Shape 12"/>
-          <p:cNvSpPr/>
-          <p:nvPr/>
-        </p:nvSpPr>
-        <p:spPr>
-          <a:xfrm>
-            <a:off x="8046720" y="1463040"/>
-            <a:ext cx="64008" cy="1828800"/>
-          </a:xfrm>
-          <a:prstGeom prst="rect">
-            <a:avLst/>
-          </a:prstGeom>
-          <a:solidFill>
-            <a:srgbClr val="2563EB"/>
-          </a:solidFill>
-          <a:ln w="12700">
-            <a:solidFill>
-              <a:srgbClr val="2563EB"/>
-            </a:solidFill>
-            <a:prstDash val="solid"/>
-          </a:ln>
-        </p:spPr>
-      </p:sp>
-      <p:sp>
-        <p:nvSpPr>
-          <p:cNvPr id="15" name="Text 13"/>
-          <p:cNvSpPr/>
-          <p:nvPr/>
-        </p:nvSpPr>
-        <p:spPr>
-          <a:xfrm>
-            <a:off x="8247888" y="1609344"/>
-            <a:ext cx="3200400" cy="219456"/>
-          </a:xfrm>
-          <a:prstGeom prst="rect">
-            <a:avLst/>
-          </a:prstGeom>
-          <a:noFill/>
-          <a:ln/>
-        </p:spPr>
-        <p:txBody>
-          <a:bodyPr wrap="square" lIns="0" tIns="0" rIns="0" bIns="0" rtlCol="0" anchor="ctr">
-            <a:normAutofit/>
-          </a:bodyPr>
-          <a:lstStyle/>
-          <a:p>
-            <a:pPr indent="0" marL="0">
-              <a:buNone/>
-            </a:pPr>
-            <a:r>
-              <a:rPr lang="en-US" sz="1200" b="1" dirty="0">
-                <a:solidFill>
-                  <a:srgbClr val="0B1220"/>
-                </a:solidFill>
-                <a:latin typeface="Aptos" pitchFamily="34" charset="0"/>
-                <a:ea typeface="Aptos" pitchFamily="34" charset="-122"/>
-                <a:cs typeface="Aptos" pitchFamily="34" charset="-120"/>
-              </a:rPr>
-              <a:t>Dedicated + CMK + AMPLS</a:t>
-            </a:r>
-            <a:endParaRPr lang="en-US" sz="1200" dirty="0"/>
-          </a:p>
-        </p:txBody>
-      </p:sp>
-      <p:sp>
-        <p:nvSpPr>
-          <p:cNvPr id="16" name="Text 14"/>
-          <p:cNvSpPr/>
-          <p:nvPr/>
-        </p:nvSpPr>
-        <p:spPr>
-          <a:xfrm>
-            <a:off x="8247888" y="1920240"/>
-            <a:ext cx="3200400" cy="1280160"/>
-          </a:xfrm>
-          <a:prstGeom prst="rect">
-            <a:avLst/>
-          </a:prstGeom>
-          <a:noFill/>
-          <a:ln/>
-        </p:spPr>
-        <p:txBody>
-          <a:bodyPr wrap="square" lIns="254" tIns="254" rIns="254" bIns="254" rtlCol="0" anchor="t">
-            <a:normAutofit/>
-          </a:bodyPr>
-          <a:lstStyle/>
-          <a:p>
-            <a:pPr indent="0" marL="0">
-              <a:buNone/>
-            </a:pPr>
-            <a:r>
-              <a:rPr lang="en-US" sz="920" dirty="0">
-                <a:solidFill>
-                  <a:srgbClr val="334155"/>
-                </a:solidFill>
-                <a:latin typeface="Aptos" pitchFamily="34" charset="0"/>
-                <a:ea typeface="Aptos" pitchFamily="34" charset="-122"/>
-                <a:cs typeface="Aptos" pitchFamily="34" charset="-120"/>
-              </a:rPr>
-              <a:t>CMK needs a dedicated LAW cluster (double encryption); AMPLS puts ingestion + query on a private endpoint. Plus minimize what you log.</a:t>
-            </a:r>
-            <a:endParaRPr lang="en-US" sz="920" dirty="0"/>
-          </a:p>
-        </p:txBody>
-      </p:sp>
-      <p:sp>
-        <p:nvSpPr>
-          <p:cNvPr id="17" name="Text 15"/>
-          <p:cNvSpPr/>
-          <p:nvPr/>
-        </p:nvSpPr>
-        <p:spPr>
-          <a:xfrm>
-            <a:off x="640080" y="3520440"/>
-            <a:ext cx="10972800" cy="2011680"/>
-          </a:xfrm>
-          <a:prstGeom prst="rect">
-            <a:avLst/>
-          </a:prstGeom>
-          <a:noFill/>
-          <a:ln/>
-        </p:spPr>
-        <p:txBody>
-          <a:bodyPr wrap="square" lIns="381" tIns="381" rIns="381" bIns="381" rtlCol="0" anchor="ctr">
-            <a:normAutofit/>
-          </a:bodyPr>
-          <a:lstStyle/>
-          <a:p>
-            <a:pPr marL="152400" indent="-152400">
-              <a:buSzPct val="100000"/>
-              <a:buChar char="•"/>
-            </a:pPr>
-            <a:r>
-              <a:rPr lang="en-US" sz="1150" dirty="0">
-                <a:solidFill>
-                  <a:srgbClr val="334155"/>
-                </a:solidFill>
-                <a:latin typeface="Aptos" pitchFamily="34" charset="0"/>
-                <a:ea typeface="Aptos" pitchFamily="34" charset="-122"/>
-                <a:cs typeface="Aptos" pitchFamily="34" charset="-120"/>
-              </a:rPr>
-              <a:t>Sensitive content off by default; pseudonymize actors; never capture secrets.</a:t>
-            </a:r>
-            <a:endParaRPr lang="en-US" sz="1150" dirty="0"/>
-          </a:p>
-          <a:p>
-            <a:pPr marL="152400" indent="-152400">
-              <a:buSzPct val="100000"/>
-              <a:buChar char="•"/>
-            </a:pPr>
-            <a:r>
-              <a:rPr lang="en-US" sz="1150" dirty="0">
-                <a:solidFill>
-                  <a:srgbClr val="334155"/>
-                </a:solidFill>
-                <a:latin typeface="Aptos" pitchFamily="34" charset="0"/>
-                <a:ea typeface="Aptos" pitchFamily="34" charset="-122"/>
-                <a:cs typeface="Aptos" pitchFamily="34" charset="-120"/>
-              </a:rPr>
-              <a:t>Start with the Foundry workspace on the dedicated cluster; KP volume makes it cost-favorable.</a:t>
-            </a:r>
-            <a:endParaRPr lang="en-US" sz="1150" dirty="0"/>
-          </a:p>
-          <a:p>
-            <a:pPr marL="152400" indent="-152400">
-              <a:buSzPct val="100000"/>
-              <a:buChar char="•"/>
-            </a:pPr>
-            <a:r>
-              <a:rPr lang="en-US" sz="1150" dirty="0">
-                <a:solidFill>
-                  <a:srgbClr val="334155"/>
-                </a:solidFill>
-                <a:latin typeface="Aptos" pitchFamily="34" charset="0"/>
-                <a:ea typeface="Aptos" pitchFamily="34" charset="-122"/>
-                <a:cs typeface="Aptos" pitchFamily="34" charset="-120"/>
-              </a:rPr>
-              <a:t>Brief: docs/observability-dedicated-cluster-cmk-ampls.md (Lee leads Day 2).</a:t>
-            </a:r>
-            <a:endParaRPr lang="en-US" sz="1150" dirty="0"/>
-          </a:p>
-        </p:txBody>
-      </p:sp>
-      <p:sp>
-        <p:nvSpPr>
-          <p:cNvPr id="18" name="Text 16"/>
-          <p:cNvSpPr/>
-          <p:nvPr/>
-        </p:nvSpPr>
-        <p:spPr>
-          <a:xfrm>
-            <a:off x="640080" y="5806440"/>
-            <a:ext cx="10972800" cy="457200"/>
-          </a:xfrm>
-          <a:prstGeom prst="rect">
-            <a:avLst/>
-          </a:prstGeom>
-          <a:noFill/>
-          <a:ln/>
-        </p:spPr>
-        <p:txBody>
-          <a:bodyPr wrap="square" lIns="0" tIns="0" rIns="0" bIns="0" rtlCol="0" anchor="ctr"/>
-          <a:lstStyle/>
-          <a:p>
-            <a:pPr indent="0" marL="0">
-              <a:buNone/>
-            </a:pPr>
-            <a:r>
-              <a:rPr lang="en-US" sz="1000" i="1" dirty="0">
-                <a:solidFill>
-                  <a:srgbClr val="64748B"/>
-                </a:solidFill>
-                <a:latin typeface="Aptos" pitchFamily="34" charset="0"/>
-                <a:ea typeface="Aptos" pitchFamily="34" charset="-122"/>
-                <a:cs typeface="Aptos" pitchFamily="34" charset="-120"/>
-              </a:rPr>
-              <a:t>Minimize at the source, CMK-encrypt what remains, keep it on the private network.</a:t>
-            </a:r>
-            <a:endParaRPr lang="en-US" sz="1000" dirty="0"/>
-          </a:p>
-        </p:txBody>
-      </p:sp>
-      <p:sp>
-        <p:nvSpPr>
-          <p:cNvPr id="25" name="Slide Number Placeholder 0"/>
-          <p:cNvSpPr>
-            <a:spLocks noGrp="1"/>
-          </p:cNvSpPr>
-          <p:nvPr>
-            <p:ph type="sldNum" sz="quarter" idx="4294967295"/>
-          </p:nvPr>
-        </p:nvSpPr>
-        <p:spPr>
-          <a:xfrm>
-            <a:off x="11475720" y="6565392"/>
-            <a:ext cx="800000" cy="300000"/>
-          </a:xfrm>
-          <a:prstGeom prst="rect">
-            <a:avLst/>
-          </a:prstGeom>
-          <a:extLst>
-            <a:ext uri="{C572A759-6A51-4108-AA02-DFA0A04FC94B}">
-              <ma14:wrappingTextBoxFlag xmlns:ma14="http://schemas.microsoft.com/office/mac/drawingml/2011/main" val="0"/>
-            </a:ext>
-          </a:extLst>
-        </p:spPr>
-        <p:txBody>
-          <a:bodyPr/>
-          <a:lstStyle>
-            <a:lvl1pPr>
-              <a:defRPr sz="700">
-                <a:solidFill>
-                  <a:srgbClr val="64748B"/>
-                </a:solidFill>
-                <a:latin typeface="Aptos"/>
-                <a:ea typeface="Aptos"/>
-                <a:cs typeface="Aptos"/>
-              </a:defRPr>
-            </a:lvl1pPr>
-          </a:lstStyle>
-          <a:p>
-            <a:pPr algn="l"/>
-            <a:fld id="{F7021451-1387-4CA6-816F-3879F97B5CBC}" type="slidenum">
-              <a:rPr b="0" lang="en-US"/>
-              <a:t>19</a:t>
-            </a:fld>
-            <a:endParaRPr lang="en-US"/>
-          </a:p>
-        </p:txBody>
-      </p:sp>
+      <p:pic>
+        <p:nvPicPr>
+          <p:cNvPr id="2" name="Image 0" descr="C:\Coding\governed-agents-workshop\workshop-assets\byor-jfrog-githubactions-architecture.png">    </p:cNvPr>
+          <p:cNvPicPr>
+            <a:picLocks noChangeAspect="1"/>
+          </p:cNvPicPr>
+          <p:nvPr/>
+        </p:nvPicPr>
+        <p:blipFill>
+          <a:blip r:embed="rId1"/>
+          <a:stretch>
+            <a:fillRect/>
+          </a:stretch>
+        </p:blipFill>
+        <p:spPr>
+          <a:xfrm>
+            <a:off x="246888" y="137160"/>
+            <a:ext cx="11704320" cy="6583680"/>
+          </a:xfrm>
+          <a:prstGeom prst="rect">
+            <a:avLst/>
+          </a:prstGeom>
+        </p:spPr>
+      </p:pic>
     </p:spTree>
   </p:cSld>
   <p:clrMapOvr>
@@ -13351,6 +12773,729 @@
     <p:bg>
       <p:bgPr>
         <a:solidFill>
+          <a:srgbClr val="F8FAFC"/>
+        </a:solidFill>
+      </p:bgPr>
+    </p:bg>
+    <p:spTree>
+      <p:nvGrpSpPr>
+        <p:cNvPr id="1" name=""/>
+        <p:cNvGrpSpPr/>
+        <p:nvPr/>
+      </p:nvGrpSpPr>
+      <p:grpSpPr>
+        <a:xfrm>
+          <a:off x="0" y="0"/>
+          <a:ext cx="0" cy="0"/>
+          <a:chOff x="0" y="0"/>
+          <a:chExt cx="0" cy="0"/>
+        </a:xfrm>
+      </p:grpSpPr>
+      <p:sp>
+        <p:nvSpPr>
+          <p:cNvPr id="2" name="Text 0"/>
+          <p:cNvSpPr/>
+          <p:nvPr/>
+        </p:nvSpPr>
+        <p:spPr>
+          <a:xfrm>
+            <a:off x="566928" y="384048"/>
+            <a:ext cx="10789920" cy="201168"/>
+          </a:xfrm>
+          <a:prstGeom prst="rect">
+            <a:avLst/>
+          </a:prstGeom>
+          <a:noFill/>
+          <a:ln/>
+        </p:spPr>
+        <p:txBody>
+          <a:bodyPr wrap="square" lIns="0" tIns="0" rIns="0" bIns="0" rtlCol="0" anchor="ctr"/>
+          <a:lstStyle/>
+          <a:p>
+            <a:pPr indent="0" marL="0">
+              <a:buNone/>
+            </a:pPr>
+            <a:r>
+              <a:rPr lang="en-US" sz="800" b="1" dirty="0">
+                <a:solidFill>
+                  <a:srgbClr val="0F766E"/>
+                </a:solidFill>
+                <a:latin typeface="Aptos" pitchFamily="34" charset="0"/>
+                <a:ea typeface="Aptos" pitchFamily="34" charset="-122"/>
+                <a:cs typeface="Aptos" pitchFamily="34" charset="-120"/>
+              </a:rPr>
+              <a:t>PRIORITY - LEE / DAY 2</a:t>
+            </a:r>
+            <a:endParaRPr lang="en-US" sz="800" dirty="0"/>
+          </a:p>
+        </p:txBody>
+      </p:sp>
+      <p:sp>
+        <p:nvSpPr>
+          <p:cNvPr id="3" name="Text 1"/>
+          <p:cNvSpPr/>
+          <p:nvPr/>
+        </p:nvSpPr>
+        <p:spPr>
+          <a:xfrm>
+            <a:off x="548640" y="658368"/>
+            <a:ext cx="11064240" cy="502920"/>
+          </a:xfrm>
+          <a:prstGeom prst="rect">
+            <a:avLst/>
+          </a:prstGeom>
+          <a:noFill/>
+          <a:ln/>
+        </p:spPr>
+        <p:txBody>
+          <a:bodyPr wrap="square" lIns="0" tIns="0" rIns="0" bIns="0" rtlCol="0" anchor="ctr">
+            <a:normAutofit/>
+          </a:bodyPr>
+          <a:lstStyle/>
+          <a:p>
+            <a:pPr indent="0" marL="0">
+              <a:buNone/>
+            </a:pPr>
+            <a:r>
+              <a:rPr lang="en-US" sz="2300" b="1" dirty="0">
+                <a:solidFill>
+                  <a:srgbClr val="0B1220"/>
+                </a:solidFill>
+                <a:latin typeface="Aptos Display" pitchFamily="34" charset="0"/>
+                <a:ea typeface="Aptos Display" pitchFamily="34" charset="-122"/>
+                <a:cs typeface="Aptos Display" pitchFamily="34" charset="-120"/>
+              </a:rPr>
+              <a:t>Observability, and protecting PHI in logs</a:t>
+            </a:r>
+            <a:endParaRPr lang="en-US" sz="2300" dirty="0"/>
+          </a:p>
+        </p:txBody>
+      </p:sp>
+      <p:sp>
+        <p:nvSpPr>
+          <p:cNvPr id="4" name="Shape 2"/>
+          <p:cNvSpPr/>
+          <p:nvPr/>
+        </p:nvSpPr>
+        <p:spPr>
+          <a:xfrm>
+            <a:off x="548640" y="1243584"/>
+            <a:ext cx="11064240" cy="0"/>
+          </a:xfrm>
+          <a:prstGeom prst="line">
+            <a:avLst/>
+          </a:prstGeom>
+          <a:noFill/>
+          <a:ln w="12700">
+            <a:solidFill>
+              <a:srgbClr val="CBD5E1"/>
+            </a:solidFill>
+            <a:prstDash val="solid"/>
+          </a:ln>
+        </p:spPr>
+      </p:sp>
+      <p:sp>
+        <p:nvSpPr>
+          <p:cNvPr id="5" name="Shape 3"/>
+          <p:cNvSpPr/>
+          <p:nvPr/>
+        </p:nvSpPr>
+        <p:spPr>
+          <a:xfrm>
+            <a:off x="640080" y="1463040"/>
+            <a:ext cx="3520440" cy="1828800"/>
+          </a:xfrm>
+          <a:prstGeom prst="roundRect">
+            <a:avLst>
+              <a:gd name="adj" fmla="val 4000"/>
+            </a:avLst>
+          </a:prstGeom>
+          <a:solidFill>
+            <a:srgbClr val="FFFFFF"/>
+          </a:solidFill>
+          <a:ln w="12700">
+            <a:solidFill>
+              <a:srgbClr val="E2E8F0"/>
+            </a:solidFill>
+            <a:prstDash val="solid"/>
+          </a:ln>
+          <a:effectLst>
+            <a:outerShdw sx="100000" sy="100000" kx="0" ky="0" algn="bl" rotWithShape="0" blurRad="25400" dist="50800" dir="2700000">
+              <a:srgbClr val="94A3B8">
+                <a:alpha val="12000"/>
+              </a:srgbClr>
+            </a:outerShdw>
+          </a:effectLst>
+        </p:spPr>
+      </p:sp>
+      <p:sp>
+        <p:nvSpPr>
+          <p:cNvPr id="6" name="Shape 4"/>
+          <p:cNvSpPr/>
+          <p:nvPr/>
+        </p:nvSpPr>
+        <p:spPr>
+          <a:xfrm>
+            <a:off x="640080" y="1463040"/>
+            <a:ext cx="64008" cy="1828800"/>
+          </a:xfrm>
+          <a:prstGeom prst="rect">
+            <a:avLst/>
+          </a:prstGeom>
+          <a:solidFill>
+            <a:srgbClr val="06B6D4"/>
+          </a:solidFill>
+          <a:ln w="12700">
+            <a:solidFill>
+              <a:srgbClr val="06B6D4"/>
+            </a:solidFill>
+            <a:prstDash val="solid"/>
+          </a:ln>
+        </p:spPr>
+      </p:sp>
+      <p:sp>
+        <p:nvSpPr>
+          <p:cNvPr id="7" name="Text 5"/>
+          <p:cNvSpPr/>
+          <p:nvPr/>
+        </p:nvSpPr>
+        <p:spPr>
+          <a:xfrm>
+            <a:off x="841248" y="1609344"/>
+            <a:ext cx="3200400" cy="219456"/>
+          </a:xfrm>
+          <a:prstGeom prst="rect">
+            <a:avLst/>
+          </a:prstGeom>
+          <a:noFill/>
+          <a:ln/>
+        </p:spPr>
+        <p:txBody>
+          <a:bodyPr wrap="square" lIns="0" tIns="0" rIns="0" bIns="0" rtlCol="0" anchor="ctr">
+            <a:normAutofit/>
+          </a:bodyPr>
+          <a:lstStyle/>
+          <a:p>
+            <a:pPr indent="0" marL="0">
+              <a:buNone/>
+            </a:pPr>
+            <a:r>
+              <a:rPr lang="en-US" sz="1200" b="1" dirty="0">
+                <a:solidFill>
+                  <a:srgbClr val="0B1220"/>
+                </a:solidFill>
+                <a:latin typeface="Aptos" pitchFamily="34" charset="0"/>
+                <a:ea typeface="Aptos" pitchFamily="34" charset="-122"/>
+                <a:cs typeface="Aptos" pitchFamily="34" charset="-120"/>
+              </a:rPr>
+              <a:t>See every decision</a:t>
+            </a:r>
+            <a:endParaRPr lang="en-US" sz="1200" dirty="0"/>
+          </a:p>
+        </p:txBody>
+      </p:sp>
+      <p:sp>
+        <p:nvSpPr>
+          <p:cNvPr id="8" name="Text 6"/>
+          <p:cNvSpPr/>
+          <p:nvPr/>
+        </p:nvSpPr>
+        <p:spPr>
+          <a:xfrm>
+            <a:off x="841248" y="1920240"/>
+            <a:ext cx="3200400" cy="1280160"/>
+          </a:xfrm>
+          <a:prstGeom prst="rect">
+            <a:avLst/>
+          </a:prstGeom>
+          <a:noFill/>
+          <a:ln/>
+        </p:spPr>
+        <p:txBody>
+          <a:bodyPr wrap="square" lIns="254" tIns="254" rIns="254" bIns="254" rtlCol="0" anchor="t">
+            <a:normAutofit/>
+          </a:bodyPr>
+          <a:lstStyle/>
+          <a:p>
+            <a:pPr indent="0" marL="0">
+              <a:buNone/>
+            </a:pPr>
+            <a:r>
+              <a:rPr lang="en-US" sz="920" dirty="0">
+                <a:solidFill>
+                  <a:srgbClr val="334155"/>
+                </a:solidFill>
+                <a:latin typeface="Aptos" pitchFamily="34" charset="0"/>
+                <a:ea typeface="Aptos" pitchFamily="34" charset="-122"/>
+                <a:cs typeface="Aptos" pitchFamily="34" charset="-120"/>
+              </a:rPr>
+              <a:t>One correlation ID joins agents, tools, policy, retrieval, and the human gate. A stable event taxonomy maps to App Insights custom events.</a:t>
+            </a:r>
+            <a:endParaRPr lang="en-US" sz="920" dirty="0"/>
+          </a:p>
+        </p:txBody>
+      </p:sp>
+      <p:sp>
+        <p:nvSpPr>
+          <p:cNvPr id="9" name="Shape 7"/>
+          <p:cNvSpPr/>
+          <p:nvPr/>
+        </p:nvSpPr>
+        <p:spPr>
+          <a:xfrm>
+            <a:off x="4343400" y="1463040"/>
+            <a:ext cx="3520440" cy="1828800"/>
+          </a:xfrm>
+          <a:prstGeom prst="roundRect">
+            <a:avLst>
+              <a:gd name="adj" fmla="val 4000"/>
+            </a:avLst>
+          </a:prstGeom>
+          <a:solidFill>
+            <a:srgbClr val="FFFFFF"/>
+          </a:solidFill>
+          <a:ln w="12700">
+            <a:solidFill>
+              <a:srgbClr val="E2E8F0"/>
+            </a:solidFill>
+            <a:prstDash val="solid"/>
+          </a:ln>
+          <a:effectLst>
+            <a:outerShdw sx="100000" sy="100000" kx="0" ky="0" algn="bl" rotWithShape="0" blurRad="25400" dist="50800" dir="2700000">
+              <a:srgbClr val="94A3B8">
+                <a:alpha val="12000"/>
+              </a:srgbClr>
+            </a:outerShdw>
+          </a:effectLst>
+        </p:spPr>
+      </p:sp>
+      <p:sp>
+        <p:nvSpPr>
+          <p:cNvPr id="10" name="Shape 8"/>
+          <p:cNvSpPr/>
+          <p:nvPr/>
+        </p:nvSpPr>
+        <p:spPr>
+          <a:xfrm>
+            <a:off x="4343400" y="1463040"/>
+            <a:ext cx="64008" cy="1828800"/>
+          </a:xfrm>
+          <a:prstGeom prst="rect">
+            <a:avLst/>
+          </a:prstGeom>
+          <a:solidFill>
+            <a:srgbClr val="F59E0B"/>
+          </a:solidFill>
+          <a:ln w="12700">
+            <a:solidFill>
+              <a:srgbClr val="F59E0B"/>
+            </a:solidFill>
+            <a:prstDash val="solid"/>
+          </a:ln>
+        </p:spPr>
+      </p:sp>
+      <p:sp>
+        <p:nvSpPr>
+          <p:cNvPr id="11" name="Text 9"/>
+          <p:cNvSpPr/>
+          <p:nvPr/>
+        </p:nvSpPr>
+        <p:spPr>
+          <a:xfrm>
+            <a:off x="4544568" y="1609344"/>
+            <a:ext cx="3200400" cy="219456"/>
+          </a:xfrm>
+          <a:prstGeom prst="rect">
+            <a:avLst/>
+          </a:prstGeom>
+          <a:noFill/>
+          <a:ln/>
+        </p:spPr>
+        <p:txBody>
+          <a:bodyPr wrap="square" lIns="0" tIns="0" rIns="0" bIns="0" rtlCol="0" anchor="ctr">
+            <a:normAutofit/>
+          </a:bodyPr>
+          <a:lstStyle/>
+          <a:p>
+            <a:pPr indent="0" marL="0">
+              <a:buNone/>
+            </a:pPr>
+            <a:r>
+              <a:rPr lang="en-US" sz="1200" b="1" dirty="0">
+                <a:solidFill>
+                  <a:srgbClr val="0B1220"/>
+                </a:solidFill>
+                <a:latin typeface="Aptos" pitchFamily="34" charset="0"/>
+                <a:ea typeface="Aptos" pitchFamily="34" charset="-122"/>
+                <a:cs typeface="Aptos" pitchFamily="34" charset="-120"/>
+              </a:rPr>
+              <a:t>Foundry changes the posture</a:t>
+            </a:r>
+            <a:endParaRPr lang="en-US" sz="1200" dirty="0"/>
+          </a:p>
+        </p:txBody>
+      </p:sp>
+      <p:sp>
+        <p:nvSpPr>
+          <p:cNvPr id="12" name="Text 10"/>
+          <p:cNvSpPr/>
+          <p:nvPr/>
+        </p:nvSpPr>
+        <p:spPr>
+          <a:xfrm>
+            <a:off x="4544568" y="1920240"/>
+            <a:ext cx="3200400" cy="1280160"/>
+          </a:xfrm>
+          <a:prstGeom prst="rect">
+            <a:avLst/>
+          </a:prstGeom>
+          <a:noFill/>
+          <a:ln/>
+        </p:spPr>
+        <p:txBody>
+          <a:bodyPr wrap="square" lIns="254" tIns="254" rIns="254" bIns="254" rtlCol="0" anchor="t">
+            <a:normAutofit/>
+          </a:bodyPr>
+          <a:lstStyle/>
+          <a:p>
+            <a:pPr indent="0" marL="0">
+              <a:buNone/>
+            </a:pPr>
+            <a:r>
+              <a:rPr lang="en-US" sz="920" dirty="0">
+                <a:solidFill>
+                  <a:srgbClr val="334155"/>
+                </a:solidFill>
+                <a:latin typeface="Aptos" pitchFamily="34" charset="0"/>
+                <a:ea typeface="Aptos" pitchFamily="34" charset="-122"/>
+                <a:cs typeface="Aptos" pitchFamily="34" charset="-120"/>
+              </a:rPr>
+              <a:t>Logs can now hold request / response content - possibly PHI. That reclassifies the store from telemetry to regulated data at rest.</a:t>
+            </a:r>
+            <a:endParaRPr lang="en-US" sz="920" dirty="0"/>
+          </a:p>
+        </p:txBody>
+      </p:sp>
+      <p:sp>
+        <p:nvSpPr>
+          <p:cNvPr id="13" name="Shape 11"/>
+          <p:cNvSpPr/>
+          <p:nvPr/>
+        </p:nvSpPr>
+        <p:spPr>
+          <a:xfrm>
+            <a:off x="8046720" y="1463040"/>
+            <a:ext cx="3520440" cy="1828800"/>
+          </a:xfrm>
+          <a:prstGeom prst="roundRect">
+            <a:avLst>
+              <a:gd name="adj" fmla="val 4000"/>
+            </a:avLst>
+          </a:prstGeom>
+          <a:solidFill>
+            <a:srgbClr val="FFFFFF"/>
+          </a:solidFill>
+          <a:ln w="12700">
+            <a:solidFill>
+              <a:srgbClr val="E2E8F0"/>
+            </a:solidFill>
+            <a:prstDash val="solid"/>
+          </a:ln>
+          <a:effectLst>
+            <a:outerShdw sx="100000" sy="100000" kx="0" ky="0" algn="bl" rotWithShape="0" blurRad="25400" dist="50800" dir="2700000">
+              <a:srgbClr val="94A3B8">
+                <a:alpha val="12000"/>
+              </a:srgbClr>
+            </a:outerShdw>
+          </a:effectLst>
+        </p:spPr>
+      </p:sp>
+      <p:sp>
+        <p:nvSpPr>
+          <p:cNvPr id="14" name="Shape 12"/>
+          <p:cNvSpPr/>
+          <p:nvPr/>
+        </p:nvSpPr>
+        <p:spPr>
+          <a:xfrm>
+            <a:off x="8046720" y="1463040"/>
+            <a:ext cx="64008" cy="1828800"/>
+          </a:xfrm>
+          <a:prstGeom prst="rect">
+            <a:avLst/>
+          </a:prstGeom>
+          <a:solidFill>
+            <a:srgbClr val="2563EB"/>
+          </a:solidFill>
+          <a:ln w="12700">
+            <a:solidFill>
+              <a:srgbClr val="2563EB"/>
+            </a:solidFill>
+            <a:prstDash val="solid"/>
+          </a:ln>
+        </p:spPr>
+      </p:sp>
+      <p:sp>
+        <p:nvSpPr>
+          <p:cNvPr id="15" name="Text 13"/>
+          <p:cNvSpPr/>
+          <p:nvPr/>
+        </p:nvSpPr>
+        <p:spPr>
+          <a:xfrm>
+            <a:off x="8247888" y="1609344"/>
+            <a:ext cx="3200400" cy="219456"/>
+          </a:xfrm>
+          <a:prstGeom prst="rect">
+            <a:avLst/>
+          </a:prstGeom>
+          <a:noFill/>
+          <a:ln/>
+        </p:spPr>
+        <p:txBody>
+          <a:bodyPr wrap="square" lIns="0" tIns="0" rIns="0" bIns="0" rtlCol="0" anchor="ctr">
+            <a:normAutofit/>
+          </a:bodyPr>
+          <a:lstStyle/>
+          <a:p>
+            <a:pPr indent="0" marL="0">
+              <a:buNone/>
+            </a:pPr>
+            <a:r>
+              <a:rPr lang="en-US" sz="1200" b="1" dirty="0">
+                <a:solidFill>
+                  <a:srgbClr val="0B1220"/>
+                </a:solidFill>
+                <a:latin typeface="Aptos" pitchFamily="34" charset="0"/>
+                <a:ea typeface="Aptos" pitchFamily="34" charset="-122"/>
+                <a:cs typeface="Aptos" pitchFamily="34" charset="-120"/>
+              </a:rPr>
+              <a:t>Dedicated + CMK + AMPLS</a:t>
+            </a:r>
+            <a:endParaRPr lang="en-US" sz="1200" dirty="0"/>
+          </a:p>
+        </p:txBody>
+      </p:sp>
+      <p:sp>
+        <p:nvSpPr>
+          <p:cNvPr id="16" name="Text 14"/>
+          <p:cNvSpPr/>
+          <p:nvPr/>
+        </p:nvSpPr>
+        <p:spPr>
+          <a:xfrm>
+            <a:off x="8247888" y="1920240"/>
+            <a:ext cx="3200400" cy="1280160"/>
+          </a:xfrm>
+          <a:prstGeom prst="rect">
+            <a:avLst/>
+          </a:prstGeom>
+          <a:noFill/>
+          <a:ln/>
+        </p:spPr>
+        <p:txBody>
+          <a:bodyPr wrap="square" lIns="254" tIns="254" rIns="254" bIns="254" rtlCol="0" anchor="t">
+            <a:normAutofit/>
+          </a:bodyPr>
+          <a:lstStyle/>
+          <a:p>
+            <a:pPr indent="0" marL="0">
+              <a:buNone/>
+            </a:pPr>
+            <a:r>
+              <a:rPr lang="en-US" sz="920" dirty="0">
+                <a:solidFill>
+                  <a:srgbClr val="334155"/>
+                </a:solidFill>
+                <a:latin typeface="Aptos" pitchFamily="34" charset="0"/>
+                <a:ea typeface="Aptos" pitchFamily="34" charset="-122"/>
+                <a:cs typeface="Aptos" pitchFamily="34" charset="-120"/>
+              </a:rPr>
+              <a:t>CMK needs a dedicated LAW cluster (double encryption); AMPLS puts ingestion + query on a private endpoint. Plus minimize what you log.</a:t>
+            </a:r>
+            <a:endParaRPr lang="en-US" sz="920" dirty="0"/>
+          </a:p>
+        </p:txBody>
+      </p:sp>
+      <p:sp>
+        <p:nvSpPr>
+          <p:cNvPr id="17" name="Text 15"/>
+          <p:cNvSpPr/>
+          <p:nvPr/>
+        </p:nvSpPr>
+        <p:spPr>
+          <a:xfrm>
+            <a:off x="640080" y="3520440"/>
+            <a:ext cx="10972800" cy="2011680"/>
+          </a:xfrm>
+          <a:prstGeom prst="rect">
+            <a:avLst/>
+          </a:prstGeom>
+          <a:noFill/>
+          <a:ln/>
+        </p:spPr>
+        <p:txBody>
+          <a:bodyPr wrap="square" lIns="381" tIns="381" rIns="381" bIns="381" rtlCol="0" anchor="ctr">
+            <a:normAutofit/>
+          </a:bodyPr>
+          <a:lstStyle/>
+          <a:p>
+            <a:pPr marL="152400" indent="-152400">
+              <a:buSzPct val="100000"/>
+              <a:buChar char="•"/>
+            </a:pPr>
+            <a:r>
+              <a:rPr lang="en-US" sz="1150" dirty="0">
+                <a:solidFill>
+                  <a:srgbClr val="334155"/>
+                </a:solidFill>
+                <a:latin typeface="Aptos" pitchFamily="34" charset="0"/>
+                <a:ea typeface="Aptos" pitchFamily="34" charset="-122"/>
+                <a:cs typeface="Aptos" pitchFamily="34" charset="-120"/>
+              </a:rPr>
+              <a:t>Sensitive content off by default; pseudonymize actors; never capture secrets.</a:t>
+            </a:r>
+            <a:endParaRPr lang="en-US" sz="1150" dirty="0"/>
+          </a:p>
+          <a:p>
+            <a:pPr marL="152400" indent="-152400">
+              <a:buSzPct val="100000"/>
+              <a:buChar char="•"/>
+            </a:pPr>
+            <a:r>
+              <a:rPr lang="en-US" sz="1150" dirty="0">
+                <a:solidFill>
+                  <a:srgbClr val="334155"/>
+                </a:solidFill>
+                <a:latin typeface="Aptos" pitchFamily="34" charset="0"/>
+                <a:ea typeface="Aptos" pitchFamily="34" charset="-122"/>
+                <a:cs typeface="Aptos" pitchFamily="34" charset="-120"/>
+              </a:rPr>
+              <a:t>Start with the Foundry workspace on the dedicated cluster; KP volume makes it cost-favorable.</a:t>
+            </a:r>
+            <a:endParaRPr lang="en-US" sz="1150" dirty="0"/>
+          </a:p>
+          <a:p>
+            <a:pPr marL="152400" indent="-152400">
+              <a:buSzPct val="100000"/>
+              <a:buChar char="•"/>
+            </a:pPr>
+            <a:r>
+              <a:rPr lang="en-US" sz="1150" dirty="0">
+                <a:solidFill>
+                  <a:srgbClr val="334155"/>
+                </a:solidFill>
+                <a:latin typeface="Aptos" pitchFamily="34" charset="0"/>
+                <a:ea typeface="Aptos" pitchFamily="34" charset="-122"/>
+                <a:cs typeface="Aptos" pitchFamily="34" charset="-120"/>
+              </a:rPr>
+              <a:t>Brief: docs/observability-dedicated-cluster-cmk-ampls.md (Lee leads Day 2).</a:t>
+            </a:r>
+            <a:endParaRPr lang="en-US" sz="1150" dirty="0"/>
+          </a:p>
+        </p:txBody>
+      </p:sp>
+      <p:sp>
+        <p:nvSpPr>
+          <p:cNvPr id="18" name="Text 16"/>
+          <p:cNvSpPr/>
+          <p:nvPr/>
+        </p:nvSpPr>
+        <p:spPr>
+          <a:xfrm>
+            <a:off x="640080" y="5806440"/>
+            <a:ext cx="10972800" cy="457200"/>
+          </a:xfrm>
+          <a:prstGeom prst="rect">
+            <a:avLst/>
+          </a:prstGeom>
+          <a:noFill/>
+          <a:ln/>
+        </p:spPr>
+        <p:txBody>
+          <a:bodyPr wrap="square" lIns="0" tIns="0" rIns="0" bIns="0" rtlCol="0" anchor="ctr"/>
+          <a:lstStyle/>
+          <a:p>
+            <a:pPr indent="0" marL="0">
+              <a:buNone/>
+            </a:pPr>
+            <a:r>
+              <a:rPr lang="en-US" sz="1000" i="1" dirty="0">
+                <a:solidFill>
+                  <a:srgbClr val="64748B"/>
+                </a:solidFill>
+                <a:latin typeface="Aptos" pitchFamily="34" charset="0"/>
+                <a:ea typeface="Aptos" pitchFamily="34" charset="-122"/>
+                <a:cs typeface="Aptos" pitchFamily="34" charset="-120"/>
+              </a:rPr>
+              <a:t>Minimize at the source, CMK-encrypt what remains, keep it on the private network.</a:t>
+            </a:r>
+            <a:endParaRPr lang="en-US" sz="1000" dirty="0"/>
+          </a:p>
+        </p:txBody>
+      </p:sp>
+      <p:sp>
+        <p:nvSpPr>
+          <p:cNvPr id="25" name="Slide Number Placeholder 0"/>
+          <p:cNvSpPr>
+            <a:spLocks noGrp="1"/>
+          </p:cNvSpPr>
+          <p:nvPr>
+            <p:ph type="sldNum" sz="quarter" idx="4294967295"/>
+          </p:nvPr>
+        </p:nvSpPr>
+        <p:spPr>
+          <a:xfrm>
+            <a:off x="11475720" y="6565392"/>
+            <a:ext cx="800000" cy="300000"/>
+          </a:xfrm>
+          <a:prstGeom prst="rect">
+            <a:avLst/>
+          </a:prstGeom>
+          <a:extLst>
+            <a:ext uri="{C572A759-6A51-4108-AA02-DFA0A04FC94B}">
+              <ma14:wrappingTextBoxFlag xmlns:ma14="http://schemas.microsoft.com/office/mac/drawingml/2011/main" val="0"/>
+            </a:ext>
+          </a:extLst>
+        </p:spPr>
+        <p:txBody>
+          <a:bodyPr/>
+          <a:lstStyle>
+            <a:lvl1pPr>
+              <a:defRPr sz="700">
+                <a:solidFill>
+                  <a:srgbClr val="64748B"/>
+                </a:solidFill>
+                <a:latin typeface="Aptos"/>
+                <a:ea typeface="Aptos"/>
+                <a:cs typeface="Aptos"/>
+              </a:defRPr>
+            </a:lvl1pPr>
+          </a:lstStyle>
+          <a:p>
+            <a:pPr algn="l"/>
+            <a:fld id="{F7021451-1387-4CA6-816F-3879F97B5CBC}" type="slidenum">
+              <a:rPr b="0" lang="en-US"/>
+              <a:t>20</a:t>
+            </a:fld>
+            <a:endParaRPr lang="en-US"/>
+          </a:p>
+        </p:txBody>
+      </p:sp>
+    </p:spTree>
+  </p:cSld>
+  <p:clrMapOvr>
+    <a:masterClrMapping/>
+  </p:clrMapOvr>
+</p:sld>
+</file>
+
+<file path=ppt/slides/slide21.xml><?xml version="1.0" encoding="utf-8"?>
+<p:sld xmlns:a="http://schemas.openxmlformats.org/drawingml/2006/main" xmlns:r="http://schemas.openxmlformats.org/officeDocument/2006/relationships" xmlns:p="http://schemas.openxmlformats.org/presentationml/2006/main">
+  <p:cSld name="Slide 21">
+    <p:bg>
+      <p:bgPr>
+        <a:solidFill>
           <a:srgbClr val="F5F6F8"/>
         </a:solidFill>
       </p:bgPr>
@@ -13401,9 +13546,9 @@
 </p:sld>
 </file>
 
-<file path=ppt/slides/slide21.xml><?xml version="1.0" encoding="utf-8"?>
+<file path=ppt/slides/slide22.xml><?xml version="1.0" encoding="utf-8"?>
 <p:sld xmlns:a="http://schemas.openxmlformats.org/drawingml/2006/main" xmlns:r="http://schemas.openxmlformats.org/officeDocument/2006/relationships" xmlns:p="http://schemas.openxmlformats.org/presentationml/2006/main">
-  <p:cSld name="Slide 21">
+  <p:cSld name="Slide 22">
     <p:bg>
       <p:bgPr>
         <a:solidFill>
@@ -13799,729 +13944,6 @@
               <a:t>30/60/90 roadmap</a:t>
             </a:r>
             <a:endParaRPr lang="en-US" sz="720" dirty="0"/>
-          </a:p>
-        </p:txBody>
-      </p:sp>
-    </p:spTree>
-  </p:cSld>
-  <p:clrMapOvr>
-    <a:masterClrMapping/>
-  </p:clrMapOvr>
-</p:sld>
-</file>
-
-<file path=ppt/slides/slide22.xml><?xml version="1.0" encoding="utf-8"?>
-<p:sld xmlns:a="http://schemas.openxmlformats.org/drawingml/2006/main" xmlns:r="http://schemas.openxmlformats.org/officeDocument/2006/relationships" xmlns:p="http://schemas.openxmlformats.org/presentationml/2006/main">
-  <p:cSld name="Slide 22">
-    <p:bg>
-      <p:bgPr>
-        <a:solidFill>
-          <a:srgbClr val="F8FAFC"/>
-        </a:solidFill>
-      </p:bgPr>
-    </p:bg>
-    <p:spTree>
-      <p:nvGrpSpPr>
-        <p:cNvPr id="1" name=""/>
-        <p:cNvGrpSpPr/>
-        <p:nvPr/>
-      </p:nvGrpSpPr>
-      <p:grpSpPr>
-        <a:xfrm>
-          <a:off x="0" y="0"/>
-          <a:ext cx="0" cy="0"/>
-          <a:chOff x="0" y="0"/>
-          <a:chExt cx="0" cy="0"/>
-        </a:xfrm>
-      </p:grpSpPr>
-      <p:sp>
-        <p:nvSpPr>
-          <p:cNvPr id="2" name="Text 0"/>
-          <p:cNvSpPr/>
-          <p:nvPr/>
-        </p:nvSpPr>
-        <p:spPr>
-          <a:xfrm>
-            <a:off x="566928" y="384048"/>
-            <a:ext cx="10789920" cy="201168"/>
-          </a:xfrm>
-          <a:prstGeom prst="rect">
-            <a:avLst/>
-          </a:prstGeom>
-          <a:noFill/>
-          <a:ln/>
-        </p:spPr>
-        <p:txBody>
-          <a:bodyPr wrap="square" lIns="0" tIns="0" rIns="0" bIns="0" rtlCol="0" anchor="ctr"/>
-          <a:lstStyle/>
-          <a:p>
-            <a:pPr indent="0" marL="0">
-              <a:buNone/>
-            </a:pPr>
-            <a:r>
-              <a:rPr lang="en-US" sz="800" b="1" dirty="0">
-                <a:solidFill>
-                  <a:srgbClr val="0F766E"/>
-                </a:solidFill>
-                <a:latin typeface="Aptos" pitchFamily="34" charset="0"/>
-                <a:ea typeface="Aptos" pitchFamily="34" charset="-122"/>
-                <a:cs typeface="Aptos" pitchFamily="34" charset="-120"/>
-              </a:rPr>
-              <a:t>PLAYBACK</a:t>
-            </a:r>
-            <a:endParaRPr lang="en-US" sz="800" dirty="0"/>
-          </a:p>
-        </p:txBody>
-      </p:sp>
-      <p:sp>
-        <p:nvSpPr>
-          <p:cNvPr id="3" name="Text 1"/>
-          <p:cNvSpPr/>
-          <p:nvPr/>
-        </p:nvSpPr>
-        <p:spPr>
-          <a:xfrm>
-            <a:off x="548640" y="658368"/>
-            <a:ext cx="11064240" cy="502920"/>
-          </a:xfrm>
-          <a:prstGeom prst="rect">
-            <a:avLst/>
-          </a:prstGeom>
-          <a:noFill/>
-          <a:ln/>
-        </p:spPr>
-        <p:txBody>
-          <a:bodyPr wrap="square" lIns="0" tIns="0" rIns="0" bIns="0" rtlCol="0" anchor="ctr">
-            <a:normAutofit/>
-          </a:bodyPr>
-          <a:lstStyle/>
-          <a:p>
-            <a:pPr indent="0" marL="0">
-              <a:buNone/>
-            </a:pPr>
-            <a:r>
-              <a:rPr lang="en-US" sz="2300" b="1" dirty="0">
-                <a:solidFill>
-                  <a:srgbClr val="0B1220"/>
-                </a:solidFill>
-                <a:latin typeface="Aptos Display" pitchFamily="34" charset="0"/>
-                <a:ea typeface="Aptos Display" pitchFamily="34" charset="-122"/>
-                <a:cs typeface="Aptos Display" pitchFamily="34" charset="-120"/>
-              </a:rPr>
-              <a:t>The whole thing, working end to end</a:t>
-            </a:r>
-            <a:endParaRPr lang="en-US" sz="2300" dirty="0"/>
-          </a:p>
-        </p:txBody>
-      </p:sp>
-      <p:sp>
-        <p:nvSpPr>
-          <p:cNvPr id="4" name="Shape 2"/>
-          <p:cNvSpPr/>
-          <p:nvPr/>
-        </p:nvSpPr>
-        <p:spPr>
-          <a:xfrm>
-            <a:off x="548640" y="1243584"/>
-            <a:ext cx="11064240" cy="0"/>
-          </a:xfrm>
-          <a:prstGeom prst="line">
-            <a:avLst/>
-          </a:prstGeom>
-          <a:noFill/>
-          <a:ln w="12700">
-            <a:solidFill>
-              <a:srgbClr val="CBD5E1"/>
-            </a:solidFill>
-            <a:prstDash val="solid"/>
-          </a:ln>
-        </p:spPr>
-      </p:sp>
-      <p:sp>
-        <p:nvSpPr>
-          <p:cNvPr id="5" name="Shape 3"/>
-          <p:cNvSpPr/>
-          <p:nvPr/>
-        </p:nvSpPr>
-        <p:spPr>
-          <a:xfrm>
-            <a:off x="640080" y="1463040"/>
-            <a:ext cx="3520440" cy="1828800"/>
-          </a:xfrm>
-          <a:prstGeom prst="roundRect">
-            <a:avLst>
-              <a:gd name="adj" fmla="val 4000"/>
-            </a:avLst>
-          </a:prstGeom>
-          <a:solidFill>
-            <a:srgbClr val="FFFFFF"/>
-          </a:solidFill>
-          <a:ln w="12700">
-            <a:solidFill>
-              <a:srgbClr val="E2E8F0"/>
-            </a:solidFill>
-            <a:prstDash val="solid"/>
-          </a:ln>
-          <a:effectLst>
-            <a:outerShdw sx="100000" sy="100000" kx="0" ky="0" algn="bl" rotWithShape="0" blurRad="25400" dist="50800" dir="2700000">
-              <a:srgbClr val="94A3B8">
-                <a:alpha val="12000"/>
-              </a:srgbClr>
-            </a:outerShdw>
-          </a:effectLst>
-        </p:spPr>
-      </p:sp>
-      <p:sp>
-        <p:nvSpPr>
-          <p:cNvPr id="6" name="Shape 4"/>
-          <p:cNvSpPr/>
-          <p:nvPr/>
-        </p:nvSpPr>
-        <p:spPr>
-          <a:xfrm>
-            <a:off x="640080" y="1463040"/>
-            <a:ext cx="64008" cy="1828800"/>
-          </a:xfrm>
-          <a:prstGeom prst="rect">
-            <a:avLst/>
-          </a:prstGeom>
-          <a:solidFill>
-            <a:srgbClr val="0F766E"/>
-          </a:solidFill>
-          <a:ln w="12700">
-            <a:solidFill>
-              <a:srgbClr val="0F766E"/>
-            </a:solidFill>
-            <a:prstDash val="solid"/>
-          </a:ln>
-        </p:spPr>
-      </p:sp>
-      <p:sp>
-        <p:nvSpPr>
-          <p:cNvPr id="7" name="Text 5"/>
-          <p:cNvSpPr/>
-          <p:nvPr/>
-        </p:nvSpPr>
-        <p:spPr>
-          <a:xfrm>
-            <a:off x="841248" y="1609344"/>
-            <a:ext cx="3200400" cy="219456"/>
-          </a:xfrm>
-          <a:prstGeom prst="rect">
-            <a:avLst/>
-          </a:prstGeom>
-          <a:noFill/>
-          <a:ln/>
-        </p:spPr>
-        <p:txBody>
-          <a:bodyPr wrap="square" lIns="0" tIns="0" rIns="0" bIns="0" rtlCol="0" anchor="ctr">
-            <a:normAutofit/>
-          </a:bodyPr>
-          <a:lstStyle/>
-          <a:p>
-            <a:pPr indent="0" marL="0">
-              <a:buNone/>
-            </a:pPr>
-            <a:r>
-              <a:rPr lang="en-US" sz="1200" b="1" dirty="0">
-                <a:solidFill>
-                  <a:srgbClr val="0B1220"/>
-                </a:solidFill>
-                <a:latin typeface="Aptos" pitchFamily="34" charset="0"/>
-                <a:ea typeface="Aptos" pitchFamily="34" charset="-122"/>
-                <a:cs typeface="Aptos" pitchFamily="34" charset="-120"/>
-              </a:rPr>
-              <a:t>One case, all layers</a:t>
-            </a:r>
-            <a:endParaRPr lang="en-US" sz="1200" dirty="0"/>
-          </a:p>
-        </p:txBody>
-      </p:sp>
-      <p:sp>
-        <p:nvSpPr>
-          <p:cNvPr id="8" name="Text 6"/>
-          <p:cNvSpPr/>
-          <p:nvPr/>
-        </p:nvSpPr>
-        <p:spPr>
-          <a:xfrm>
-            <a:off x="841248" y="1920240"/>
-            <a:ext cx="3200400" cy="1280160"/>
-          </a:xfrm>
-          <a:prstGeom prst="rect">
-            <a:avLst/>
-          </a:prstGeom>
-          <a:noFill/>
-          <a:ln/>
-        </p:spPr>
-        <p:txBody>
-          <a:bodyPr wrap="square" lIns="254" tIns="254" rIns="254" bIns="254" rtlCol="0" anchor="t">
-            <a:normAutofit/>
-          </a:bodyPr>
-          <a:lstStyle/>
-          <a:p>
-            <a:pPr indent="0" marL="0">
-              <a:buNone/>
-            </a:pPr>
-            <a:r>
-              <a:rPr lang="en-US" sz="920" dirty="0">
-                <a:solidFill>
-                  <a:srgbClr val="334155"/>
-                </a:solidFill>
-                <a:latin typeface="Aptos" pitchFamily="34" charset="0"/>
-                <a:ea typeface="Aptos" pitchFamily="34" charset="-122"/>
-                <a:cs typeface="Aptos" pitchFamily="34" charset="-120"/>
-              </a:rPr>
-              <a:t>Invoke a discharge case: eight agents hand off, tools are scoped and redacted, RAG cites protocol, guardrails hold, and it stops at the human gate.</a:t>
-            </a:r>
-            <a:endParaRPr lang="en-US" sz="920" dirty="0"/>
-          </a:p>
-        </p:txBody>
-      </p:sp>
-      <p:sp>
-        <p:nvSpPr>
-          <p:cNvPr id="9" name="Shape 7"/>
-          <p:cNvSpPr/>
-          <p:nvPr/>
-        </p:nvSpPr>
-        <p:spPr>
-          <a:xfrm>
-            <a:off x="4343400" y="1463040"/>
-            <a:ext cx="3520440" cy="1828800"/>
-          </a:xfrm>
-          <a:prstGeom prst="roundRect">
-            <a:avLst>
-              <a:gd name="adj" fmla="val 4000"/>
-            </a:avLst>
-          </a:prstGeom>
-          <a:solidFill>
-            <a:srgbClr val="FFFFFF"/>
-          </a:solidFill>
-          <a:ln w="12700">
-            <a:solidFill>
-              <a:srgbClr val="E2E8F0"/>
-            </a:solidFill>
-            <a:prstDash val="solid"/>
-          </a:ln>
-          <a:effectLst>
-            <a:outerShdw sx="100000" sy="100000" kx="0" ky="0" algn="bl" rotWithShape="0" blurRad="25400" dist="50800" dir="2700000">
-              <a:srgbClr val="94A3B8">
-                <a:alpha val="12000"/>
-              </a:srgbClr>
-            </a:outerShdw>
-          </a:effectLst>
-        </p:spPr>
-      </p:sp>
-      <p:sp>
-        <p:nvSpPr>
-          <p:cNvPr id="10" name="Shape 8"/>
-          <p:cNvSpPr/>
-          <p:nvPr/>
-        </p:nvSpPr>
-        <p:spPr>
-          <a:xfrm>
-            <a:off x="4343400" y="1463040"/>
-            <a:ext cx="64008" cy="1828800"/>
-          </a:xfrm>
-          <a:prstGeom prst="rect">
-            <a:avLst/>
-          </a:prstGeom>
-          <a:solidFill>
-            <a:srgbClr val="06B6D4"/>
-          </a:solidFill>
-          <a:ln w="12700">
-            <a:solidFill>
-              <a:srgbClr val="06B6D4"/>
-            </a:solidFill>
-            <a:prstDash val="solid"/>
-          </a:ln>
-        </p:spPr>
-      </p:sp>
-      <p:sp>
-        <p:nvSpPr>
-          <p:cNvPr id="11" name="Text 9"/>
-          <p:cNvSpPr/>
-          <p:nvPr/>
-        </p:nvSpPr>
-        <p:spPr>
-          <a:xfrm>
-            <a:off x="4544568" y="1609344"/>
-            <a:ext cx="3200400" cy="219456"/>
-          </a:xfrm>
-          <a:prstGeom prst="rect">
-            <a:avLst/>
-          </a:prstGeom>
-          <a:noFill/>
-          <a:ln/>
-        </p:spPr>
-        <p:txBody>
-          <a:bodyPr wrap="square" lIns="0" tIns="0" rIns="0" bIns="0" rtlCol="0" anchor="ctr">
-            <a:normAutofit/>
-          </a:bodyPr>
-          <a:lstStyle/>
-          <a:p>
-            <a:pPr indent="0" marL="0">
-              <a:buNone/>
-            </a:pPr>
-            <a:r>
-              <a:rPr lang="en-US" sz="1200" b="1" dirty="0">
-                <a:solidFill>
-                  <a:srgbClr val="0B1220"/>
-                </a:solidFill>
-                <a:latin typeface="Aptos" pitchFamily="34" charset="0"/>
-                <a:ea typeface="Aptos" pitchFamily="34" charset="-122"/>
-                <a:cs typeface="Aptos" pitchFamily="34" charset="-120"/>
-              </a:rPr>
-              <a:t>One trace</a:t>
-            </a:r>
-            <a:endParaRPr lang="en-US" sz="1200" dirty="0"/>
-          </a:p>
-        </p:txBody>
-      </p:sp>
-      <p:sp>
-        <p:nvSpPr>
-          <p:cNvPr id="12" name="Text 10"/>
-          <p:cNvSpPr/>
-          <p:nvPr/>
-        </p:nvSpPr>
-        <p:spPr>
-          <a:xfrm>
-            <a:off x="4544568" y="1920240"/>
-            <a:ext cx="3200400" cy="1280160"/>
-          </a:xfrm>
-          <a:prstGeom prst="rect">
-            <a:avLst/>
-          </a:prstGeom>
-          <a:noFill/>
-          <a:ln/>
-        </p:spPr>
-        <p:txBody>
-          <a:bodyPr wrap="square" lIns="254" tIns="254" rIns="254" bIns="254" rtlCol="0" anchor="t">
-            <a:normAutofit/>
-          </a:bodyPr>
-          <a:lstStyle/>
-          <a:p>
-            <a:pPr indent="0" marL="0">
-              <a:buNone/>
-            </a:pPr>
-            <a:r>
-              <a:rPr lang="en-US" sz="920" dirty="0">
-                <a:solidFill>
-                  <a:srgbClr val="334155"/>
-                </a:solidFill>
-                <a:latin typeface="Aptos" pitchFamily="34" charset="0"/>
-                <a:ea typeface="Aptos" pitchFamily="34" charset="-122"/>
-                <a:cs typeface="Aptos" pitchFamily="34" charset="-120"/>
-              </a:rPr>
-              <a:t>Copy the correlation ID and walk the ordered events - tool decisions, agent handoffs, policy calls, the review transition - one join key across the run.</a:t>
-            </a:r>
-            <a:endParaRPr lang="en-US" sz="920" dirty="0"/>
-          </a:p>
-        </p:txBody>
-      </p:sp>
-      <p:sp>
-        <p:nvSpPr>
-          <p:cNvPr id="13" name="Shape 11"/>
-          <p:cNvSpPr/>
-          <p:nvPr/>
-        </p:nvSpPr>
-        <p:spPr>
-          <a:xfrm>
-            <a:off x="8046720" y="1463040"/>
-            <a:ext cx="3520440" cy="1828800"/>
-          </a:xfrm>
-          <a:prstGeom prst="roundRect">
-            <a:avLst>
-              <a:gd name="adj" fmla="val 4000"/>
-            </a:avLst>
-          </a:prstGeom>
-          <a:solidFill>
-            <a:srgbClr val="FFFFFF"/>
-          </a:solidFill>
-          <a:ln w="12700">
-            <a:solidFill>
-              <a:srgbClr val="E2E8F0"/>
-            </a:solidFill>
-            <a:prstDash val="solid"/>
-          </a:ln>
-          <a:effectLst>
-            <a:outerShdw sx="100000" sy="100000" kx="0" ky="0" algn="bl" rotWithShape="0" blurRad="25400" dist="50800" dir="2700000">
-              <a:srgbClr val="94A3B8">
-                <a:alpha val="12000"/>
-              </a:srgbClr>
-            </a:outerShdw>
-          </a:effectLst>
-        </p:spPr>
-      </p:sp>
-      <p:sp>
-        <p:nvSpPr>
-          <p:cNvPr id="14" name="Shape 12"/>
-          <p:cNvSpPr/>
-          <p:nvPr/>
-        </p:nvSpPr>
-        <p:spPr>
-          <a:xfrm>
-            <a:off x="8046720" y="1463040"/>
-            <a:ext cx="64008" cy="1828800"/>
-          </a:xfrm>
-          <a:prstGeom prst="rect">
-            <a:avLst/>
-          </a:prstGeom>
-          <a:solidFill>
-            <a:srgbClr val="F59E0B"/>
-          </a:solidFill>
-          <a:ln w="12700">
-            <a:solidFill>
-              <a:srgbClr val="F59E0B"/>
-            </a:solidFill>
-            <a:prstDash val="solid"/>
-          </a:ln>
-        </p:spPr>
-      </p:sp>
-      <p:sp>
-        <p:nvSpPr>
-          <p:cNvPr id="15" name="Text 13"/>
-          <p:cNvSpPr/>
-          <p:nvPr/>
-        </p:nvSpPr>
-        <p:spPr>
-          <a:xfrm>
-            <a:off x="8247888" y="1609344"/>
-            <a:ext cx="3200400" cy="219456"/>
-          </a:xfrm>
-          <a:prstGeom prst="rect">
-            <a:avLst/>
-          </a:prstGeom>
-          <a:noFill/>
-          <a:ln/>
-        </p:spPr>
-        <p:txBody>
-          <a:bodyPr wrap="square" lIns="0" tIns="0" rIns="0" bIns="0" rtlCol="0" anchor="ctr">
-            <a:normAutofit/>
-          </a:bodyPr>
-          <a:lstStyle/>
-          <a:p>
-            <a:pPr indent="0" marL="0">
-              <a:buNone/>
-            </a:pPr>
-            <a:r>
-              <a:rPr lang="en-US" sz="1200" b="1" dirty="0">
-                <a:solidFill>
-                  <a:srgbClr val="0B1220"/>
-                </a:solidFill>
-                <a:latin typeface="Aptos" pitchFamily="34" charset="0"/>
-                <a:ea typeface="Aptos" pitchFamily="34" charset="-122"/>
-                <a:cs typeface="Aptos" pitchFamily="34" charset="-120"/>
-              </a:rPr>
-              <a:t>One decision</a:t>
-            </a:r>
-            <a:endParaRPr lang="en-US" sz="1200" dirty="0"/>
-          </a:p>
-        </p:txBody>
-      </p:sp>
-      <p:sp>
-        <p:nvSpPr>
-          <p:cNvPr id="16" name="Text 14"/>
-          <p:cNvSpPr/>
-          <p:nvPr/>
-        </p:nvSpPr>
-        <p:spPr>
-          <a:xfrm>
-            <a:off x="8247888" y="1920240"/>
-            <a:ext cx="3200400" cy="1280160"/>
-          </a:xfrm>
-          <a:prstGeom prst="rect">
-            <a:avLst/>
-          </a:prstGeom>
-          <a:noFill/>
-          <a:ln/>
-        </p:spPr>
-        <p:txBody>
-          <a:bodyPr wrap="square" lIns="254" tIns="254" rIns="254" bIns="254" rtlCol="0" anchor="t">
-            <a:normAutofit/>
-          </a:bodyPr>
-          <a:lstStyle/>
-          <a:p>
-            <a:pPr indent="0" marL="0">
-              <a:buNone/>
-            </a:pPr>
-            <a:r>
-              <a:rPr lang="en-US" sz="920" dirty="0">
-                <a:solidFill>
-                  <a:srgbClr val="334155"/>
-                </a:solidFill>
-                <a:latin typeface="Aptos" pitchFamily="34" charset="0"/>
-                <a:ea typeface="Aptos" pitchFamily="34" charset="-122"/>
-                <a:cs typeface="Aptos" pitchFamily="34" charset="-120"/>
-              </a:rPr>
-              <a:t>A care manager approves in the UI; the durable task reaches Approved with a full audit trail. An agent-actor approve is denied.</a:t>
-            </a:r>
-            <a:endParaRPr lang="en-US" sz="920" dirty="0"/>
-          </a:p>
-        </p:txBody>
-      </p:sp>
-      <p:sp>
-        <p:nvSpPr>
-          <p:cNvPr id="17" name="Text 15"/>
-          <p:cNvSpPr/>
-          <p:nvPr/>
-        </p:nvSpPr>
-        <p:spPr>
-          <a:xfrm>
-            <a:off x="640080" y="3520440"/>
-            <a:ext cx="10972800" cy="2011680"/>
-          </a:xfrm>
-          <a:prstGeom prst="rect">
-            <a:avLst/>
-          </a:prstGeom>
-          <a:noFill/>
-          <a:ln/>
-        </p:spPr>
-        <p:txBody>
-          <a:bodyPr wrap="square" lIns="381" tIns="381" rIns="381" bIns="381" rtlCol="0" anchor="ctr">
-            <a:normAutofit/>
-          </a:bodyPr>
-          <a:lstStyle/>
-          <a:p>
-            <a:pPr marL="152400" indent="-152400">
-              <a:buSzPct val="100000"/>
-              <a:buChar char="•"/>
-            </a:pPr>
-            <a:r>
-              <a:rPr lang="en-US" sz="1150" dirty="0">
-                <a:solidFill>
-                  <a:srgbClr val="334155"/>
-                </a:solidFill>
-                <a:latin typeface="Aptos" pitchFamily="34" charset="0"/>
-                <a:ea typeface="Aptos" pitchFamily="34" charset="-122"/>
-                <a:cs typeface="Aptos" pitchFamily="34" charset="-120"/>
-              </a:rPr>
-              <a:t>This is the deployed system, not a mockup - live on Azure Container Apps + Foundry.</a:t>
-            </a:r>
-            <a:endParaRPr lang="en-US" sz="1150" dirty="0"/>
-          </a:p>
-          <a:p>
-            <a:pPr marL="152400" indent="-152400">
-              <a:buSzPct val="100000"/>
-              <a:buChar char="•"/>
-            </a:pPr>
-            <a:r>
-              <a:rPr lang="en-US" sz="1150" dirty="0">
-                <a:solidFill>
-                  <a:srgbClr val="334155"/>
-                </a:solidFill>
-                <a:latin typeface="Aptos" pitchFamily="34" charset="0"/>
-                <a:ea typeface="Aptos" pitchFamily="34" charset="-122"/>
-                <a:cs typeface="Aptos" pitchFamily="34" charset="-120"/>
-              </a:rPr>
-              <a:t>The same contract runs in foundry mode (hosted agents) and a local mode for offline demos.</a:t>
-            </a:r>
-            <a:endParaRPr lang="en-US" sz="1150" dirty="0"/>
-          </a:p>
-          <a:p>
-            <a:pPr marL="152400" indent="-152400">
-              <a:buSzPct val="100000"/>
-              <a:buChar char="•"/>
-            </a:pPr>
-            <a:r>
-              <a:rPr lang="en-US" sz="1150" dirty="0">
-                <a:solidFill>
-                  <a:srgbClr val="334155"/>
-                </a:solidFill>
-                <a:latin typeface="Aptos" pitchFamily="34" charset="0"/>
-                <a:ea typeface="Aptos" pitchFamily="34" charset="-122"/>
-                <a:cs typeface="Aptos" pitchFamily="34" charset="-120"/>
-              </a:rPr>
-              <a:t>Reference: docs/observability-correlation-trace.md, docs/hitl-durable-task-scheduler.md.</a:t>
-            </a:r>
-            <a:endParaRPr lang="en-US" sz="1150" dirty="0"/>
-          </a:p>
-        </p:txBody>
-      </p:sp>
-      <p:sp>
-        <p:nvSpPr>
-          <p:cNvPr id="18" name="Text 16"/>
-          <p:cNvSpPr/>
-          <p:nvPr/>
-        </p:nvSpPr>
-        <p:spPr>
-          <a:xfrm>
-            <a:off x="640080" y="5806440"/>
-            <a:ext cx="10972800" cy="457200"/>
-          </a:xfrm>
-          <a:prstGeom prst="rect">
-            <a:avLst/>
-          </a:prstGeom>
-          <a:noFill/>
-          <a:ln/>
-        </p:spPr>
-        <p:txBody>
-          <a:bodyPr wrap="square" lIns="0" tIns="0" rIns="0" bIns="0" rtlCol="0" anchor="ctr"/>
-          <a:lstStyle/>
-          <a:p>
-            <a:pPr indent="0" marL="0">
-              <a:buNone/>
-            </a:pPr>
-            <a:r>
-              <a:rPr lang="en-US" sz="1000" i="1" dirty="0">
-                <a:solidFill>
-                  <a:srgbClr val="64748B"/>
-                </a:solidFill>
-                <a:latin typeface="Aptos" pitchFamily="34" charset="0"/>
-                <a:ea typeface="Aptos" pitchFamily="34" charset="-122"/>
-                <a:cs typeface="Aptos" pitchFamily="34" charset="-120"/>
-              </a:rPr>
-              <a:t>Capability and governance in one run - the point of the whole two days.</a:t>
-            </a:r>
-            <a:endParaRPr lang="en-US" sz="1000" dirty="0"/>
-          </a:p>
-        </p:txBody>
-      </p:sp>
-      <p:sp>
-        <p:nvSpPr>
-          <p:cNvPr id="25" name="Slide Number Placeholder 0"/>
-          <p:cNvSpPr>
-            <a:spLocks noGrp="1"/>
-          </p:cNvSpPr>
-          <p:nvPr>
-            <p:ph type="sldNum" sz="quarter" idx="4294967295"/>
-          </p:nvPr>
-        </p:nvSpPr>
-        <p:spPr>
-          <a:xfrm>
-            <a:off x="11475720" y="6565392"/>
-            <a:ext cx="800000" cy="300000"/>
-          </a:xfrm>
-          <a:prstGeom prst="rect">
-            <a:avLst/>
-          </a:prstGeom>
-          <a:extLst>
-            <a:ext uri="{C572A759-6A51-4108-AA02-DFA0A04FC94B}">
-              <ma14:wrappingTextBoxFlag xmlns:ma14="http://schemas.microsoft.com/office/mac/drawingml/2011/main" val="0"/>
-            </a:ext>
-          </a:extLst>
-        </p:spPr>
-        <p:txBody>
-          <a:bodyPr/>
-          <a:lstStyle>
-            <a:lvl1pPr>
-              <a:defRPr sz="700">
-                <a:solidFill>
-                  <a:srgbClr val="64748B"/>
-                </a:solidFill>
-                <a:latin typeface="Aptos"/>
-                <a:ea typeface="Aptos"/>
-                <a:cs typeface="Aptos"/>
-              </a:defRPr>
-            </a:lvl1pPr>
-          </a:lstStyle>
-          <a:p>
-            <a:pPr algn="l"/>
-            <a:fld id="{F7021451-1387-4CA6-816F-3879F97B5CBC}" type="slidenum">
-              <a:rPr b="0" lang="en-US"/>
-              <a:t>22</a:t>
-            </a:fld>
-            <a:endParaRPr lang="en-US"/>
           </a:p>
         </p:txBody>
       </p:sp>
@@ -14590,7 +14012,7 @@
                 <a:ea typeface="Aptos" pitchFamily="34" charset="-122"/>
                 <a:cs typeface="Aptos" pitchFamily="34" charset="-120"/>
               </a:rPr>
-              <a:t>PROVE IT IS SAFE</a:t>
+              <a:t>PLAYBACK</a:t>
             </a:r>
             <a:endParaRPr lang="en-US" sz="800" dirty="0"/>
           </a:p>
@@ -14631,7 +14053,7 @@
                 <a:ea typeface="Aptos Display" pitchFamily="34" charset="-122"/>
                 <a:cs typeface="Aptos Display" pitchFamily="34" charset="-120"/>
               </a:rPr>
-              <a:t>Evaluation as a release gate</a:t>
+              <a:t>The whole thing, working end to end</a:t>
             </a:r>
             <a:endParaRPr lang="en-US" sz="2300" dirty="0"/>
           </a:p>
@@ -14669,11 +14091,11 @@
         <p:spPr>
           <a:xfrm>
             <a:off x="640080" y="1463040"/>
-            <a:ext cx="3520440" cy="1737360"/>
+            <a:ext cx="3520440" cy="1828800"/>
           </a:xfrm>
           <a:prstGeom prst="roundRect">
             <a:avLst>
-              <a:gd name="adj" fmla="val 4211"/>
+              <a:gd name="adj" fmla="val 4000"/>
             </a:avLst>
           </a:prstGeom>
           <a:solidFill>
@@ -14703,17 +14125,17 @@
         <p:spPr>
           <a:xfrm>
             <a:off x="640080" y="1463040"/>
-            <a:ext cx="64008" cy="1737360"/>
+            <a:ext cx="64008" cy="1828800"/>
           </a:xfrm>
           <a:prstGeom prst="rect">
             <a:avLst/>
           </a:prstGeom>
           <a:solidFill>
-            <a:srgbClr val="16A34A"/>
+            <a:srgbClr val="0F766E"/>
           </a:solidFill>
           <a:ln w="12700">
             <a:solidFill>
-              <a:srgbClr val="16A34A"/>
+              <a:srgbClr val="0F766E"/>
             </a:solidFill>
             <a:prstDash val="solid"/>
           </a:ln>
@@ -14754,7 +14176,7 @@
                 <a:ea typeface="Aptos" pitchFamily="34" charset="-122"/>
                 <a:cs typeface="Aptos" pitchFamily="34" charset="-120"/>
               </a:rPr>
-              <a:t>Golden cases</a:t>
+              <a:t>One case, all layers</a:t>
             </a:r>
             <a:endParaRPr lang="en-US" sz="1200" dirty="0"/>
           </a:p>
@@ -14769,7 +14191,7 @@
         <p:spPr>
           <a:xfrm>
             <a:off x="841248" y="1920240"/>
-            <a:ext cx="3200400" cy="1188720"/>
+            <a:ext cx="3200400" cy="1280160"/>
           </a:xfrm>
           <a:prstGeom prst="rect">
             <a:avLst/>
@@ -14795,7 +14217,7 @@
                 <a:ea typeface="Aptos" pitchFamily="34" charset="-122"/>
                 <a:cs typeface="Aptos" pitchFamily="34" charset="-120"/>
               </a:rPr>
-              <a:t>What it must do well: cite grounded evidence, disclose missing info, consume the approved score, route to human review.</a:t>
+              <a:t>Invoke a discharge case: eight agents hand off, tools are scoped and redacted, RAG cites protocol, guardrails hold, and it stops at the human gate.</a:t>
             </a:r>
             <a:endParaRPr lang="en-US" sz="920" dirty="0"/>
           </a:p>
@@ -14810,11 +14232,11 @@
         <p:spPr>
           <a:xfrm>
             <a:off x="4343400" y="1463040"/>
-            <a:ext cx="3520440" cy="1737360"/>
+            <a:ext cx="3520440" cy="1828800"/>
           </a:xfrm>
           <a:prstGeom prst="roundRect">
             <a:avLst>
-              <a:gd name="adj" fmla="val 4211"/>
+              <a:gd name="adj" fmla="val 4000"/>
             </a:avLst>
           </a:prstGeom>
           <a:solidFill>
@@ -14844,17 +14266,17 @@
         <p:spPr>
           <a:xfrm>
             <a:off x="4343400" y="1463040"/>
-            <a:ext cx="64008" cy="1737360"/>
+            <a:ext cx="64008" cy="1828800"/>
           </a:xfrm>
           <a:prstGeom prst="rect">
             <a:avLst/>
           </a:prstGeom>
           <a:solidFill>
-            <a:srgbClr val="DC2626"/>
+            <a:srgbClr val="06B6D4"/>
           </a:solidFill>
           <a:ln w="12700">
             <a:solidFill>
-              <a:srgbClr val="DC2626"/>
+              <a:srgbClr val="06B6D4"/>
             </a:solidFill>
             <a:prstDash val="solid"/>
           </a:ln>
@@ -14895,7 +14317,7 @@
                 <a:ea typeface="Aptos" pitchFamily="34" charset="-122"/>
                 <a:cs typeface="Aptos" pitchFamily="34" charset="-120"/>
               </a:rPr>
-              <a:t>Adversarial cases</a:t>
+              <a:t>One trace</a:t>
             </a:r>
             <a:endParaRPr lang="en-US" sz="1200" dirty="0"/>
           </a:p>
@@ -14910,7 +14332,7 @@
         <p:spPr>
           <a:xfrm>
             <a:off x="4544568" y="1920240"/>
-            <a:ext cx="3200400" cy="1188720"/>
+            <a:ext cx="3200400" cy="1280160"/>
           </a:xfrm>
           <a:prstGeom prst="rect">
             <a:avLst/>
@@ -14936,7 +14358,7 @@
                 <a:ea typeface="Aptos" pitchFamily="34" charset="-122"/>
                 <a:cs typeface="Aptos" pitchFamily="34" charset="-120"/>
               </a:rPr>
-              <a:t>What it must refuse: say 'safe to discharge', expand PHI, or recalculate / lower the risk score. Score-override is CRITICAL and must fail-closed.</a:t>
+              <a:t>Copy the correlation ID and walk the ordered events - tool decisions, agent handoffs, policy calls, the review transition - one join key across the run.</a:t>
             </a:r>
             <a:endParaRPr lang="en-US" sz="920" dirty="0"/>
           </a:p>
@@ -14951,11 +14373,11 @@
         <p:spPr>
           <a:xfrm>
             <a:off x="8046720" y="1463040"/>
-            <a:ext cx="3520440" cy="1737360"/>
+            <a:ext cx="3520440" cy="1828800"/>
           </a:xfrm>
           <a:prstGeom prst="roundRect">
             <a:avLst>
-              <a:gd name="adj" fmla="val 4211"/>
+              <a:gd name="adj" fmla="val 4000"/>
             </a:avLst>
           </a:prstGeom>
           <a:solidFill>
@@ -14985,17 +14407,17 @@
         <p:spPr>
           <a:xfrm>
             <a:off x="8046720" y="1463040"/>
-            <a:ext cx="64008" cy="1737360"/>
+            <a:ext cx="64008" cy="1828800"/>
           </a:xfrm>
           <a:prstGeom prst="rect">
             <a:avLst/>
           </a:prstGeom>
           <a:solidFill>
-            <a:srgbClr val="0F766E"/>
+            <a:srgbClr val="F59E0B"/>
           </a:solidFill>
           <a:ln w="12700">
             <a:solidFill>
-              <a:srgbClr val="0F766E"/>
+              <a:srgbClr val="F59E0B"/>
             </a:solidFill>
             <a:prstDash val="solid"/>
           </a:ln>
@@ -15036,7 +14458,7 @@
                 <a:ea typeface="Aptos" pitchFamily="34" charset="-122"/>
                 <a:cs typeface="Aptos" pitchFamily="34" charset="-120"/>
               </a:rPr>
-              <a:t>A real gate</a:t>
+              <a:t>One decision</a:t>
             </a:r>
             <a:endParaRPr lang="en-US" sz="1200" dirty="0"/>
           </a:p>
@@ -15051,7 +14473,7 @@
         <p:spPr>
           <a:xfrm>
             <a:off x="8247888" y="1920240"/>
-            <a:ext cx="3200400" cy="1188720"/>
+            <a:ext cx="3200400" cy="1280160"/>
           </a:xfrm>
           <a:prstGeom prst="rect">
             <a:avLst/>
@@ -15077,7 +14499,7 @@
                 <a:ea typeface="Aptos" pitchFamily="34" charset="-122"/>
                 <a:cs typeface="Aptos" pitchFamily="34" charset="-120"/>
               </a:rPr>
-              <a:t>Deterministic, offline checks over synthetic cases; a failure returns non-zero and blocks the release. Not a vibe check.</a:t>
+              <a:t>A care manager approves in the UI; the durable task reaches Approved with a full audit trail. An agent-actor approve is denied.</a:t>
             </a:r>
             <a:endParaRPr lang="en-US" sz="920" dirty="0"/>
           </a:p>
@@ -15091,7 +14513,7 @@
         </p:nvSpPr>
         <p:spPr>
           <a:xfrm>
-            <a:off x="640080" y="3429000"/>
+            <a:off x="640080" y="3520440"/>
             <a:ext cx="10972800" cy="2011680"/>
           </a:xfrm>
           <a:prstGeom prst="rect">
@@ -15119,7 +14541,7 @@
                 <a:ea typeface="Aptos" pitchFamily="34" charset="-122"/>
                 <a:cs typeface="Aptos" pitchFamily="34" charset="-120"/>
               </a:rPr>
-              <a:t>Measure retrieval with qrels; assert safety gates on the structured result before any pilot.</a:t>
+              <a:t>This is the deployed system, not a mockup - live on Azure Container Apps + Foundry.</a:t>
             </a:r>
             <a:endParaRPr lang="en-US" sz="1150" dirty="0"/>
           </a:p>
@@ -15137,7 +14559,7 @@
                 <a:ea typeface="Aptos" pitchFamily="34" charset="-122"/>
                 <a:cs typeface="Aptos" pitchFamily="34" charset="-120"/>
               </a:rPr>
-              <a:t>Datasets: evaluation/golden-cases.jsonl and evaluation/adversarial-cases.jsonl.</a:t>
+              <a:t>The same contract runs in foundry mode (hosted agents) and a local mode for offline demos.</a:t>
             </a:r>
             <a:endParaRPr lang="en-US" sz="1150" dirty="0"/>
           </a:p>
@@ -15155,7 +14577,7 @@
                 <a:ea typeface="Aptos" pitchFamily="34" charset="-122"/>
                 <a:cs typeface="Aptos" pitchFamily="34" charset="-120"/>
               </a:rPr>
-              <a:t>Demo: green -&gt; inject a break -&gt; red / gate-blocked -&gt; revert -&gt; green (no code editing).</a:t>
+              <a:t>Reference: docs/observability-correlation-trace.md, docs/hitl-durable-task-scheduler.md.</a:t>
             </a:r>
             <a:endParaRPr lang="en-US" sz="1150" dirty="0"/>
           </a:p>
@@ -15194,7 +14616,7 @@
                 <a:ea typeface="Aptos" pitchFamily="34" charset="-122"/>
                 <a:cs typeface="Aptos" pitchFamily="34" charset="-120"/>
               </a:rPr>
-              <a:t>You do not pilot a healthcare agent on trust - you pilot it on a passing gate.</a:t>
+              <a:t>Capability and governance in one run - the point of the whole two days.</a:t>
             </a:r>
             <a:endParaRPr lang="en-US" sz="1000" dirty="0"/>
           </a:p>
@@ -15313,7 +14735,7 @@
                 <a:ea typeface="Aptos" pitchFamily="34" charset="-122"/>
                 <a:cs typeface="Aptos" pitchFamily="34" charset="-120"/>
               </a:rPr>
-              <a:t>WHAT KAISER DOES NEXT</a:t>
+              <a:t>PROVE IT IS SAFE</a:t>
             </a:r>
             <a:endParaRPr lang="en-US" sz="800" dirty="0"/>
           </a:p>
@@ -15354,7 +14776,7 @@
                 <a:ea typeface="Aptos Display" pitchFamily="34" charset="-122"/>
                 <a:cs typeface="Aptos Display" pitchFamily="34" charset="-120"/>
               </a:rPr>
-              <a:t>30 / 60 / 90-day pilot roadmap</a:t>
+              <a:t>Evaluation as a release gate</a:t>
             </a:r>
             <a:endParaRPr lang="en-US" sz="2300" dirty="0"/>
           </a:p>
@@ -15392,11 +14814,11 @@
         <p:spPr>
           <a:xfrm>
             <a:off x="640080" y="1463040"/>
-            <a:ext cx="3520440" cy="1828800"/>
+            <a:ext cx="3520440" cy="1737360"/>
           </a:xfrm>
           <a:prstGeom prst="roundRect">
             <a:avLst>
-              <a:gd name="adj" fmla="val 4000"/>
+              <a:gd name="adj" fmla="val 4211"/>
             </a:avLst>
           </a:prstGeom>
           <a:solidFill>
@@ -15426,17 +14848,17 @@
         <p:spPr>
           <a:xfrm>
             <a:off x="640080" y="1463040"/>
-            <a:ext cx="64008" cy="1828800"/>
+            <a:ext cx="64008" cy="1737360"/>
           </a:xfrm>
           <a:prstGeom prst="rect">
             <a:avLst/>
           </a:prstGeom>
           <a:solidFill>
-            <a:srgbClr val="0F766E"/>
+            <a:srgbClr val="16A34A"/>
           </a:solidFill>
           <a:ln w="12700">
             <a:solidFill>
-              <a:srgbClr val="0F766E"/>
+              <a:srgbClr val="16A34A"/>
             </a:solidFill>
             <a:prstDash val="solid"/>
           </a:ln>
@@ -15477,7 +14899,7 @@
                 <a:ea typeface="Aptos" pitchFamily="34" charset="-122"/>
                 <a:cs typeface="Aptos" pitchFamily="34" charset="-120"/>
               </a:rPr>
-              <a:t>0 - 30 days</a:t>
+              <a:t>Golden cases</a:t>
             </a:r>
             <a:endParaRPr lang="en-US" sz="1200" dirty="0"/>
           </a:p>
@@ -15492,7 +14914,7 @@
         <p:spPr>
           <a:xfrm>
             <a:off x="841248" y="1920240"/>
-            <a:ext cx="3200400" cy="1280160"/>
+            <a:ext cx="3200400" cy="1188720"/>
           </a:xfrm>
           <a:prstGeom prst="rect">
             <a:avLst/>
@@ -15518,7 +14940,7 @@
                 <a:ea typeface="Aptos" pitchFamily="34" charset="-122"/>
                 <a:cs typeface="Aptos" pitchFamily="34" charset="-120"/>
               </a:rPr>
-              <a:t>Stand up the governed pattern on a synthetic corpus; wire Foundry IQ to approved protocols; agree the safety gate and telemetry taxonomy.</a:t>
+              <a:t>What it must do well: cite grounded evidence, disclose missing info, consume the approved score, route to human review.</a:t>
             </a:r>
             <a:endParaRPr lang="en-US" sz="920" dirty="0"/>
           </a:p>
@@ -15533,11 +14955,11 @@
         <p:spPr>
           <a:xfrm>
             <a:off x="4343400" y="1463040"/>
-            <a:ext cx="3520440" cy="1828800"/>
+            <a:ext cx="3520440" cy="1737360"/>
           </a:xfrm>
           <a:prstGeom prst="roundRect">
             <a:avLst>
-              <a:gd name="adj" fmla="val 4000"/>
+              <a:gd name="adj" fmla="val 4211"/>
             </a:avLst>
           </a:prstGeom>
           <a:solidFill>
@@ -15567,17 +14989,17 @@
         <p:spPr>
           <a:xfrm>
             <a:off x="4343400" y="1463040"/>
-            <a:ext cx="64008" cy="1828800"/>
+            <a:ext cx="64008" cy="1737360"/>
           </a:xfrm>
           <a:prstGeom prst="rect">
             <a:avLst/>
           </a:prstGeom>
           <a:solidFill>
-            <a:srgbClr val="2563EB"/>
+            <a:srgbClr val="DC2626"/>
           </a:solidFill>
           <a:ln w="12700">
             <a:solidFill>
-              <a:srgbClr val="2563EB"/>
+              <a:srgbClr val="DC2626"/>
             </a:solidFill>
             <a:prstDash val="solid"/>
           </a:ln>
@@ -15618,7 +15040,7 @@
                 <a:ea typeface="Aptos" pitchFamily="34" charset="-122"/>
                 <a:cs typeface="Aptos" pitchFamily="34" charset="-120"/>
               </a:rPr>
-              <a:t>30 - 60 days</a:t>
+              <a:t>Adversarial cases</a:t>
             </a:r>
             <a:endParaRPr lang="en-US" sz="1200" dirty="0"/>
           </a:p>
@@ -15633,7 +15055,7 @@
         <p:spPr>
           <a:xfrm>
             <a:off x="4544568" y="1920240"/>
-            <a:ext cx="3200400" cy="1280160"/>
+            <a:ext cx="3200400" cy="1188720"/>
           </a:xfrm>
           <a:prstGeom prst="rect">
             <a:avLst/>
@@ -15659,7 +15081,7 @@
                 <a:ea typeface="Aptos" pitchFamily="34" charset="-122"/>
                 <a:cs typeface="Aptos" pitchFamily="34" charset="-120"/>
               </a:rPr>
-              <a:t>Secure MCP + Toolbox for the first real tools; dedicated LAW cluster + CMK + AMPLS; capability-host reuse decisions per app team.</a:t>
+              <a:t>What it must refuse: say 'safe to discharge', expand PHI, or recalculate / lower the risk score. Score-override is CRITICAL and must fail-closed.</a:t>
             </a:r>
             <a:endParaRPr lang="en-US" sz="920" dirty="0"/>
           </a:p>
@@ -15674,11 +15096,11 @@
         <p:spPr>
           <a:xfrm>
             <a:off x="8046720" y="1463040"/>
-            <a:ext cx="3520440" cy="1828800"/>
+            <a:ext cx="3520440" cy="1737360"/>
           </a:xfrm>
           <a:prstGeom prst="roundRect">
             <a:avLst>
-              <a:gd name="adj" fmla="val 4000"/>
+              <a:gd name="adj" fmla="val 4211"/>
             </a:avLst>
           </a:prstGeom>
           <a:solidFill>
@@ -15708,17 +15130,17 @@
         <p:spPr>
           <a:xfrm>
             <a:off x="8046720" y="1463040"/>
-            <a:ext cx="64008" cy="1828800"/>
+            <a:ext cx="64008" cy="1737360"/>
           </a:xfrm>
           <a:prstGeom prst="rect">
             <a:avLst/>
           </a:prstGeom>
           <a:solidFill>
-            <a:srgbClr val="7C3AED"/>
+            <a:srgbClr val="0F766E"/>
           </a:solidFill>
           <a:ln w="12700">
             <a:solidFill>
-              <a:srgbClr val="7C3AED"/>
+              <a:srgbClr val="0F766E"/>
             </a:solidFill>
             <a:prstDash val="solid"/>
           </a:ln>
@@ -15759,7 +15181,7 @@
                 <a:ea typeface="Aptos" pitchFamily="34" charset="-122"/>
                 <a:cs typeface="Aptos" pitchFamily="34" charset="-120"/>
               </a:rPr>
-              <a:t>60 - 90 days</a:t>
+              <a:t>A real gate</a:t>
             </a:r>
             <a:endParaRPr lang="en-US" sz="1200" dirty="0"/>
           </a:p>
@@ -15774,7 +15196,7 @@
         <p:spPr>
           <a:xfrm>
             <a:off x="8247888" y="1920240"/>
-            <a:ext cx="3200400" cy="1280160"/>
+            <a:ext cx="3200400" cy="1188720"/>
           </a:xfrm>
           <a:prstGeom prst="rect">
             <a:avLst/>
@@ -15800,7 +15222,7 @@
                 <a:ea typeface="Aptos" pitchFamily="34" charset="-122"/>
                 <a:cs typeface="Aptos" pitchFamily="34" charset="-120"/>
               </a:rPr>
-              <a:t>Limited pilot behind the human gate with a real (governed) source; continuous evaluation; expand toolboxes and observability dashboards.</a:t>
+              <a:t>Deterministic, offline checks over synthetic cases; a failure returns non-zero and blocks the release. Not a vibe check.</a:t>
             </a:r>
             <a:endParaRPr lang="en-US" sz="920" dirty="0"/>
           </a:p>
@@ -15814,7 +15236,7 @@
         </p:nvSpPr>
         <p:spPr>
           <a:xfrm>
-            <a:off x="640080" y="3520440"/>
+            <a:off x="640080" y="3429000"/>
             <a:ext cx="10972800" cy="2011680"/>
           </a:xfrm>
           <a:prstGeom prst="rect">
@@ -15842,7 +15264,7 @@
                 <a:ea typeface="Aptos" pitchFamily="34" charset="-122"/>
                 <a:cs typeface="Aptos" pitchFamily="34" charset="-120"/>
               </a:rPr>
-              <a:t>Cost discipline throughout: reuse platform resources; commitment-tier logging; no duplicated Search.</a:t>
+              <a:t>Measure retrieval with qrels; assert safety gates on the structured result before any pilot.</a:t>
             </a:r>
             <a:endParaRPr lang="en-US" sz="1150" dirty="0"/>
           </a:p>
@@ -15860,7 +15282,7 @@
                 <a:ea typeface="Aptos" pitchFamily="34" charset="-122"/>
                 <a:cs typeface="Aptos" pitchFamily="34" charset="-120"/>
               </a:rPr>
-              <a:t>Governance owners named per control (guardrails, RBAC, content safety, HITL).</a:t>
+              <a:t>Datasets: evaluation/golden-cases.jsonl and evaluation/adversarial-cases.jsonl.</a:t>
             </a:r>
             <a:endParaRPr lang="en-US" sz="1150" dirty="0"/>
           </a:p>
@@ -15878,7 +15300,7 @@
                 <a:ea typeface="Aptos" pitchFamily="34" charset="-122"/>
                 <a:cs typeface="Aptos" pitchFamily="34" charset="-120"/>
               </a:rPr>
-              <a:t>Futures to scope: BYO Registry, BYO AKS for hosted agents, SRE agent - as separate tracks.</a:t>
+              <a:t>Demo: green -&gt; inject a break -&gt; red / gate-blocked -&gt; revert -&gt; green (no code editing).</a:t>
             </a:r>
             <a:endParaRPr lang="en-US" sz="1150" dirty="0"/>
           </a:p>
@@ -15917,7 +15339,7 @@
                 <a:ea typeface="Aptos" pitchFamily="34" charset="-122"/>
                 <a:cs typeface="Aptos" pitchFamily="34" charset="-120"/>
               </a:rPr>
-              <a:t>A staged path: prove the pattern, harden the platform, then pilot behind the human gate.</a:t>
+              <a:t>You do not pilot a healthcare agent on trust - you pilot it on a passing gate.</a:t>
             </a:r>
             <a:endParaRPr lang="en-US" sz="1000" dirty="0"/>
           </a:p>
@@ -16036,7 +15458,7 @@
                 <a:ea typeface="Aptos" pitchFamily="34" charset="-122"/>
                 <a:cs typeface="Aptos" pitchFamily="34" charset="-120"/>
               </a:rPr>
-              <a:t>SOURCE-GROUNDED BRIEFS</a:t>
+              <a:t>WHAT KAISER DOES NEXT</a:t>
             </a:r>
             <a:endParaRPr lang="en-US" sz="800" dirty="0"/>
           </a:p>
@@ -16077,7 +15499,7 @@
                 <a:ea typeface="Aptos Display" pitchFamily="34" charset="-122"/>
                 <a:cs typeface="Aptos Display" pitchFamily="34" charset="-120"/>
               </a:rPr>
-              <a:t>Where to go deeper</a:t>
+              <a:t>30 / 60 / 90-day pilot roadmap</a:t>
             </a:r>
             <a:endParaRPr lang="en-US" sz="2300" dirty="0"/>
           </a:p>
@@ -16115,11 +15537,11 @@
         <p:spPr>
           <a:xfrm>
             <a:off x="640080" y="1463040"/>
-            <a:ext cx="5394960" cy="1737360"/>
+            <a:ext cx="3520440" cy="1828800"/>
           </a:xfrm>
           <a:prstGeom prst="roundRect">
             <a:avLst>
-              <a:gd name="adj" fmla="val 4211"/>
+              <a:gd name="adj" fmla="val 4000"/>
             </a:avLst>
           </a:prstGeom>
           <a:solidFill>
@@ -16149,7 +15571,7 @@
         <p:spPr>
           <a:xfrm>
             <a:off x="640080" y="1463040"/>
-            <a:ext cx="64008" cy="1737360"/>
+            <a:ext cx="64008" cy="1828800"/>
           </a:xfrm>
           <a:prstGeom prst="rect">
             <a:avLst/>
@@ -16174,7 +15596,7 @@
         <p:spPr>
           <a:xfrm>
             <a:off x="841248" y="1609344"/>
-            <a:ext cx="5074920" cy="219456"/>
+            <a:ext cx="3200400" cy="219456"/>
           </a:xfrm>
           <a:prstGeom prst="rect">
             <a:avLst/>
@@ -16200,7 +15622,7 @@
                 <a:ea typeface="Aptos" pitchFamily="34" charset="-122"/>
                 <a:cs typeface="Aptos" pitchFamily="34" charset="-120"/>
               </a:rPr>
-              <a:t>Tools + grounding</a:t>
+              <a:t>0 - 30 days</a:t>
             </a:r>
             <a:endParaRPr lang="en-US" sz="1200" dirty="0"/>
           </a:p>
@@ -16215,7 +15637,7 @@
         <p:spPr>
           <a:xfrm>
             <a:off x="841248" y="1920240"/>
-            <a:ext cx="5074920" cy="1188720"/>
+            <a:ext cx="3200400" cy="1280160"/>
           </a:xfrm>
           <a:prstGeom prst="rect">
             <a:avLst/>
@@ -16241,7 +15663,7 @@
                 <a:ea typeface="Aptos" pitchFamily="34" charset="-122"/>
                 <a:cs typeface="Aptos" pitchFamily="34" charset="-120"/>
               </a:rPr>
-              <a:t>Securing MCP tool servers; reusing capability-host Search and its cost; existing vs. Foundry search; SharePoint / O365 RAG ingest; RAG design guidance.</a:t>
+              <a:t>Stand up the governed pattern on a synthetic corpus; wire Foundry IQ to approved protocols; agree the safety gate and telemetry taxonomy.</a:t>
             </a:r>
             <a:endParaRPr lang="en-US" sz="920" dirty="0"/>
           </a:p>
@@ -16255,12 +15677,12 @@
         </p:nvSpPr>
         <p:spPr>
           <a:xfrm>
-            <a:off x="6217920" y="1463040"/>
-            <a:ext cx="5394960" cy="1737360"/>
+            <a:off x="4343400" y="1463040"/>
+            <a:ext cx="3520440" cy="1828800"/>
           </a:xfrm>
           <a:prstGeom prst="roundRect">
             <a:avLst>
-              <a:gd name="adj" fmla="val 4211"/>
+              <a:gd name="adj" fmla="val 4000"/>
             </a:avLst>
           </a:prstGeom>
           <a:solidFill>
@@ -16289,18 +15711,18 @@
         </p:nvSpPr>
         <p:spPr>
           <a:xfrm>
-            <a:off x="6217920" y="1463040"/>
-            <a:ext cx="64008" cy="1737360"/>
+            <a:off x="4343400" y="1463040"/>
+            <a:ext cx="64008" cy="1828800"/>
           </a:xfrm>
           <a:prstGeom prst="rect">
             <a:avLst/>
           </a:prstGeom>
           <a:solidFill>
-            <a:srgbClr val="7C3AED"/>
+            <a:srgbClr val="2563EB"/>
           </a:solidFill>
           <a:ln w="12700">
             <a:solidFill>
-              <a:srgbClr val="7C3AED"/>
+              <a:srgbClr val="2563EB"/>
             </a:solidFill>
             <a:prstDash val="solid"/>
           </a:ln>
@@ -16314,8 +15736,8 @@
         </p:nvSpPr>
         <p:spPr>
           <a:xfrm>
-            <a:off x="6419088" y="1609344"/>
-            <a:ext cx="5074920" cy="219456"/>
+            <a:off x="4544568" y="1609344"/>
+            <a:ext cx="3200400" cy="219456"/>
           </a:xfrm>
           <a:prstGeom prst="rect">
             <a:avLst/>
@@ -16341,7 +15763,7 @@
                 <a:ea typeface="Aptos" pitchFamily="34" charset="-122"/>
                 <a:cs typeface="Aptos" pitchFamily="34" charset="-120"/>
               </a:rPr>
-              <a:t>Safety + agents</a:t>
+              <a:t>30 - 60 days</a:t>
             </a:r>
             <a:endParaRPr lang="en-US" sz="1200" dirty="0"/>
           </a:p>
@@ -16355,8 +15777,8 @@
         </p:nvSpPr>
         <p:spPr>
           <a:xfrm>
-            <a:off x="6419088" y="1920240"/>
-            <a:ext cx="5074920" cy="1188720"/>
+            <a:off x="4544568" y="1920240"/>
+            <a:ext cx="3200400" cy="1280160"/>
           </a:xfrm>
           <a:prstGeom prst="rect">
             <a:avLst/>
@@ -16382,7 +15804,7 @@
                 <a:ea typeface="Aptos" pitchFamily="34" charset="-122"/>
                 <a:cs typeface="Aptos" pitchFamily="34" charset="-120"/>
               </a:rPr>
-              <a:t>Healthcare content safety; choosing the right agent type; governance, security and observability; guardrail policy and its test matrix.</a:t>
+              <a:t>Secure MCP + Toolbox for the first real tools; dedicated LAW cluster + CMK + AMPLS; capability-host reuse decisions per app team.</a:t>
             </a:r>
             <a:endParaRPr lang="en-US" sz="920" dirty="0"/>
           </a:p>
@@ -16396,12 +15818,12 @@
         </p:nvSpPr>
         <p:spPr>
           <a:xfrm>
-            <a:off x="640080" y="3337560"/>
-            <a:ext cx="5394960" cy="1554480"/>
+            <a:off x="8046720" y="1463040"/>
+            <a:ext cx="3520440" cy="1828800"/>
           </a:xfrm>
           <a:prstGeom prst="roundRect">
             <a:avLst>
-              <a:gd name="adj" fmla="val 4706"/>
+              <a:gd name="adj" fmla="val 4000"/>
             </a:avLst>
           </a:prstGeom>
           <a:solidFill>
@@ -16430,18 +15852,18 @@
         </p:nvSpPr>
         <p:spPr>
           <a:xfrm>
-            <a:off x="640080" y="3337560"/>
-            <a:ext cx="64008" cy="1554480"/>
+            <a:off x="8046720" y="1463040"/>
+            <a:ext cx="64008" cy="1828800"/>
           </a:xfrm>
           <a:prstGeom prst="rect">
             <a:avLst/>
           </a:prstGeom>
           <a:solidFill>
-            <a:srgbClr val="2563EB"/>
+            <a:srgbClr val="7C3AED"/>
           </a:solidFill>
           <a:ln w="12700">
             <a:solidFill>
-              <a:srgbClr val="2563EB"/>
+              <a:srgbClr val="7C3AED"/>
             </a:solidFill>
             <a:prstDash val="solid"/>
           </a:ln>
@@ -16455,8 +15877,8 @@
         </p:nvSpPr>
         <p:spPr>
           <a:xfrm>
-            <a:off x="841248" y="3483864"/>
-            <a:ext cx="5074920" cy="219456"/>
+            <a:off x="8247888" y="1609344"/>
+            <a:ext cx="3200400" cy="219456"/>
           </a:xfrm>
           <a:prstGeom prst="rect">
             <a:avLst/>
@@ -16482,7 +15904,7 @@
                 <a:ea typeface="Aptos" pitchFamily="34" charset="-122"/>
                 <a:cs typeface="Aptos" pitchFamily="34" charset="-120"/>
               </a:rPr>
-              <a:t>Operate</a:t>
+              <a:t>60 - 90 days</a:t>
             </a:r>
             <a:endParaRPr lang="en-US" sz="1200" dirty="0"/>
           </a:p>
@@ -16496,8 +15918,8 @@
         </p:nvSpPr>
         <p:spPr>
           <a:xfrm>
-            <a:off x="841248" y="3794760"/>
-            <a:ext cx="5074920" cy="1005840"/>
+            <a:off x="8247888" y="1920240"/>
+            <a:ext cx="3200400" cy="1280160"/>
           </a:xfrm>
           <a:prstGeom prst="rect">
             <a:avLst/>
@@ -16523,7 +15945,7 @@
                 <a:ea typeface="Aptos" pitchFamily="34" charset="-122"/>
                 <a:cs typeface="Aptos" pitchFamily="34" charset="-120"/>
               </a:rPr>
-              <a:t>Dedicated cluster with CMK and AMPLS; end-to-end trace correlation; human-in-the-loop with the Durable Task Scheduler.</a:t>
+              <a:t>Limited pilot behind the human gate with a real (governed) source; continuous evaluation; expand toolboxes and observability dashboards.</a:t>
             </a:r>
             <a:endParaRPr lang="en-US" sz="920" dirty="0"/>
           </a:p>
@@ -16531,18 +15953,318 @@
       </p:sp>
       <p:sp>
         <p:nvSpPr>
-          <p:cNvPr id="17" name="Shape 15"/>
-          <p:cNvSpPr/>
-          <p:nvPr/>
-        </p:nvSpPr>
-        <p:spPr>
-          <a:xfrm>
-            <a:off x="6217920" y="3337560"/>
-            <a:ext cx="5394960" cy="1554480"/>
+          <p:cNvPr id="17" name="Text 15"/>
+          <p:cNvSpPr/>
+          <p:nvPr/>
+        </p:nvSpPr>
+        <p:spPr>
+          <a:xfrm>
+            <a:off x="640080" y="3520440"/>
+            <a:ext cx="10972800" cy="2011680"/>
+          </a:xfrm>
+          <a:prstGeom prst="rect">
+            <a:avLst/>
+          </a:prstGeom>
+          <a:noFill/>
+          <a:ln/>
+        </p:spPr>
+        <p:txBody>
+          <a:bodyPr wrap="square" lIns="381" tIns="381" rIns="381" bIns="381" rtlCol="0" anchor="ctr">
+            <a:normAutofit/>
+          </a:bodyPr>
+          <a:lstStyle/>
+          <a:p>
+            <a:pPr marL="152400" indent="-152400">
+              <a:buSzPct val="100000"/>
+              <a:buChar char="•"/>
+            </a:pPr>
+            <a:r>
+              <a:rPr lang="en-US" sz="1150" dirty="0">
+                <a:solidFill>
+                  <a:srgbClr val="334155"/>
+                </a:solidFill>
+                <a:latin typeface="Aptos" pitchFamily="34" charset="0"/>
+                <a:ea typeface="Aptos" pitchFamily="34" charset="-122"/>
+                <a:cs typeface="Aptos" pitchFamily="34" charset="-120"/>
+              </a:rPr>
+              <a:t>Cost discipline throughout: reuse platform resources; commitment-tier logging; no duplicated Search.</a:t>
+            </a:r>
+            <a:endParaRPr lang="en-US" sz="1150" dirty="0"/>
+          </a:p>
+          <a:p>
+            <a:pPr marL="152400" indent="-152400">
+              <a:buSzPct val="100000"/>
+              <a:buChar char="•"/>
+            </a:pPr>
+            <a:r>
+              <a:rPr lang="en-US" sz="1150" dirty="0">
+                <a:solidFill>
+                  <a:srgbClr val="334155"/>
+                </a:solidFill>
+                <a:latin typeface="Aptos" pitchFamily="34" charset="0"/>
+                <a:ea typeface="Aptos" pitchFamily="34" charset="-122"/>
+                <a:cs typeface="Aptos" pitchFamily="34" charset="-120"/>
+              </a:rPr>
+              <a:t>Governance owners named per control (guardrails, RBAC, content safety, HITL).</a:t>
+            </a:r>
+            <a:endParaRPr lang="en-US" sz="1150" dirty="0"/>
+          </a:p>
+          <a:p>
+            <a:pPr marL="152400" indent="-152400">
+              <a:buSzPct val="100000"/>
+              <a:buChar char="•"/>
+            </a:pPr>
+            <a:r>
+              <a:rPr lang="en-US" sz="1150" dirty="0">
+                <a:solidFill>
+                  <a:srgbClr val="334155"/>
+                </a:solidFill>
+                <a:latin typeface="Aptos" pitchFamily="34" charset="0"/>
+                <a:ea typeface="Aptos" pitchFamily="34" charset="-122"/>
+                <a:cs typeface="Aptos" pitchFamily="34" charset="-120"/>
+              </a:rPr>
+              <a:t>Futures to scope: BYO Registry, BYO AKS for hosted agents, SRE agent - as separate tracks.</a:t>
+            </a:r>
+            <a:endParaRPr lang="en-US" sz="1150" dirty="0"/>
+          </a:p>
+        </p:txBody>
+      </p:sp>
+      <p:sp>
+        <p:nvSpPr>
+          <p:cNvPr id="18" name="Text 16"/>
+          <p:cNvSpPr/>
+          <p:nvPr/>
+        </p:nvSpPr>
+        <p:spPr>
+          <a:xfrm>
+            <a:off x="640080" y="5806440"/>
+            <a:ext cx="10972800" cy="457200"/>
+          </a:xfrm>
+          <a:prstGeom prst="rect">
+            <a:avLst/>
+          </a:prstGeom>
+          <a:noFill/>
+          <a:ln/>
+        </p:spPr>
+        <p:txBody>
+          <a:bodyPr wrap="square" lIns="0" tIns="0" rIns="0" bIns="0" rtlCol="0" anchor="ctr"/>
+          <a:lstStyle/>
+          <a:p>
+            <a:pPr indent="0" marL="0">
+              <a:buNone/>
+            </a:pPr>
+            <a:r>
+              <a:rPr lang="en-US" sz="1000" i="1" dirty="0">
+                <a:solidFill>
+                  <a:srgbClr val="64748B"/>
+                </a:solidFill>
+                <a:latin typeface="Aptos" pitchFamily="34" charset="0"/>
+                <a:ea typeface="Aptos" pitchFamily="34" charset="-122"/>
+                <a:cs typeface="Aptos" pitchFamily="34" charset="-120"/>
+              </a:rPr>
+              <a:t>A staged path: prove the pattern, harden the platform, then pilot behind the human gate.</a:t>
+            </a:r>
+            <a:endParaRPr lang="en-US" sz="1000" dirty="0"/>
+          </a:p>
+        </p:txBody>
+      </p:sp>
+      <p:sp>
+        <p:nvSpPr>
+          <p:cNvPr id="25" name="Slide Number Placeholder 0"/>
+          <p:cNvSpPr>
+            <a:spLocks noGrp="1"/>
+          </p:cNvSpPr>
+          <p:nvPr>
+            <p:ph type="sldNum" sz="quarter" idx="4294967295"/>
+          </p:nvPr>
+        </p:nvSpPr>
+        <p:spPr>
+          <a:xfrm>
+            <a:off x="11475720" y="6565392"/>
+            <a:ext cx="800000" cy="300000"/>
+          </a:xfrm>
+          <a:prstGeom prst="rect">
+            <a:avLst/>
+          </a:prstGeom>
+          <a:extLst>
+            <a:ext uri="{C572A759-6A51-4108-AA02-DFA0A04FC94B}">
+              <ma14:wrappingTextBoxFlag xmlns:ma14="http://schemas.microsoft.com/office/mac/drawingml/2011/main" val="0"/>
+            </a:ext>
+          </a:extLst>
+        </p:spPr>
+        <p:txBody>
+          <a:bodyPr/>
+          <a:lstStyle>
+            <a:lvl1pPr>
+              <a:defRPr sz="700">
+                <a:solidFill>
+                  <a:srgbClr val="64748B"/>
+                </a:solidFill>
+                <a:latin typeface="Aptos"/>
+                <a:ea typeface="Aptos"/>
+                <a:cs typeface="Aptos"/>
+              </a:defRPr>
+            </a:lvl1pPr>
+          </a:lstStyle>
+          <a:p>
+            <a:pPr algn="l"/>
+            <a:fld id="{F7021451-1387-4CA6-816F-3879F97B5CBC}" type="slidenum">
+              <a:rPr b="0" lang="en-US"/>
+              <a:t>25</a:t>
+            </a:fld>
+            <a:endParaRPr lang="en-US"/>
+          </a:p>
+        </p:txBody>
+      </p:sp>
+    </p:spTree>
+  </p:cSld>
+  <p:clrMapOvr>
+    <a:masterClrMapping/>
+  </p:clrMapOvr>
+</p:sld>
+</file>
+
+<file path=ppt/slides/slide26.xml><?xml version="1.0" encoding="utf-8"?>
+<p:sld xmlns:a="http://schemas.openxmlformats.org/drawingml/2006/main" xmlns:r="http://schemas.openxmlformats.org/officeDocument/2006/relationships" xmlns:p="http://schemas.openxmlformats.org/presentationml/2006/main">
+  <p:cSld name="Slide 26">
+    <p:bg>
+      <p:bgPr>
+        <a:solidFill>
+          <a:srgbClr val="F8FAFC"/>
+        </a:solidFill>
+      </p:bgPr>
+    </p:bg>
+    <p:spTree>
+      <p:nvGrpSpPr>
+        <p:cNvPr id="1" name=""/>
+        <p:cNvGrpSpPr/>
+        <p:nvPr/>
+      </p:nvGrpSpPr>
+      <p:grpSpPr>
+        <a:xfrm>
+          <a:off x="0" y="0"/>
+          <a:ext cx="0" cy="0"/>
+          <a:chOff x="0" y="0"/>
+          <a:chExt cx="0" cy="0"/>
+        </a:xfrm>
+      </p:grpSpPr>
+      <p:sp>
+        <p:nvSpPr>
+          <p:cNvPr id="2" name="Text 0"/>
+          <p:cNvSpPr/>
+          <p:nvPr/>
+        </p:nvSpPr>
+        <p:spPr>
+          <a:xfrm>
+            <a:off x="566928" y="384048"/>
+            <a:ext cx="10789920" cy="201168"/>
+          </a:xfrm>
+          <a:prstGeom prst="rect">
+            <a:avLst/>
+          </a:prstGeom>
+          <a:noFill/>
+          <a:ln/>
+        </p:spPr>
+        <p:txBody>
+          <a:bodyPr wrap="square" lIns="0" tIns="0" rIns="0" bIns="0" rtlCol="0" anchor="ctr"/>
+          <a:lstStyle/>
+          <a:p>
+            <a:pPr indent="0" marL="0">
+              <a:buNone/>
+            </a:pPr>
+            <a:r>
+              <a:rPr lang="en-US" sz="800" b="1" dirty="0">
+                <a:solidFill>
+                  <a:srgbClr val="0F766E"/>
+                </a:solidFill>
+                <a:latin typeface="Aptos" pitchFamily="34" charset="0"/>
+                <a:ea typeface="Aptos" pitchFamily="34" charset="-122"/>
+                <a:cs typeface="Aptos" pitchFamily="34" charset="-120"/>
+              </a:rPr>
+              <a:t>SOURCE-GROUNDED BRIEFS</a:t>
+            </a:r>
+            <a:endParaRPr lang="en-US" sz="800" dirty="0"/>
+          </a:p>
+        </p:txBody>
+      </p:sp>
+      <p:sp>
+        <p:nvSpPr>
+          <p:cNvPr id="3" name="Text 1"/>
+          <p:cNvSpPr/>
+          <p:nvPr/>
+        </p:nvSpPr>
+        <p:spPr>
+          <a:xfrm>
+            <a:off x="548640" y="658368"/>
+            <a:ext cx="11064240" cy="502920"/>
+          </a:xfrm>
+          <a:prstGeom prst="rect">
+            <a:avLst/>
+          </a:prstGeom>
+          <a:noFill/>
+          <a:ln/>
+        </p:spPr>
+        <p:txBody>
+          <a:bodyPr wrap="square" lIns="0" tIns="0" rIns="0" bIns="0" rtlCol="0" anchor="ctr">
+            <a:normAutofit/>
+          </a:bodyPr>
+          <a:lstStyle/>
+          <a:p>
+            <a:pPr indent="0" marL="0">
+              <a:buNone/>
+            </a:pPr>
+            <a:r>
+              <a:rPr lang="en-US" sz="2300" b="1" dirty="0">
+                <a:solidFill>
+                  <a:srgbClr val="0B1220"/>
+                </a:solidFill>
+                <a:latin typeface="Aptos Display" pitchFamily="34" charset="0"/>
+                <a:ea typeface="Aptos Display" pitchFamily="34" charset="-122"/>
+                <a:cs typeface="Aptos Display" pitchFamily="34" charset="-120"/>
+              </a:rPr>
+              <a:t>Where to go deeper</a:t>
+            </a:r>
+            <a:endParaRPr lang="en-US" sz="2300" dirty="0"/>
+          </a:p>
+        </p:txBody>
+      </p:sp>
+      <p:sp>
+        <p:nvSpPr>
+          <p:cNvPr id="4" name="Shape 2"/>
+          <p:cNvSpPr/>
+          <p:nvPr/>
+        </p:nvSpPr>
+        <p:spPr>
+          <a:xfrm>
+            <a:off x="548640" y="1243584"/>
+            <a:ext cx="11064240" cy="0"/>
+          </a:xfrm>
+          <a:prstGeom prst="line">
+            <a:avLst/>
+          </a:prstGeom>
+          <a:noFill/>
+          <a:ln w="12700">
+            <a:solidFill>
+              <a:srgbClr val="CBD5E1"/>
+            </a:solidFill>
+            <a:prstDash val="solid"/>
+          </a:ln>
+        </p:spPr>
+      </p:sp>
+      <p:sp>
+        <p:nvSpPr>
+          <p:cNvPr id="5" name="Shape 3"/>
+          <p:cNvSpPr/>
+          <p:nvPr/>
+        </p:nvSpPr>
+        <p:spPr>
+          <a:xfrm>
+            <a:off x="640080" y="1463040"/>
+            <a:ext cx="5394960" cy="1737360"/>
           </a:xfrm>
           <a:prstGeom prst="roundRect">
             <a:avLst>
-              <a:gd name="adj" fmla="val 4706"/>
+              <a:gd name="adj" fmla="val 4211"/>
             </a:avLst>
           </a:prstGeom>
           <a:solidFill>
@@ -16565,6 +16287,429 @@
       </p:sp>
       <p:sp>
         <p:nvSpPr>
+          <p:cNvPr id="6" name="Shape 4"/>
+          <p:cNvSpPr/>
+          <p:nvPr/>
+        </p:nvSpPr>
+        <p:spPr>
+          <a:xfrm>
+            <a:off x="640080" y="1463040"/>
+            <a:ext cx="64008" cy="1737360"/>
+          </a:xfrm>
+          <a:prstGeom prst="rect">
+            <a:avLst/>
+          </a:prstGeom>
+          <a:solidFill>
+            <a:srgbClr val="0F766E"/>
+          </a:solidFill>
+          <a:ln w="12700">
+            <a:solidFill>
+              <a:srgbClr val="0F766E"/>
+            </a:solidFill>
+            <a:prstDash val="solid"/>
+          </a:ln>
+        </p:spPr>
+      </p:sp>
+      <p:sp>
+        <p:nvSpPr>
+          <p:cNvPr id="7" name="Text 5"/>
+          <p:cNvSpPr/>
+          <p:nvPr/>
+        </p:nvSpPr>
+        <p:spPr>
+          <a:xfrm>
+            <a:off x="841248" y="1609344"/>
+            <a:ext cx="5074920" cy="219456"/>
+          </a:xfrm>
+          <a:prstGeom prst="rect">
+            <a:avLst/>
+          </a:prstGeom>
+          <a:noFill/>
+          <a:ln/>
+        </p:spPr>
+        <p:txBody>
+          <a:bodyPr wrap="square" lIns="0" tIns="0" rIns="0" bIns="0" rtlCol="0" anchor="ctr">
+            <a:normAutofit/>
+          </a:bodyPr>
+          <a:lstStyle/>
+          <a:p>
+            <a:pPr indent="0" marL="0">
+              <a:buNone/>
+            </a:pPr>
+            <a:r>
+              <a:rPr lang="en-US" sz="1200" b="1" dirty="0">
+                <a:solidFill>
+                  <a:srgbClr val="0B1220"/>
+                </a:solidFill>
+                <a:latin typeface="Aptos" pitchFamily="34" charset="0"/>
+                <a:ea typeface="Aptos" pitchFamily="34" charset="-122"/>
+                <a:cs typeface="Aptos" pitchFamily="34" charset="-120"/>
+              </a:rPr>
+              <a:t>Tools + grounding</a:t>
+            </a:r>
+            <a:endParaRPr lang="en-US" sz="1200" dirty="0"/>
+          </a:p>
+        </p:txBody>
+      </p:sp>
+      <p:sp>
+        <p:nvSpPr>
+          <p:cNvPr id="8" name="Text 6"/>
+          <p:cNvSpPr/>
+          <p:nvPr/>
+        </p:nvSpPr>
+        <p:spPr>
+          <a:xfrm>
+            <a:off x="841248" y="1920240"/>
+            <a:ext cx="5074920" cy="1188720"/>
+          </a:xfrm>
+          <a:prstGeom prst="rect">
+            <a:avLst/>
+          </a:prstGeom>
+          <a:noFill/>
+          <a:ln/>
+        </p:spPr>
+        <p:txBody>
+          <a:bodyPr wrap="square" lIns="254" tIns="254" rIns="254" bIns="254" rtlCol="0" anchor="t">
+            <a:normAutofit/>
+          </a:bodyPr>
+          <a:lstStyle/>
+          <a:p>
+            <a:pPr indent="0" marL="0">
+              <a:buNone/>
+            </a:pPr>
+            <a:r>
+              <a:rPr lang="en-US" sz="920" dirty="0">
+                <a:solidFill>
+                  <a:srgbClr val="334155"/>
+                </a:solidFill>
+                <a:latin typeface="Aptos" pitchFamily="34" charset="0"/>
+                <a:ea typeface="Aptos" pitchFamily="34" charset="-122"/>
+                <a:cs typeface="Aptos" pitchFamily="34" charset="-120"/>
+              </a:rPr>
+              <a:t>Securing MCP tool servers; reusing capability-host Search and its cost; existing vs. Foundry search; SharePoint / O365 RAG ingest; RAG design guidance.</a:t>
+            </a:r>
+            <a:endParaRPr lang="en-US" sz="920" dirty="0"/>
+          </a:p>
+        </p:txBody>
+      </p:sp>
+      <p:sp>
+        <p:nvSpPr>
+          <p:cNvPr id="9" name="Shape 7"/>
+          <p:cNvSpPr/>
+          <p:nvPr/>
+        </p:nvSpPr>
+        <p:spPr>
+          <a:xfrm>
+            <a:off x="6217920" y="1463040"/>
+            <a:ext cx="5394960" cy="1737360"/>
+          </a:xfrm>
+          <a:prstGeom prst="roundRect">
+            <a:avLst>
+              <a:gd name="adj" fmla="val 4211"/>
+            </a:avLst>
+          </a:prstGeom>
+          <a:solidFill>
+            <a:srgbClr val="FFFFFF"/>
+          </a:solidFill>
+          <a:ln w="12700">
+            <a:solidFill>
+              <a:srgbClr val="E2E8F0"/>
+            </a:solidFill>
+            <a:prstDash val="solid"/>
+          </a:ln>
+          <a:effectLst>
+            <a:outerShdw sx="100000" sy="100000" kx="0" ky="0" algn="bl" rotWithShape="0" blurRad="25400" dist="50800" dir="2700000">
+              <a:srgbClr val="94A3B8">
+                <a:alpha val="12000"/>
+              </a:srgbClr>
+            </a:outerShdw>
+          </a:effectLst>
+        </p:spPr>
+      </p:sp>
+      <p:sp>
+        <p:nvSpPr>
+          <p:cNvPr id="10" name="Shape 8"/>
+          <p:cNvSpPr/>
+          <p:nvPr/>
+        </p:nvSpPr>
+        <p:spPr>
+          <a:xfrm>
+            <a:off x="6217920" y="1463040"/>
+            <a:ext cx="64008" cy="1737360"/>
+          </a:xfrm>
+          <a:prstGeom prst="rect">
+            <a:avLst/>
+          </a:prstGeom>
+          <a:solidFill>
+            <a:srgbClr val="7C3AED"/>
+          </a:solidFill>
+          <a:ln w="12700">
+            <a:solidFill>
+              <a:srgbClr val="7C3AED"/>
+            </a:solidFill>
+            <a:prstDash val="solid"/>
+          </a:ln>
+        </p:spPr>
+      </p:sp>
+      <p:sp>
+        <p:nvSpPr>
+          <p:cNvPr id="11" name="Text 9"/>
+          <p:cNvSpPr/>
+          <p:nvPr/>
+        </p:nvSpPr>
+        <p:spPr>
+          <a:xfrm>
+            <a:off x="6419088" y="1609344"/>
+            <a:ext cx="5074920" cy="219456"/>
+          </a:xfrm>
+          <a:prstGeom prst="rect">
+            <a:avLst/>
+          </a:prstGeom>
+          <a:noFill/>
+          <a:ln/>
+        </p:spPr>
+        <p:txBody>
+          <a:bodyPr wrap="square" lIns="0" tIns="0" rIns="0" bIns="0" rtlCol="0" anchor="ctr">
+            <a:normAutofit/>
+          </a:bodyPr>
+          <a:lstStyle/>
+          <a:p>
+            <a:pPr indent="0" marL="0">
+              <a:buNone/>
+            </a:pPr>
+            <a:r>
+              <a:rPr lang="en-US" sz="1200" b="1" dirty="0">
+                <a:solidFill>
+                  <a:srgbClr val="0B1220"/>
+                </a:solidFill>
+                <a:latin typeface="Aptos" pitchFamily="34" charset="0"/>
+                <a:ea typeface="Aptos" pitchFamily="34" charset="-122"/>
+                <a:cs typeface="Aptos" pitchFamily="34" charset="-120"/>
+              </a:rPr>
+              <a:t>Safety + agents</a:t>
+            </a:r>
+            <a:endParaRPr lang="en-US" sz="1200" dirty="0"/>
+          </a:p>
+        </p:txBody>
+      </p:sp>
+      <p:sp>
+        <p:nvSpPr>
+          <p:cNvPr id="12" name="Text 10"/>
+          <p:cNvSpPr/>
+          <p:nvPr/>
+        </p:nvSpPr>
+        <p:spPr>
+          <a:xfrm>
+            <a:off x="6419088" y="1920240"/>
+            <a:ext cx="5074920" cy="1188720"/>
+          </a:xfrm>
+          <a:prstGeom prst="rect">
+            <a:avLst/>
+          </a:prstGeom>
+          <a:noFill/>
+          <a:ln/>
+        </p:spPr>
+        <p:txBody>
+          <a:bodyPr wrap="square" lIns="254" tIns="254" rIns="254" bIns="254" rtlCol="0" anchor="t">
+            <a:normAutofit/>
+          </a:bodyPr>
+          <a:lstStyle/>
+          <a:p>
+            <a:pPr indent="0" marL="0">
+              <a:buNone/>
+            </a:pPr>
+            <a:r>
+              <a:rPr lang="en-US" sz="920" dirty="0">
+                <a:solidFill>
+                  <a:srgbClr val="334155"/>
+                </a:solidFill>
+                <a:latin typeface="Aptos" pitchFamily="34" charset="0"/>
+                <a:ea typeface="Aptos" pitchFamily="34" charset="-122"/>
+                <a:cs typeface="Aptos" pitchFamily="34" charset="-120"/>
+              </a:rPr>
+              <a:t>Healthcare content safety; choosing the right agent type; governance, security and observability; guardrail policy and its test matrix.</a:t>
+            </a:r>
+            <a:endParaRPr lang="en-US" sz="920" dirty="0"/>
+          </a:p>
+        </p:txBody>
+      </p:sp>
+      <p:sp>
+        <p:nvSpPr>
+          <p:cNvPr id="13" name="Shape 11"/>
+          <p:cNvSpPr/>
+          <p:nvPr/>
+        </p:nvSpPr>
+        <p:spPr>
+          <a:xfrm>
+            <a:off x="640080" y="3337560"/>
+            <a:ext cx="5394960" cy="1554480"/>
+          </a:xfrm>
+          <a:prstGeom prst="roundRect">
+            <a:avLst>
+              <a:gd name="adj" fmla="val 4706"/>
+            </a:avLst>
+          </a:prstGeom>
+          <a:solidFill>
+            <a:srgbClr val="FFFFFF"/>
+          </a:solidFill>
+          <a:ln w="12700">
+            <a:solidFill>
+              <a:srgbClr val="E2E8F0"/>
+            </a:solidFill>
+            <a:prstDash val="solid"/>
+          </a:ln>
+          <a:effectLst>
+            <a:outerShdw sx="100000" sy="100000" kx="0" ky="0" algn="bl" rotWithShape="0" blurRad="25400" dist="50800" dir="2700000">
+              <a:srgbClr val="94A3B8">
+                <a:alpha val="12000"/>
+              </a:srgbClr>
+            </a:outerShdw>
+          </a:effectLst>
+        </p:spPr>
+      </p:sp>
+      <p:sp>
+        <p:nvSpPr>
+          <p:cNvPr id="14" name="Shape 12"/>
+          <p:cNvSpPr/>
+          <p:nvPr/>
+        </p:nvSpPr>
+        <p:spPr>
+          <a:xfrm>
+            <a:off x="640080" y="3337560"/>
+            <a:ext cx="64008" cy="1554480"/>
+          </a:xfrm>
+          <a:prstGeom prst="rect">
+            <a:avLst/>
+          </a:prstGeom>
+          <a:solidFill>
+            <a:srgbClr val="2563EB"/>
+          </a:solidFill>
+          <a:ln w="12700">
+            <a:solidFill>
+              <a:srgbClr val="2563EB"/>
+            </a:solidFill>
+            <a:prstDash val="solid"/>
+          </a:ln>
+        </p:spPr>
+      </p:sp>
+      <p:sp>
+        <p:nvSpPr>
+          <p:cNvPr id="15" name="Text 13"/>
+          <p:cNvSpPr/>
+          <p:nvPr/>
+        </p:nvSpPr>
+        <p:spPr>
+          <a:xfrm>
+            <a:off x="841248" y="3483864"/>
+            <a:ext cx="5074920" cy="219456"/>
+          </a:xfrm>
+          <a:prstGeom prst="rect">
+            <a:avLst/>
+          </a:prstGeom>
+          <a:noFill/>
+          <a:ln/>
+        </p:spPr>
+        <p:txBody>
+          <a:bodyPr wrap="square" lIns="0" tIns="0" rIns="0" bIns="0" rtlCol="0" anchor="ctr">
+            <a:normAutofit/>
+          </a:bodyPr>
+          <a:lstStyle/>
+          <a:p>
+            <a:pPr indent="0" marL="0">
+              <a:buNone/>
+            </a:pPr>
+            <a:r>
+              <a:rPr lang="en-US" sz="1200" b="1" dirty="0">
+                <a:solidFill>
+                  <a:srgbClr val="0B1220"/>
+                </a:solidFill>
+                <a:latin typeface="Aptos" pitchFamily="34" charset="0"/>
+                <a:ea typeface="Aptos" pitchFamily="34" charset="-122"/>
+                <a:cs typeface="Aptos" pitchFamily="34" charset="-120"/>
+              </a:rPr>
+              <a:t>Operate</a:t>
+            </a:r>
+            <a:endParaRPr lang="en-US" sz="1200" dirty="0"/>
+          </a:p>
+        </p:txBody>
+      </p:sp>
+      <p:sp>
+        <p:nvSpPr>
+          <p:cNvPr id="16" name="Text 14"/>
+          <p:cNvSpPr/>
+          <p:nvPr/>
+        </p:nvSpPr>
+        <p:spPr>
+          <a:xfrm>
+            <a:off x="841248" y="3794760"/>
+            <a:ext cx="5074920" cy="1005840"/>
+          </a:xfrm>
+          <a:prstGeom prst="rect">
+            <a:avLst/>
+          </a:prstGeom>
+          <a:noFill/>
+          <a:ln/>
+        </p:spPr>
+        <p:txBody>
+          <a:bodyPr wrap="square" lIns="254" tIns="254" rIns="254" bIns="254" rtlCol="0" anchor="t">
+            <a:normAutofit/>
+          </a:bodyPr>
+          <a:lstStyle/>
+          <a:p>
+            <a:pPr indent="0" marL="0">
+              <a:buNone/>
+            </a:pPr>
+            <a:r>
+              <a:rPr lang="en-US" sz="920" dirty="0">
+                <a:solidFill>
+                  <a:srgbClr val="334155"/>
+                </a:solidFill>
+                <a:latin typeface="Aptos" pitchFamily="34" charset="0"/>
+                <a:ea typeface="Aptos" pitchFamily="34" charset="-122"/>
+                <a:cs typeface="Aptos" pitchFamily="34" charset="-120"/>
+              </a:rPr>
+              <a:t>Dedicated cluster with CMK and AMPLS; end-to-end trace correlation; human-in-the-loop with the Durable Task Scheduler.</a:t>
+            </a:r>
+            <a:endParaRPr lang="en-US" sz="920" dirty="0"/>
+          </a:p>
+        </p:txBody>
+      </p:sp>
+      <p:sp>
+        <p:nvSpPr>
+          <p:cNvPr id="17" name="Shape 15"/>
+          <p:cNvSpPr/>
+          <p:nvPr/>
+        </p:nvSpPr>
+        <p:spPr>
+          <a:xfrm>
+            <a:off x="6217920" y="3337560"/>
+            <a:ext cx="5394960" cy="1554480"/>
+          </a:xfrm>
+          <a:prstGeom prst="roundRect">
+            <a:avLst>
+              <a:gd name="adj" fmla="val 4706"/>
+            </a:avLst>
+          </a:prstGeom>
+          <a:solidFill>
+            <a:srgbClr val="FFFFFF"/>
+          </a:solidFill>
+          <a:ln w="12700">
+            <a:solidFill>
+              <a:srgbClr val="E2E8F0"/>
+            </a:solidFill>
+            <a:prstDash val="solid"/>
+          </a:ln>
+          <a:effectLst>
+            <a:outerShdw sx="100000" sy="100000" kx="0" ky="0" algn="bl" rotWithShape="0" blurRad="25400" dist="50800" dir="2700000">
+              <a:srgbClr val="94A3B8">
+                <a:alpha val="12000"/>
+              </a:srgbClr>
+            </a:outerShdw>
+          </a:effectLst>
+        </p:spPr>
+      </p:sp>
+      <p:sp>
+        <p:nvSpPr>
           <p:cNvPr id="18" name="Shape 16"/>
           <p:cNvSpPr/>
           <p:nvPr/>
@@ -16751,7 +16896,7 @@
             <a:pPr algn="l"/>
             <a:fld id="{F7021451-1387-4CA6-816F-3879F97B5CBC}" type="slidenum">
               <a:rPr b="0" lang="en-US"/>
-              <a:t>25</a:t>
+              <a:t>26</a:t>
             </a:fld>
             <a:endParaRPr lang="en-US"/>
           </a:p>
@@ -16765,9 +16910,9 @@
 </p:sld>
 </file>
 
-<file path=ppt/slides/slide26.xml><?xml version="1.0" encoding="utf-8"?>
+<file path=ppt/slides/slide27.xml><?xml version="1.0" encoding="utf-8"?>
 <p:sld xmlns:a="http://schemas.openxmlformats.org/drawingml/2006/main" xmlns:r="http://schemas.openxmlformats.org/officeDocument/2006/relationships" xmlns:p="http://schemas.openxmlformats.org/presentationml/2006/main">
-  <p:cSld name="Slide 26">
+  <p:cSld name="Slide 27">
     <p:bg>
       <p:bgPr>
         <a:solidFill>

</xml_diff>